<commit_message>
Deploy cleaned facilitator deck
</commit_message>
<xml_diff>
--- a/downloads/workshop-1-presentation.pptx
+++ b/downloads/workshop-1-presentation.pptx
@@ -521,7 +521,7 @@
           <a:p>
             <a:r>
               <a:rPr lang="en-US" dirty="0"/>
-              <a:t>Facilitation mode: this deck is the spine. Yellow ask-the-room bars are cold-call or turn-and-talk prompts — pause and wait for answers. Leave each slide up until the checkpoint is true for most of the room. Press R only for ZIPs, the student guide, or presenter desk. Promise: local preview → one change → commit → branch/PR → live Pages URL.</a:t>
+              <a:t>Promise for the day: local preview → one change → commit → branch/PR → live Pages URL. Leave cover up while people settle. Press R only for ZIPs or the walkthrough.</a:t>
             </a:r>
             <a:endParaRPr lang="en-US" dirty="0"/>
           </a:p>
@@ -609,7 +609,7 @@
           <a:p>
             <a:r>
               <a:rPr lang="en-US" dirty="0"/>
-              <a:t>Demo Status Bar branch picker → Create new branch. Then Source Control stage/commit/Publish Branch. Cold-call: what goes wrong if you commit feature work on main? Terminal is optional backup only.</a:t>
+              <a:t>Demo Status Bar → Create new branch → add-featured-project. Status Bar must show the new name before they edit. Ask: why not commit feature work on main? Keep this slide simple — detail is in the walkthrough.</a:t>
             </a:r>
             <a:endParaRPr lang="en-US" dirty="0"/>
           </a:p>
@@ -697,7 +697,7 @@
           <a:p>
             <a:r>
               <a:rPr lang="en-US" dirty="0"/>
-              <a:t>Emphasize the difference between unstaged edits, staged changes, and committed work. The first two recovery commands shown here are scoped to one file and are useful for common mistakes. git restore FILE discards local edits to that file, so first make sure the edits are not needed. Avoid git reset --hard and force pushes in the workshop; ask for help rather than risking lost work.</a:t>
+              <a:t>After their edit on the feature branch: Source Control → stage → commit → Publish Branch. Then GitHub can open a PR. Terminal optional: git push -u origin add-featured-project.</a:t>
             </a:r>
             <a:endParaRPr lang="en-US" dirty="0"/>
           </a:p>
@@ -785,7 +785,7 @@
           <a:p>
             <a:r>
               <a:rPr lang="en-US" dirty="0"/>
-              <a:t>Show the New issue screenshot. Students invent one featured-project issue with checkable criteria. Cold-call: could a stranger verify each criterion without reading your mind?</a:t>
+              <a:t>Students invent one featured-project issue with checkable criteria. Partner check: could a stranger verify done?</a:t>
             </a:r>
             <a:endParaRPr lang="en-US" dirty="0"/>
           </a:p>
@@ -873,7 +873,7 @@
           <a:p>
             <a:r>
               <a:rPr lang="en-US" dirty="0"/>
-              <a:t>Project Pass 1 on the screen; wait until students open the named files. Then Pass 2 with their real project. Cold-call: what would you refuse to paste into Copilot? Stress review responsibility.</a:t>
+              <a:t>Pass 1: explain only. Pass 2: one focused edit in profile.js. Never paste secrets. They own the review. Full prompts are in the student guide.</a:t>
             </a:r>
             <a:endParaRPr lang="en-US" dirty="0"/>
           </a:p>
@@ -961,7 +961,7 @@
           <a:p>
             <a:r>
               <a:rPr lang="en-US" dirty="0"/>
-              <a:t>Gate before PR. Have students shout out when build succeeds. Cold-call one student to explain their diff in one sentence.</a:t>
+              <a:t>Gate before PR. Have students shout when local preview looks right. One-sentence diff explanation.</a:t>
             </a:r>
             <a:endParaRPr lang="en-US" dirty="0"/>
           </a:p>
@@ -1049,7 +1049,7 @@
           <a:p>
             <a:r>
               <a:rPr lang="en-US" dirty="0"/>
-              <a:t>Switch to browser. Confirm base/compare. Have partners review Files changed. Cold-call: what would make you reject this PR? Merge only when criteria pass.</a:t>
+              <a:t>Browser: Compare &amp; pull request. base main, compare feature branch. Files changed is the review. Merge only when criteria pass. Partner review if time.</a:t>
             </a:r>
             <a:endParaRPr lang="en-US" dirty="0"/>
           </a:p>
@@ -1137,7 +1137,7 @@
           <a:p>
             <a:r>
               <a:rPr lang="en-US" dirty="0"/>
-              <a:t>Show Source = GitHub Actions, then Visit site. Stress merge to main. First run often fails until Source is set — teach Re-run all jobs. Cold-call: does a feature branch publish? Wait for no.</a:t>
+              <a:t>Source must be GitHub Actions. First run often fails until Source is set — teach Re-run all jobs. Feature branches do not publish. Cold-call: does pushing a feature branch publish? Wait for no.</a:t>
             </a:r>
             <a:endParaRPr lang="en-US" dirty="0"/>
           </a:p>
@@ -1225,7 +1225,7 @@
           <a:p>
             <a:r>
               <a:rPr lang="en-US" dirty="0"/>
-              <a:t>Use this as the help desk slide during lab. Point at the Actions log screenshot. Protocol: status → reproduce → first error → one fix. Cold-call a stuck student to narrate their symptom without fixing yet.</a:t>
+              <a:t>Help-desk slide for lab. Protocol: status → reproduce → first error → one fix. More cases in the student guide.</a:t>
             </a:r>
             <a:endParaRPr lang="en-US" dirty="0"/>
           </a:p>
@@ -1313,7 +1313,7 @@
           <a:p>
             <a:r>
               <a:rPr lang="en-US" dirty="0"/>
-              <a:t>Leave this slide up for ~30 min. Circulate: ask each student to show issue, branch name, and git status before debugging for them. Prefer a finished small change.</a:t>
+              <a:t>Leave up ~30 min. Circulate: issue, Status Bar branch name, Source Control diff. Prefer a finished small change over a perfect portfolio.</a:t>
             </a:r>
             <a:endParaRPr lang="en-US" dirty="0"/>
           </a:p>
@@ -1401,7 +1401,7 @@
           <a:p>
             <a:r>
               <a:rPr lang="en-US" dirty="0"/>
-              <a:t>Run this as a gallery walk or pair share. Each student shows issue → diff → PR → URL (or Actions). Instructor check: explain one Copilot line and one verification.</a:t>
+              <a:t>Gallery walk or pair share. Issue → diff → PR → URL. Ask one Copilot line + one verification.</a:t>
             </a:r>
             <a:endParaRPr lang="en-US" dirty="0"/>
           </a:p>
@@ -1489,7 +1489,7 @@
           <a:p>
             <a:r>
               <a:rPr lang="en-US" dirty="0"/>
-              <a:t>Walk through the definition of done before students start. The target is one focused change that the student can explain, review, and publish. If someone gets stuck, use the troubleshooting slide and keep going from a working checkpoint. If students get stuck, they can use the checkpoint on the relevant slide rather than jumping ahead.</a:t>
+              <a:t>Definition of done: one focused change they can explain, review, and publish. Schedule lives in the facilitator guide — do not read the clock aloud unless asked.</a:t>
             </a:r>
             <a:endParaRPr lang="en-US" dirty="0"/>
           </a:p>
@@ -1577,7 +1577,7 @@
           <a:p>
             <a:r>
               <a:rPr lang="en-US" dirty="0"/>
-              <a:t>Park this slide during leftover lab time. Exit ticket aloud. Resources (R) for ZIPs and student guide. Remind: status first, verify live URL.</a:t>
+              <a:t>Park during leftover lab. Exit ticket aloud. Resources (R) for ZIP and walkthrough.</a:t>
             </a:r>
             <a:endParaRPr lang="en-US" dirty="0"/>
           </a:p>
@@ -1665,7 +1665,7 @@
           <a:p>
             <a:r>
               <a:rPr lang="en-US" dirty="0"/>
-              <a:t>Pause until every student has an unzipped ZIP and (ideally) an empty public GitHub repo with no README. One starter for everyone — no theme pick. Cold-call: what folder must contain package.json after unzip? Do not start git init until local preview works.</a:t>
+              <a:t>Pause until every hand is up for unzipped folder. Also create empty Public repo with no README. Folder name should be my-resume-site. Do not git init yet.</a:t>
             </a:r>
             <a:endParaRPr lang="en-US" dirty="0"/>
           </a:p>
@@ -1753,7 +1753,7 @@
           <a:p>
             <a:r>
               <a:rPr lang="en-US" dirty="0"/>
-              <a:t>Zero VS Code experience: point at Activity Bar (Explorer), File→Open Folder, Terminal→New Terminal, trust authors dialog. Leave up until localhost loads. Cold-call: what folder must contain package.json? If npm fails, read the first error.</a:t>
+              <a:t>Zero VS Code experience: File→Open Folder, trust authors, Activity Bar = Explorer, Terminal→New Terminal. Cold-call: which folder has package.json? Wait for localhost before continuing.</a:t>
             </a:r>
             <a:endParaRPr lang="en-US" dirty="0"/>
           </a:p>
@@ -1841,7 +1841,7 @@
           <a:p>
             <a:r>
               <a:rPr lang="en-US" dirty="0"/>
-              <a:t>Leave the Explorer diagram up and walk the room: expand src → data → profile.js. Cold-call three students to name what lives in that file. Photo goes in public/. Leave unused lists as []. After they find the file, flash Source Control later when committing — this slide is about finding content, not the diff yet.</a:t>
+              <a:t>Walk Explorer live: src → data → profile.js. Photo goes in public/. Empty arrays stay hidden. Do not teach Source Control yet.</a:t>
             </a:r>
             <a:endParaRPr lang="en-US" dirty="0"/>
           </a:p>
@@ -1929,7 +1929,7 @@
           <a:p>
             <a:r>
               <a:rPr lang="en-US" dirty="0"/>
-              <a:t>Teach this as the spine for the rest of the session. Cold-call: if you saved in VS Code, is the live site updated? Wait for no. Then walk Save → Commit → Push → Deploy. Revisit this slide whenever someone is stuck on 'I pushed but the site didn't change.'</a:t>
+              <a:t>Spine of the day. Cold-call: if you saved in VS Code, is the live site updated? Wait for no. Revisit whenever someone says I pushed but the site didn’t change.</a:t>
             </a:r>
             <a:endParaRPr lang="en-US" dirty="0"/>
           </a:p>
@@ -2017,7 +2017,7 @@
           <a:p>
             <a:r>
               <a:rPr lang="en-US" dirty="0"/>
-              <a:t>Students should already have an empty public repo from the theme slide (or create it now). Live-demo git init → first commit → push. Cover browser auth / PAT when push fails. Cold-call: why Public? ZIP path only — no clone.</a:t>
+              <a:t>Demo git init through push. Public repo required. If push asks for password: browser sign-in or PAT with repo scope — never account password. Student guide Step 3 for auth recovery.</a:t>
             </a:r>
             <a:endParaRPr lang="en-US" dirty="0"/>
           </a:p>
@@ -2105,7 +2105,7 @@
           <a:p>
             <a:r>
               <a:rPr lang="en-US" dirty="0"/>
-              <a:t>Only after first push / git init. Have every student run git status. Cold-call: what four things can status tell you? Safe reads only.</a:t>
+              <a:t>Have everyone run git status once. Safe reads only. Rule: status before you change anything.</a:t>
             </a:r>
             <a:endParaRPr lang="en-US" dirty="0"/>
           </a:p>
@@ -2193,7 +2193,7 @@
           <a:p>
             <a:r>
               <a:rPr lang="en-US" dirty="0"/>
-              <a:t>This is for feature commits after the first push. Live-demo in Source Control once. Do not stage everything blindly. If someone still sees 'not a git repository', send them back to the first-push slide.</a:t>
+              <a:t>Live-demo Source Control. Do not stage everything blindly. Good messages beat vague ones. After commit, Publish/Sync comes on the next slide with branches.</a:t>
             </a:r>
             <a:endParaRPr lang="en-US" dirty="0"/>
           </a:p>
@@ -2720,7 +2720,7 @@
                 <a:ea typeface="Arial" pitchFamily="34" charset="-122"/>
                 <a:cs typeface="Arial" pitchFamily="34" charset="-120"/>
               </a:rPr>
-              <a:t>WICHITA STATE UNIVERSITY</a:t>
+              <a:t>WICHITA STATE · MIS CLUB</a:t>
             </a:r>
             <a:endParaRPr lang="en-US" sz="1200" dirty="0"/>
           </a:p>
@@ -2759,7 +2759,7 @@
                 <a:ea typeface="Arial" pitchFamily="34" charset="-122"/>
                 <a:cs typeface="Arial" pitchFamily="34" charset="-120"/>
               </a:rPr>
-              <a:t>Git and GitHub: from your computer to a published site.</a:t>
+              <a:t>From your laptop to a live site.</a:t>
             </a:r>
             <a:endParaRPr lang="en-US" sz="2800" dirty="0"/>
           </a:p>
@@ -2774,7 +2774,7 @@
         <p:spPr>
           <a:xfrm>
             <a:off x="502920" y="1783080"/>
-            <a:ext cx="11155680" cy="1225296"/>
+            <a:ext cx="11155680" cy="1572768"/>
           </a:xfrm>
           <a:prstGeom prst="rect">
             <a:avLst/>
@@ -2799,7 +2799,7 @@
                 <a:ea typeface="Arial" pitchFamily="34" charset="-122"/>
                 <a:cs typeface="Arial" pitchFamily="34" charset="-120"/>
               </a:rPr>
-              <a:t>Make one small change: One clear outcome</a:t>
+              <a:t>Run the starter</a:t>
             </a:r>
             <a:endParaRPr lang="en-US" sz="1500" dirty="0"/>
           </a:p>
@@ -2817,7 +2817,7 @@
                 <a:ea typeface="Arial" pitchFamily="34" charset="-122"/>
                 <a:cs typeface="Arial" pitchFamily="34" charset="-120"/>
               </a:rPr>
-              <a:t>Commit and push: Keep the history readable</a:t>
+              <a:t>Make one change</a:t>
             </a:r>
             <a:endParaRPr lang="en-US" sz="1500" dirty="0"/>
           </a:p>
@@ -2835,7 +2835,25 @@
                 <a:ea typeface="Arial" pitchFamily="34" charset="-122"/>
                 <a:cs typeface="Arial" pitchFamily="34" charset="-120"/>
               </a:rPr>
-              <a:t>Review and publish: Prove it works</a:t>
+              <a:t>Commit and review</a:t>
+            </a:r>
+            <a:endParaRPr lang="en-US" sz="1500" dirty="0"/>
+          </a:p>
+          <a:p>
+            <a:pPr marL="342900" indent="-342900">
+              <a:buSzPct val="100000"/>
+              <a:buChar char="•"/>
+            </a:pPr>
+            <a:r>
+              <a:rPr lang="en-US" sz="1500" dirty="0">
+                <a:solidFill>
+                  <a:srgbClr val="1A1A1A"/>
+                </a:solidFill>
+                <a:latin typeface="Arial" pitchFamily="34" charset="0"/>
+                <a:ea typeface="Arial" pitchFamily="34" charset="-122"/>
+                <a:cs typeface="Arial" pitchFamily="34" charset="-120"/>
+              </a:rPr>
+              <a:t>Publish</a:t>
             </a:r>
             <a:endParaRPr lang="en-US" sz="1500" dirty="0"/>
           </a:p>
@@ -2899,7 +2917,7 @@
                 <a:ea typeface="Arial" pitchFamily="34" charset="-122"/>
                 <a:cs typeface="Arial" pitchFamily="34" charset="-120"/>
               </a:rPr>
-              <a:t>USE THE WALKTHROUGH WHILE YOU WORK · ARROWS TO MOVE · R FOR RESOURCES · N FOR NOTES</a:t>
+              <a:t>WALKTHROUGH OPEN WHILE YOU WORK · ← → · R RESOURCES · N NOTES</a:t>
             </a:r>
             <a:endParaRPr lang="en-US" sz="1100" dirty="0"/>
           </a:p>
@@ -3091,7 +3109,7 @@
                 <a:ea typeface="Arial" pitchFamily="34" charset="-122"/>
                 <a:cs typeface="Arial" pitchFamily="34" charset="-120"/>
               </a:rPr>
-              <a:t>USE A BRANCH FOR EACH TASK</a:t>
+              <a:t>DO NOT WORK ON MAIN</a:t>
             </a:r>
             <a:endParaRPr lang="en-US" sz="1200" dirty="0"/>
           </a:p>
@@ -3130,7 +3148,7 @@
                 <a:ea typeface="Arial" pitchFamily="34" charset="-122"/>
                 <a:cs typeface="Arial" pitchFamily="34" charset="-120"/>
               </a:rPr>
-              <a:t>Create the branch in VS Code, then commit and publish.</a:t>
+              <a:t>Create a branch for the task.</a:t>
             </a:r>
             <a:endParaRPr lang="en-US" sz="2800" dirty="0"/>
           </a:p>
@@ -3145,46 +3163,7 @@
         <p:spPr>
           <a:xfrm>
             <a:off x="502920" y="1783080"/>
-            <a:ext cx="11155680" cy="502920"/>
-          </a:xfrm>
-          <a:prstGeom prst="rect">
-            <a:avLst/>
-          </a:prstGeom>
-          <a:noFill/>
-          <a:ln/>
-        </p:spPr>
-        <p:txBody>
-          <a:bodyPr wrap="square" rtlCol="0" anchor="ctr"/>
-          <a:lstStyle/>
-          <a:p>
-            <a:pPr indent="0" marL="0">
-              <a:buNone/>
-            </a:pPr>
-            <a:r>
-              <a:rPr lang="en-US" sz="1500" dirty="0">
-                <a:solidFill>
-                  <a:srgbClr val="555555"/>
-                </a:solidFill>
-                <a:latin typeface="Arial" pitchFamily="34" charset="0"/>
-                <a:ea typeface="Arial" pitchFamily="34" charset="-122"/>
-                <a:cs typeface="Arial" pitchFamily="34" charset="-120"/>
-              </a:rPr>
-              <a:t>Primary path: Status Bar + Source Control. Terminal is optional.</a:t>
-            </a:r>
-            <a:endParaRPr lang="en-US" sz="1500" dirty="0"/>
-          </a:p>
-        </p:txBody>
-      </p:sp>
-      <p:sp>
-        <p:nvSpPr>
-          <p:cNvPr id="9" name="Text 7"/>
-          <p:cNvSpPr/>
-          <p:nvPr/>
-        </p:nvSpPr>
-        <p:spPr>
-          <a:xfrm>
-            <a:off x="502920" y="2377440"/>
-            <a:ext cx="11155680" cy="2267712"/>
+            <a:ext cx="11155680" cy="1920240"/>
           </a:xfrm>
           <a:prstGeom prst="rect">
             <a:avLst/>
@@ -3209,7 +3188,7 @@
                 <a:ea typeface="Arial" pitchFamily="34" charset="-122"/>
                 <a:cs typeface="Arial" pitchFamily="34" charset="-120"/>
               </a:rPr>
-              <a:t>Ask: Why not commit feature work directly on main ?</a:t>
+              <a:t>Click the branch name bottom-left Status Bar</a:t>
             </a:r>
             <a:endParaRPr lang="en-US" sz="1500" dirty="0"/>
           </a:p>
@@ -3227,7 +3206,7 @@
                 <a:ea typeface="Arial" pitchFamily="34" charset="-122"/>
                 <a:cs typeface="Arial" pitchFamily="34" charset="-120"/>
               </a:rPr>
-              <a:t>Status Bar → main → Create new branch… → add-featured-project</a:t>
+              <a:t>Create new branch…</a:t>
             </a:r>
             <a:endParaRPr lang="en-US" sz="1500" dirty="0"/>
           </a:p>
@@ -3245,7 +3224,7 @@
                 <a:ea typeface="Arial" pitchFamily="34" charset="-122"/>
                 <a:cs typeface="Arial" pitchFamily="34" charset="-120"/>
               </a:rPr>
-              <a:t>Edit src/data/profile.js Save · refresh localhost</a:t>
+              <a:t>Name it add-featured-project</a:t>
             </a:r>
             <a:endParaRPr lang="en-US" sz="1500" dirty="0"/>
           </a:p>
@@ -3263,7 +3242,7 @@
                 <a:ea typeface="Arial" pitchFamily="34" charset="-122"/>
                 <a:cs typeface="Arial" pitchFamily="34" charset="-120"/>
               </a:rPr>
-              <a:t>Source Control → open diff → Stage (+) → message → Commit</a:t>
+              <a:t>Click the branch name: bottom-left Status Bar</a:t>
             </a:r>
             <a:endParaRPr lang="en-US" sz="1500" dirty="0"/>
           </a:p>
@@ -3281,33 +3260,15 @@
                 <a:ea typeface="Arial" pitchFamily="34" charset="-122"/>
                 <a:cs typeface="Arial" pitchFamily="34" charset="-120"/>
               </a:rPr>
-              <a:t>Publish Branch (or Sync Changes)</a:t>
+              <a:t>Create new branch… Name it: add-featured-project</a:t>
             </a:r>
             <a:endParaRPr lang="en-US" sz="1500" dirty="0"/>
           </a:p>
-          <a:p>
-            <a:pPr marL="342900" indent="-342900">
-              <a:buSzPct val="100000"/>
-              <a:buChar char="•"/>
-            </a:pPr>
-            <a:r>
-              <a:rPr lang="en-US" sz="1500" dirty="0">
-                <a:solidFill>
-                  <a:srgbClr val="1A1A1A"/>
-                </a:solidFill>
-                <a:latin typeface="Arial" pitchFamily="34" charset="0"/>
-                <a:ea typeface="Arial" pitchFamily="34" charset="-122"/>
-                <a:cs typeface="Arial" pitchFamily="34" charset="-120"/>
-              </a:rPr>
-              <a:t>GitHub → Compare &amp; pull request base: main · compare: branch</a:t>
-            </a:r>
-            <a:endParaRPr lang="en-US" sz="1500" dirty="0"/>
-          </a:p>
-        </p:txBody>
-      </p:sp>
-      <p:sp>
-        <p:nvSpPr>
-          <p:cNvPr id="10" name="Shape 8"/>
+        </p:txBody>
+      </p:sp>
+      <p:sp>
+        <p:nvSpPr>
+          <p:cNvPr id="9" name="Shape 7"/>
           <p:cNvSpPr/>
           <p:nvPr/>
         </p:nvSpPr>
@@ -3332,7 +3293,7 @@
       </p:sp>
       <p:sp>
         <p:nvSpPr>
-          <p:cNvPr id="11" name="Text 9"/>
+          <p:cNvPr id="10" name="Text 8"/>
           <p:cNvSpPr/>
           <p:nvPr/>
         </p:nvSpPr>
@@ -3363,7 +3324,7 @@
                 <a:ea typeface="Arial" pitchFamily="34" charset="-122"/>
                 <a:cs typeface="Arial" pitchFamily="34" charset="-120"/>
               </a:rPr>
-              <a:t>DON'T DO FEATURE WORK DIRECTLY ON MAIN · BRANCH → COMMIT → PUBLISH → PR</a:t>
+              <a:t>ARROWS ON THE WEB DECK · R FOR RESOURCES · N FOR NOTES</a:t>
             </a:r>
             <a:endParaRPr lang="en-US" sz="1100" dirty="0"/>
           </a:p>
@@ -3555,7 +3516,7 @@
                 <a:ea typeface="Arial" pitchFamily="34" charset="-122"/>
                 <a:cs typeface="Arial" pitchFamily="34" charset="-120"/>
               </a:rPr>
-              <a:t>HOW TO UNDO A CHANGE</a:t>
+              <a:t>AFTER YOU EDIT</a:t>
             </a:r>
             <a:endParaRPr lang="en-US" sz="1200" dirty="0"/>
           </a:p>
@@ -3594,7 +3555,7 @@
                 <a:ea typeface="Arial" pitchFamily="34" charset="-122"/>
                 <a:cs typeface="Arial" pitchFamily="34" charset="-120"/>
               </a:rPr>
-              <a:t>Check what changed before you undo anything.</a:t>
+              <a:t>Commit. Publish the branch.</a:t>
             </a:r>
             <a:endParaRPr lang="en-US" sz="2800" dirty="0"/>
           </a:p>
@@ -3609,46 +3570,7 @@
         <p:spPr>
           <a:xfrm>
             <a:off x="502920" y="1783080"/>
-            <a:ext cx="11155680" cy="502920"/>
-          </a:xfrm>
-          <a:prstGeom prst="rect">
-            <a:avLst/>
-          </a:prstGeom>
-          <a:noFill/>
-          <a:ln/>
-        </p:spPr>
-        <p:txBody>
-          <a:bodyPr wrap="square" rtlCol="0" anchor="ctr"/>
-          <a:lstStyle/>
-          <a:p>
-            <a:pPr indent="0" marL="0">
-              <a:buNone/>
-            </a:pPr>
-            <a:r>
-              <a:rPr lang="en-US" sz="1500" dirty="0">
-                <a:solidFill>
-                  <a:srgbClr val="555555"/>
-                </a:solidFill>
-                <a:latin typeface="Arial" pitchFamily="34" charset="0"/>
-                <a:ea typeface="Arial" pitchFamily="34" charset="-122"/>
-                <a:cs typeface="Arial" pitchFamily="34" charset="-120"/>
-              </a:rPr>
-              <a:t>Use the least destructive action that matches the state of your file.</a:t>
-            </a:r>
-            <a:endParaRPr lang="en-US" sz="1500" dirty="0"/>
-          </a:p>
-        </p:txBody>
-      </p:sp>
-      <p:sp>
-        <p:nvSpPr>
-          <p:cNvPr id="9" name="Text 7"/>
-          <p:cNvSpPr/>
-          <p:nvPr/>
-        </p:nvSpPr>
-        <p:spPr>
-          <a:xfrm>
-            <a:off x="502920" y="2377440"/>
-            <a:ext cx="11155680" cy="877824"/>
+            <a:ext cx="11155680" cy="1225296"/>
           </a:xfrm>
           <a:prstGeom prst="rect">
             <a:avLst/>
@@ -3673,7 +3595,7 @@
                 <a:ea typeface="Arial" pitchFamily="34" charset="-122"/>
                 <a:cs typeface="Arial" pitchFamily="34" charset="-120"/>
               </a:rPr>
-              <a:t>Recover safely — common undo commands</a:t>
+              <a:t>Edit profile.js · save · refresh localhost</a:t>
             </a:r>
             <a:endParaRPr lang="en-US" sz="1500" dirty="0"/>
           </a:p>
@@ -3691,15 +3613,33 @@
                 <a:ea typeface="Arial" pitchFamily="34" charset="-122"/>
                 <a:cs typeface="Arial" pitchFamily="34" charset="-120"/>
               </a:rPr>
-              <a:t>See the live web deck for full layout and screenshots.</a:t>
+              <a:t>Source Control · stage (+) · message · Commit</a:t>
             </a:r>
             <a:endParaRPr lang="en-US" sz="1500" dirty="0"/>
           </a:p>
-        </p:txBody>
-      </p:sp>
-      <p:sp>
-        <p:nvSpPr>
-          <p:cNvPr id="10" name="Shape 8"/>
+          <a:p>
+            <a:pPr marL="342900" indent="-342900">
+              <a:buSzPct val="100000"/>
+              <a:buChar char="•"/>
+            </a:pPr>
+            <a:r>
+              <a:rPr lang="en-US" sz="1500" dirty="0">
+                <a:solidFill>
+                  <a:srgbClr val="1A1A1A"/>
+                </a:solidFill>
+                <a:latin typeface="Arial" pitchFamily="34" charset="0"/>
+                <a:ea typeface="Arial" pitchFamily="34" charset="-122"/>
+                <a:cs typeface="Arial" pitchFamily="34" charset="-120"/>
+              </a:rPr>
+              <a:t>Publish Branch or Sync Changes</a:t>
+            </a:r>
+            <a:endParaRPr lang="en-US" sz="1500" dirty="0"/>
+          </a:p>
+        </p:txBody>
+      </p:sp>
+      <p:sp>
+        <p:nvSpPr>
+          <p:cNvPr id="9" name="Shape 7"/>
           <p:cNvSpPr/>
           <p:nvPr/>
         </p:nvSpPr>
@@ -3724,7 +3664,7 @@
       </p:sp>
       <p:sp>
         <p:nvSpPr>
-          <p:cNvPr id="11" name="Text 9"/>
+          <p:cNvPr id="10" name="Text 8"/>
           <p:cNvSpPr/>
           <p:nvPr/>
         </p:nvSpPr>
@@ -3755,7 +3695,7 @@
                 <a:ea typeface="Arial" pitchFamily="34" charset="-122"/>
                 <a:cs typeface="Arial" pitchFamily="34" charset="-120"/>
               </a:rPr>
-              <a:t>IF YOU’RE UNSURE, STOP AND CHECK STATUS · STATUS FIRST · ASK IF UNSURE</a:t>
+              <a:t>ARROWS ON THE WEB DECK · R FOR RESOURCES · N FOR NOTES</a:t>
             </a:r>
             <a:endParaRPr lang="en-US" sz="1100" dirty="0"/>
           </a:p>
@@ -3947,7 +3887,7 @@
                 <a:ea typeface="Arial" pitchFamily="34" charset="-122"/>
                 <a:cs typeface="Arial" pitchFamily="34" charset="-120"/>
               </a:rPr>
-              <a:t>CREATE AN ISSUE FIRST</a:t>
+              <a:t>BEFORE YOU CODE</a:t>
             </a:r>
             <a:endParaRPr lang="en-US" sz="1200" dirty="0"/>
           </a:p>
@@ -3986,7 +3926,7 @@
                 <a:ea typeface="Arial" pitchFamily="34" charset="-122"/>
                 <a:cs typeface="Arial" pitchFamily="34" charset="-120"/>
               </a:rPr>
-              <a:t>Describe the change and how you’ll check it.</a:t>
+              <a:t>Write an issue.</a:t>
             </a:r>
             <a:endParaRPr lang="en-US" sz="2800" dirty="0"/>
           </a:p>
@@ -4001,46 +3941,7 @@
         <p:spPr>
           <a:xfrm>
             <a:off x="502920" y="1783080"/>
-            <a:ext cx="11155680" cy="502920"/>
-          </a:xfrm>
-          <a:prstGeom prst="rect">
-            <a:avLst/>
-          </a:prstGeom>
-          <a:noFill/>
-          <a:ln/>
-        </p:spPr>
-        <p:txBody>
-          <a:bodyPr wrap="square" rtlCol="0" anchor="ctr"/>
-          <a:lstStyle/>
-          <a:p>
-            <a:pPr indent="0" marL="0">
-              <a:buNone/>
-            </a:pPr>
-            <a:r>
-              <a:rPr lang="en-US" sz="1500" dirty="0">
-                <a:solidFill>
-                  <a:srgbClr val="555555"/>
-                </a:solidFill>
-                <a:latin typeface="Arial" pitchFamily="34" charset="0"/>
-                <a:ea typeface="Arial" pitchFamily="34" charset="-122"/>
-                <a:cs typeface="Arial" pitchFamily="34" charset="-120"/>
-              </a:rPr>
-              <a:t>Create an issue in GitHub: Issues → New issue . Use a clear title and acceptance criteria.</a:t>
-            </a:r>
-            <a:endParaRPr lang="en-US" sz="1500" dirty="0"/>
-          </a:p>
-        </p:txBody>
-      </p:sp>
-      <p:sp>
-        <p:nvSpPr>
-          <p:cNvPr id="9" name="Text 7"/>
-          <p:cNvSpPr/>
-          <p:nvPr/>
-        </p:nvSpPr>
-        <p:spPr>
-          <a:xfrm>
-            <a:off x="502920" y="2377440"/>
-            <a:ext cx="11155680" cy="2615184"/>
+            <a:ext cx="11155680" cy="1920240"/>
           </a:xfrm>
           <a:prstGeom prst="rect">
             <a:avLst/>
@@ -4065,7 +3966,7 @@
                 <a:ea typeface="Arial" pitchFamily="34" charset="-122"/>
                 <a:cs typeface="Arial" pitchFamily="34" charset="-120"/>
               </a:rPr>
-              <a:t>Open your repository.</a:t>
+              <a:t>Issues → New issue</a:t>
             </a:r>
             <a:endParaRPr lang="en-US" sz="1500" dirty="0"/>
           </a:p>
@@ -4083,7 +3984,7 @@
                 <a:ea typeface="Arial" pitchFamily="34" charset="-122"/>
                 <a:cs typeface="Arial" pitchFamily="34" charset="-120"/>
               </a:rPr>
-              <a:t>Select Issues → New issue .</a:t>
+              <a:t>Title Add a featured project card</a:t>
             </a:r>
             <a:endParaRPr lang="en-US" sz="1500" dirty="0"/>
           </a:p>
@@ -4101,7 +4002,7 @@
                 <a:ea typeface="Arial" pitchFamily="34" charset="-122"/>
                 <a:cs typeface="Arial" pitchFamily="34" charset="-120"/>
               </a:rPr>
-              <a:t>Choose a template or open a blank issue.</a:t>
+              <a:t>Checks honest summary · working link · readable on phone · no secrets</a:t>
             </a:r>
             <a:endParaRPr lang="en-US" sz="1500" dirty="0"/>
           </a:p>
@@ -4119,7 +4020,7 @@
                 <a:ea typeface="Arial" pitchFamily="34" charset="-122"/>
                 <a:cs typeface="Arial" pitchFamily="34" charset="-120"/>
               </a:rPr>
-              <a:t>Use the title and acceptance criteria below.</a:t>
+              <a:t>Issues → New issue Title: Add a featured project card</a:t>
             </a:r>
             <a:endParaRPr lang="en-US" sz="1500" dirty="0"/>
           </a:p>
@@ -4137,51 +4038,15 @@
                 <a:ea typeface="Arial" pitchFamily="34" charset="-122"/>
                 <a:cs typeface="Arial" pitchFamily="34" charset="-120"/>
               </a:rPr>
-              <a:t>Create the issue before changing code.</a:t>
+              <a:t>Checks: honest summary · working link · readable on phone · no secrets</a:t>
             </a:r>
             <a:endParaRPr lang="en-US" sz="1500" dirty="0"/>
           </a:p>
-          <a:p>
-            <a:pPr marL="342900" indent="-342900">
-              <a:buSzPct val="100000"/>
-              <a:buChar char="•"/>
-            </a:pPr>
-            <a:r>
-              <a:rPr lang="en-US" sz="1500" dirty="0">
-                <a:solidFill>
-                  <a:srgbClr val="1A1A1A"/>
-                </a:solidFill>
-                <a:latin typeface="Arial" pitchFamily="34" charset="0"/>
-                <a:ea typeface="Arial" pitchFamily="34" charset="-122"/>
-                <a:cs typeface="Arial" pitchFamily="34" charset="-120"/>
-              </a:rPr>
-              <a:t>Checkpoint: Could someone who didn't write the code verify each criterion? If not, make it more specific.</a:t>
-            </a:r>
-            <a:endParaRPr lang="en-US" sz="1500" dirty="0"/>
-          </a:p>
-          <a:p>
-            <a:pPr marL="342900" indent="-342900">
-              <a:buSzPct val="100000"/>
-              <a:buChar char="•"/>
-            </a:pPr>
-            <a:r>
-              <a:rPr lang="en-US" sz="1500" dirty="0">
-                <a:solidFill>
-                  <a:srgbClr val="1A1A1A"/>
-                </a:solidFill>
-                <a:latin typeface="Arial" pitchFamily="34" charset="0"/>
-                <a:ea typeface="Arial" pitchFamily="34" charset="-122"/>
-                <a:cs typeface="Arial" pitchFamily="34" charset="-120"/>
-              </a:rPr>
-              <a:t>Ask: Read a neighbor's criteria. Could you verify their done state?</a:t>
-            </a:r>
-            <a:endParaRPr lang="en-US" sz="1500" dirty="0"/>
-          </a:p>
-        </p:txBody>
-      </p:sp>
-      <p:sp>
-        <p:nvSpPr>
-          <p:cNvPr id="10" name="Shape 8"/>
+        </p:txBody>
+      </p:sp>
+      <p:sp>
+        <p:nvSpPr>
+          <p:cNvPr id="9" name="Shape 7"/>
           <p:cNvSpPr/>
           <p:nvPr/>
         </p:nvSpPr>
@@ -4206,7 +4071,7 @@
       </p:sp>
       <p:sp>
         <p:nvSpPr>
-          <p:cNvPr id="11" name="Text 9"/>
+          <p:cNvPr id="10" name="Text 8"/>
           <p:cNvSpPr/>
           <p:nvPr/>
         </p:nvSpPr>
@@ -4237,7 +4102,7 @@
                 <a:ea typeface="Arial" pitchFamily="34" charset="-122"/>
                 <a:cs typeface="Arial" pitchFamily="34" charset="-120"/>
               </a:rPr>
-              <a:t>CREATE AN ISSUE BEFORE CODING · REVIEW THE RESULT AGAINST THE CRITERIA</a:t>
+              <a:t>ARROWS ON THE WEB DECK · R FOR RESOURCES · N FOR NOTES</a:t>
             </a:r>
             <a:endParaRPr lang="en-US" sz="1100" dirty="0"/>
           </a:p>
@@ -4429,7 +4294,7 @@
                 <a:ea typeface="Arial" pitchFamily="34" charset="-122"/>
                 <a:cs typeface="Arial" pitchFamily="34" charset="-120"/>
               </a:rPr>
-              <a:t>WHAT TO INCLUDE IN A COPILOT REQUEST</a:t>
+              <a:t>OPTIONAL</a:t>
             </a:r>
             <a:endParaRPr lang="en-US" sz="1200" dirty="0"/>
           </a:p>
@@ -4468,7 +4333,7 @@
                 <a:ea typeface="Arial" pitchFamily="34" charset="-122"/>
                 <a:cs typeface="Arial" pitchFamily="34" charset="-120"/>
               </a:rPr>
-              <a:t>Ask Copilot to make one specific change.</a:t>
+              <a:t>One task. You review it.</a:t>
             </a:r>
             <a:endParaRPr lang="en-US" sz="2800" dirty="0"/>
           </a:p>
@@ -4483,46 +4348,7 @@
         <p:spPr>
           <a:xfrm>
             <a:off x="502920" y="1783080"/>
-            <a:ext cx="11155680" cy="502920"/>
-          </a:xfrm>
-          <a:prstGeom prst="rect">
-            <a:avLst/>
-          </a:prstGeom>
-          <a:noFill/>
-          <a:ln/>
-        </p:spPr>
-        <p:txBody>
-          <a:bodyPr wrap="square" rtlCol="0" anchor="ctr"/>
-          <a:lstStyle/>
-          <a:p>
-            <a:pPr indent="0" marL="0">
-              <a:buNone/>
-            </a:pPr>
-            <a:r>
-              <a:rPr lang="en-US" sz="1500" dirty="0">
-                <a:solidFill>
-                  <a:srgbClr val="555555"/>
-                </a:solidFill>
-                <a:latin typeface="Arial" pitchFamily="34" charset="0"/>
-                <a:ea typeface="Arial" pitchFamily="34" charset="-122"/>
-                <a:cs typeface="Arial" pitchFamily="34" charset="-120"/>
-              </a:rPr>
-              <a:t>Use Copilot Chat in VS Code. Don't ask it to “make the whole site better.”</a:t>
-            </a:r>
-            <a:endParaRPr lang="en-US" sz="1500" dirty="0"/>
-          </a:p>
-        </p:txBody>
-      </p:sp>
-      <p:sp>
-        <p:nvSpPr>
-          <p:cNvPr id="9" name="Text 7"/>
-          <p:cNvSpPr/>
-          <p:nvPr/>
-        </p:nvSpPr>
-        <p:spPr>
-          <a:xfrm>
-            <a:off x="502920" y="2377440"/>
-            <a:ext cx="11155680" cy="1225296"/>
+            <a:ext cx="11155680" cy="2267712"/>
           </a:xfrm>
           <a:prstGeom prst="rect">
             <a:avLst/>
@@ -4547,7 +4373,7 @@
                 <a:ea typeface="Arial" pitchFamily="34" charset="-122"/>
                 <a:cs typeface="Arial" pitchFamily="34" charset="-120"/>
               </a:rPr>
-              <a:t>Check the result: Generated code, claims, links, and accessibility can all be wrong.</a:t>
+              <a:t>Ask it to explain first no edits yet</a:t>
             </a:r>
             <a:endParaRPr lang="en-US" sz="1500" dirty="0"/>
           </a:p>
@@ -4565,7 +4391,7 @@
                 <a:ea typeface="Arial" pitchFamily="34" charset="-122"/>
                 <a:cs typeface="Arial" pitchFamily="34" charset="-120"/>
               </a:rPr>
-              <a:t>Know what changed: You should be able to explain and maintain the code you submit.</a:t>
+              <a:t>Then ask for one change in profile.js</a:t>
             </a:r>
             <a:endParaRPr lang="en-US" sz="1500" dirty="0"/>
           </a:p>
@@ -4583,65 +4409,17 @@
                 <a:ea typeface="Arial" pitchFamily="34" charset="-122"/>
                 <a:cs typeface="Arial" pitchFamily="34" charset="-120"/>
               </a:rPr>
-              <a:t>Ask the room: What is one thing you would refuse to paste into Copilot Chat?</a:t>
+              <a:t>Read every line you are responsible for it</a:t>
             </a:r>
             <a:endParaRPr lang="en-US" sz="1500" dirty="0"/>
           </a:p>
-        </p:txBody>
-      </p:sp>
-      <p:sp>
-        <p:nvSpPr>
-          <p:cNvPr id="10" name="Shape 8"/>
-          <p:cNvSpPr/>
-          <p:nvPr/>
-        </p:nvSpPr>
-        <p:spPr>
-          <a:xfrm>
-            <a:off x="502920" y="3739896"/>
-            <a:ext cx="11155680" cy="640080"/>
-          </a:xfrm>
-          <a:prstGeom prst="roundRect">
-            <a:avLst>
-              <a:gd name="adj" fmla="val 8571"/>
-            </a:avLst>
-          </a:prstGeom>
-          <a:solidFill>
-            <a:srgbClr val="FFF8CC"/>
-          </a:solidFill>
-          <a:ln w="12700">
-            <a:solidFill>
-              <a:srgbClr val="FFDB00"/>
-            </a:solidFill>
-            <a:prstDash val="solid"/>
-          </a:ln>
-        </p:spPr>
-      </p:sp>
-      <p:sp>
-        <p:nvSpPr>
-          <p:cNvPr id="11" name="Text 9"/>
-          <p:cNvSpPr/>
-          <p:nvPr/>
-        </p:nvSpPr>
-        <p:spPr>
-          <a:xfrm>
-            <a:off x="640080" y="3849624"/>
-            <a:ext cx="10881360" cy="438912"/>
-          </a:xfrm>
-          <a:prstGeom prst="rect">
-            <a:avLst/>
-          </a:prstGeom>
-          <a:noFill/>
-          <a:ln/>
-        </p:spPr>
-        <p:txBody>
-          <a:bodyPr wrap="square" rtlCol="0" anchor="ctr"/>
-          <a:lstStyle/>
-          <a:p>
-            <a:pPr indent="0" marL="0">
-              <a:buNone/>
-            </a:pPr>
-            <a:r>
-              <a:rPr lang="en-US" sz="1300" b="1" dirty="0">
+          <a:p>
+            <a:pPr marL="342900" indent="-342900">
+              <a:buSzPct val="100000"/>
+              <a:buChar char="•"/>
+            </a:pPr>
+            <a:r>
+              <a:rPr lang="en-US" sz="1500" dirty="0">
                 <a:solidFill>
                   <a:srgbClr val="1A1A1A"/>
                 </a:solidFill>
@@ -4649,15 +4427,51 @@
                 <a:ea typeface="Arial" pitchFamily="34" charset="-122"/>
                 <a:cs typeface="Arial" pitchFamily="34" charset="-120"/>
               </a:rPr>
-              <a:t>Ask the room: What is one thing you would refuse to paste into Copilot Chat?</a:t>
-            </a:r>
-            <a:endParaRPr lang="en-US" sz="1300" dirty="0"/>
-          </a:p>
-        </p:txBody>
-      </p:sp>
-      <p:sp>
-        <p:nvSpPr>
-          <p:cNvPr id="12" name="Shape 10"/>
+              <a:t>Ask it to explain first: no edits yet</a:t>
+            </a:r>
+            <a:endParaRPr lang="en-US" sz="1500" dirty="0"/>
+          </a:p>
+          <a:p>
+            <a:pPr marL="342900" indent="-342900">
+              <a:buSzPct val="100000"/>
+              <a:buChar char="•"/>
+            </a:pPr>
+            <a:r>
+              <a:rPr lang="en-US" sz="1500" dirty="0">
+                <a:solidFill>
+                  <a:srgbClr val="1A1A1A"/>
+                </a:solidFill>
+                <a:latin typeface="Arial" pitchFamily="34" charset="0"/>
+                <a:ea typeface="Arial" pitchFamily="34" charset="-122"/>
+                <a:cs typeface="Arial" pitchFamily="34" charset="-120"/>
+              </a:rPr>
+              <a:t>Then ask for one change: in profile.js</a:t>
+            </a:r>
+            <a:endParaRPr lang="en-US" sz="1500" dirty="0"/>
+          </a:p>
+          <a:p>
+            <a:pPr marL="342900" indent="-342900">
+              <a:buSzPct val="100000"/>
+              <a:buChar char="•"/>
+            </a:pPr>
+            <a:r>
+              <a:rPr lang="en-US" sz="1500" dirty="0">
+                <a:solidFill>
+                  <a:srgbClr val="1A1A1A"/>
+                </a:solidFill>
+                <a:latin typeface="Arial" pitchFamily="34" charset="0"/>
+                <a:ea typeface="Arial" pitchFamily="34" charset="-122"/>
+                <a:cs typeface="Arial" pitchFamily="34" charset="-120"/>
+              </a:rPr>
+              <a:t>Read every line: you are responsible for it</a:t>
+            </a:r>
+            <a:endParaRPr lang="en-US" sz="1500" dirty="0"/>
+          </a:p>
+        </p:txBody>
+      </p:sp>
+      <p:sp>
+        <p:nvSpPr>
+          <p:cNvPr id="9" name="Shape 7"/>
           <p:cNvSpPr/>
           <p:nvPr/>
         </p:nvSpPr>
@@ -4682,7 +4496,7 @@
       </p:sp>
       <p:sp>
         <p:nvSpPr>
-          <p:cNvPr id="13" name="Text 11"/>
+          <p:cNvPr id="10" name="Text 8"/>
           <p:cNvSpPr/>
           <p:nvPr/>
         </p:nvSpPr>
@@ -4713,7 +4527,7 @@
                 <a:ea typeface="Arial" pitchFamily="34" charset="-122"/>
                 <a:cs typeface="Arial" pitchFamily="34" charset="-120"/>
               </a:rPr>
-              <a:t>COPILOT SUGGESTS CHANGES. YOU REVIEW THEM. · DESCRIBE ONE TASK PER REQUEST</a:t>
+              <a:t>ARROWS ON THE WEB DECK · R FOR RESOURCES · N FOR NOTES</a:t>
             </a:r>
             <a:endParaRPr lang="en-US" sz="1100" dirty="0"/>
           </a:p>
@@ -4905,7 +4719,7 @@
                 <a:ea typeface="Arial" pitchFamily="34" charset="-122"/>
                 <a:cs typeface="Arial" pitchFamily="34" charset="-120"/>
               </a:rPr>
-              <a:t>CHECK THE RESULT BEFORE OPENING A PULL REQUEST</a:t>
+              <a:t>CHECK LOCALLY</a:t>
             </a:r>
             <a:endParaRPr lang="en-US" sz="1200" dirty="0"/>
           </a:p>
@@ -4944,7 +4758,7 @@
                 <a:ea typeface="Arial" pitchFamily="34" charset="-122"/>
                 <a:cs typeface="Arial" pitchFamily="34" charset="-120"/>
               </a:rPr>
-              <a:t>Read the diff and test your change before asking for review.</a:t>
+              <a:t>Before the pull request.</a:t>
             </a:r>
             <a:endParaRPr lang="en-US" sz="2800" dirty="0"/>
           </a:p>
@@ -4959,45 +4773,6 @@
         <p:spPr>
           <a:xfrm>
             <a:off x="502920" y="1783080"/>
-            <a:ext cx="11155680" cy="502920"/>
-          </a:xfrm>
-          <a:prstGeom prst="rect">
-            <a:avLst/>
-          </a:prstGeom>
-          <a:noFill/>
-          <a:ln/>
-        </p:spPr>
-        <p:txBody>
-          <a:bodyPr wrap="square" rtlCol="0" anchor="ctr"/>
-          <a:lstStyle/>
-          <a:p>
-            <a:pPr indent="0" marL="0">
-              <a:buNone/>
-            </a:pPr>
-            <a:r>
-              <a:rPr lang="en-US" sz="1500" dirty="0">
-                <a:solidFill>
-                  <a:srgbClr val="555555"/>
-                </a:solidFill>
-                <a:latin typeface="Arial" pitchFamily="34" charset="0"/>
-                <a:ea typeface="Arial" pitchFamily="34" charset="-122"/>
-                <a:cs typeface="Arial" pitchFamily="34" charset="-120"/>
-              </a:rPr>
-              <a:t>Use the same checks every time, even when the code was written with AI assistance.</a:t>
-            </a:r>
-            <a:endParaRPr lang="en-US" sz="1500" dirty="0"/>
-          </a:p>
-        </p:txBody>
-      </p:sp>
-      <p:sp>
-        <p:nvSpPr>
-          <p:cNvPr id="9" name="Text 7"/>
-          <p:cNvSpPr/>
-          <p:nvPr/>
-        </p:nvSpPr>
-        <p:spPr>
-          <a:xfrm>
-            <a:off x="502920" y="2377440"/>
             <a:ext cx="11155680" cy="1225296"/>
           </a:xfrm>
           <a:prstGeom prst="rect">
@@ -5023,7 +4798,7 @@
                 <a:ea typeface="Arial" pitchFamily="34" charset="-122"/>
                 <a:cs typeface="Arial" pitchFamily="34" charset="-120"/>
               </a:rPr>
-              <a:t>Expected result: Build completes without an error. Diff contains only the intended change.</a:t>
+              <a:t>Diff shows only the intended files</a:t>
             </a:r>
             <a:endParaRPr lang="en-US" sz="1500" dirty="0"/>
           </a:p>
@@ -5041,7 +4816,7 @@
                 <a:ea typeface="Arial" pitchFamily="34" charset="-122"/>
                 <a:cs typeface="Arial" pitchFamily="34" charset="-120"/>
               </a:rPr>
-              <a:t>Ask: Can you explain your diff in one sentence before opening a PR?</a:t>
+              <a:t>Localhost looks right on a narrow window</a:t>
             </a:r>
             <a:endParaRPr lang="en-US" sz="1500" dirty="0"/>
           </a:p>
@@ -5059,7 +4834,7 @@
                 <a:ea typeface="Arial" pitchFamily="34" charset="-122"/>
                 <a:cs typeface="Arial" pitchFamily="34" charset="-120"/>
               </a:rPr>
-              <a:t>git status git diff --check git diff npm run build</a:t>
+              <a:t>You can explain the change in one sentence</a:t>
             </a:r>
             <a:endParaRPr lang="en-US" sz="1500" dirty="0"/>
           </a:p>
@@ -5067,7 +4842,7 @@
       </p:sp>
       <p:sp>
         <p:nvSpPr>
-          <p:cNvPr id="10" name="Shape 8"/>
+          <p:cNvPr id="9" name="Shape 7"/>
           <p:cNvSpPr/>
           <p:nvPr/>
         </p:nvSpPr>
@@ -5092,7 +4867,7 @@
       </p:sp>
       <p:sp>
         <p:nvSpPr>
-          <p:cNvPr id="11" name="Text 9"/>
+          <p:cNvPr id="10" name="Text 8"/>
           <p:cNvSpPr/>
           <p:nvPr/>
         </p:nvSpPr>
@@ -5123,7 +4898,7 @@
                 <a:ea typeface="Arial" pitchFamily="34" charset="-122"/>
                 <a:cs typeface="Arial" pitchFamily="34" charset="-120"/>
               </a:rPr>
-              <a:t>TEST LOCALLY BEFORE PUSHING · FIX THE SMALLEST CAUSE</a:t>
+              <a:t>ARROWS ON THE WEB DECK · R FOR RESOURCES · N FOR NOTES</a:t>
             </a:r>
             <a:endParaRPr lang="en-US" sz="1100" dirty="0"/>
           </a:p>
@@ -5315,7 +5090,7 @@
                 <a:ea typeface="Arial" pitchFamily="34" charset="-122"/>
                 <a:cs typeface="Arial" pitchFamily="34" charset="-120"/>
               </a:rPr>
-              <a:t>REVIEW THE CHANGE ON GITHUB</a:t>
+              <a:t>GITHUB</a:t>
             </a:r>
             <a:endParaRPr lang="en-US" sz="1200" dirty="0"/>
           </a:p>
@@ -5354,7 +5129,7 @@
                 <a:ea typeface="Arial" pitchFamily="34" charset="-122"/>
                 <a:cs typeface="Arial" pitchFamily="34" charset="-120"/>
               </a:rPr>
-              <a:t>Check the diff and acceptance criteria before merging.</a:t>
+              <a:t>Open the pull request. Read Files changed.</a:t>
             </a:r>
             <a:endParaRPr lang="en-US" sz="2800" dirty="0"/>
           </a:p>
@@ -5369,46 +5144,7 @@
         <p:spPr>
           <a:xfrm>
             <a:off x="502920" y="1783080"/>
-            <a:ext cx="11155680" cy="502920"/>
-          </a:xfrm>
-          <a:prstGeom prst="rect">
-            <a:avLst/>
-          </a:prstGeom>
-          <a:noFill/>
-          <a:ln/>
-        </p:spPr>
-        <p:txBody>
-          <a:bodyPr wrap="square" rtlCol="0" anchor="ctr"/>
-          <a:lstStyle/>
-          <a:p>
-            <a:pPr indent="0" marL="0">
-              <a:buNone/>
-            </a:pPr>
-            <a:r>
-              <a:rPr lang="en-US" sz="1500" dirty="0">
-                <a:solidFill>
-                  <a:srgbClr val="555555"/>
-                </a:solidFill>
-                <a:latin typeface="Arial" pitchFamily="34" charset="0"/>
-                <a:ea typeface="Arial" pitchFamily="34" charset="-122"/>
-                <a:cs typeface="Arial" pitchFamily="34" charset="-120"/>
-              </a:rPr>
-              <a:t>After Publish Branch in VS Code, open GitHub in your browser.</a:t>
-            </a:r>
-            <a:endParaRPr lang="en-US" sz="1500" dirty="0"/>
-          </a:p>
-        </p:txBody>
-      </p:sp>
-      <p:sp>
-        <p:nvSpPr>
-          <p:cNvPr id="9" name="Text 7"/>
-          <p:cNvSpPr/>
-          <p:nvPr/>
-        </p:nvSpPr>
-        <p:spPr>
-          <a:xfrm>
-            <a:off x="502920" y="2377440"/>
-            <a:ext cx="11155680" cy="877824"/>
+            <a:ext cx="11155680" cy="1572768"/>
           </a:xfrm>
           <a:prstGeom prst="rect">
             <a:avLst/>
@@ -5433,7 +5169,7 @@
                 <a:ea typeface="Arial" pitchFamily="34" charset="-122"/>
                 <a:cs typeface="Arial" pitchFamily="34" charset="-120"/>
               </a:rPr>
-              <a:t>Open and review a pull request</a:t>
+              <a:t>Compare &amp; pull request</a:t>
             </a:r>
             <a:endParaRPr lang="en-US" sz="1500" dirty="0"/>
           </a:p>
@@ -5451,65 +5187,17 @@
                 <a:ea typeface="Arial" pitchFamily="34" charset="-122"/>
                 <a:cs typeface="Arial" pitchFamily="34" charset="-120"/>
               </a:rPr>
-              <a:t>See the live web deck for full layout and screenshots.</a:t>
+              <a:t>base: main · compare: your branch</a:t>
             </a:r>
             <a:endParaRPr lang="en-US" sz="1500" dirty="0"/>
           </a:p>
-        </p:txBody>
-      </p:sp>
-      <p:sp>
-        <p:nvSpPr>
-          <p:cNvPr id="10" name="Shape 8"/>
-          <p:cNvSpPr/>
-          <p:nvPr/>
-        </p:nvSpPr>
-        <p:spPr>
-          <a:xfrm>
-            <a:off x="502920" y="3392424"/>
-            <a:ext cx="11155680" cy="640080"/>
-          </a:xfrm>
-          <a:prstGeom prst="roundRect">
-            <a:avLst>
-              <a:gd name="adj" fmla="val 8571"/>
-            </a:avLst>
-          </a:prstGeom>
-          <a:solidFill>
-            <a:srgbClr val="FFF8CC"/>
-          </a:solidFill>
-          <a:ln w="12700">
-            <a:solidFill>
-              <a:srgbClr val="FFDB00"/>
-            </a:solidFill>
-            <a:prstDash val="solid"/>
-          </a:ln>
-        </p:spPr>
-      </p:sp>
-      <p:sp>
-        <p:nvSpPr>
-          <p:cNvPr id="11" name="Text 9"/>
-          <p:cNvSpPr/>
-          <p:nvPr/>
-        </p:nvSpPr>
-        <p:spPr>
-          <a:xfrm>
-            <a:off x="640080" y="3502152"/>
-            <a:ext cx="10881360" cy="438912"/>
-          </a:xfrm>
-          <a:prstGeom prst="rect">
-            <a:avLst/>
-          </a:prstGeom>
-          <a:noFill/>
-          <a:ln/>
-        </p:spPr>
-        <p:txBody>
-          <a:bodyPr wrap="square" rtlCol="0" anchor="ctr"/>
-          <a:lstStyle/>
-          <a:p>
-            <a:pPr indent="0" marL="0">
-              <a:buNone/>
-            </a:pPr>
-            <a:r>
-              <a:rPr lang="en-US" sz="1300" b="1" dirty="0">
+          <a:p>
+            <a:pPr marL="342900" indent="-342900">
+              <a:buSzPct val="100000"/>
+              <a:buChar char="•"/>
+            </a:pPr>
+            <a:r>
+              <a:rPr lang="en-US" sz="1500" dirty="0">
                 <a:solidFill>
                   <a:srgbClr val="1A1A1A"/>
                 </a:solidFill>
@@ -5517,15 +5205,33 @@
                 <a:ea typeface="Arial" pitchFamily="34" charset="-122"/>
                 <a:cs typeface="Arial" pitchFamily="34" charset="-120"/>
               </a:rPr>
-              <a:t>Ask the room: What is one reason you would not merge a classmate’s pull request yet?</a:t>
-            </a:r>
-            <a:endParaRPr lang="en-US" sz="1300" dirty="0"/>
-          </a:p>
-        </p:txBody>
-      </p:sp>
-      <p:sp>
-        <p:nvSpPr>
-          <p:cNvPr id="12" name="Shape 10"/>
+              <a:t>Files changed · match the issue?</a:t>
+            </a:r>
+            <a:endParaRPr lang="en-US" sz="1500" dirty="0"/>
+          </a:p>
+          <a:p>
+            <a:pPr marL="342900" indent="-342900">
+              <a:buSzPct val="100000"/>
+              <a:buChar char="•"/>
+            </a:pPr>
+            <a:r>
+              <a:rPr lang="en-US" sz="1500" dirty="0">
+                <a:solidFill>
+                  <a:srgbClr val="1A1A1A"/>
+                </a:solidFill>
+                <a:latin typeface="Arial" pitchFamily="34" charset="0"/>
+                <a:ea typeface="Arial" pitchFamily="34" charset="-122"/>
+                <a:cs typeface="Arial" pitchFamily="34" charset="-120"/>
+              </a:rPr>
+              <a:t>Merge when it is correct</a:t>
+            </a:r>
+            <a:endParaRPr lang="en-US" sz="1500" dirty="0"/>
+          </a:p>
+        </p:txBody>
+      </p:sp>
+      <p:sp>
+        <p:nvSpPr>
+          <p:cNvPr id="9" name="Shape 7"/>
           <p:cNvSpPr/>
           <p:nvPr/>
         </p:nvSpPr>
@@ -5550,7 +5256,7 @@
       </p:sp>
       <p:sp>
         <p:nvSpPr>
-          <p:cNvPr id="13" name="Text 11"/>
+          <p:cNvPr id="10" name="Text 8"/>
           <p:cNvSpPr/>
           <p:nvPr/>
         </p:nvSpPr>
@@ -5581,7 +5287,7 @@
                 <a:ea typeface="Arial" pitchFamily="34" charset="-122"/>
                 <a:cs typeface="Arial" pitchFamily="34" charset="-120"/>
               </a:rPr>
-              <a:t>BRANCH → PULL REQUEST → REVIEW → MERGE · CHECK THE FILES CHANGED TAB</a:t>
+              <a:t>ARROWS ON THE WEB DECK · R FOR RESOURCES · N FOR NOTES</a:t>
             </a:r>
             <a:endParaRPr lang="en-US" sz="1100" dirty="0"/>
           </a:p>
@@ -5773,7 +5479,7 @@
                 <a:ea typeface="Arial" pitchFamily="34" charset="-122"/>
                 <a:cs typeface="Arial" pitchFamily="34" charset="-120"/>
               </a:rPr>
-              <a:t>PUBLISH THE BUILT SITE</a:t>
+              <a:t>LIVE SITE</a:t>
             </a:r>
             <a:endParaRPr lang="en-US" sz="1200" dirty="0"/>
           </a:p>
@@ -5812,7 +5518,7 @@
                 <a:ea typeface="Arial" pitchFamily="34" charset="-122"/>
                 <a:cs typeface="Arial" pitchFamily="34" charset="-120"/>
               </a:rPr>
-              <a:t>Merge to main → Actions → open the live URL.</a:t>
+              <a:t>Merge to main. Open the URL.</a:t>
             </a:r>
             <a:endParaRPr lang="en-US" sz="2800" dirty="0"/>
           </a:p>
@@ -5827,46 +5533,7 @@
         <p:spPr>
           <a:xfrm>
             <a:off x="502920" y="1783080"/>
-            <a:ext cx="11155680" cy="502920"/>
-          </a:xfrm>
-          <a:prstGeom prst="rect">
-            <a:avLst/>
-          </a:prstGeom>
-          <a:noFill/>
-          <a:ln/>
-        </p:spPr>
-        <p:txBody>
-          <a:bodyPr wrap="square" rtlCol="0" anchor="ctr"/>
-          <a:lstStyle/>
-          <a:p>
-            <a:pPr indent="0" marL="0">
-              <a:buNone/>
-            </a:pPr>
-            <a:r>
-              <a:rPr lang="en-US" sz="1500" dirty="0">
-                <a:solidFill>
-                  <a:srgbClr val="555555"/>
-                </a:solidFill>
-                <a:latin typeface="Arial" pitchFamily="34" charset="0"/>
-                <a:ea typeface="Arial" pitchFamily="34" charset="-122"/>
-                <a:cs typeface="Arial" pitchFamily="34" charset="-120"/>
-              </a:rPr>
-              <a:t>Set Pages source to GitHub Actions . A green workflow is not enough — open the real URL.</a:t>
-            </a:r>
-            <a:endParaRPr lang="en-US" sz="1500" dirty="0"/>
-          </a:p>
-        </p:txBody>
-      </p:sp>
-      <p:sp>
-        <p:nvSpPr>
-          <p:cNvPr id="9" name="Text 7"/>
-          <p:cNvSpPr/>
-          <p:nvPr/>
-        </p:nvSpPr>
-        <p:spPr>
-          <a:xfrm>
-            <a:off x="502920" y="2377440"/>
-            <a:ext cx="11155680" cy="2615184"/>
+            <a:ext cx="11155680" cy="1225296"/>
           </a:xfrm>
           <a:prstGeom prst="rect">
             <a:avLst/>
@@ -5891,7 +5558,7 @@
                 <a:ea typeface="Arial" pitchFamily="34" charset="-122"/>
                 <a:cs typeface="Arial" pitchFamily="34" charset="-120"/>
               </a:rPr>
-              <a:t>Open Actions .</a:t>
+              <a:t>Settings → Pages · Source = GitHub Actions</a:t>
             </a:r>
             <a:endParaRPr lang="en-US" sz="1500" dirty="0"/>
           </a:p>
@@ -5909,7 +5576,7 @@
                 <a:ea typeface="Arial" pitchFamily="34" charset="-122"/>
                 <a:cs typeface="Arial" pitchFamily="34" charset="-120"/>
               </a:rPr>
-              <a:t>Open the latest run.</a:t>
+              <a:t>Actions · wait for green (Re-run if needed)</a:t>
             </a:r>
             <a:endParaRPr lang="en-US" sz="1500" dirty="0"/>
           </a:p>
@@ -5927,87 +5594,15 @@
                 <a:ea typeface="Arial" pitchFamily="34" charset="-122"/>
                 <a:cs typeface="Arial" pitchFamily="34" charset="-120"/>
               </a:rPr>
-              <a:t>Confirm success or read the first failed step.</a:t>
+              <a:t>Visit site · test the real URL</a:t>
             </a:r>
             <a:endParaRPr lang="en-US" sz="1500" dirty="0"/>
           </a:p>
-          <a:p>
-            <a:pPr marL="342900" indent="-342900">
-              <a:buSzPct val="100000"/>
-              <a:buChar char="•"/>
-            </a:pPr>
-            <a:r>
-              <a:rPr lang="en-US" sz="1500" dirty="0">
-                <a:solidFill>
-                  <a:srgbClr val="1A1A1A"/>
-                </a:solidFill>
-                <a:latin typeface="Arial" pitchFamily="34" charset="0"/>
-                <a:ea typeface="Arial" pitchFamily="34" charset="-122"/>
-                <a:cs typeface="Arial" pitchFamily="34" charset="-120"/>
-              </a:rPr>
-              <a:t>Open the deployed URL and test it.</a:t>
-            </a:r>
-            <a:endParaRPr lang="en-US" sz="1500" dirty="0"/>
-          </a:p>
-          <a:p>
-            <a:pPr marL="342900" indent="-342900">
-              <a:buSzPct val="100000"/>
-              <a:buChar char="•"/>
-            </a:pPr>
-            <a:r>
-              <a:rPr lang="en-US" sz="1500" dirty="0">
-                <a:solidFill>
-                  <a:srgbClr val="1A1A1A"/>
-                </a:solidFill>
-                <a:latin typeface="Arial" pitchFamily="34" charset="0"/>
-                <a:ea typeface="Arial" pitchFamily="34" charset="-122"/>
-                <a:cs typeface="Arial" pitchFamily="34" charset="-120"/>
-              </a:rPr>
-              <a:t>Actions runs: npm install npm run build Uploads dist/</a:t>
-            </a:r>
-            <a:endParaRPr lang="en-US" sz="1500" dirty="0"/>
-          </a:p>
-          <a:p>
-            <a:pPr marL="342900" indent="-342900">
-              <a:buSzPct val="100000"/>
-              <a:buChar char="•"/>
-            </a:pPr>
-            <a:r>
-              <a:rPr lang="en-US" sz="1500" dirty="0">
-                <a:solidFill>
-                  <a:srgbClr val="1A1A1A"/>
-                </a:solidFill>
-                <a:latin typeface="Arial" pitchFamily="34" charset="0"/>
-                <a:ea typeface="Arial" pitchFamily="34" charset="-122"/>
-                <a:cs typeface="Arial" pitchFamily="34" charset="-120"/>
-              </a:rPr>
-              <a:t>Pages deploys: Static output goes live.</a:t>
-            </a:r>
-            <a:endParaRPr lang="en-US" sz="1500" dirty="0"/>
-          </a:p>
-          <a:p>
-            <a:pPr marL="342900" indent="-342900">
-              <a:buSzPct val="100000"/>
-              <a:buChar char="•"/>
-            </a:pPr>
-            <a:r>
-              <a:rPr lang="en-US" sz="1500" dirty="0">
-                <a:solidFill>
-                  <a:srgbClr val="1A1A1A"/>
-                </a:solidFill>
-                <a:latin typeface="Arial" pitchFamily="34" charset="0"/>
-                <a:ea typeface="Arial" pitchFamily="34" charset="-122"/>
-                <a:cs typeface="Arial" pitchFamily="34" charset="-120"/>
-              </a:rPr>
-              <a:t>Verify URL: Test content, links, assets.</a:t>
-            </a:r>
-            <a:endParaRPr lang="en-US" sz="1500" dirty="0"/>
-          </a:p>
-        </p:txBody>
-      </p:sp>
-      <p:sp>
-        <p:nvSpPr>
-          <p:cNvPr id="10" name="Shape 8"/>
+        </p:txBody>
+      </p:sp>
+      <p:sp>
+        <p:nvSpPr>
+          <p:cNvPr id="9" name="Shape 7"/>
           <p:cNvSpPr/>
           <p:nvPr/>
         </p:nvSpPr>
@@ -6032,7 +5627,7 @@
       </p:sp>
       <p:sp>
         <p:nvSpPr>
-          <p:cNvPr id="11" name="Text 9"/>
+          <p:cNvPr id="10" name="Text 8"/>
           <p:cNvSpPr/>
           <p:nvPr/>
         </p:nvSpPr>
@@ -6063,7 +5658,7 @@
                 <a:ea typeface="Arial" pitchFamily="34" charset="-122"/>
                 <a:cs typeface="Arial" pitchFamily="34" charset="-120"/>
               </a:rPr>
-              <a:t>MAIN → ACTIONS → PAGES · TEST THE REAL URL</a:t>
+              <a:t>ARROWS ON THE WEB DECK · R FOR RESOURCES · N FOR NOTES</a:t>
             </a:r>
             <a:endParaRPr lang="en-US" sz="1100" dirty="0"/>
           </a:p>
@@ -6255,7 +5850,7 @@
                 <a:ea typeface="Arial" pitchFamily="34" charset="-122"/>
                 <a:cs typeface="Arial" pitchFamily="34" charset="-120"/>
               </a:rPr>
-              <a:t>FIND THE STEP THAT FAILED</a:t>
+              <a:t>TROUBLESHOOTING</a:t>
             </a:r>
             <a:endParaRPr lang="en-US" sz="1200" dirty="0"/>
           </a:p>
@@ -6294,7 +5889,7 @@
                 <a:ea typeface="Arial" pitchFamily="34" charset="-122"/>
                 <a:cs typeface="Arial" pitchFamily="34" charset="-120"/>
               </a:rPr>
-              <a:t>Find the failing step before changing anything.</a:t>
+              <a:t>Read the error. Fix one thing.</a:t>
             </a:r>
             <a:endParaRPr lang="en-US" sz="2800" dirty="0"/>
           </a:p>
@@ -6309,46 +5904,7 @@
         <p:spPr>
           <a:xfrm>
             <a:off x="502920" y="1783080"/>
-            <a:ext cx="11155680" cy="502920"/>
-          </a:xfrm>
-          <a:prstGeom prst="rect">
-            <a:avLst/>
-          </a:prstGeom>
-          <a:noFill/>
-          <a:ln/>
-        </p:spPr>
-        <p:txBody>
-          <a:bodyPr wrap="square" rtlCol="0" anchor="ctr"/>
-          <a:lstStyle/>
-          <a:p>
-            <a:pPr indent="0" marL="0">
-              <a:buNone/>
-            </a:pPr>
-            <a:r>
-              <a:rPr lang="en-US" sz="1500" dirty="0">
-                <a:solidFill>
-                  <a:srgbClr val="555555"/>
-                </a:solidFill>
-                <a:latin typeface="Arial" pitchFamily="34" charset="0"/>
-                <a:ea typeface="Arial" pitchFamily="34" charset="-122"/>
-                <a:cs typeface="Arial" pitchFamily="34" charset="-120"/>
-              </a:rPr>
-              <a:t>Start with the symptom, inspect evidence, and change one thing at a time.</a:t>
-            </a:r>
-            <a:endParaRPr lang="en-US" sz="1500" dirty="0"/>
-          </a:p>
-        </p:txBody>
-      </p:sp>
-      <p:sp>
-        <p:nvSpPr>
-          <p:cNvPr id="9" name="Text 7"/>
-          <p:cNvSpPr/>
-          <p:nvPr/>
-        </p:nvSpPr>
-        <p:spPr>
-          <a:xfrm>
-            <a:off x="502920" y="2377440"/>
-            <a:ext cx="11155680" cy="2962656"/>
+            <a:ext cx="11155680" cy="1572768"/>
           </a:xfrm>
           <a:prstGeom prst="rect">
             <a:avLst/>
@@ -6373,7 +5929,7 @@
                 <a:ea typeface="Arial" pitchFamily="34" charset="-122"/>
                 <a:cs typeface="Arial" pitchFamily="34" charset="-120"/>
               </a:rPr>
-              <a:t>“not a git repository”: Run pwd / inspect the folder. Move to the project root that contains package.json ; use git init only for a downloaded ZIP without Git.</a:t>
+              <a:t>Auth / password — browser sign-in or PAT, not your GitHub password</a:t>
             </a:r>
             <a:endParaRPr lang="en-US" sz="1500" dirty="0"/>
           </a:p>
@@ -6391,7 +5947,7 @@
                 <a:ea typeface="Arial" pitchFamily="34" charset="-122"/>
                 <a:cs typeface="Arial" pitchFamily="34" charset="-120"/>
               </a:rPr>
-              <a:t>Push asks for password / auth failed: Use browser sign-in, or a classic PAT with repo scope as the password — not the GitHub account password. See student guide Step 3.</a:t>
+              <a:t>Actions failed — open the log, fix the first real error</a:t>
             </a:r>
             <a:endParaRPr lang="en-US" sz="1500" dirty="0"/>
           </a:p>
@@ -6409,7 +5965,7 @@
                 <a:ea typeface="Arial" pitchFamily="34" charset="-122"/>
                 <a:cs typeface="Arial" pitchFamily="34" charset="-120"/>
               </a:rPr>
-              <a:t>Push rejected: Run git status and git remote -v . Stop and inspect why the remote differs; don't force push or blindly overwrite history.</a:t>
+              <a:t>404 on the site — Pages source set? Latest run green? Full project URL?</a:t>
             </a:r>
             <a:endParaRPr lang="en-US" sz="1500" dirty="0"/>
           </a:p>
@@ -6427,153 +5983,15 @@
                 <a:ea typeface="Arial" pitchFamily="34" charset="-122"/>
                 <a:cs typeface="Arial" pitchFamily="34" charset="-120"/>
               </a:rPr>
-              <a:t>Build failed in Actions: Open the failed job log and find the first useful error. Reproduce locally with npm run build ; fix the referenced file and push again.</a:t>
+              <a:t>Change missing — merged to main ? Hard refresh?</a:t>
             </a:r>
             <a:endParaRPr lang="en-US" sz="1500" dirty="0"/>
           </a:p>
-          <a:p>
-            <a:pPr marL="342900" indent="-342900">
-              <a:buSzPct val="100000"/>
-              <a:buChar char="•"/>
-            </a:pPr>
-            <a:r>
-              <a:rPr lang="en-US" sz="1500" dirty="0">
-                <a:solidFill>
-                  <a:srgbClr val="1A1A1A"/>
-                </a:solidFill>
-                <a:latin typeface="Arial" pitchFamily="34" charset="0"/>
-                <a:ea typeface="Arial" pitchFamily="34" charset="-122"/>
-                <a:cs typeface="Arial" pitchFamily="34" charset="-120"/>
-              </a:rPr>
-              <a:t>First Actions run failed: Confirm Settings → Pages → Source = GitHub Actions , then open the failed run and choose Re-run all jobs .</a:t>
-            </a:r>
-            <a:endParaRPr lang="en-US" sz="1500" dirty="0"/>
-          </a:p>
-          <a:p>
-            <a:pPr marL="342900" indent="-342900">
-              <a:buSzPct val="100000"/>
-              <a:buChar char="•"/>
-            </a:pPr>
-            <a:r>
-              <a:rPr lang="en-US" sz="1500" dirty="0">
-                <a:solidFill>
-                  <a:srgbClr val="1A1A1A"/>
-                </a:solidFill>
-                <a:latin typeface="Arial" pitchFamily="34" charset="0"/>
-                <a:ea typeface="Arial" pitchFamily="34" charset="-122"/>
-                <a:cs typeface="Arial" pitchFamily="34" charset="-120"/>
-              </a:rPr>
-              <a:t>Site URL returns 404: Check Settings → Pages, confirm the latest workflow succeeded, and use the full project URL including the repository path.</a:t>
-            </a:r>
-            <a:endParaRPr lang="en-US" sz="1500" dirty="0"/>
-          </a:p>
-          <a:p>
-            <a:pPr marL="342900" indent="-342900">
-              <a:buSzPct val="100000"/>
-              <a:buChar char="•"/>
-            </a:pPr>
-            <a:r>
-              <a:rPr lang="en-US" sz="1500" dirty="0">
-                <a:solidFill>
-                  <a:srgbClr val="1A1A1A"/>
-                </a:solidFill>
-                <a:latin typeface="Arial" pitchFamily="34" charset="0"/>
-                <a:ea typeface="Arial" pitchFamily="34" charset="-122"/>
-                <a:cs typeface="Arial" pitchFamily="34" charset="-120"/>
-              </a:rPr>
-              <a:t>HTML loads, styles/assets don't: Check the asset URL in browser dev tools and the Astro base path. A leading slash can point at the domain root rather than the project subpath.</a:t>
-            </a:r>
-            <a:endParaRPr lang="en-US" sz="1500" dirty="0"/>
-          </a:p>
-          <a:p>
-            <a:pPr marL="342900" indent="-342900">
-              <a:buSzPct val="100000"/>
-              <a:buChar char="•"/>
-            </a:pPr>
-            <a:r>
-              <a:rPr lang="en-US" sz="1500" dirty="0">
-                <a:solidFill>
-                  <a:srgbClr val="1A1A1A"/>
-                </a:solidFill>
-                <a:latin typeface="Arial" pitchFamily="34" charset="0"/>
-                <a:ea typeface="Arial" pitchFamily="34" charset="-122"/>
-                <a:cs typeface="Arial" pitchFamily="34" charset="-120"/>
-              </a:rPr>
-              <a:t>Latest change isn't visible: Confirm the PR was merged to main , the newest Actions run succeeded, the URL is correct, then hard refresh.</a:t>
-            </a:r>
-            <a:endParaRPr lang="en-US" sz="1500" dirty="0"/>
-          </a:p>
-        </p:txBody>
-      </p:sp>
-      <p:sp>
-        <p:nvSpPr>
-          <p:cNvPr id="10" name="Shape 8"/>
-          <p:cNvSpPr/>
-          <p:nvPr/>
-        </p:nvSpPr>
-        <p:spPr>
-          <a:xfrm>
-            <a:off x="502920" y="5074920"/>
-            <a:ext cx="11155680" cy="640080"/>
-          </a:xfrm>
-          <a:prstGeom prst="roundRect">
-            <a:avLst>
-              <a:gd name="adj" fmla="val 8571"/>
-            </a:avLst>
-          </a:prstGeom>
-          <a:solidFill>
-            <a:srgbClr val="FFF8CC"/>
-          </a:solidFill>
-          <a:ln w="12700">
-            <a:solidFill>
-              <a:srgbClr val="FFDB00"/>
-            </a:solidFill>
-            <a:prstDash val="solid"/>
-          </a:ln>
-        </p:spPr>
-      </p:sp>
-      <p:sp>
-        <p:nvSpPr>
-          <p:cNvPr id="11" name="Text 9"/>
-          <p:cNvSpPr/>
-          <p:nvPr/>
-        </p:nvSpPr>
-        <p:spPr>
-          <a:xfrm>
-            <a:off x="640080" y="5184648"/>
-            <a:ext cx="10881360" cy="438912"/>
-          </a:xfrm>
-          <a:prstGeom prst="rect">
-            <a:avLst/>
-          </a:prstGeom>
-          <a:noFill/>
-          <a:ln/>
-        </p:spPr>
-        <p:txBody>
-          <a:bodyPr wrap="square" rtlCol="0" anchor="ctr"/>
-          <a:lstStyle/>
-          <a:p>
-            <a:pPr indent="0" marL="0">
-              <a:buNone/>
-            </a:pPr>
-            <a:r>
-              <a:rPr lang="en-US" sz="1300" b="1" dirty="0">
-                <a:solidFill>
-                  <a:srgbClr val="1A1A1A"/>
-                </a:solidFill>
-                <a:latin typeface="Arial" pitchFamily="34" charset="0"/>
-                <a:ea typeface="Arial" pitchFamily="34" charset="-122"/>
-                <a:cs typeface="Arial" pitchFamily="34" charset="-120"/>
-              </a:rPr>
-              <a:t>Ask the room: Before changing anything: what is the exact error text or screenshot you would show a helper?</a:t>
-            </a:r>
-            <a:endParaRPr lang="en-US" sz="1300" dirty="0"/>
-          </a:p>
-        </p:txBody>
-      </p:sp>
-      <p:sp>
-        <p:nvSpPr>
-          <p:cNvPr id="12" name="Shape 10"/>
+        </p:txBody>
+      </p:sp>
+      <p:sp>
+        <p:nvSpPr>
+          <p:cNvPr id="9" name="Shape 7"/>
           <p:cNvSpPr/>
           <p:nvPr/>
         </p:nvSpPr>
@@ -6598,7 +6016,7 @@
       </p:sp>
       <p:sp>
         <p:nvSpPr>
-          <p:cNvPr id="13" name="Text 11"/>
+          <p:cNvPr id="10" name="Text 8"/>
           <p:cNvSpPr/>
           <p:nvPr/>
         </p:nvSpPr>
@@ -6629,7 +6047,7 @@
                 <a:ea typeface="Arial" pitchFamily="34" charset="-122"/>
                 <a:cs typeface="Arial" pitchFamily="34" charset="-120"/>
               </a:rPr>
-              <a:t>READ THE FIRST ERROR BEFORE CHANGING FILES · CHANGE ONE THING, THEN TEST AGAIN</a:t>
+              <a:t>ARROWS ON THE WEB DECK · R FOR RESOURCES · N FOR NOTES</a:t>
             </a:r>
             <a:endParaRPr lang="en-US" sz="1100" dirty="0"/>
           </a:p>
@@ -6821,7 +6239,7 @@
                 <a:ea typeface="Arial" pitchFamily="34" charset="-122"/>
                 <a:cs typeface="Arial" pitchFamily="34" charset="-120"/>
               </a:rPr>
-              <a:t>PRACTICE · 30 MINUTES</a:t>
+              <a:t>~30 MINUTES</a:t>
             </a:r>
             <a:endParaRPr lang="en-US" sz="1200" dirty="0"/>
           </a:p>
@@ -6860,7 +6278,7 @@
                 <a:ea typeface="Arial" pitchFamily="34" charset="-122"/>
                 <a:cs typeface="Arial" pitchFamily="34" charset="-120"/>
               </a:rPr>
-              <a:t>Implement the featured project issue.</a:t>
+              <a:t>Build the featured project change.</a:t>
             </a:r>
             <a:endParaRPr lang="en-US" sz="2800" dirty="0"/>
           </a:p>
@@ -6875,45 +6293,6 @@
         <p:spPr>
           <a:xfrm>
             <a:off x="502920" y="1783080"/>
-            <a:ext cx="11155680" cy="502920"/>
-          </a:xfrm>
-          <a:prstGeom prst="rect">
-            <a:avLst/>
-          </a:prstGeom>
-          <a:noFill/>
-          <a:ln/>
-        </p:spPr>
-        <p:txBody>
-          <a:bodyPr wrap="square" rtlCol="0" anchor="ctr"/>
-          <a:lstStyle/>
-          <a:p>
-            <a:pPr indent="0" marL="0">
-              <a:buNone/>
-            </a:pPr>
-            <a:r>
-              <a:rPr lang="en-US" sz="1500" dirty="0">
-                <a:solidFill>
-                  <a:srgbClr val="555555"/>
-                </a:solidFill>
-                <a:latin typeface="Arial" pitchFamily="34" charset="0"/>
-                <a:ea typeface="Arial" pitchFamily="34" charset="-122"/>
-                <a:cs typeface="Arial" pitchFamily="34" charset="-120"/>
-              </a:rPr>
-              <a:t>Keep this slide up while you work. Complete the steps in order; don't skip the review.</a:t>
-            </a:r>
-            <a:endParaRPr lang="en-US" sz="1500" dirty="0"/>
-          </a:p>
-        </p:txBody>
-      </p:sp>
-      <p:sp>
-        <p:nvSpPr>
-          <p:cNvPr id="9" name="Text 7"/>
-          <p:cNvSpPr/>
-          <p:nvPr/>
-        </p:nvSpPr>
-        <p:spPr>
-          <a:xfrm>
-            <a:off x="502920" y="2377440"/>
             <a:ext cx="11155680" cy="1572768"/>
           </a:xfrm>
           <a:prstGeom prst="rect">
@@ -6939,7 +6318,7 @@
                 <a:ea typeface="Arial" pitchFamily="34" charset="-122"/>
                 <a:cs typeface="Arial" pitchFamily="34" charset="-120"/>
               </a:rPr>
-              <a:t>Create the branch: Status Bar → branch name → Create new branch… → add-featured-project .</a:t>
+              <a:t>Issue with clear checks</a:t>
             </a:r>
             <a:endParaRPr lang="en-US" sz="1500" dirty="0"/>
           </a:p>
@@ -6957,7 +6336,7 @@
                 <a:ea typeface="Arial" pitchFamily="34" charset="-122"/>
                 <a:cs typeface="Arial" pitchFamily="34" charset="-120"/>
               </a:rPr>
-              <a:t>Edit + inspect: Update profile.js . Refresh localhost. In Source Control, open the diff.</a:t>
+              <a:t>Branch add-featured-project</a:t>
             </a:r>
             <a:endParaRPr lang="en-US" sz="1500" dirty="0"/>
           </a:p>
@@ -6975,7 +6354,7 @@
                 <a:ea typeface="Arial" pitchFamily="34" charset="-122"/>
                 <a:cs typeface="Arial" pitchFamily="34" charset="-120"/>
               </a:rPr>
-              <a:t>Commit + publish: Stage (+) → message → Commit → Publish Branch .</a:t>
+              <a:t>Edit · commit · publish</a:t>
             </a:r>
             <a:endParaRPr lang="en-US" sz="1500" dirty="0"/>
           </a:p>
@@ -6993,7 +6372,7 @@
                 <a:ea typeface="Arial" pitchFamily="34" charset="-122"/>
                 <a:cs typeface="Arial" pitchFamily="34" charset="-120"/>
               </a:rPr>
-              <a:t>Open the PR: GitHub → Compare &amp; pull request → Files changed → merge when ready.</a:t>
+              <a:t>PR · Files changed · merge</a:t>
             </a:r>
             <a:endParaRPr lang="en-US" sz="1500" dirty="0"/>
           </a:p>
@@ -7001,7 +6380,7 @@
       </p:sp>
       <p:sp>
         <p:nvSpPr>
-          <p:cNvPr id="10" name="Shape 8"/>
+          <p:cNvPr id="9" name="Shape 7"/>
           <p:cNvSpPr/>
           <p:nvPr/>
         </p:nvSpPr>
@@ -7026,7 +6405,7 @@
       </p:sp>
       <p:sp>
         <p:nvSpPr>
-          <p:cNvPr id="11" name="Text 9"/>
+          <p:cNvPr id="10" name="Text 8"/>
           <p:cNvSpPr/>
           <p:nvPr/>
         </p:nvSpPr>
@@ -7057,7 +6436,7 @@
                 <a:ea typeface="Arial" pitchFamily="34" charset="-122"/>
                 <a:cs typeface="Arial" pitchFamily="34" charset="-120"/>
               </a:rPr>
-              <a:t>WHEN ASKING FOR HELP, SHOW THE ERROR AND GIT STATUS · SHOW YOUR STATUS + DIFF</a:t>
+              <a:t>ARROWS ON THE WEB DECK · R FOR RESOURCES · N FOR NOTES</a:t>
             </a:r>
             <a:endParaRPr lang="en-US" sz="1100" dirty="0"/>
           </a:p>
@@ -7249,7 +6628,7 @@
                 <a:ea typeface="Arial" pitchFamily="34" charset="-122"/>
                 <a:cs typeface="Arial" pitchFamily="34" charset="-120"/>
               </a:rPr>
-              <a:t>SHOW YOUR WORK</a:t>
+              <a:t>CHECKPOINT</a:t>
             </a:r>
             <a:endParaRPr lang="en-US" sz="1200" dirty="0"/>
           </a:p>
@@ -7288,7 +6667,7 @@
                 <a:ea typeface="Arial" pitchFamily="34" charset="-122"/>
                 <a:cs typeface="Arial" pitchFamily="34" charset="-120"/>
               </a:rPr>
-              <a:t>Show what you changed and how you tested it.</a:t>
+              <a:t>Show four things.</a:t>
             </a:r>
             <a:endParaRPr lang="en-US" sz="2800" dirty="0"/>
           </a:p>
@@ -7303,46 +6682,7 @@
         <p:spPr>
           <a:xfrm>
             <a:off x="502920" y="1783080"/>
-            <a:ext cx="11155680" cy="502920"/>
-          </a:xfrm>
-          <a:prstGeom prst="rect">
-            <a:avLst/>
-          </a:prstGeom>
-          <a:noFill/>
-          <a:ln/>
-        </p:spPr>
-        <p:txBody>
-          <a:bodyPr wrap="square" rtlCol="0" anchor="ctr"/>
-          <a:lstStyle/>
-          <a:p>
-            <a:pPr indent="0" marL="0">
-              <a:buNone/>
-            </a:pPr>
-            <a:r>
-              <a:rPr lang="en-US" sz="1500" dirty="0">
-                <a:solidFill>
-                  <a:srgbClr val="555555"/>
-                </a:solidFill>
-                <a:latin typeface="Arial" pitchFamily="34" charset="0"/>
-                <a:ea typeface="Arial" pitchFamily="34" charset="-122"/>
-                <a:cs typeface="Arial" pitchFamily="34" charset="-120"/>
-              </a:rPr>
-              <a:t>You’re done when you can show the issue, the code change, the pull request, and the published page.</a:t>
-            </a:r>
-            <a:endParaRPr lang="en-US" sz="1500" dirty="0"/>
-          </a:p>
-        </p:txBody>
-      </p:sp>
-      <p:sp>
-        <p:nvSpPr>
-          <p:cNvPr id="9" name="Text 7"/>
-          <p:cNvSpPr/>
-          <p:nvPr/>
-        </p:nvSpPr>
-        <p:spPr>
-          <a:xfrm>
-            <a:off x="502920" y="2377440"/>
-            <a:ext cx="11155680" cy="2267712"/>
+            <a:ext cx="11155680" cy="1920240"/>
           </a:xfrm>
           <a:prstGeom prst="rect">
             <a:avLst/>
@@ -7367,7 +6707,7 @@
                 <a:ea typeface="Arial" pitchFamily="34" charset="-122"/>
                 <a:cs typeface="Arial" pitchFamily="34" charset="-120"/>
               </a:rPr>
-              <a:t>Task: Which issue did you implement? How does the result meet each criterion?</a:t>
+              <a:t>Issue</a:t>
             </a:r>
             <a:endParaRPr lang="en-US" sz="1500" dirty="0"/>
           </a:p>
@@ -7385,7 +6725,7 @@
                 <a:ea typeface="Arial" pitchFamily="34" charset="-122"/>
                 <a:cs typeface="Arial" pitchFamily="34" charset="-120"/>
               </a:rPr>
-              <a:t>Show the issue. 02 Code: Which file changed? Why was it the right file? What does the diff show?</a:t>
+              <a:t>Diff</a:t>
             </a:r>
             <a:endParaRPr lang="en-US" sz="1500" dirty="0"/>
           </a:p>
@@ -7403,7 +6743,7 @@
                 <a:ea typeface="Arial" pitchFamily="34" charset="-122"/>
                 <a:cs typeface="Arial" pitchFamily="34" charset="-120"/>
               </a:rPr>
-              <a:t>Show the file + diff. 03 History: What branch and commit hold the change? Why is the message useful?</a:t>
+              <a:t>Pull request</a:t>
             </a:r>
             <a:endParaRPr lang="en-US" sz="1500" dirty="0"/>
           </a:p>
@@ -7421,7 +6761,7 @@
                 <a:ea typeface="Arial" pitchFamily="34" charset="-122"/>
                 <a:cs typeface="Arial" pitchFamily="34" charset="-120"/>
               </a:rPr>
-              <a:t>Show git log . 04 Review: What did you test? What review feedback or acceptance check matters most?</a:t>
+              <a:t>Live URL or Actions status</a:t>
             </a:r>
             <a:endParaRPr lang="en-US" sz="1500" dirty="0"/>
           </a:p>
@@ -7439,33 +6779,15 @@
                 <a:ea typeface="Arial" pitchFamily="34" charset="-122"/>
                 <a:cs typeface="Arial" pitchFamily="34" charset="-120"/>
               </a:rPr>
-              <a:t>Show the PR. 05 Deployment: Did Actions succeed? Have you checked the actual published page, not just local preview?</a:t>
+              <a:t>Issue Diff Pull request Live URL: or Actions status</a:t>
             </a:r>
             <a:endParaRPr lang="en-US" sz="1500" dirty="0"/>
           </a:p>
-          <a:p>
-            <a:pPr marL="342900" indent="-342900">
-              <a:buSzPct val="100000"/>
-              <a:buChar char="•"/>
-            </a:pPr>
-            <a:r>
-              <a:rPr lang="en-US" sz="1500" dirty="0">
-                <a:solidFill>
-                  <a:srgbClr val="1A1A1A"/>
-                </a:solidFill>
-                <a:latin typeface="Arial" pitchFamily="34" charset="0"/>
-                <a:ea typeface="Arial" pitchFamily="34" charset="-122"/>
-                <a:cs typeface="Arial" pitchFamily="34" charset="-120"/>
-              </a:rPr>
-              <a:t>Show Actions + URL. Instructor check: Ask the student to explain one line changed by Copilot and one check they used to verify it.</a:t>
-            </a:r>
-            <a:endParaRPr lang="en-US" sz="1500" dirty="0"/>
-          </a:p>
-        </p:txBody>
-      </p:sp>
-      <p:sp>
-        <p:nvSpPr>
-          <p:cNvPr id="10" name="Shape 8"/>
+        </p:txBody>
+      </p:sp>
+      <p:sp>
+        <p:nvSpPr>
+          <p:cNvPr id="9" name="Shape 7"/>
           <p:cNvSpPr/>
           <p:nvPr/>
         </p:nvSpPr>
@@ -7490,7 +6812,7 @@
       </p:sp>
       <p:sp>
         <p:nvSpPr>
-          <p:cNvPr id="11" name="Text 9"/>
+          <p:cNvPr id="10" name="Text 8"/>
           <p:cNvSpPr/>
           <p:nvPr/>
         </p:nvSpPr>
@@ -7521,7 +6843,7 @@
                 <a:ea typeface="Arial" pitchFamily="34" charset="-122"/>
                 <a:cs typeface="Arial" pitchFamily="34" charset="-120"/>
               </a:rPr>
-              <a:t>SHOW THE ISSUE, DIFF, PULL REQUEST, AND LIVE URL · REVIEWED AND TESTED</a:t>
+              <a:t>ARROWS ON THE WEB DECK · R FOR RESOURCES · N FOR NOTES</a:t>
             </a:r>
             <a:endParaRPr lang="en-US" sz="1100" dirty="0"/>
           </a:p>
@@ -7713,7 +7035,7 @@
                 <a:ea typeface="Arial" pitchFamily="34" charset="-122"/>
                 <a:cs typeface="Arial" pitchFamily="34" charset="-120"/>
               </a:rPr>
-              <a:t>TODAY’S GOAL</a:t>
+              <a:t>TODAY</a:t>
             </a:r>
             <a:endParaRPr lang="en-US" sz="1200" dirty="0"/>
           </a:p>
@@ -7752,7 +7074,7 @@
                 <a:ea typeface="Arial" pitchFamily="34" charset="-122"/>
                 <a:cs typeface="Arial" pitchFamily="34" charset="-120"/>
               </a:rPr>
-              <a:t>Today’s goal: make and publish one change.</a:t>
+              <a:t>Make one change. Publish it.</a:t>
             </a:r>
             <a:endParaRPr lang="en-US" sz="2800" dirty="0"/>
           </a:p>
@@ -7767,46 +7089,7 @@
         <p:spPr>
           <a:xfrm>
             <a:off x="502920" y="1783080"/>
-            <a:ext cx="11155680" cy="502920"/>
-          </a:xfrm>
-          <a:prstGeom prst="rect">
-            <a:avLst/>
-          </a:prstGeom>
-          <a:noFill/>
-          <a:ln/>
-        </p:spPr>
-        <p:txBody>
-          <a:bodyPr wrap="square" rtlCol="0" anchor="ctr"/>
-          <a:lstStyle/>
-          <a:p>
-            <a:pPr indent="0" marL="0">
-              <a:buNone/>
-            </a:pPr>
-            <a:r>
-              <a:rPr lang="en-US" sz="1500" dirty="0">
-                <a:solidFill>
-                  <a:srgbClr val="555555"/>
-                </a:solidFill>
-                <a:latin typeface="Arial" pitchFamily="34" charset="0"/>
-                <a:ea typeface="Arial" pitchFamily="34" charset="-122"/>
-                <a:cs typeface="Arial" pitchFamily="34" charset="-120"/>
-              </a:rPr>
-              <a:t>You don’t need to finish the whole portfolio today. Make one useful change, review it, and follow the steps through publishing.</a:t>
-            </a:r>
-            <a:endParaRPr lang="en-US" sz="1500" dirty="0"/>
-          </a:p>
-        </p:txBody>
-      </p:sp>
-      <p:sp>
-        <p:nvSpPr>
-          <p:cNvPr id="9" name="Text 7"/>
-          <p:cNvSpPr/>
-          <p:nvPr/>
-        </p:nvSpPr>
-        <p:spPr>
-          <a:xfrm>
-            <a:off x="502920" y="2377440"/>
-            <a:ext cx="11155680" cy="3291840"/>
+            <a:ext cx="11155680" cy="2962656"/>
           </a:xfrm>
           <a:prstGeom prst="rect">
             <a:avLst/>
@@ -7831,7 +7114,7 @@
                 <a:ea typeface="Arial" pitchFamily="34" charset="-122"/>
                 <a:cs typeface="Arial" pitchFamily="34" charset="-120"/>
               </a:rPr>
-              <a:t>Run locally: The project opens in VS Code and the local preview loads.</a:t>
+              <a:t>Run locally VS Code + localhost</a:t>
             </a:r>
             <a:endParaRPr lang="en-US" sz="1500" dirty="0"/>
           </a:p>
@@ -7849,7 +7132,7 @@
                 <a:ea typeface="Arial" pitchFamily="34" charset="-122"/>
                 <a:cs typeface="Arial" pitchFamily="34" charset="-120"/>
               </a:rPr>
-              <a:t>Change one thing: Update one project, profile detail, or content section.</a:t>
+              <a:t>Change one thing in profile.js</a:t>
             </a:r>
             <a:endParaRPr lang="en-US" sz="1500" dirty="0"/>
           </a:p>
@@ -7867,7 +7150,7 @@
                 <a:ea typeface="Arial" pitchFamily="34" charset="-122"/>
                 <a:cs typeface="Arial" pitchFamily="34" charset="-120"/>
               </a:rPr>
-              <a:t>Record the work: Check the diff, stage only intended files, and make a clear commit.</a:t>
+              <a:t>Commit + PR review before merge</a:t>
             </a:r>
             <a:endParaRPr lang="en-US" sz="1500" dirty="0"/>
           </a:p>
@@ -7885,7 +7168,7 @@
                 <a:ea typeface="Arial" pitchFamily="34" charset="-122"/>
                 <a:cs typeface="Arial" pitchFamily="34" charset="-120"/>
               </a:rPr>
-              <a:t>Review + publish: Open a pull request, merge after review, then check the live URL.</a:t>
+              <a:t>Open the live URL not just local preview</a:t>
             </a:r>
             <a:endParaRPr lang="en-US" sz="1500" dirty="0"/>
           </a:p>
@@ -7903,7 +7186,7 @@
                 <a:ea typeface="Arial" pitchFamily="34" charset="-122"/>
                 <a:cs typeface="Arial" pitchFamily="34" charset="-120"/>
               </a:rPr>
-              <a:t>15 min: Starter + empty repo</a:t>
+              <a:t>Run locally: VS Code + localhost</a:t>
             </a:r>
             <a:endParaRPr lang="en-US" sz="1500" dirty="0"/>
           </a:p>
@@ -7921,7 +7204,7 @@
                 <a:ea typeface="Arial" pitchFamily="34" charset="-122"/>
                 <a:cs typeface="Arial" pitchFamily="34" charset="-120"/>
               </a:rPr>
-              <a:t>15 min: Open + local preview</a:t>
+              <a:t>Change one thing: in profile.js</a:t>
             </a:r>
             <a:endParaRPr lang="en-US" sz="1500" dirty="0"/>
           </a:p>
@@ -7939,7 +7222,7 @@
                 <a:ea typeface="Arial" pitchFamily="34" charset="-122"/>
                 <a:cs typeface="Arial" pitchFamily="34" charset="-120"/>
               </a:rPr>
-              <a:t>15 min: First push (git init)</a:t>
+              <a:t>Commit + PR: review before merge</a:t>
             </a:r>
             <a:endParaRPr lang="en-US" sz="1500" dirty="0"/>
           </a:p>
@@ -7957,51 +7240,15 @@
                 <a:ea typeface="Arial" pitchFamily="34" charset="-122"/>
                 <a:cs typeface="Arial" pitchFamily="34" charset="-120"/>
               </a:rPr>
-              <a:t>20 min: Personalize in profile.js</a:t>
+              <a:t>Open the live URL: not just local preview</a:t>
             </a:r>
             <a:endParaRPr lang="en-US" sz="1500" dirty="0"/>
           </a:p>
-          <a:p>
-            <a:pPr marL="342900" indent="-342900">
-              <a:buSzPct val="100000"/>
-              <a:buChar char="•"/>
-            </a:pPr>
-            <a:r>
-              <a:rPr lang="en-US" sz="1500" dirty="0">
-                <a:solidFill>
-                  <a:srgbClr val="1A1A1A"/>
-                </a:solidFill>
-                <a:latin typeface="Arial" pitchFamily="34" charset="0"/>
-                <a:ea typeface="Arial" pitchFamily="34" charset="-122"/>
-                <a:cs typeface="Arial" pitchFamily="34" charset="-120"/>
-              </a:rPr>
-              <a:t>10 min: Break</a:t>
-            </a:r>
-            <a:endParaRPr lang="en-US" sz="1500" dirty="0"/>
-          </a:p>
-          <a:p>
-            <a:pPr marL="342900" indent="-342900">
-              <a:buSzPct val="100000"/>
-              <a:buChar char="•"/>
-            </a:pPr>
-            <a:r>
-              <a:rPr lang="en-US" sz="1500" dirty="0">
-                <a:solidFill>
-                  <a:srgbClr val="1A1A1A"/>
-                </a:solidFill>
-                <a:latin typeface="Arial" pitchFamily="34" charset="0"/>
-                <a:ea typeface="Arial" pitchFamily="34" charset="-122"/>
-                <a:cs typeface="Arial" pitchFamily="34" charset="-120"/>
-              </a:rPr>
-              <a:t>30 min: Issue → VS Code branch → PR</a:t>
-            </a:r>
-            <a:endParaRPr lang="en-US" sz="1500" dirty="0"/>
-          </a:p>
-        </p:txBody>
-      </p:sp>
-      <p:sp>
-        <p:nvSpPr>
-          <p:cNvPr id="10" name="Shape 8"/>
+        </p:txBody>
+      </p:sp>
+      <p:sp>
+        <p:nvSpPr>
+          <p:cNvPr id="9" name="Shape 7"/>
           <p:cNvSpPr/>
           <p:nvPr/>
         </p:nvSpPr>
@@ -8026,7 +7273,7 @@
       </p:sp>
       <p:sp>
         <p:nvSpPr>
-          <p:cNvPr id="11" name="Text 9"/>
+          <p:cNvPr id="10" name="Text 8"/>
           <p:cNvSpPr/>
           <p:nvPr/>
         </p:nvSpPr>
@@ -8057,7 +7304,7 @@
                 <a:ea typeface="Arial" pitchFamily="34" charset="-122"/>
                 <a:cs typeface="Arial" pitchFamily="34" charset="-120"/>
               </a:rPr>
-              <a:t>A CHANGE YOU CAN EXPLAIN AND SHOW · FOLLOW THE STEPS IN ORDER</a:t>
+              <a:t>ARROWS ON THE WEB DECK · R FOR RESOURCES · N FOR NOTES</a:t>
             </a:r>
             <a:endParaRPr lang="en-US" sz="1100" dirty="0"/>
           </a:p>
@@ -8249,7 +7496,7 @@
                 <a:ea typeface="Arial" pitchFamily="34" charset="-122"/>
                 <a:cs typeface="Arial" pitchFamily="34" charset="-120"/>
               </a:rPr>
-              <a:t>COMMANDS TO KEEP HANDY</a:t>
+              <a:t>REMEMBER</a:t>
             </a:r>
             <a:endParaRPr lang="en-US" sz="1200" dirty="0"/>
           </a:p>
@@ -8288,7 +7535,7 @@
                 <a:ea typeface="Arial" pitchFamily="34" charset="-122"/>
                 <a:cs typeface="Arial" pitchFamily="34" charset="-120"/>
               </a:rPr>
-              <a:t>Run these commands and read the output.</a:t>
+              <a:t>Status first. Diff always. Verify the URL.</a:t>
             </a:r>
             <a:endParaRPr lang="en-US" sz="2800" dirty="0"/>
           </a:p>
@@ -8303,46 +7550,7 @@
         <p:spPr>
           <a:xfrm>
             <a:off x="502920" y="1783080"/>
-            <a:ext cx="11155680" cy="502920"/>
-          </a:xfrm>
-          <a:prstGeom prst="rect">
-            <a:avLst/>
-          </a:prstGeom>
-          <a:noFill/>
-          <a:ln/>
-        </p:spPr>
-        <p:txBody>
-          <a:bodyPr wrap="square" rtlCol="0" anchor="ctr"/>
-          <a:lstStyle/>
-          <a:p>
-            <a:pPr indent="0" marL="0">
-              <a:buNone/>
-            </a:pPr>
-            <a:r>
-              <a:rPr lang="en-US" sz="1500" dirty="0">
-                <a:solidFill>
-                  <a:srgbClr val="555555"/>
-                </a:solidFill>
-                <a:latin typeface="Arial" pitchFamily="34" charset="0"/>
-                <a:ea typeface="Arial" pitchFamily="34" charset="-122"/>
-                <a:cs typeface="Arial" pitchFamily="34" charset="-120"/>
-              </a:rPr>
-              <a:t>This is the compact sequence to leave on screen during independent work.</a:t>
-            </a:r>
-            <a:endParaRPr lang="en-US" sz="1500" dirty="0"/>
-          </a:p>
-        </p:txBody>
-      </p:sp>
-      <p:sp>
-        <p:nvSpPr>
-          <p:cNvPr id="9" name="Text 7"/>
-          <p:cNvSpPr/>
-          <p:nvPr/>
-        </p:nvSpPr>
-        <p:spPr>
-          <a:xfrm>
-            <a:off x="502920" y="2377440"/>
-            <a:ext cx="11155680" cy="1920240"/>
+            <a:ext cx="11155680" cy="1572768"/>
           </a:xfrm>
           <a:prstGeom prst="rect">
             <a:avLst/>
@@ -8367,7 +7575,7 @@
                 <a:ea typeface="Arial" pitchFamily="34" charset="-122"/>
                 <a:cs typeface="Arial" pitchFamily="34" charset="-120"/>
               </a:rPr>
-              <a:t>Inspect: git status git diff git diff --staged git log --oneline -5 git branch --show-current Record git add path/to/file git diff --staged git commit -m "Describe the change" git status Branch + share git switch main git pull git switch -c feature/name git push -u origin feature/name Validate + publish npm run dev npm run build # push branch → open PR # merge → check Actions # open and test live URL EXIT TICKET What changed? Where is the diff? What proves it works? What happens after merge?</a:t>
+              <a:t>VS Code: Status Bar · Source Control · Publish</a:t>
             </a:r>
             <a:endParaRPr lang="en-US" sz="1500" dirty="0"/>
           </a:p>
@@ -8385,7 +7593,7 @@
                 <a:ea typeface="Arial" pitchFamily="34" charset="-122"/>
                 <a:cs typeface="Arial" pitchFamily="34" charset="-120"/>
               </a:rPr>
-              <a:t>git status git diff git diff --staged git log --oneline -5 git branch --show-current</a:t>
+              <a:t>GitHub: Issue · PR · Files changed · Merge</a:t>
             </a:r>
             <a:endParaRPr lang="en-US" sz="1500" dirty="0"/>
           </a:p>
@@ -8403,7 +7611,7 @@
                 <a:ea typeface="Arial" pitchFamily="34" charset="-122"/>
                 <a:cs typeface="Arial" pitchFamily="34" charset="-120"/>
               </a:rPr>
-              <a:t>git add path/to/file git diff --staged git commit -m "Describe the change" git status</a:t>
+              <a:t>Pages: Actions green · Visit site</a:t>
             </a:r>
             <a:endParaRPr lang="en-US" sz="1500" dirty="0"/>
           </a:p>
@@ -8421,33 +7629,15 @@
                 <a:ea typeface="Arial" pitchFamily="34" charset="-122"/>
                 <a:cs typeface="Arial" pitchFamily="34" charset="-120"/>
               </a:rPr>
-              <a:t>git switch main git pull git switch -c feature/name git push -u origin feature/name</a:t>
+              <a:t>Stuck: git status · first error · ask</a:t>
             </a:r>
             <a:endParaRPr lang="en-US" sz="1500" dirty="0"/>
           </a:p>
-          <a:p>
-            <a:pPr marL="342900" indent="-342900">
-              <a:buSzPct val="100000"/>
-              <a:buChar char="•"/>
-            </a:pPr>
-            <a:r>
-              <a:rPr lang="en-US" sz="1500" dirty="0">
-                <a:solidFill>
-                  <a:srgbClr val="1A1A1A"/>
-                </a:solidFill>
-                <a:latin typeface="Arial" pitchFamily="34" charset="0"/>
-                <a:ea typeface="Arial" pitchFamily="34" charset="-122"/>
-                <a:cs typeface="Arial" pitchFamily="34" charset="-120"/>
-              </a:rPr>
-              <a:t>npm run dev npm run build # push branch → open PR # merge → check Actions # open and test live URL</a:t>
-            </a:r>
-            <a:endParaRPr lang="en-US" sz="1500" dirty="0"/>
-          </a:p>
-        </p:txBody>
-      </p:sp>
-      <p:sp>
-        <p:nvSpPr>
-          <p:cNvPr id="10" name="Shape 8"/>
+        </p:txBody>
+      </p:sp>
+      <p:sp>
+        <p:nvSpPr>
+          <p:cNvPr id="9" name="Shape 7"/>
           <p:cNvSpPr/>
           <p:nvPr/>
         </p:nvSpPr>
@@ -8472,7 +7662,7 @@
       </p:sp>
       <p:sp>
         <p:nvSpPr>
-          <p:cNvPr id="11" name="Text 9"/>
+          <p:cNvPr id="10" name="Text 8"/>
           <p:cNvSpPr/>
           <p:nvPr/>
         </p:nvSpPr>
@@ -8503,7 +7693,7 @@
                 <a:ea typeface="Arial" pitchFamily="34" charset="-122"/>
                 <a:cs typeface="Arial" pitchFamily="34" charset="-120"/>
               </a:rPr>
-              <a:t>STATUS FIRST · DIFF ALWAYS · VERIFY THE LIVE URL · RESOURCES: PRESS R</a:t>
+              <a:t>ARROWS ON THE WEB DECK · R FOR RESOURCES · N FOR NOTES</a:t>
             </a:r>
             <a:endParaRPr lang="en-US" sz="1100" dirty="0"/>
           </a:p>
@@ -8695,7 +7885,7 @@
                 <a:ea typeface="Arial" pitchFamily="34" charset="-122"/>
                 <a:cs typeface="Arial" pitchFamily="34" charset="-120"/>
               </a:rPr>
-              <a:t>ONE LAYOUT FOR EVERYONE</a:t>
+              <a:t>BEFORE CODE</a:t>
             </a:r>
             <a:endParaRPr lang="en-US" sz="1200" dirty="0"/>
           </a:p>
@@ -8734,7 +7924,7 @@
                 <a:ea typeface="Arial" pitchFamily="34" charset="-122"/>
                 <a:cs typeface="Arial" pitchFamily="34" charset="-120"/>
               </a:rPr>
-              <a:t>Download the starter ZIP. Unzip it.</a:t>
+              <a:t>Download. Unzip. Open the folder.</a:t>
             </a:r>
             <a:endParaRPr lang="en-US" sz="2800" dirty="0"/>
           </a:p>
@@ -8749,46 +7939,7 @@
         <p:spPr>
           <a:xfrm>
             <a:off x="502920" y="1783080"/>
-            <a:ext cx="11155680" cy="502920"/>
-          </a:xfrm>
-          <a:prstGeom prst="rect">
-            <a:avLst/>
-          </a:prstGeom>
-          <a:noFill/>
-          <a:ln/>
-        </p:spPr>
-        <p:txBody>
-          <a:bodyPr wrap="square" rtlCol="0" anchor="ctr"/>
-          <a:lstStyle/>
-          <a:p>
-            <a:pPr indent="0" marL="0">
-              <a:buNone/>
-            </a:pPr>
-            <a:r>
-              <a:rPr lang="en-US" sz="1500" dirty="0">
-                <a:solidFill>
-                  <a:srgbClr val="555555"/>
-                </a:solidFill>
-                <a:latin typeface="Arial" pitchFamily="34" charset="0"/>
-                <a:ea typeface="Arial" pitchFamily="34" charset="-122"/>
-                <a:cs typeface="Arial" pitchFamily="34" charset="-120"/>
-              </a:rPr>
-              <a:t>Same resume site for the whole room. Empty sections stay hidden — fill what you have in profile.js .</a:t>
-            </a:r>
-            <a:endParaRPr lang="en-US" sz="1500" dirty="0"/>
-          </a:p>
-        </p:txBody>
-      </p:sp>
-      <p:sp>
-        <p:nvSpPr>
-          <p:cNvPr id="9" name="Text 7"/>
-          <p:cNvSpPr/>
-          <p:nvPr/>
-        </p:nvSpPr>
-        <p:spPr>
-          <a:xfrm>
-            <a:off x="502920" y="2377440"/>
-            <a:ext cx="11155680" cy="877824"/>
+            <a:ext cx="11155680" cy="2267712"/>
           </a:xfrm>
           <a:prstGeom prst="rect">
             <a:avLst/>
@@ -8813,7 +7964,7 @@
                 <a:ea typeface="Arial" pitchFamily="34" charset="-122"/>
                 <a:cs typeface="Arial" pitchFamily="34" charset="-120"/>
               </a:rPr>
-              <a:t>Resume starter: Edit profile.js · publish with Pages</a:t>
+              <a:t>Download the starter ZIP portfolio-starter.zip ↓</a:t>
             </a:r>
             <a:endParaRPr lang="en-US" sz="1500" dirty="0"/>
           </a:p>
@@ -8831,65 +7982,17 @@
                 <a:ea typeface="Arial" pitchFamily="34" charset="-122"/>
                 <a:cs typeface="Arial" pitchFamily="34" charset="-120"/>
               </a:rPr>
-              <a:t>Ask the room: Raise your hand when your ZIP is downloaded and unzipped. What folder did you get?</a:t>
+              <a:t>Unzip you should get my-resume-site</a:t>
             </a:r>
             <a:endParaRPr lang="en-US" sz="1500" dirty="0"/>
           </a:p>
-        </p:txBody>
-      </p:sp>
-      <p:sp>
-        <p:nvSpPr>
-          <p:cNvPr id="10" name="Shape 8"/>
-          <p:cNvSpPr/>
-          <p:nvPr/>
-        </p:nvSpPr>
-        <p:spPr>
-          <a:xfrm>
-            <a:off x="502920" y="3392424"/>
-            <a:ext cx="11155680" cy="640080"/>
-          </a:xfrm>
-          <a:prstGeom prst="roundRect">
-            <a:avLst>
-              <a:gd name="adj" fmla="val 8571"/>
-            </a:avLst>
-          </a:prstGeom>
-          <a:solidFill>
-            <a:srgbClr val="FFF8CC"/>
-          </a:solidFill>
-          <a:ln w="12700">
-            <a:solidFill>
-              <a:srgbClr val="FFDB00"/>
-            </a:solidFill>
-            <a:prstDash val="solid"/>
-          </a:ln>
-        </p:spPr>
-      </p:sp>
-      <p:sp>
-        <p:nvSpPr>
-          <p:cNvPr id="11" name="Text 9"/>
-          <p:cNvSpPr/>
-          <p:nvPr/>
-        </p:nvSpPr>
-        <p:spPr>
-          <a:xfrm>
-            <a:off x="640080" y="3502152"/>
-            <a:ext cx="10881360" cy="438912"/>
-          </a:xfrm>
-          <a:prstGeom prst="rect">
-            <a:avLst/>
-          </a:prstGeom>
-          <a:noFill/>
-          <a:ln/>
-        </p:spPr>
-        <p:txBody>
-          <a:bodyPr wrap="square" rtlCol="0" anchor="ctr"/>
-          <a:lstStyle/>
-          <a:p>
-            <a:pPr indent="0" marL="0">
-              <a:buNone/>
-            </a:pPr>
-            <a:r>
-              <a:rPr lang="en-US" sz="1300" b="1" dirty="0">
+          <a:p>
+            <a:pPr marL="342900" indent="-342900">
+              <a:buSzPct val="100000"/>
+              <a:buChar char="•"/>
+            </a:pPr>
+            <a:r>
+              <a:rPr lang="en-US" sz="1500" dirty="0">
                 <a:solidFill>
                   <a:srgbClr val="1A1A1A"/>
                 </a:solidFill>
@@ -8897,15 +8000,69 @@
                 <a:ea typeface="Arial" pitchFamily="34" charset="-122"/>
                 <a:cs typeface="Arial" pitchFamily="34" charset="-120"/>
               </a:rPr>
-              <a:t>Ask the room: Raise your hand when your ZIP is downloaded and unzipped. What folder did you get?</a:t>
-            </a:r>
-            <a:endParaRPr lang="en-US" sz="1300" dirty="0"/>
-          </a:p>
-        </p:txBody>
-      </p:sp>
-      <p:sp>
-        <p:nvSpPr>
-          <p:cNvPr id="12" name="Shape 10"/>
+              <a:t>Create an empty Public repo no README · no .gitignore</a:t>
+            </a:r>
+            <a:endParaRPr lang="en-US" sz="1500" dirty="0"/>
+          </a:p>
+          <a:p>
+            <a:pPr marL="342900" indent="-342900">
+              <a:buSzPct val="100000"/>
+              <a:buChar char="•"/>
+            </a:pPr>
+            <a:r>
+              <a:rPr lang="en-US" sz="1500" dirty="0">
+                <a:solidFill>
+                  <a:srgbClr val="1A1A1A"/>
+                </a:solidFill>
+                <a:latin typeface="Arial" pitchFamily="34" charset="0"/>
+                <a:ea typeface="Arial" pitchFamily="34" charset="-122"/>
+                <a:cs typeface="Arial" pitchFamily="34" charset="-120"/>
+              </a:rPr>
+              <a:t>Download the starter ZIP: portfolio-starter.zip ↓</a:t>
+            </a:r>
+            <a:endParaRPr lang="en-US" sz="1500" dirty="0"/>
+          </a:p>
+          <a:p>
+            <a:pPr marL="342900" indent="-342900">
+              <a:buSzPct val="100000"/>
+              <a:buChar char="•"/>
+            </a:pPr>
+            <a:r>
+              <a:rPr lang="en-US" sz="1500" dirty="0">
+                <a:solidFill>
+                  <a:srgbClr val="1A1A1A"/>
+                </a:solidFill>
+                <a:latin typeface="Arial" pitchFamily="34" charset="0"/>
+                <a:ea typeface="Arial" pitchFamily="34" charset="-122"/>
+                <a:cs typeface="Arial" pitchFamily="34" charset="-120"/>
+              </a:rPr>
+              <a:t>Unzip: you should get my-resume-site</a:t>
+            </a:r>
+            <a:endParaRPr lang="en-US" sz="1500" dirty="0"/>
+          </a:p>
+          <a:p>
+            <a:pPr marL="342900" indent="-342900">
+              <a:buSzPct val="100000"/>
+              <a:buChar char="•"/>
+            </a:pPr>
+            <a:r>
+              <a:rPr lang="en-US" sz="1500" dirty="0">
+                <a:solidFill>
+                  <a:srgbClr val="1A1A1A"/>
+                </a:solidFill>
+                <a:latin typeface="Arial" pitchFamily="34" charset="0"/>
+                <a:ea typeface="Arial" pitchFamily="34" charset="-122"/>
+                <a:cs typeface="Arial" pitchFamily="34" charset="-120"/>
+              </a:rPr>
+              <a:t>Create an empty Public repo: no README · no .gitignore</a:t>
+            </a:r>
+            <a:endParaRPr lang="en-US" sz="1500" dirty="0"/>
+          </a:p>
+        </p:txBody>
+      </p:sp>
+      <p:sp>
+        <p:nvSpPr>
+          <p:cNvPr id="9" name="Shape 7"/>
           <p:cNvSpPr/>
           <p:nvPr/>
         </p:nvSpPr>
@@ -8930,7 +8087,7 @@
       </p:sp>
       <p:sp>
         <p:nvSpPr>
-          <p:cNvPr id="13" name="Text 11"/>
+          <p:cNvPr id="10" name="Text 8"/>
           <p:cNvSpPr/>
           <p:nvPr/>
         </p:nvSpPr>
@@ -8961,7 +8118,7 @@
                 <a:ea typeface="Arial" pitchFamily="34" charset="-122"/>
                 <a:cs typeface="Arial" pitchFamily="34" charset="-120"/>
               </a:rPr>
-              <a:t>ONE ZIP PER STUDENT · ALSO CREATE EMPTY PUBLIC REPO</a:t>
+              <a:t>ARROWS ON THE WEB DECK · R FOR RESOURCES · N FOR NOTES</a:t>
             </a:r>
             <a:endParaRPr lang="en-US" sz="1100" dirty="0"/>
           </a:p>
@@ -9153,7 +8310,7 @@
                 <a:ea typeface="Arial" pitchFamily="34" charset="-122"/>
                 <a:cs typeface="Arial" pitchFamily="34" charset="-120"/>
               </a:rPr>
-              <a:t>GET A KNOWN-GOOD START</a:t>
+              <a:t>VS CODE</a:t>
             </a:r>
             <a:endParaRPr lang="en-US" sz="1200" dirty="0"/>
           </a:p>
@@ -9192,7 +8349,7 @@
                 <a:ea typeface="Arial" pitchFamily="34" charset="-122"/>
                 <a:cs typeface="Arial" pitchFamily="34" charset="-120"/>
               </a:rPr>
-              <a:t>Open the project. Run it before editing.</a:t>
+              <a:t>Open the folder. Run it.</a:t>
             </a:r>
             <a:endParaRPr lang="en-US" sz="2800" dirty="0"/>
           </a:p>
@@ -9207,46 +8364,7 @@
         <p:spPr>
           <a:xfrm>
             <a:off x="502920" y="1783080"/>
-            <a:ext cx="11155680" cy="502920"/>
-          </a:xfrm>
-          <a:prstGeom prst="rect">
-            <a:avLst/>
-          </a:prstGeom>
-          <a:noFill/>
-          <a:ln/>
-        </p:spPr>
-        <p:txBody>
-          <a:bodyPr wrap="square" rtlCol="0" anchor="ctr"/>
-          <a:lstStyle/>
-          <a:p>
-            <a:pPr indent="0" marL="0">
-              <a:buNone/>
-            </a:pPr>
-            <a:r>
-              <a:rPr lang="en-US" sz="1500" dirty="0">
-                <a:solidFill>
-                  <a:srgbClr val="555555"/>
-                </a:solidFill>
-                <a:latin typeface="Arial" pitchFamily="34" charset="0"/>
-                <a:ea typeface="Arial" pitchFamily="34" charset="-122"/>
-                <a:cs typeface="Arial" pitchFamily="34" charset="-120"/>
-              </a:rPr>
-              <a:t>Start in the project root — the folder with package.json . Name every VS Code click for beginners.</a:t>
-            </a:r>
-            <a:endParaRPr lang="en-US" sz="1500" dirty="0"/>
-          </a:p>
-        </p:txBody>
-      </p:sp>
-      <p:sp>
-        <p:nvSpPr>
-          <p:cNvPr id="9" name="Text 7"/>
-          <p:cNvSpPr/>
-          <p:nvPr/>
-        </p:nvSpPr>
-        <p:spPr>
-          <a:xfrm>
-            <a:off x="502920" y="2377440"/>
-            <a:ext cx="11155680" cy="2615184"/>
+            <a:ext cx="11155680" cy="1920240"/>
           </a:xfrm>
           <a:prstGeom prst="rect">
             <a:avLst/>
@@ -9271,7 +8389,7 @@
                 <a:ea typeface="Arial" pitchFamily="34" charset="-122"/>
                 <a:cs typeface="Arial" pitchFamily="34" charset="-120"/>
               </a:rPr>
-              <a:t>File → Open Folder… and select unzipped my-resume-site (trust authors if asked).</a:t>
+              <a:t>File → Open Folder… my-resume-site</a:t>
             </a:r>
             <a:endParaRPr lang="en-US" sz="1500" dirty="0"/>
           </a:p>
@@ -9289,7 +8407,7 @@
                 <a:ea typeface="Arial" pitchFamily="34" charset="-122"/>
                 <a:cs typeface="Arial" pitchFamily="34" charset="-120"/>
               </a:rPr>
-              <a:t>Activity Bar → top icon = Explorer . Confirm package.json and src .</a:t>
+              <a:t>Terminal → New Terminal</a:t>
             </a:r>
             <a:endParaRPr lang="en-US" sz="1500" dirty="0"/>
           </a:p>
@@ -9307,7 +8425,7 @@
                 <a:ea typeface="Arial" pitchFamily="34" charset="-122"/>
                 <a:cs typeface="Arial" pitchFamily="34" charset="-120"/>
               </a:rPr>
-              <a:t>Terminal → New Terminal . Click in the bottom panel to type.</a:t>
+              <a:t>Run the two commands then open localhost</a:t>
             </a:r>
             <a:endParaRPr lang="en-US" sz="1500" dirty="0"/>
           </a:p>
@@ -9325,7 +8443,7 @@
                 <a:ea typeface="Arial" pitchFamily="34" charset="-122"/>
                 <a:cs typeface="Arial" pitchFamily="34" charset="-120"/>
               </a:rPr>
-              <a:t>Run install, then dev. Click the localhost link while holding Cmd/Ctrl.</a:t>
+              <a:t>File → Open Folder…: my-resume-site</a:t>
             </a:r>
             <a:endParaRPr lang="en-US" sz="1500" dirty="0"/>
           </a:p>
@@ -9343,117 +8461,15 @@
                 <a:ea typeface="Arial" pitchFamily="34" charset="-122"/>
                 <a:cs typeface="Arial" pitchFamily="34" charset="-120"/>
               </a:rPr>
-              <a:t>Checkpoint: Open the local URL shown in the terminal, usually http://localhost:4321 .</a:t>
+              <a:t>Terminal → New Terminal Run the two commands: then open localhost</a:t>
             </a:r>
             <a:endParaRPr lang="en-US" sz="1500" dirty="0"/>
           </a:p>
-          <a:p>
-            <a:pPr marL="342900" indent="-342900">
-              <a:buSzPct val="100000"/>
-              <a:buChar char="•"/>
-            </a:pPr>
-            <a:r>
-              <a:rPr lang="en-US" sz="1500" dirty="0">
-                <a:solidFill>
-                  <a:srgbClr val="1A1A1A"/>
-                </a:solidFill>
-                <a:latin typeface="Arial" pitchFamily="34" charset="0"/>
-                <a:ea typeface="Arial" pitchFamily="34" charset="-122"/>
-                <a:cs typeface="Arial" pitchFamily="34" charset="-120"/>
-              </a:rPr>
-              <a:t>Ask the room: Did you open the folder that contains package.json , or only one file? Hands up when the local preview loads.</a:t>
-            </a:r>
-            <a:endParaRPr lang="en-US" sz="1500" dirty="0"/>
-          </a:p>
-          <a:p>
-            <a:pPr marL="342900" indent="-342900">
-              <a:buSzPct val="100000"/>
-              <a:buChar char="•"/>
-            </a:pPr>
-            <a:r>
-              <a:rPr lang="en-US" sz="1500" dirty="0">
-                <a:solidFill>
-                  <a:srgbClr val="1A1A1A"/>
-                </a:solidFill>
-                <a:latin typeface="Arial" pitchFamily="34" charset="0"/>
-                <a:ea typeface="Arial" pitchFamily="34" charset="-122"/>
-                <a:cs typeface="Arial" pitchFamily="34" charset="-120"/>
-              </a:rPr>
-              <a:t>npm install npm run dev</a:t>
-            </a:r>
-            <a:endParaRPr lang="en-US" sz="1500" dirty="0"/>
-          </a:p>
-        </p:txBody>
-      </p:sp>
-      <p:sp>
-        <p:nvSpPr>
-          <p:cNvPr id="10" name="Shape 8"/>
-          <p:cNvSpPr/>
-          <p:nvPr/>
-        </p:nvSpPr>
-        <p:spPr>
-          <a:xfrm>
-            <a:off x="502920" y="5074920"/>
-            <a:ext cx="11155680" cy="640080"/>
-          </a:xfrm>
-          <a:prstGeom prst="roundRect">
-            <a:avLst>
-              <a:gd name="adj" fmla="val 8571"/>
-            </a:avLst>
-          </a:prstGeom>
-          <a:solidFill>
-            <a:srgbClr val="FFF8CC"/>
-          </a:solidFill>
-          <a:ln w="12700">
-            <a:solidFill>
-              <a:srgbClr val="FFDB00"/>
-            </a:solidFill>
-            <a:prstDash val="solid"/>
-          </a:ln>
-        </p:spPr>
-      </p:sp>
-      <p:sp>
-        <p:nvSpPr>
-          <p:cNvPr id="11" name="Text 9"/>
-          <p:cNvSpPr/>
-          <p:nvPr/>
-        </p:nvSpPr>
-        <p:spPr>
-          <a:xfrm>
-            <a:off x="640080" y="5184648"/>
-            <a:ext cx="10881360" cy="438912"/>
-          </a:xfrm>
-          <a:prstGeom prst="rect">
-            <a:avLst/>
-          </a:prstGeom>
-          <a:noFill/>
-          <a:ln/>
-        </p:spPr>
-        <p:txBody>
-          <a:bodyPr wrap="square" rtlCol="0" anchor="ctr"/>
-          <a:lstStyle/>
-          <a:p>
-            <a:pPr indent="0" marL="0">
-              <a:buNone/>
-            </a:pPr>
-            <a:r>
-              <a:rPr lang="en-US" sz="1300" b="1" dirty="0">
-                <a:solidFill>
-                  <a:srgbClr val="1A1A1A"/>
-                </a:solidFill>
-                <a:latin typeface="Arial" pitchFamily="34" charset="0"/>
-                <a:ea typeface="Arial" pitchFamily="34" charset="-122"/>
-                <a:cs typeface="Arial" pitchFamily="34" charset="-120"/>
-              </a:rPr>
-              <a:t>Ask the room: Did you open the folder that contains package.json , or only one file? Hands up when the local preview loads.</a:t>
-            </a:r>
-            <a:endParaRPr lang="en-US" sz="1300" dirty="0"/>
-          </a:p>
-        </p:txBody>
-      </p:sp>
-      <p:sp>
-        <p:nvSpPr>
-          <p:cNvPr id="12" name="Shape 10"/>
+        </p:txBody>
+      </p:sp>
+      <p:sp>
+        <p:nvSpPr>
+          <p:cNvPr id="9" name="Shape 7"/>
           <p:cNvSpPr/>
           <p:nvPr/>
         </p:nvSpPr>
@@ -9478,7 +8494,7 @@
       </p:sp>
       <p:sp>
         <p:nvSpPr>
-          <p:cNvPr id="13" name="Text 11"/>
+          <p:cNvPr id="10" name="Text 8"/>
           <p:cNvSpPr/>
           <p:nvPr/>
         </p:nvSpPr>
@@ -9509,7 +8525,7 @@
                 <a:ea typeface="Arial" pitchFamily="34" charset="-122"/>
                 <a:cs typeface="Arial" pitchFamily="34" charset="-120"/>
               </a:rPr>
-              <a:t>RUN THE STARTER BEFORE EDITING · LOCAL PREVIEW FIRST</a:t>
+              <a:t>ARROWS ON THE WEB DECK · R FOR RESOURCES · N FOR NOTES</a:t>
             </a:r>
             <a:endParaRPr lang="en-US" sz="1100" dirty="0"/>
           </a:p>
@@ -9701,7 +8717,7 @@
                 <a:ea typeface="Arial" pitchFamily="34" charset="-122"/>
                 <a:cs typeface="Arial" pitchFamily="34" charset="-120"/>
               </a:rPr>
-              <a:t>READ THE PROJECT BEFORE CHANGING IT</a:t>
+              <a:t>WHERE TO EDIT</a:t>
             </a:r>
             <a:endParaRPr lang="en-US" sz="1200" dirty="0"/>
           </a:p>
@@ -9740,7 +8756,7 @@
                 <a:ea typeface="Arial" pitchFamily="34" charset="-122"/>
                 <a:cs typeface="Arial" pitchFamily="34" charset="-120"/>
               </a:rPr>
-              <a:t>Open Explorer → src → data → profile.js.</a:t>
+              <a:t>Open src/data/profile.js</a:t>
             </a:r>
             <a:endParaRPr lang="en-US" sz="2800" dirty="0"/>
           </a:p>
@@ -9755,46 +8771,7 @@
         <p:spPr>
           <a:xfrm>
             <a:off x="502920" y="1783080"/>
-            <a:ext cx="11155680" cy="502920"/>
-          </a:xfrm>
-          <a:prstGeom prst="rect">
-            <a:avLst/>
-          </a:prstGeom>
-          <a:noFill/>
-          <a:ln/>
-        </p:spPr>
-        <p:txBody>
-          <a:bodyPr wrap="square" rtlCol="0" anchor="ctr"/>
-          <a:lstStyle/>
-          <a:p>
-            <a:pPr indent="0" marL="0">
-              <a:buNone/>
-            </a:pPr>
-            <a:r>
-              <a:rPr lang="en-US" sz="1500" dirty="0">
-                <a:solidFill>
-                  <a:srgbClr val="555555"/>
-                </a:solidFill>
-                <a:latin typeface="Arial" pitchFamily="34" charset="0"/>
-                <a:ea typeface="Arial" pitchFamily="34" charset="-122"/>
-                <a:cs typeface="Arial" pitchFamily="34" charset="-120"/>
-              </a:rPr>
-              <a:t>Almost all resume content lives in that one file. Photos go in public/ .</a:t>
-            </a:r>
-            <a:endParaRPr lang="en-US" sz="1500" dirty="0"/>
-          </a:p>
-        </p:txBody>
-      </p:sp>
-      <p:sp>
-        <p:nvSpPr>
-          <p:cNvPr id="9" name="Text 7"/>
-          <p:cNvSpPr/>
-          <p:nvPr/>
-        </p:nvSpPr>
-        <p:spPr>
-          <a:xfrm>
-            <a:off x="502920" y="2377440"/>
-            <a:ext cx="11155680" cy="3291840"/>
+            <a:ext cx="11155680" cy="1225296"/>
           </a:xfrm>
           <a:prstGeom prst="rect">
             <a:avLst/>
@@ -9819,7 +8796,7 @@
                 <a:ea typeface="Arial" pitchFamily="34" charset="-122"/>
                 <a:cs typeface="Arial" pitchFamily="34" charset="-120"/>
               </a:rPr>
-              <a:t>portfolio-…</a:t>
+              <a:t>Name, about, skills, education, projects</a:t>
             </a:r>
             <a:endParaRPr lang="en-US" sz="1500" dirty="0"/>
           </a:p>
@@ -9837,7 +8814,7 @@
                 <a:ea typeface="Arial" pitchFamily="34" charset="-122"/>
                 <a:cs typeface="Arial" pitchFamily="34" charset="-120"/>
               </a:rPr>
-              <a:t>public</a:t>
+              <a:t>Optional photo: public/photo.jpg</a:t>
             </a:r>
             <a:endParaRPr lang="en-US" sz="1500" dirty="0"/>
           </a:p>
@@ -9855,123 +8832,15 @@
                 <a:ea typeface="Arial" pitchFamily="34" charset="-122"/>
                 <a:cs typeface="Arial" pitchFamily="34" charset="-120"/>
               </a:rPr>
-              <a:t>photo.svg</a:t>
+              <a:t>Leave unused lists as []</a:t>
             </a:r>
             <a:endParaRPr lang="en-US" sz="1500" dirty="0"/>
           </a:p>
-          <a:p>
-            <a:pPr marL="342900" indent="-342900">
-              <a:buSzPct val="100000"/>
-              <a:buChar char="•"/>
-            </a:pPr>
-            <a:r>
-              <a:rPr lang="en-US" sz="1500" dirty="0">
-                <a:solidFill>
-                  <a:srgbClr val="1A1A1A"/>
-                </a:solidFill>
-                <a:latin typeface="Arial" pitchFamily="34" charset="0"/>
-                <a:ea typeface="Arial" pitchFamily="34" charset="-122"/>
-                <a:cs typeface="Arial" pitchFamily="34" charset="-120"/>
-              </a:rPr>
-              <a:t>src</a:t>
-            </a:r>
-            <a:endParaRPr lang="en-US" sz="1500" dirty="0"/>
-          </a:p>
-          <a:p>
-            <a:pPr marL="342900" indent="-342900">
-              <a:buSzPct val="100000"/>
-              <a:buChar char="•"/>
-            </a:pPr>
-            <a:r>
-              <a:rPr lang="en-US" sz="1500" dirty="0">
-                <a:solidFill>
-                  <a:srgbClr val="1A1A1A"/>
-                </a:solidFill>
-                <a:latin typeface="Arial" pitchFamily="34" charset="0"/>
-                <a:ea typeface="Arial" pitchFamily="34" charset="-122"/>
-                <a:cs typeface="Arial" pitchFamily="34" charset="-120"/>
-              </a:rPr>
-              <a:t>data</a:t>
-            </a:r>
-            <a:endParaRPr lang="en-US" sz="1500" dirty="0"/>
-          </a:p>
-          <a:p>
-            <a:pPr marL="342900" indent="-342900">
-              <a:buSzPct val="100000"/>
-              <a:buChar char="•"/>
-            </a:pPr>
-            <a:r>
-              <a:rPr lang="en-US" sz="1500" dirty="0">
-                <a:solidFill>
-                  <a:srgbClr val="1A1A1A"/>
-                </a:solidFill>
-                <a:latin typeface="Arial" pitchFamily="34" charset="0"/>
-                <a:ea typeface="Arial" pitchFamily="34" charset="-122"/>
-                <a:cs typeface="Arial" pitchFamily="34" charset="-120"/>
-              </a:rPr>
-              <a:t>profile.js</a:t>
-            </a:r>
-            <a:endParaRPr lang="en-US" sz="1500" dirty="0"/>
-          </a:p>
-          <a:p>
-            <a:pPr marL="342900" indent="-342900">
-              <a:buSzPct val="100000"/>
-              <a:buChar char="•"/>
-            </a:pPr>
-            <a:r>
-              <a:rPr lang="en-US" sz="1500" dirty="0">
-                <a:solidFill>
-                  <a:srgbClr val="1A1A1A"/>
-                </a:solidFill>
-                <a:latin typeface="Arial" pitchFamily="34" charset="0"/>
-                <a:ea typeface="Arial" pitchFamily="34" charset="-122"/>
-                <a:cs typeface="Arial" pitchFamily="34" charset="-120"/>
-              </a:rPr>
-              <a:t>layouts</a:t>
-            </a:r>
-            <a:endParaRPr lang="en-US" sz="1500" dirty="0"/>
-          </a:p>
-          <a:p>
-            <a:pPr marL="342900" indent="-342900">
-              <a:buSzPct val="100000"/>
-              <a:buChar char="•"/>
-            </a:pPr>
-            <a:r>
-              <a:rPr lang="en-US" sz="1500" dirty="0">
-                <a:solidFill>
-                  <a:srgbClr val="1A1A1A"/>
-                </a:solidFill>
-                <a:latin typeface="Arial" pitchFamily="34" charset="0"/>
-                <a:ea typeface="Arial" pitchFamily="34" charset="-122"/>
-                <a:cs typeface="Arial" pitchFamily="34" charset="-120"/>
-              </a:rPr>
-              <a:t>pages</a:t>
-            </a:r>
-            <a:endParaRPr lang="en-US" sz="1500" dirty="0"/>
-          </a:p>
-          <a:p>
-            <a:pPr marL="342900" indent="-342900">
-              <a:buSzPct val="100000"/>
-              <a:buChar char="•"/>
-            </a:pPr>
-            <a:r>
-              <a:rPr lang="en-US" sz="1500" dirty="0">
-                <a:solidFill>
-                  <a:srgbClr val="1A1A1A"/>
-                </a:solidFill>
-                <a:latin typeface="Arial" pitchFamily="34" charset="0"/>
-                <a:ea typeface="Arial" pitchFamily="34" charset="-122"/>
-                <a:cs typeface="Arial" pitchFamily="34" charset="-120"/>
-              </a:rPr>
-              <a:t>package.json</a:t>
-            </a:r>
-            <a:endParaRPr lang="en-US" sz="1500" dirty="0"/>
-          </a:p>
-        </p:txBody>
-      </p:sp>
-      <p:sp>
-        <p:nvSpPr>
-          <p:cNvPr id="10" name="Shape 8"/>
+        </p:txBody>
+      </p:sp>
+      <p:sp>
+        <p:nvSpPr>
+          <p:cNvPr id="9" name="Shape 7"/>
           <p:cNvSpPr/>
           <p:nvPr/>
         </p:nvSpPr>
@@ -9996,7 +8865,7 @@
       </p:sp>
       <p:sp>
         <p:nvSpPr>
-          <p:cNvPr id="11" name="Text 9"/>
+          <p:cNvPr id="10" name="Text 8"/>
           <p:cNvSpPr/>
           <p:nvPr/>
         </p:nvSpPr>
@@ -10027,7 +8896,7 @@
                 <a:ea typeface="Arial" pitchFamily="34" charset="-122"/>
                 <a:cs typeface="Arial" pitchFamily="34" charset="-120"/>
               </a:rPr>
-              <a:t>EXPLORER: SRC → DATA → PROFILE.JS · ASK COPILOT TO EXPLAIN BEFORE EDITING</a:t>
+              <a:t>ARROWS ON THE WEB DECK · R FOR RESOURCES · N FOR NOTES</a:t>
             </a:r>
             <a:endParaRPr lang="en-US" sz="1100" dirty="0"/>
           </a:p>
@@ -10219,7 +9088,7 @@
                 <a:ea typeface="Arial" pitchFamily="34" charset="-122"/>
                 <a:cs typeface="Arial" pitchFamily="34" charset="-120"/>
               </a:rPr>
-              <a:t>HOW A CHANGE GETS PUBLISHED</a:t>
+              <a:t>MENTAL MODEL</a:t>
             </a:r>
             <a:endParaRPr lang="en-US" sz="1200" dirty="0"/>
           </a:p>
@@ -10258,7 +9127,7 @@
                 <a:ea typeface="Arial" pitchFamily="34" charset="-122"/>
                 <a:cs typeface="Arial" pitchFamily="34" charset="-120"/>
               </a:rPr>
-              <a:t>What happens between editing and publishing?</a:t>
+              <a:t>Saving is not publishing.</a:t>
             </a:r>
             <a:endParaRPr lang="en-US" sz="2800" dirty="0"/>
           </a:p>
@@ -10273,46 +9142,7 @@
         <p:spPr>
           <a:xfrm>
             <a:off x="502920" y="1783080"/>
-            <a:ext cx="11155680" cy="502920"/>
-          </a:xfrm>
-          <a:prstGeom prst="rect">
-            <a:avLst/>
-          </a:prstGeom>
-          <a:noFill/>
-          <a:ln/>
-        </p:spPr>
-        <p:txBody>
-          <a:bodyPr wrap="square" rtlCol="0" anchor="ctr"/>
-          <a:lstStyle/>
-          <a:p>
-            <a:pPr indent="0" marL="0">
-              <a:buNone/>
-            </a:pPr>
-            <a:r>
-              <a:rPr lang="en-US" sz="1500" dirty="0">
-                <a:solidFill>
-                  <a:srgbClr val="555555"/>
-                </a:solidFill>
-                <a:latin typeface="Arial" pitchFamily="34" charset="0"/>
-                <a:ea typeface="Arial" pitchFamily="34" charset="-122"/>
-                <a:cs typeface="Arial" pitchFamily="34" charset="-120"/>
-              </a:rPr>
-              <a:t>The most common confusion is assuming a save, a commit, a push, and a deployment are the same thing.</a:t>
-            </a:r>
-            <a:endParaRPr lang="en-US" sz="1500" dirty="0"/>
-          </a:p>
-        </p:txBody>
-      </p:sp>
-      <p:sp>
-        <p:nvSpPr>
-          <p:cNvPr id="9" name="Text 7"/>
-          <p:cNvSpPr/>
-          <p:nvPr/>
-        </p:nvSpPr>
-        <p:spPr>
-          <a:xfrm>
-            <a:off x="502920" y="2377440"/>
-            <a:ext cx="11155680" cy="3291840"/>
+            <a:ext cx="11155680" cy="877824"/>
           </a:xfrm>
           <a:prstGeom prst="rect">
             <a:avLst/>
@@ -10337,7 +9167,7 @@
                 <a:ea typeface="Arial" pitchFamily="34" charset="-122"/>
                 <a:cs typeface="Arial" pitchFamily="34" charset="-120"/>
               </a:rPr>
-              <a:t>VS Code: Edit files on your computer.</a:t>
+              <a:t>Save ≠ commit ≠ push ≠ deploy</a:t>
             </a:r>
             <a:endParaRPr lang="en-US" sz="1500" dirty="0"/>
           </a:p>
@@ -10355,159 +9185,15 @@
                 <a:ea typeface="Arial" pitchFamily="34" charset="-122"/>
                 <a:cs typeface="Arial" pitchFamily="34" charset="-120"/>
               </a:rPr>
-              <a:t>Git: Stage and record a local snapshot.</a:t>
+              <a:t>See the live web deck for full layout and screenshots.</a:t>
             </a:r>
             <a:endParaRPr lang="en-US" sz="1500" dirty="0"/>
           </a:p>
-          <a:p>
-            <a:pPr marL="342900" indent="-342900">
-              <a:buSzPct val="100000"/>
-              <a:buChar char="•"/>
-            </a:pPr>
-            <a:r>
-              <a:rPr lang="en-US" sz="1500" dirty="0">
-                <a:solidFill>
-                  <a:srgbClr val="1A1A1A"/>
-                </a:solidFill>
-                <a:latin typeface="Arial" pitchFamily="34" charset="0"/>
-                <a:ea typeface="Arial" pitchFamily="34" charset="-122"/>
-                <a:cs typeface="Arial" pitchFamily="34" charset="-120"/>
-              </a:rPr>
-              <a:t>GitHub: Share commits and review the change.</a:t>
-            </a:r>
-            <a:endParaRPr lang="en-US" sz="1500" dirty="0"/>
-          </a:p>
-          <a:p>
-            <a:pPr marL="342900" indent="-342900">
-              <a:buSzPct val="100000"/>
-              <a:buChar char="•"/>
-            </a:pPr>
-            <a:r>
-              <a:rPr lang="en-US" sz="1500" dirty="0">
-                <a:solidFill>
-                  <a:srgbClr val="1A1A1A"/>
-                </a:solidFill>
-                <a:latin typeface="Arial" pitchFamily="34" charset="0"/>
-                <a:ea typeface="Arial" pitchFamily="34" charset="-122"/>
-                <a:cs typeface="Arial" pitchFamily="34" charset="-120"/>
-              </a:rPr>
-              <a:t>Actions: Install, build, and deploy.</a:t>
-            </a:r>
-            <a:endParaRPr lang="en-US" sz="1500" dirty="0"/>
-          </a:p>
-          <a:p>
-            <a:pPr marL="342900" indent="-342900">
-              <a:buSzPct val="100000"/>
-              <a:buChar char="•"/>
-            </a:pPr>
-            <a:r>
-              <a:rPr lang="en-US" sz="1500" dirty="0">
-                <a:solidFill>
-                  <a:srgbClr val="1A1A1A"/>
-                </a:solidFill>
-                <a:latin typeface="Arial" pitchFamily="34" charset="0"/>
-                <a:ea typeface="Arial" pitchFamily="34" charset="-122"/>
-                <a:cs typeface="Arial" pitchFamily="34" charset="-120"/>
-              </a:rPr>
-              <a:t>Pages: Serve the published site.</a:t>
-            </a:r>
-            <a:endParaRPr lang="en-US" sz="1500" dirty="0"/>
-          </a:p>
-          <a:p>
-            <a:pPr marL="342900" indent="-342900">
-              <a:buSzPct val="100000"/>
-              <a:buChar char="•"/>
-            </a:pPr>
-            <a:r>
-              <a:rPr lang="en-US" sz="1500" dirty="0">
-                <a:solidFill>
-                  <a:srgbClr val="1A1A1A"/>
-                </a:solidFill>
-                <a:latin typeface="Arial" pitchFamily="34" charset="0"/>
-                <a:ea typeface="Arial" pitchFamily="34" charset="-122"/>
-                <a:cs typeface="Arial" pitchFamily="34" charset="-120"/>
-              </a:rPr>
-              <a:t>Saved: The file on your computer changed.</a:t>
-            </a:r>
-            <a:endParaRPr lang="en-US" sz="1500" dirty="0"/>
-          </a:p>
-          <a:p>
-            <a:pPr marL="342900" indent="-342900">
-              <a:buSzPct val="100000"/>
-              <a:buChar char="•"/>
-            </a:pPr>
-            <a:r>
-              <a:rPr lang="en-US" sz="1500" dirty="0">
-                <a:solidFill>
-                  <a:srgbClr val="1A1A1A"/>
-                </a:solidFill>
-                <a:latin typeface="Arial" pitchFamily="34" charset="0"/>
-                <a:ea typeface="Arial" pitchFamily="34" charset="-122"/>
-                <a:cs typeface="Arial" pitchFamily="34" charset="-120"/>
-              </a:rPr>
-              <a:t>Committed: Git recorded a snapshot in local history.</a:t>
-            </a:r>
-            <a:endParaRPr lang="en-US" sz="1500" dirty="0"/>
-          </a:p>
-          <a:p>
-            <a:pPr marL="342900" indent="-342900">
-              <a:buSzPct val="100000"/>
-              <a:buChar char="•"/>
-            </a:pPr>
-            <a:r>
-              <a:rPr lang="en-US" sz="1500" dirty="0">
-                <a:solidFill>
-                  <a:srgbClr val="1A1A1A"/>
-                </a:solidFill>
-                <a:latin typeface="Arial" pitchFamily="34" charset="0"/>
-                <a:ea typeface="Arial" pitchFamily="34" charset="-122"/>
-                <a:cs typeface="Arial" pitchFamily="34" charset="-120"/>
-              </a:rPr>
-              <a:t>Pushed: Your commit was sent to GitHub.</a:t>
-            </a:r>
-            <a:endParaRPr lang="en-US" sz="1500" dirty="0"/>
-          </a:p>
-          <a:p>
-            <a:pPr marL="342900" indent="-342900">
-              <a:buSzPct val="100000"/>
-              <a:buChar char="•"/>
-            </a:pPr>
-            <a:r>
-              <a:rPr lang="en-US" sz="1500" dirty="0">
-                <a:solidFill>
-                  <a:srgbClr val="1A1A1A"/>
-                </a:solidFill>
-                <a:latin typeface="Arial" pitchFamily="34" charset="0"/>
-                <a:ea typeface="Arial" pitchFamily="34" charset="-122"/>
-                <a:cs typeface="Arial" pitchFamily="34" charset="-120"/>
-              </a:rPr>
-              <a:t>Deployed: The automated publish finished; verify the URL.</a:t>
-            </a:r>
-            <a:endParaRPr lang="en-US" sz="1500" dirty="0"/>
-          </a:p>
-          <a:p>
-            <a:pPr marL="342900" indent="-342900">
-              <a:buSzPct val="100000"/>
-              <a:buChar char="•"/>
-            </a:pPr>
-            <a:r>
-              <a:rPr lang="en-US" sz="1500" dirty="0">
-                <a:solidFill>
-                  <a:srgbClr val="1A1A1A"/>
-                </a:solidFill>
-                <a:latin typeface="Arial" pitchFamily="34" charset="0"/>
-                <a:ea typeface="Arial" pitchFamily="34" charset="-122"/>
-                <a:cs typeface="Arial" pitchFamily="34" charset="-120"/>
-              </a:rPr>
-              <a:t>Ask the room: Raise your hand if you think saving a file in VS Code updates the live website. (It does not — wait for hands, then correct.)</a:t>
-            </a:r>
-            <a:endParaRPr lang="en-US" sz="1500" dirty="0"/>
-          </a:p>
-        </p:txBody>
-      </p:sp>
-      <p:sp>
-        <p:nvSpPr>
-          <p:cNvPr id="10" name="Shape 8"/>
+        </p:txBody>
+      </p:sp>
+      <p:sp>
+        <p:nvSpPr>
+          <p:cNvPr id="9" name="Shape 7"/>
           <p:cNvSpPr/>
           <p:nvPr/>
         </p:nvSpPr>
@@ -10532,7 +9218,7 @@
       </p:sp>
       <p:sp>
         <p:nvSpPr>
-          <p:cNvPr id="11" name="Text 9"/>
+          <p:cNvPr id="10" name="Text 8"/>
           <p:cNvSpPr/>
           <p:nvPr/>
         </p:nvSpPr>
@@ -10563,7 +9249,7 @@
                 <a:ea typeface="Arial" pitchFamily="34" charset="-122"/>
                 <a:cs typeface="Arial" pitchFamily="34" charset="-120"/>
               </a:rPr>
-              <a:t>SAVE ≠ COMMIT ≠ PUSH ≠ DEPLOY · CHECK EACH STAGE</a:t>
+              <a:t>ARROWS ON THE WEB DECK · R FOR RESOURCES · N FOR NOTES</a:t>
             </a:r>
             <a:endParaRPr lang="en-US" sz="1100" dirty="0"/>
           </a:p>
@@ -10755,7 +9441,7 @@
                 <a:ea typeface="Arial" pitchFamily="34" charset="-122"/>
                 <a:cs typeface="Arial" pitchFamily="34" charset="-120"/>
               </a:rPr>
-              <a:t>AFTER THE LOCAL PREVIEW WORKS</a:t>
+              <a:t>FIRST PUSH</a:t>
             </a:r>
             <a:endParaRPr lang="en-US" sz="1200" dirty="0"/>
           </a:p>
@@ -10794,7 +9480,7 @@
                 <a:ea typeface="Arial" pitchFamily="34" charset="-122"/>
                 <a:cs typeface="Arial" pitchFamily="34" charset="-120"/>
               </a:rPr>
-              <a:t>Initialize Git, then push to your empty public repo.</a:t>
+              <a:t>Connect the project to GitHub.</a:t>
             </a:r>
             <a:endParaRPr lang="en-US" sz="2800" dirty="0"/>
           </a:p>
@@ -10833,7 +9519,7 @@
                 <a:ea typeface="Arial" pitchFamily="34" charset="-122"/>
                 <a:cs typeface="Arial" pitchFamily="34" charset="-120"/>
               </a:rPr>
-              <a:t>Use the empty Public repository you created (no README). This is the first time git init runs — do it before any other Git commands.</a:t>
+              <a:t>Empty Public repo. No README. Second terminal if npm run dev is still running.</a:t>
             </a:r>
             <a:endParaRPr lang="en-US" sz="1500" dirty="0"/>
           </a:p>
@@ -10848,7 +9534,7 @@
         <p:spPr>
           <a:xfrm>
             <a:off x="502920" y="2377440"/>
-            <a:ext cx="11155680" cy="1920240"/>
+            <a:ext cx="11155680" cy="877824"/>
           </a:xfrm>
           <a:prstGeom prst="rect">
             <a:avLst/>
@@ -10873,7 +9559,7 @@
                 <a:ea typeface="Arial" pitchFamily="34" charset="-122"/>
                 <a:cs typeface="Arial" pitchFamily="34" charset="-120"/>
               </a:rPr>
-              <a:t>Initialize and first commit: git init git branch -M main git add . git diff --staged git commit -m "Create my portfolio" C</a:t>
+              <a:t>First push</a:t>
             </a:r>
             <a:endParaRPr lang="en-US" sz="1500" dirty="0"/>
           </a:p>
@@ -10891,135 +9577,15 @@
                 <a:ea typeface="Arial" pitchFamily="34" charset="-122"/>
                 <a:cs typeface="Arial" pitchFamily="34" charset="-120"/>
               </a:rPr>
-              <a:t>Add remote and push: git remote add origin https://github.com/YOUR-USERNAME/YOUR-REPOSITORY.git git remote -v git push -u origin main If push asks for a password GitHub rejects account passwords for HTTPS. Use browser sign-in when prompted, or a classic Personal Access Token with repo scope (paste it as the password). Do not force-push. Walkthrough: student guide Step 3.</a:t>
+              <a:t>See the live web deck for full layout and screenshots.</a:t>
             </a:r>
             <a:endParaRPr lang="en-US" sz="1500" dirty="0"/>
           </a:p>
-          <a:p>
-            <a:pPr marL="342900" indent="-342900">
-              <a:buSzPct val="100000"/>
-              <a:buChar char="•"/>
-            </a:pPr>
-            <a:r>
-              <a:rPr lang="en-US" sz="1500" dirty="0">
-                <a:solidFill>
-                  <a:srgbClr val="1A1A1A"/>
-                </a:solidFill>
-                <a:latin typeface="Arial" pitchFamily="34" charset="0"/>
-                <a:ea typeface="Arial" pitchFamily="34" charset="-122"/>
-                <a:cs typeface="Arial" pitchFamily="34" charset="-120"/>
-              </a:rPr>
-              <a:t>Ask the room: Why must the repository be Public for free GitHub Pages on a student account?</a:t>
-            </a:r>
-            <a:endParaRPr lang="en-US" sz="1500" dirty="0"/>
-          </a:p>
-          <a:p>
-            <a:pPr marL="342900" indent="-342900">
-              <a:buSzPct val="100000"/>
-              <a:buChar char="•"/>
-            </a:pPr>
-            <a:r>
-              <a:rPr lang="en-US" sz="1500" dirty="0">
-                <a:solidFill>
-                  <a:srgbClr val="1A1A1A"/>
-                </a:solidFill>
-                <a:latin typeface="Arial" pitchFamily="34" charset="0"/>
-                <a:ea typeface="Arial" pitchFamily="34" charset="-122"/>
-                <a:cs typeface="Arial" pitchFamily="34" charset="-120"/>
-              </a:rPr>
-              <a:t>git init git branch -M main git add . git diff --staged git commit -m "Create my portfolio"</a:t>
-            </a:r>
-            <a:endParaRPr lang="en-US" sz="1500" dirty="0"/>
-          </a:p>
-          <a:p>
-            <a:pPr marL="342900" indent="-342900">
-              <a:buSzPct val="100000"/>
-              <a:buChar char="•"/>
-            </a:pPr>
-            <a:r>
-              <a:rPr lang="en-US" sz="1500" dirty="0">
-                <a:solidFill>
-                  <a:srgbClr val="1A1A1A"/>
-                </a:solidFill>
-                <a:latin typeface="Arial" pitchFamily="34" charset="0"/>
-                <a:ea typeface="Arial" pitchFamily="34" charset="-122"/>
-                <a:cs typeface="Arial" pitchFamily="34" charset="-120"/>
-              </a:rPr>
-              <a:t>git remote add origin https://github.com/YOUR-USERNAME/YOUR-REPOSITORY.git git remote -v git push -u origin main</a:t>
-            </a:r>
-            <a:endParaRPr lang="en-US" sz="1500" dirty="0"/>
-          </a:p>
         </p:txBody>
       </p:sp>
       <p:sp>
         <p:nvSpPr>
           <p:cNvPr id="10" name="Shape 8"/>
-          <p:cNvSpPr/>
-          <p:nvPr/>
-        </p:nvSpPr>
-        <p:spPr>
-          <a:xfrm>
-            <a:off x="502920" y="4434840"/>
-            <a:ext cx="11155680" cy="640080"/>
-          </a:xfrm>
-          <a:prstGeom prst="roundRect">
-            <a:avLst>
-              <a:gd name="adj" fmla="val 8571"/>
-            </a:avLst>
-          </a:prstGeom>
-          <a:solidFill>
-            <a:srgbClr val="FFF8CC"/>
-          </a:solidFill>
-          <a:ln w="12700">
-            <a:solidFill>
-              <a:srgbClr val="FFDB00"/>
-            </a:solidFill>
-            <a:prstDash val="solid"/>
-          </a:ln>
-        </p:spPr>
-      </p:sp>
-      <p:sp>
-        <p:nvSpPr>
-          <p:cNvPr id="11" name="Text 9"/>
-          <p:cNvSpPr/>
-          <p:nvPr/>
-        </p:nvSpPr>
-        <p:spPr>
-          <a:xfrm>
-            <a:off x="640080" y="4544568"/>
-            <a:ext cx="10881360" cy="438912"/>
-          </a:xfrm>
-          <a:prstGeom prst="rect">
-            <a:avLst/>
-          </a:prstGeom>
-          <a:noFill/>
-          <a:ln/>
-        </p:spPr>
-        <p:txBody>
-          <a:bodyPr wrap="square" rtlCol="0" anchor="ctr"/>
-          <a:lstStyle/>
-          <a:p>
-            <a:pPr indent="0" marL="0">
-              <a:buNone/>
-            </a:pPr>
-            <a:r>
-              <a:rPr lang="en-US" sz="1300" b="1" dirty="0">
-                <a:solidFill>
-                  <a:srgbClr val="1A1A1A"/>
-                </a:solidFill>
-                <a:latin typeface="Arial" pitchFamily="34" charset="0"/>
-                <a:ea typeface="Arial" pitchFamily="34" charset="-122"/>
-                <a:cs typeface="Arial" pitchFamily="34" charset="-120"/>
-              </a:rPr>
-              <a:t>Ask the room: Why must the repository be Public for free GitHub Pages on a student account?</a:t>
-            </a:r>
-            <a:endParaRPr lang="en-US" sz="1300" dirty="0"/>
-          </a:p>
-        </p:txBody>
-      </p:sp>
-      <p:sp>
-        <p:nvSpPr>
-          <p:cNvPr id="12" name="Shape 10"/>
           <p:cNvSpPr/>
           <p:nvPr/>
         </p:nvSpPr>
@@ -11044,7 +9610,7 @@
       </p:sp>
       <p:sp>
         <p:nvSpPr>
-          <p:cNvPr id="13" name="Text 11"/>
+          <p:cNvPr id="11" name="Text 9"/>
           <p:cNvSpPr/>
           <p:nvPr/>
         </p:nvSpPr>
@@ -11075,7 +9641,7 @@
                 <a:ea typeface="Arial" pitchFamily="34" charset="-122"/>
                 <a:cs typeface="Arial" pitchFamily="34" charset="-120"/>
               </a:rPr>
-              <a:t>GIT INIT STARTS HISTORY · THEN PUSH TO ORIGIN</a:t>
+              <a:t>ARROWS ON THE WEB DECK · R FOR RESOURCES · N FOR NOTES</a:t>
             </a:r>
             <a:endParaRPr lang="en-US" sz="1100" dirty="0"/>
           </a:p>
@@ -11267,7 +9833,7 @@
                 <a:ea typeface="Arial" pitchFamily="34" charset="-122"/>
                 <a:cs typeface="Arial" pitchFamily="34" charset="-120"/>
               </a:rPr>
-              <a:t>COMMANDS TO KEEP HANDY</a:t>
+              <a:t>SAFE READS</a:t>
             </a:r>
             <a:endParaRPr lang="en-US" sz="1200" dirty="0"/>
           </a:p>
@@ -11306,7 +9872,7 @@
                 <a:ea typeface="Arial" pitchFamily="34" charset="-122"/>
                 <a:cs typeface="Arial" pitchFamily="34" charset="-120"/>
               </a:rPr>
-              <a:t>Check the current state first.</a:t>
+              <a:t>Start with git status .</a:t>
             </a:r>
             <a:endParaRPr lang="en-US" sz="2800" dirty="0"/>
           </a:p>
@@ -11321,46 +9887,7 @@
         <p:spPr>
           <a:xfrm>
             <a:off x="502920" y="1783080"/>
-            <a:ext cx="11155680" cy="502920"/>
-          </a:xfrm>
-          <a:prstGeom prst="rect">
-            <a:avLst/>
-          </a:prstGeom>
-          <a:noFill/>
-          <a:ln/>
-        </p:spPr>
-        <p:txBody>
-          <a:bodyPr wrap="square" rtlCol="0" anchor="ctr"/>
-          <a:lstStyle/>
-          <a:p>
-            <a:pPr indent="0" marL="0">
-              <a:buNone/>
-            </a:pPr>
-            <a:r>
-              <a:rPr lang="en-US" sz="1500" dirty="0">
-                <a:solidFill>
-                  <a:srgbClr val="555555"/>
-                </a:solidFill>
-                <a:latin typeface="Arial" pitchFamily="34" charset="0"/>
-                <a:ea typeface="Arial" pitchFamily="34" charset="-122"/>
-                <a:cs typeface="Arial" pitchFamily="34" charset="-120"/>
-              </a:rPr>
-              <a:t>Use these after git init from the previous slide. Start with git status when you're unsure.</a:t>
-            </a:r>
-            <a:endParaRPr lang="en-US" sz="1500" dirty="0"/>
-          </a:p>
-        </p:txBody>
-      </p:sp>
-      <p:sp>
-        <p:nvSpPr>
-          <p:cNvPr id="9" name="Text 7"/>
-          <p:cNvSpPr/>
-          <p:nvPr/>
-        </p:nvSpPr>
-        <p:spPr>
-          <a:xfrm>
-            <a:off x="502920" y="2377440"/>
-            <a:ext cx="11155680" cy="2267712"/>
+            <a:ext cx="11155680" cy="1225296"/>
           </a:xfrm>
           <a:prstGeom prst="rect">
             <a:avLst/>
@@ -11385,7 +9912,7 @@
                 <a:ea typeface="Arial" pitchFamily="34" charset="-122"/>
                 <a:cs typeface="Arial" pitchFamily="34" charset="-120"/>
               </a:rPr>
-              <a:t>What is changed?: Shows the branch, staged files, unstaged edits, and untracked files.</a:t>
+              <a:t>git status What changed? Which branch?</a:t>
             </a:r>
             <a:endParaRPr lang="en-US" sz="1500" dirty="0"/>
           </a:p>
@@ -11403,7 +9930,7 @@
                 <a:ea typeface="Arial" pitchFamily="34" charset="-122"/>
                 <a:cs typeface="Arial" pitchFamily="34" charset="-120"/>
               </a:rPr>
-              <a:t>What did I edit?: Shows changes that are not staged yet.</a:t>
+              <a:t>git diff What did I edit?</a:t>
             </a:r>
             <a:endParaRPr lang="en-US" sz="1500" dirty="0"/>
           </a:p>
@@ -11421,135 +9948,15 @@
                 <a:ea typeface="Arial" pitchFamily="34" charset="-122"/>
                 <a:cs typeface="Arial" pitchFamily="34" charset="-120"/>
               </a:rPr>
-              <a:t>What will I commit?: Shows the staged snapshot that the next commit will record.</a:t>
+              <a:t>git remote -v Where does push go?</a:t>
             </a:r>
             <a:endParaRPr lang="en-US" sz="1500" dirty="0"/>
           </a:p>
-          <a:p>
-            <a:pPr marL="342900" indent="-342900">
-              <a:buSzPct val="100000"/>
-              <a:buChar char="•"/>
-            </a:pPr>
-            <a:r>
-              <a:rPr lang="en-US" sz="1500" dirty="0">
-                <a:solidFill>
-                  <a:srgbClr val="1A1A1A"/>
-                </a:solidFill>
-                <a:latin typeface="Arial" pitchFamily="34" charset="0"/>
-                <a:ea typeface="Arial" pitchFamily="34" charset="-122"/>
-                <a:cs typeface="Arial" pitchFamily="34" charset="-120"/>
-              </a:rPr>
-              <a:t>What happened recently?: Shows the five latest commits in a compact list.</a:t>
-            </a:r>
-            <a:endParaRPr lang="en-US" sz="1500" dirty="0"/>
-          </a:p>
-          <a:p>
-            <a:pPr marL="342900" indent="-342900">
-              <a:buSzPct val="100000"/>
-              <a:buChar char="•"/>
-            </a:pPr>
-            <a:r>
-              <a:rPr lang="en-US" sz="1500" dirty="0">
-                <a:solidFill>
-                  <a:srgbClr val="1A1A1A"/>
-                </a:solidFill>
-                <a:latin typeface="Arial" pitchFamily="34" charset="0"/>
-                <a:ea typeface="Arial" pitchFamily="34" charset="-122"/>
-                <a:cs typeface="Arial" pitchFamily="34" charset="-120"/>
-              </a:rPr>
-              <a:t>Where am I working?: Prints the current branch name.</a:t>
-            </a:r>
-            <a:endParaRPr lang="en-US" sz="1500" dirty="0"/>
-          </a:p>
-          <a:p>
-            <a:pPr marL="342900" indent="-342900">
-              <a:buSzPct val="100000"/>
-              <a:buChar char="•"/>
-            </a:pPr>
-            <a:r>
-              <a:rPr lang="en-US" sz="1500" dirty="0">
-                <a:solidFill>
-                  <a:srgbClr val="1A1A1A"/>
-                </a:solidFill>
-                <a:latin typeface="Arial" pitchFamily="34" charset="0"/>
-                <a:ea typeface="Arial" pitchFamily="34" charset="-122"/>
-                <a:cs typeface="Arial" pitchFamily="34" charset="-120"/>
-              </a:rPr>
-              <a:t>Where does push go?: Shows the remote repository URL, normally named origin .</a:t>
-            </a:r>
-            <a:endParaRPr lang="en-US" sz="1500" dirty="0"/>
-          </a:p>
-        </p:txBody>
-      </p:sp>
-      <p:sp>
-        <p:nvSpPr>
-          <p:cNvPr id="10" name="Shape 8"/>
-          <p:cNvSpPr/>
-          <p:nvPr/>
-        </p:nvSpPr>
-        <p:spPr>
-          <a:xfrm>
-            <a:off x="502920" y="4782312"/>
-            <a:ext cx="11155680" cy="640080"/>
-          </a:xfrm>
-          <a:prstGeom prst="roundRect">
-            <a:avLst>
-              <a:gd name="adj" fmla="val 8571"/>
-            </a:avLst>
-          </a:prstGeom>
-          <a:solidFill>
-            <a:srgbClr val="FFF8CC"/>
-          </a:solidFill>
-          <a:ln w="12700">
-            <a:solidFill>
-              <a:srgbClr val="FFDB00"/>
-            </a:solidFill>
-            <a:prstDash val="solid"/>
-          </a:ln>
-        </p:spPr>
-      </p:sp>
-      <p:sp>
-        <p:nvSpPr>
-          <p:cNvPr id="11" name="Text 9"/>
-          <p:cNvSpPr/>
-          <p:nvPr/>
-        </p:nvSpPr>
-        <p:spPr>
-          <a:xfrm>
-            <a:off x="640080" y="4892040"/>
-            <a:ext cx="10881360" cy="438912"/>
-          </a:xfrm>
-          <a:prstGeom prst="rect">
-            <a:avLst/>
-          </a:prstGeom>
-          <a:noFill/>
-          <a:ln/>
-        </p:spPr>
-        <p:txBody>
-          <a:bodyPr wrap="square" rtlCol="0" anchor="ctr"/>
-          <a:lstStyle/>
-          <a:p>
-            <a:pPr indent="0" marL="0">
-              <a:buNone/>
-            </a:pPr>
-            <a:r>
-              <a:rPr lang="en-US" sz="1300" b="1" dirty="0">
-                <a:solidFill>
-                  <a:srgbClr val="1A1A1A"/>
-                </a:solidFill>
-                <a:latin typeface="Arial" pitchFamily="34" charset="0"/>
-                <a:ea typeface="Arial" pitchFamily="34" charset="-122"/>
-                <a:cs typeface="Arial" pitchFamily="34" charset="-120"/>
-              </a:rPr>
-              <a:t>Ask the room: Turn and talk (30 sec): which command do you run first when something looks wrong?</a:t>
-            </a:r>
-            <a:endParaRPr lang="en-US" sz="1300" dirty="0"/>
-          </a:p>
-        </p:txBody>
-      </p:sp>
-      <p:sp>
-        <p:nvSpPr>
-          <p:cNvPr id="12" name="Shape 10"/>
+        </p:txBody>
+      </p:sp>
+      <p:sp>
+        <p:nvSpPr>
+          <p:cNvPr id="9" name="Shape 7"/>
           <p:cNvSpPr/>
           <p:nvPr/>
         </p:nvSpPr>
@@ -11574,7 +9981,7 @@
       </p:sp>
       <p:sp>
         <p:nvSpPr>
-          <p:cNvPr id="13" name="Text 11"/>
+          <p:cNvPr id="10" name="Text 8"/>
           <p:cNvSpPr/>
           <p:nvPr/>
         </p:nvSpPr>
@@ -11605,7 +10012,7 @@
                 <a:ea typeface="Arial" pitchFamily="34" charset="-122"/>
                 <a:cs typeface="Arial" pitchFamily="34" charset="-120"/>
               </a:rPr>
-              <a:t>INSPECT FIRST · MAKE ONE CHANGE AT A TIME · THESE COMMANDS ONLY SHOW THE CURRENT STATE</a:t>
+              <a:t>ARROWS ON THE WEB DECK · R FOR RESOURCES · N FOR NOTES</a:t>
             </a:r>
             <a:endParaRPr lang="en-US" sz="1100" dirty="0"/>
           </a:p>
@@ -11797,7 +10204,7 @@
                 <a:ea typeface="Arial" pitchFamily="34" charset="-122"/>
                 <a:cs typeface="Arial" pitchFamily="34" charset="-120"/>
               </a:rPr>
-              <a:t>MAKING A COMMIT</a:t>
+              <a:t>SOURCE CONTROL</a:t>
             </a:r>
             <a:endParaRPr lang="en-US" sz="1200" dirty="0"/>
           </a:p>
@@ -11836,7 +10243,7 @@
                 <a:ea typeface="Arial" pitchFamily="34" charset="-122"/>
                 <a:cs typeface="Arial" pitchFamily="34" charset="-120"/>
               </a:rPr>
-              <a:t>Review the diff before you commit.</a:t>
+              <a:t>Read the diff. Then commit.</a:t>
             </a:r>
             <a:endParaRPr lang="en-US" sz="2800" dirty="0"/>
           </a:p>
@@ -11851,46 +10258,7 @@
         <p:spPr>
           <a:xfrm>
             <a:off x="502920" y="1783080"/>
-            <a:ext cx="11155680" cy="502920"/>
-          </a:xfrm>
-          <a:prstGeom prst="rect">
-            <a:avLst/>
-          </a:prstGeom>
-          <a:noFill/>
-          <a:ln/>
-        </p:spPr>
-        <p:txBody>
-          <a:bodyPr wrap="square" rtlCol="0" anchor="ctr"/>
-          <a:lstStyle/>
-          <a:p>
-            <a:pPr indent="0" marL="0">
-              <a:buNone/>
-            </a:pPr>
-            <a:r>
-              <a:rPr lang="en-US" sz="1500" dirty="0">
-                <a:solidFill>
-                  <a:srgbClr val="555555"/>
-                </a:solidFill>
-                <a:latin typeface="Arial" pitchFamily="34" charset="0"/>
-                <a:ea typeface="Arial" pitchFamily="34" charset="-122"/>
-                <a:cs typeface="Arial" pitchFamily="34" charset="-120"/>
-              </a:rPr>
-              <a:t>Primary path: Source Control in VS Code. Keep each commit to one change.</a:t>
-            </a:r>
-            <a:endParaRPr lang="en-US" sz="1500" dirty="0"/>
-          </a:p>
-        </p:txBody>
-      </p:sp>
-      <p:sp>
-        <p:nvSpPr>
-          <p:cNvPr id="9" name="Text 7"/>
-          <p:cNvSpPr/>
-          <p:nvPr/>
-        </p:nvSpPr>
-        <p:spPr>
-          <a:xfrm>
-            <a:off x="502920" y="2377440"/>
-            <a:ext cx="11155680" cy="2615184"/>
+            <a:ext cx="11155680" cy="2962656"/>
           </a:xfrm>
           <a:prstGeom prst="rect">
             <a:avLst/>
@@ -11915,7 +10283,7 @@
                 <a:ea typeface="Arial" pitchFamily="34" charset="-122"/>
                 <a:cs typeface="Arial" pitchFamily="34" charset="-120"/>
               </a:rPr>
-              <a:t>Vague commit: updates</a:t>
+              <a:t>Open Source Control Activity Bar · branch icon</a:t>
             </a:r>
             <a:endParaRPr lang="en-US" sz="1500" dirty="0"/>
           </a:p>
@@ -11933,7 +10301,7 @@
                 <a:ea typeface="Arial" pitchFamily="34" charset="-122"/>
                 <a:cs typeface="Arial" pitchFamily="34" charset="-120"/>
               </a:rPr>
-              <a:t>After committing: Source Control should show no pending changes for this task.</a:t>
+              <a:t>Click the file read green / red</a:t>
             </a:r>
             <a:endParaRPr lang="en-US" sz="1500" dirty="0"/>
           </a:p>
@@ -11951,7 +10319,7 @@
                 <a:ea typeface="Arial" pitchFamily="34" charset="-122"/>
                 <a:cs typeface="Arial" pitchFamily="34" charset="-120"/>
               </a:rPr>
-              <a:t>Ask the room: Which message would you accept in a PR review: updates or Add featured project ? Why?</a:t>
+              <a:t>Stage with + only what you mean</a:t>
             </a:r>
             <a:endParaRPr lang="en-US" sz="1500" dirty="0"/>
           </a:p>
@@ -11969,7 +10337,7 @@
                 <a:ea typeface="Arial" pitchFamily="34" charset="-122"/>
                 <a:cs typeface="Arial" pitchFamily="34" charset="-120"/>
               </a:rPr>
-              <a:t>Source Control click the changed file</a:t>
+              <a:t>Message → Commit e.g. Add featured project</a:t>
             </a:r>
             <a:endParaRPr lang="en-US" sz="1500" dirty="0"/>
           </a:p>
@@ -11987,7 +10355,7 @@
                 <a:ea typeface="Arial" pitchFamily="34" charset="-122"/>
                 <a:cs typeface="Arial" pitchFamily="34" charset="-120"/>
               </a:rPr>
-              <a:t>Click + next to src/data/profile.js</a:t>
+              <a:t>Open Source Control: Activity Bar · branch icon</a:t>
             </a:r>
             <a:endParaRPr lang="en-US" sz="1500" dirty="0"/>
           </a:p>
@@ -12005,7 +10373,7 @@
                 <a:ea typeface="Arial" pitchFamily="34" charset="-122"/>
                 <a:cs typeface="Arial" pitchFamily="34" charset="-120"/>
               </a:rPr>
-              <a:t>Staged Changes read green/red diff</a:t>
+              <a:t>Click the file: read green / red</a:t>
             </a:r>
             <a:endParaRPr lang="en-US" sz="1500" dirty="0"/>
           </a:p>
@@ -12023,65 +10391,17 @@
                 <a:ea typeface="Arial" pitchFamily="34" charset="-122"/>
                 <a:cs typeface="Arial" pitchFamily="34" charset="-120"/>
               </a:rPr>
-              <a:t>Message → Commit then Publish / Sync</a:t>
+              <a:t>Stage with +: only what you mean</a:t>
             </a:r>
             <a:endParaRPr lang="en-US" sz="1500" dirty="0"/>
           </a:p>
-        </p:txBody>
-      </p:sp>
-      <p:sp>
-        <p:nvSpPr>
-          <p:cNvPr id="10" name="Shape 8"/>
-          <p:cNvSpPr/>
-          <p:nvPr/>
-        </p:nvSpPr>
-        <p:spPr>
-          <a:xfrm>
-            <a:off x="502920" y="5074920"/>
-            <a:ext cx="11155680" cy="640080"/>
-          </a:xfrm>
-          <a:prstGeom prst="roundRect">
-            <a:avLst>
-              <a:gd name="adj" fmla="val 8571"/>
-            </a:avLst>
-          </a:prstGeom>
-          <a:solidFill>
-            <a:srgbClr val="FFF8CC"/>
-          </a:solidFill>
-          <a:ln w="12700">
-            <a:solidFill>
-              <a:srgbClr val="FFDB00"/>
-            </a:solidFill>
-            <a:prstDash val="solid"/>
-          </a:ln>
-        </p:spPr>
-      </p:sp>
-      <p:sp>
-        <p:nvSpPr>
-          <p:cNvPr id="11" name="Text 9"/>
-          <p:cNvSpPr/>
-          <p:nvPr/>
-        </p:nvSpPr>
-        <p:spPr>
-          <a:xfrm>
-            <a:off x="640080" y="5184648"/>
-            <a:ext cx="10881360" cy="438912"/>
-          </a:xfrm>
-          <a:prstGeom prst="rect">
-            <a:avLst/>
-          </a:prstGeom>
-          <a:noFill/>
-          <a:ln/>
-        </p:spPr>
-        <p:txBody>
-          <a:bodyPr wrap="square" rtlCol="0" anchor="ctr"/>
-          <a:lstStyle/>
-          <a:p>
-            <a:pPr indent="0" marL="0">
-              <a:buNone/>
-            </a:pPr>
-            <a:r>
-              <a:rPr lang="en-US" sz="1300" b="1" dirty="0">
+          <a:p>
+            <a:pPr marL="342900" indent="-342900">
+              <a:buSzPct val="100000"/>
+              <a:buChar char="•"/>
+            </a:pPr>
+            <a:r>
+              <a:rPr lang="en-US" sz="1500" dirty="0">
                 <a:solidFill>
                   <a:srgbClr val="1A1A1A"/>
                 </a:solidFill>
@@ -12089,15 +10409,15 @@
                 <a:ea typeface="Arial" pitchFamily="34" charset="-122"/>
                 <a:cs typeface="Arial" pitchFamily="34" charset="-120"/>
               </a:rPr>
-              <a:t>Ask the room: Which message would you accept in a PR review: updates or Add featured project ? Why?</a:t>
-            </a:r>
-            <a:endParaRPr lang="en-US" sz="1300" dirty="0"/>
-          </a:p>
-        </p:txBody>
-      </p:sp>
-      <p:sp>
-        <p:nvSpPr>
-          <p:cNvPr id="12" name="Shape 10"/>
+              <a:t>Message → Commit: e.g. Add featured project</a:t>
+            </a:r>
+            <a:endParaRPr lang="en-US" sz="1500" dirty="0"/>
+          </a:p>
+        </p:txBody>
+      </p:sp>
+      <p:sp>
+        <p:nvSpPr>
+          <p:cNvPr id="9" name="Shape 7"/>
           <p:cNvSpPr/>
           <p:nvPr/>
         </p:nvSpPr>
@@ -12122,7 +10442,7 @@
       </p:sp>
       <p:sp>
         <p:nvSpPr>
-          <p:cNvPr id="13" name="Text 11"/>
+          <p:cNvPr id="10" name="Text 8"/>
           <p:cNvSpPr/>
           <p:nvPr/>
         </p:nvSpPr>
@@ -12153,7 +10473,7 @@
                 <a:ea typeface="Arial" pitchFamily="34" charset="-122"/>
                 <a:cs typeface="Arial" pitchFamily="34" charset="-120"/>
               </a:rPr>
-              <a:t>STAGE ONLY THE FILES YOU MEAN TO COMMIT · COMMIT WHAT YOU INTEND</a:t>
+              <a:t>ARROWS ON THE WEB DECK · R FOR RESOURCES · N FOR NOTES</a:t>
             </a:r>
             <a:endParaRPr lang="en-US" sz="1100" dirty="0"/>
           </a:p>

</xml_diff>

<commit_message>
Add Actions section using bundled deploy.yml
</commit_message>
<xml_diff>
--- a/downloads/workshop-1-presentation.pptx
+++ b/downloads/workshop-1-presentation.pptx
@@ -25,9 +25,10 @@
     <p:sldId id="273" r:id="rId19"/>
     <p:sldId id="274" r:id="rId20"/>
     <p:sldId id="275" r:id="rId21"/>
+    <p:sldId id="276" r:id="rId22"/>
   </p:sldIdLst>
   <p:notesMasterIdLst>
-    <p:notesMasterId r:id="rId22"/>
+    <p:notesMasterId r:id="rId23"/>
   </p:notesMasterIdLst>
   <p:sldSz cx="12191695" cy="6858000"/>
   <p:notesSz cx="6858000" cy="12191695"/>
@@ -1137,7 +1138,7 @@
           <a:p>
             <a:r>
               <a:rPr lang="en-US" dirty="0"/>
-              <a:t>Source must be GitHub Actions. First run often fails until Source is set — teach Re-run all jobs. Feature branches do not publish. Cold-call: does pushing a feature branch publish? Wait for no.</a:t>
+              <a:t>Open the file in Explorer live: .github/workflows/deploy.yml. Emphasize: it came in the ZIP — students do not author YAML today. Walk three ideas only: trigger on main, build steps, deploy to Pages. Cold-call: does a feature-branch push publish? Wait for no — on: branches: [main].</a:t>
             </a:r>
             <a:endParaRPr lang="en-US" dirty="0"/>
           </a:p>
@@ -1225,7 +1226,7 @@
           <a:p>
             <a:r>
               <a:rPr lang="en-US" dirty="0"/>
-              <a:t>Help-desk slide for lab. Protocol: status → reproduce → first error → one fix. More cases in the student guide.</a:t>
+              <a:t>Source must be GitHub Actions. First run often fails until Source is set — teach Re-run all jobs. Feature branches do not publish. Point back to the workflow file: that is why Source = GitHub Actions.</a:t>
             </a:r>
             <a:endParaRPr lang="en-US" dirty="0"/>
           </a:p>
@@ -1313,7 +1314,7 @@
           <a:p>
             <a:r>
               <a:rPr lang="en-US" dirty="0"/>
-              <a:t>Leave up ~30 min. Circulate: issue, Status Bar branch name, Source Control diff. Prefer a finished small change over a perfect portfolio.</a:t>
+              <a:t>Help-desk slide for lab. Protocol: status → reproduce → first error → one fix. More cases in the student guide.</a:t>
             </a:r>
             <a:endParaRPr lang="en-US" dirty="0"/>
           </a:p>
@@ -1401,7 +1402,7 @@
           <a:p>
             <a:r>
               <a:rPr lang="en-US" dirty="0"/>
-              <a:t>Gallery walk or pair share. Issue → diff → PR → URL. Ask one Copilot line + one verification.</a:t>
+              <a:t>Leave up ~30 min. Circulate: issue, Status Bar branch name, Source Control diff. Prefer a finished small change over a perfect portfolio.</a:t>
             </a:r>
             <a:endParaRPr lang="en-US" dirty="0"/>
           </a:p>
@@ -1577,7 +1578,7 @@
           <a:p>
             <a:r>
               <a:rPr lang="en-US" dirty="0"/>
-              <a:t>Park during leftover lab. Exit ticket aloud. Resources (R) for ZIP and walkthrough.</a:t>
+              <a:t>Gallery walk or pair share. Issue → diff → PR → URL. Ask one Copilot line + one verification.</a:t>
             </a:r>
             <a:endParaRPr lang="en-US" dirty="0"/>
           </a:p>
@@ -1601,6 +1602,94 @@
             <a:fld id="{F7021451-1387-4CA6-816F-3879F97B5CBC}" type="slidenum">
               <a:rPr lang="en-US"/>
               <a:t>20</a:t>
+            </a:fld>
+            <a:endParaRPr lang="en-US"/>
+          </a:p>
+        </p:txBody>
+      </p:sp>
+    </p:spTree>
+    <p:extLst>
+      <p:ext uri="{BB962C8B-B14F-4D97-AF65-F5344CB8AC3E}">
+        <p14:creationId xmlns:p14="http://schemas.microsoft.com/office/powerpoint/2010/main" val="1024086991"/>
+      </p:ext>
+    </p:extLst>
+  </p:cSld>
+  <p:clrMapOvr>
+    <a:masterClrMapping/>
+  </p:clrMapOvr>
+</p:notes>
+</file>
+
+<file path=ppt/notesSlides/notesSlide21.xml><?xml version="1.0" encoding="utf-8"?>
+<p:notes xmlns:a="http://schemas.openxmlformats.org/drawingml/2006/main" xmlns:r="http://schemas.openxmlformats.org/officeDocument/2006/relationships" xmlns:p="http://schemas.openxmlformats.org/presentationml/2006/main">
+  <p:cSld>
+    <p:spTree>
+      <p:nvGrpSpPr>
+        <p:cNvPr id="1" name=""/>
+        <p:cNvGrpSpPr/>
+        <p:nvPr/>
+      </p:nvGrpSpPr>
+      <p:grpSpPr>
+        <a:xfrm>
+          <a:off x="0" y="0"/>
+          <a:ext cx="0" cy="0"/>
+          <a:chOff x="0" y="0"/>
+          <a:chExt cx="0" cy="0"/>
+        </a:xfrm>
+      </p:grpSpPr>
+      <p:sp>
+        <p:nvSpPr>
+          <p:cNvPr id="2" name="Slide Image Placeholder 1"/>
+          <p:cNvSpPr>
+            <a:spLocks noGrp="1" noRot="1" noChangeAspect="1"/>
+          </p:cNvSpPr>
+          <p:nvPr>
+            <p:ph type="sldImg"/>
+          </p:nvPr>
+        </p:nvSpPr>
+        <p:spPr/>
+      </p:sp>
+      <p:sp>
+        <p:nvSpPr>
+          <p:cNvPr id="3" name="Notes Placeholder 2"/>
+          <p:cNvSpPr>
+            <a:spLocks noGrp="1"/>
+          </p:cNvSpPr>
+          <p:nvPr>
+            <p:ph type="body" idx="1"/>
+          </p:nvPr>
+        </p:nvSpPr>
+        <p:spPr/>
+        <p:txBody>
+          <a:bodyPr/>
+          <a:lstStyle/>
+          <a:p>
+            <a:r>
+              <a:rPr lang="en-US" dirty="0"/>
+              <a:t>Park during leftover lab. Exit ticket aloud. Resources (R) for ZIP and walkthrough.</a:t>
+            </a:r>
+            <a:endParaRPr lang="en-US" dirty="0"/>
+          </a:p>
+        </p:txBody>
+      </p:sp>
+      <p:sp>
+        <p:nvSpPr>
+          <p:cNvPr id="4" name="Slide Number Placeholder 3"/>
+          <p:cNvSpPr>
+            <a:spLocks noGrp="1"/>
+          </p:cNvSpPr>
+          <p:nvPr>
+            <p:ph type="sldNum" sz="quarter" idx="10"/>
+          </p:nvPr>
+        </p:nvSpPr>
+        <p:spPr/>
+        <p:txBody>
+          <a:bodyPr/>
+          <a:lstStyle/>
+          <a:p>
+            <a:fld id="{F7021451-1387-4CA6-816F-3879F97B5CBC}" type="slidenum">
+              <a:rPr lang="en-US"/>
+              <a:t>21</a:t>
             </a:fld>
             <a:endParaRPr lang="en-US"/>
           </a:p>
@@ -2681,7 +2770,7 @@
                 <a:ea typeface="Arial" pitchFamily="34" charset="-122"/>
                 <a:cs typeface="Arial" pitchFamily="34" charset="-120"/>
               </a:rPr>
-              <a:t>01 / 20</a:t>
+              <a:t>01 / 21</a:t>
             </a:r>
             <a:endParaRPr lang="en-US" sz="1100" dirty="0"/>
           </a:p>
@@ -3070,7 +3159,7 @@
                 <a:ea typeface="Arial" pitchFamily="34" charset="-122"/>
                 <a:cs typeface="Arial" pitchFamily="34" charset="-120"/>
               </a:rPr>
-              <a:t>10 / 20</a:t>
+              <a:t>10 / 21</a:t>
             </a:r>
             <a:endParaRPr lang="en-US" sz="1100" dirty="0"/>
           </a:p>
@@ -3477,7 +3566,7 @@
                 <a:ea typeface="Arial" pitchFamily="34" charset="-122"/>
                 <a:cs typeface="Arial" pitchFamily="34" charset="-120"/>
               </a:rPr>
-              <a:t>11 / 20</a:t>
+              <a:t>11 / 21</a:t>
             </a:r>
             <a:endParaRPr lang="en-US" sz="1100" dirty="0"/>
           </a:p>
@@ -3848,7 +3937,7 @@
                 <a:ea typeface="Arial" pitchFamily="34" charset="-122"/>
                 <a:cs typeface="Arial" pitchFamily="34" charset="-120"/>
               </a:rPr>
-              <a:t>12 / 20</a:t>
+              <a:t>12 / 21</a:t>
             </a:r>
             <a:endParaRPr lang="en-US" sz="1100" dirty="0"/>
           </a:p>
@@ -4255,7 +4344,7 @@
                 <a:ea typeface="Arial" pitchFamily="34" charset="-122"/>
                 <a:cs typeface="Arial" pitchFamily="34" charset="-120"/>
               </a:rPr>
-              <a:t>13 / 20</a:t>
+              <a:t>13 / 21</a:t>
             </a:r>
             <a:endParaRPr lang="en-US" sz="1100" dirty="0"/>
           </a:p>
@@ -4680,7 +4769,7 @@
                 <a:ea typeface="Arial" pitchFamily="34" charset="-122"/>
                 <a:cs typeface="Arial" pitchFamily="34" charset="-120"/>
               </a:rPr>
-              <a:t>14 / 20</a:t>
+              <a:t>14 / 21</a:t>
             </a:r>
             <a:endParaRPr lang="en-US" sz="1100" dirty="0"/>
           </a:p>
@@ -5051,7 +5140,7 @@
                 <a:ea typeface="Arial" pitchFamily="34" charset="-122"/>
                 <a:cs typeface="Arial" pitchFamily="34" charset="-120"/>
               </a:rPr>
-              <a:t>15 / 20</a:t>
+              <a:t>15 / 21</a:t>
             </a:r>
             <a:endParaRPr lang="en-US" sz="1100" dirty="0"/>
           </a:p>
@@ -5440,7 +5529,7 @@
                 <a:ea typeface="Arial" pitchFamily="34" charset="-122"/>
                 <a:cs typeface="Arial" pitchFamily="34" charset="-120"/>
               </a:rPr>
-              <a:t>16 / 20</a:t>
+              <a:t>16 / 21</a:t>
             </a:r>
             <a:endParaRPr lang="en-US" sz="1100" dirty="0"/>
           </a:p>
@@ -5479,7 +5568,7 @@
                 <a:ea typeface="Arial" pitchFamily="34" charset="-122"/>
                 <a:cs typeface="Arial" pitchFamily="34" charset="-120"/>
               </a:rPr>
-              <a:t>LIVE SITE</a:t>
+              <a:t>ALREADY IN YOUR ZIP</a:t>
             </a:r>
             <a:endParaRPr lang="en-US" sz="1200" dirty="0"/>
           </a:p>
@@ -5518,7 +5607,7 @@
                 <a:ea typeface="Arial" pitchFamily="34" charset="-122"/>
                 <a:cs typeface="Arial" pitchFamily="34" charset="-120"/>
               </a:rPr>
-              <a:t>Merge to main. Open the URL.</a:t>
+              <a:t>Actions is the robot that builds the site.</a:t>
             </a:r>
             <a:endParaRPr lang="en-US" sz="2800" dirty="0"/>
           </a:p>
@@ -5533,7 +5622,46 @@
         <p:spPr>
           <a:xfrm>
             <a:off x="502920" y="1783080"/>
-            <a:ext cx="11155680" cy="1225296"/>
+            <a:ext cx="11155680" cy="502920"/>
+          </a:xfrm>
+          <a:prstGeom prst="rect">
+            <a:avLst/>
+          </a:prstGeom>
+          <a:noFill/>
+          <a:ln/>
+        </p:spPr>
+        <p:txBody>
+          <a:bodyPr wrap="square" rtlCol="0" anchor="ctr"/>
+          <a:lstStyle/>
+          <a:p>
+            <a:pPr indent="0" marL="0">
+              <a:buNone/>
+            </a:pPr>
+            <a:r>
+              <a:rPr lang="en-US" sz="1500" dirty="0">
+                <a:solidFill>
+                  <a:srgbClr val="555555"/>
+                </a:solidFill>
+                <a:latin typeface="Arial" pitchFamily="34" charset="0"/>
+                <a:ea typeface="Arial" pitchFamily="34" charset="-122"/>
+                <a:cs typeface="Arial" pitchFamily="34" charset="-120"/>
+              </a:rPr>
+              <a:t>Open .github/workflows/deploy.yml — you do not write this file today.</a:t>
+            </a:r>
+            <a:endParaRPr lang="en-US" sz="1500" dirty="0"/>
+          </a:p>
+        </p:txBody>
+      </p:sp>
+      <p:sp>
+        <p:nvSpPr>
+          <p:cNvPr id="9" name="Text 7"/>
+          <p:cNvSpPr/>
+          <p:nvPr/>
+        </p:nvSpPr>
+        <p:spPr>
+          <a:xfrm>
+            <a:off x="502920" y="2377440"/>
+            <a:ext cx="11155680" cy="2267712"/>
           </a:xfrm>
           <a:prstGeom prst="rect">
             <a:avLst/>
@@ -5558,7 +5686,7 @@
                 <a:ea typeface="Arial" pitchFamily="34" charset="-122"/>
                 <a:cs typeface="Arial" pitchFamily="34" charset="-120"/>
               </a:rPr>
-              <a:t>Settings → Pages · Source = GitHub Actions</a:t>
+              <a:t>When push (or merge) to main</a:t>
             </a:r>
             <a:endParaRPr lang="en-US" sz="1500" dirty="0"/>
           </a:p>
@@ -5576,7 +5704,7 @@
                 <a:ea typeface="Arial" pitchFamily="34" charset="-122"/>
                 <a:cs typeface="Arial" pitchFamily="34" charset="-120"/>
               </a:rPr>
-              <a:t>Actions · wait for green (Re-run if needed)</a:t>
+              <a:t>Build npm install → npm run build</a:t>
             </a:r>
             <a:endParaRPr lang="en-US" sz="1500" dirty="0"/>
           </a:p>
@@ -5594,15 +5722,69 @@
                 <a:ea typeface="Arial" pitchFamily="34" charset="-122"/>
                 <a:cs typeface="Arial" pitchFamily="34" charset="-120"/>
               </a:rPr>
-              <a:t>Visit site · test the real URL</a:t>
+              <a:t>Deploy send dist/ to GitHub Pages</a:t>
             </a:r>
             <a:endParaRPr lang="en-US" sz="1500" dirty="0"/>
           </a:p>
-        </p:txBody>
-      </p:sp>
-      <p:sp>
-        <p:nvSpPr>
-          <p:cNvPr id="9" name="Shape 7"/>
+          <a:p>
+            <a:pPr marL="342900" indent="-342900">
+              <a:buSzPct val="100000"/>
+              <a:buChar char="•"/>
+            </a:pPr>
+            <a:r>
+              <a:rPr lang="en-US" sz="1500" dirty="0">
+                <a:solidFill>
+                  <a:srgbClr val="1A1A1A"/>
+                </a:solidFill>
+                <a:latin typeface="Arial" pitchFamily="34" charset="0"/>
+                <a:ea typeface="Arial" pitchFamily="34" charset="-122"/>
+                <a:cs typeface="Arial" pitchFamily="34" charset="-120"/>
+              </a:rPr>
+              <a:t>When: push (or merge) to main</a:t>
+            </a:r>
+            <a:endParaRPr lang="en-US" sz="1500" dirty="0"/>
+          </a:p>
+          <a:p>
+            <a:pPr marL="342900" indent="-342900">
+              <a:buSzPct val="100000"/>
+              <a:buChar char="•"/>
+            </a:pPr>
+            <a:r>
+              <a:rPr lang="en-US" sz="1500" dirty="0">
+                <a:solidFill>
+                  <a:srgbClr val="1A1A1A"/>
+                </a:solidFill>
+                <a:latin typeface="Arial" pitchFamily="34" charset="0"/>
+                <a:ea typeface="Arial" pitchFamily="34" charset="-122"/>
+                <a:cs typeface="Arial" pitchFamily="34" charset="-120"/>
+              </a:rPr>
+              <a:t>Build: npm install → npm run build</a:t>
+            </a:r>
+            <a:endParaRPr lang="en-US" sz="1500" dirty="0"/>
+          </a:p>
+          <a:p>
+            <a:pPr marL="342900" indent="-342900">
+              <a:buSzPct val="100000"/>
+              <a:buChar char="•"/>
+            </a:pPr>
+            <a:r>
+              <a:rPr lang="en-US" sz="1500" dirty="0">
+                <a:solidFill>
+                  <a:srgbClr val="1A1A1A"/>
+                </a:solidFill>
+                <a:latin typeface="Arial" pitchFamily="34" charset="0"/>
+                <a:ea typeface="Arial" pitchFamily="34" charset="-122"/>
+                <a:cs typeface="Arial" pitchFamily="34" charset="-120"/>
+              </a:rPr>
+              <a:t>Deploy: send dist/ to GitHub Pages</a:t>
+            </a:r>
+            <a:endParaRPr lang="en-US" sz="1500" dirty="0"/>
+          </a:p>
+        </p:txBody>
+      </p:sp>
+      <p:sp>
+        <p:nvSpPr>
+          <p:cNvPr id="10" name="Shape 8"/>
           <p:cNvSpPr/>
           <p:nvPr/>
         </p:nvSpPr>
@@ -5627,7 +5809,7 @@
       </p:sp>
       <p:sp>
         <p:nvSpPr>
-          <p:cNvPr id="10" name="Text 8"/>
+          <p:cNvPr id="11" name="Text 9"/>
           <p:cNvSpPr/>
           <p:nvPr/>
         </p:nvSpPr>
@@ -5811,7 +5993,7 @@
                 <a:ea typeface="Arial" pitchFamily="34" charset="-122"/>
                 <a:cs typeface="Arial" pitchFamily="34" charset="-120"/>
               </a:rPr>
-              <a:t>17 / 20</a:t>
+              <a:t>17 / 21</a:t>
             </a:r>
             <a:endParaRPr lang="en-US" sz="1100" dirty="0"/>
           </a:p>
@@ -5850,7 +6032,7 @@
                 <a:ea typeface="Arial" pitchFamily="34" charset="-122"/>
                 <a:cs typeface="Arial" pitchFamily="34" charset="-120"/>
               </a:rPr>
-              <a:t>TROUBLESHOOTING</a:t>
+              <a:t>LIVE SITE</a:t>
             </a:r>
             <a:endParaRPr lang="en-US" sz="1200" dirty="0"/>
           </a:p>
@@ -5889,7 +6071,7 @@
                 <a:ea typeface="Arial" pitchFamily="34" charset="-122"/>
                 <a:cs typeface="Arial" pitchFamily="34" charset="-120"/>
               </a:rPr>
-              <a:t>Read the error. Fix one thing.</a:t>
+              <a:t>Turn Pages on. Watch the run.</a:t>
             </a:r>
             <a:endParaRPr lang="en-US" sz="2800" dirty="0"/>
           </a:p>
@@ -5904,7 +6086,7 @@
         <p:spPr>
           <a:xfrm>
             <a:off x="502920" y="1783080"/>
-            <a:ext cx="11155680" cy="1572768"/>
+            <a:ext cx="11155680" cy="1225296"/>
           </a:xfrm>
           <a:prstGeom prst="rect">
             <a:avLst/>
@@ -5929,7 +6111,7 @@
                 <a:ea typeface="Arial" pitchFamily="34" charset="-122"/>
                 <a:cs typeface="Arial" pitchFamily="34" charset="-120"/>
               </a:rPr>
-              <a:t>Auth / password — browser sign-in or PAT, not your GitHub password</a:t>
+              <a:t>Settings → Pages · Source = GitHub Actions</a:t>
             </a:r>
             <a:endParaRPr lang="en-US" sz="1500" dirty="0"/>
           </a:p>
@@ -5947,7 +6129,7 @@
                 <a:ea typeface="Arial" pitchFamily="34" charset="-122"/>
                 <a:cs typeface="Arial" pitchFamily="34" charset="-120"/>
               </a:rPr>
-              <a:t>Actions failed — open the log, fix the first real error</a:t>
+              <a:t>Actions · wait for green (Re-run if needed)</a:t>
             </a:r>
             <a:endParaRPr lang="en-US" sz="1500" dirty="0"/>
           </a:p>
@@ -5965,25 +6147,7 @@
                 <a:ea typeface="Arial" pitchFamily="34" charset="-122"/>
                 <a:cs typeface="Arial" pitchFamily="34" charset="-120"/>
               </a:rPr>
-              <a:t>404 on the site — Pages source set? Latest run green? Full project URL?</a:t>
-            </a:r>
-            <a:endParaRPr lang="en-US" sz="1500" dirty="0"/>
-          </a:p>
-          <a:p>
-            <a:pPr marL="342900" indent="-342900">
-              <a:buSzPct val="100000"/>
-              <a:buChar char="•"/>
-            </a:pPr>
-            <a:r>
-              <a:rPr lang="en-US" sz="1500" dirty="0">
-                <a:solidFill>
-                  <a:srgbClr val="1A1A1A"/>
-                </a:solidFill>
-                <a:latin typeface="Arial" pitchFamily="34" charset="0"/>
-                <a:ea typeface="Arial" pitchFamily="34" charset="-122"/>
-                <a:cs typeface="Arial" pitchFamily="34" charset="-120"/>
-              </a:rPr>
-              <a:t>Change missing — merged to main ? Hard refresh?</a:t>
+              <a:t>Visit site · test the real URL</a:t>
             </a:r>
             <a:endParaRPr lang="en-US" sz="1500" dirty="0"/>
           </a:p>
@@ -6200,7 +6364,7 @@
                 <a:ea typeface="Arial" pitchFamily="34" charset="-122"/>
                 <a:cs typeface="Arial" pitchFamily="34" charset="-120"/>
               </a:rPr>
-              <a:t>18 / 20</a:t>
+              <a:t>18 / 21</a:t>
             </a:r>
             <a:endParaRPr lang="en-US" sz="1100" dirty="0"/>
           </a:p>
@@ -6239,7 +6403,7 @@
                 <a:ea typeface="Arial" pitchFamily="34" charset="-122"/>
                 <a:cs typeface="Arial" pitchFamily="34" charset="-120"/>
               </a:rPr>
-              <a:t>~30 MINUTES</a:t>
+              <a:t>TROUBLESHOOTING</a:t>
             </a:r>
             <a:endParaRPr lang="en-US" sz="1200" dirty="0"/>
           </a:p>
@@ -6278,7 +6442,7 @@
                 <a:ea typeface="Arial" pitchFamily="34" charset="-122"/>
                 <a:cs typeface="Arial" pitchFamily="34" charset="-120"/>
               </a:rPr>
-              <a:t>Build the featured project change.</a:t>
+              <a:t>Read the error. Fix one thing.</a:t>
             </a:r>
             <a:endParaRPr lang="en-US" sz="2800" dirty="0"/>
           </a:p>
@@ -6318,7 +6482,7 @@
                 <a:ea typeface="Arial" pitchFamily="34" charset="-122"/>
                 <a:cs typeface="Arial" pitchFamily="34" charset="-120"/>
               </a:rPr>
-              <a:t>Issue with clear checks</a:t>
+              <a:t>Auth / password — browser sign-in or PAT, not your GitHub password</a:t>
             </a:r>
             <a:endParaRPr lang="en-US" sz="1500" dirty="0"/>
           </a:p>
@@ -6336,7 +6500,7 @@
                 <a:ea typeface="Arial" pitchFamily="34" charset="-122"/>
                 <a:cs typeface="Arial" pitchFamily="34" charset="-120"/>
               </a:rPr>
-              <a:t>Branch add-featured-project</a:t>
+              <a:t>Actions failed — open the log, fix the first real error</a:t>
             </a:r>
             <a:endParaRPr lang="en-US" sz="1500" dirty="0"/>
           </a:p>
@@ -6354,7 +6518,7 @@
                 <a:ea typeface="Arial" pitchFamily="34" charset="-122"/>
                 <a:cs typeface="Arial" pitchFamily="34" charset="-120"/>
               </a:rPr>
-              <a:t>Edit · commit · publish</a:t>
+              <a:t>404 on the site — Pages source set? Latest run green? Full project URL?</a:t>
             </a:r>
             <a:endParaRPr lang="en-US" sz="1500" dirty="0"/>
           </a:p>
@@ -6372,7 +6536,7 @@
                 <a:ea typeface="Arial" pitchFamily="34" charset="-122"/>
                 <a:cs typeface="Arial" pitchFamily="34" charset="-120"/>
               </a:rPr>
-              <a:t>PR · Files changed · merge</a:t>
+              <a:t>Change missing — merged to main ? Hard refresh?</a:t>
             </a:r>
             <a:endParaRPr lang="en-US" sz="1500" dirty="0"/>
           </a:p>
@@ -6589,7 +6753,7 @@
                 <a:ea typeface="Arial" pitchFamily="34" charset="-122"/>
                 <a:cs typeface="Arial" pitchFamily="34" charset="-120"/>
               </a:rPr>
-              <a:t>19 / 20</a:t>
+              <a:t>19 / 21</a:t>
             </a:r>
             <a:endParaRPr lang="en-US" sz="1100" dirty="0"/>
           </a:p>
@@ -6628,7 +6792,7 @@
                 <a:ea typeface="Arial" pitchFamily="34" charset="-122"/>
                 <a:cs typeface="Arial" pitchFamily="34" charset="-120"/>
               </a:rPr>
-              <a:t>CHECKPOINT</a:t>
+              <a:t>~30 MINUTES</a:t>
             </a:r>
             <a:endParaRPr lang="en-US" sz="1200" dirty="0"/>
           </a:p>
@@ -6667,7 +6831,7 @@
                 <a:ea typeface="Arial" pitchFamily="34" charset="-122"/>
                 <a:cs typeface="Arial" pitchFamily="34" charset="-120"/>
               </a:rPr>
-              <a:t>Show four things.</a:t>
+              <a:t>Build the featured project change.</a:t>
             </a:r>
             <a:endParaRPr lang="en-US" sz="2800" dirty="0"/>
           </a:p>
@@ -6682,7 +6846,7 @@
         <p:spPr>
           <a:xfrm>
             <a:off x="502920" y="1783080"/>
-            <a:ext cx="11155680" cy="1920240"/>
+            <a:ext cx="11155680" cy="1572768"/>
           </a:xfrm>
           <a:prstGeom prst="rect">
             <a:avLst/>
@@ -6707,7 +6871,7 @@
                 <a:ea typeface="Arial" pitchFamily="34" charset="-122"/>
                 <a:cs typeface="Arial" pitchFamily="34" charset="-120"/>
               </a:rPr>
-              <a:t>Issue</a:t>
+              <a:t>Issue with clear checks</a:t>
             </a:r>
             <a:endParaRPr lang="en-US" sz="1500" dirty="0"/>
           </a:p>
@@ -6725,7 +6889,7 @@
                 <a:ea typeface="Arial" pitchFamily="34" charset="-122"/>
                 <a:cs typeface="Arial" pitchFamily="34" charset="-120"/>
               </a:rPr>
-              <a:t>Diff</a:t>
+              <a:t>Branch add-featured-project</a:t>
             </a:r>
             <a:endParaRPr lang="en-US" sz="1500" dirty="0"/>
           </a:p>
@@ -6743,7 +6907,7 @@
                 <a:ea typeface="Arial" pitchFamily="34" charset="-122"/>
                 <a:cs typeface="Arial" pitchFamily="34" charset="-120"/>
               </a:rPr>
-              <a:t>Pull request</a:t>
+              <a:t>Edit · commit · publish</a:t>
             </a:r>
             <a:endParaRPr lang="en-US" sz="1500" dirty="0"/>
           </a:p>
@@ -6761,25 +6925,7 @@
                 <a:ea typeface="Arial" pitchFamily="34" charset="-122"/>
                 <a:cs typeface="Arial" pitchFamily="34" charset="-120"/>
               </a:rPr>
-              <a:t>Live URL or Actions status</a:t>
-            </a:r>
-            <a:endParaRPr lang="en-US" sz="1500" dirty="0"/>
-          </a:p>
-          <a:p>
-            <a:pPr marL="342900" indent="-342900">
-              <a:buSzPct val="100000"/>
-              <a:buChar char="•"/>
-            </a:pPr>
-            <a:r>
-              <a:rPr lang="en-US" sz="1500" dirty="0">
-                <a:solidFill>
-                  <a:srgbClr val="1A1A1A"/>
-                </a:solidFill>
-                <a:latin typeface="Arial" pitchFamily="34" charset="0"/>
-                <a:ea typeface="Arial" pitchFamily="34" charset="-122"/>
-                <a:cs typeface="Arial" pitchFamily="34" charset="-120"/>
-              </a:rPr>
-              <a:t>Issue Diff Pull request Live URL: or Actions status</a:t>
+              <a:t>PR · Files changed · merge</a:t>
             </a:r>
             <a:endParaRPr lang="en-US" sz="1500" dirty="0"/>
           </a:p>
@@ -6996,7 +7142,7 @@
                 <a:ea typeface="Arial" pitchFamily="34" charset="-122"/>
                 <a:cs typeface="Arial" pitchFamily="34" charset="-120"/>
               </a:rPr>
-              <a:t>02 / 20</a:t>
+              <a:t>02 / 21</a:t>
             </a:r>
             <a:endParaRPr lang="en-US" sz="1100" dirty="0"/>
           </a:p>
@@ -7457,7 +7603,7 @@
                 <a:ea typeface="Arial" pitchFamily="34" charset="-122"/>
                 <a:cs typeface="Arial" pitchFamily="34" charset="-120"/>
               </a:rPr>
-              <a:t>20 / 20</a:t>
+              <a:t>20 / 21</a:t>
             </a:r>
             <a:endParaRPr lang="en-US" sz="1100" dirty="0"/>
           </a:p>
@@ -7496,7 +7642,7 @@
                 <a:ea typeface="Arial" pitchFamily="34" charset="-122"/>
                 <a:cs typeface="Arial" pitchFamily="34" charset="-120"/>
               </a:rPr>
-              <a:t>REMEMBER</a:t>
+              <a:t>CHECKPOINT</a:t>
             </a:r>
             <a:endParaRPr lang="en-US" sz="1200" dirty="0"/>
           </a:p>
@@ -7535,7 +7681,7 @@
                 <a:ea typeface="Arial" pitchFamily="34" charset="-122"/>
                 <a:cs typeface="Arial" pitchFamily="34" charset="-120"/>
               </a:rPr>
-              <a:t>Status first. Diff always. Verify the URL.</a:t>
+              <a:t>Show four things.</a:t>
             </a:r>
             <a:endParaRPr lang="en-US" sz="2800" dirty="0"/>
           </a:p>
@@ -7550,7 +7696,7 @@
         <p:spPr>
           <a:xfrm>
             <a:off x="502920" y="1783080"/>
-            <a:ext cx="11155680" cy="1572768"/>
+            <a:ext cx="11155680" cy="1920240"/>
           </a:xfrm>
           <a:prstGeom prst="rect">
             <a:avLst/>
@@ -7575,7 +7721,7 @@
                 <a:ea typeface="Arial" pitchFamily="34" charset="-122"/>
                 <a:cs typeface="Arial" pitchFamily="34" charset="-120"/>
               </a:rPr>
-              <a:t>VS Code: Status Bar · Source Control · Publish</a:t>
+              <a:t>Issue</a:t>
             </a:r>
             <a:endParaRPr lang="en-US" sz="1500" dirty="0"/>
           </a:p>
@@ -7593,7 +7739,7 @@
                 <a:ea typeface="Arial" pitchFamily="34" charset="-122"/>
                 <a:cs typeface="Arial" pitchFamily="34" charset="-120"/>
               </a:rPr>
-              <a:t>GitHub: Issue · PR · Files changed · Merge</a:t>
+              <a:t>Diff</a:t>
             </a:r>
             <a:endParaRPr lang="en-US" sz="1500" dirty="0"/>
           </a:p>
@@ -7611,7 +7757,414 @@
                 <a:ea typeface="Arial" pitchFamily="34" charset="-122"/>
                 <a:cs typeface="Arial" pitchFamily="34" charset="-120"/>
               </a:rPr>
-              <a:t>Pages: Actions green · Visit site</a:t>
+              <a:t>Pull request</a:t>
+            </a:r>
+            <a:endParaRPr lang="en-US" sz="1500" dirty="0"/>
+          </a:p>
+          <a:p>
+            <a:pPr marL="342900" indent="-342900">
+              <a:buSzPct val="100000"/>
+              <a:buChar char="•"/>
+            </a:pPr>
+            <a:r>
+              <a:rPr lang="en-US" sz="1500" dirty="0">
+                <a:solidFill>
+                  <a:srgbClr val="1A1A1A"/>
+                </a:solidFill>
+                <a:latin typeface="Arial" pitchFamily="34" charset="0"/>
+                <a:ea typeface="Arial" pitchFamily="34" charset="-122"/>
+                <a:cs typeface="Arial" pitchFamily="34" charset="-120"/>
+              </a:rPr>
+              <a:t>Live URL or Actions status</a:t>
+            </a:r>
+            <a:endParaRPr lang="en-US" sz="1500" dirty="0"/>
+          </a:p>
+          <a:p>
+            <a:pPr marL="342900" indent="-342900">
+              <a:buSzPct val="100000"/>
+              <a:buChar char="•"/>
+            </a:pPr>
+            <a:r>
+              <a:rPr lang="en-US" sz="1500" dirty="0">
+                <a:solidFill>
+                  <a:srgbClr val="1A1A1A"/>
+                </a:solidFill>
+                <a:latin typeface="Arial" pitchFamily="34" charset="0"/>
+                <a:ea typeface="Arial" pitchFamily="34" charset="-122"/>
+                <a:cs typeface="Arial" pitchFamily="34" charset="-120"/>
+              </a:rPr>
+              <a:t>Issue Diff Pull request Live URL: or Actions status</a:t>
+            </a:r>
+            <a:endParaRPr lang="en-US" sz="1500" dirty="0"/>
+          </a:p>
+        </p:txBody>
+      </p:sp>
+      <p:sp>
+        <p:nvSpPr>
+          <p:cNvPr id="9" name="Shape 7"/>
+          <p:cNvSpPr/>
+          <p:nvPr/>
+        </p:nvSpPr>
+        <p:spPr>
+          <a:xfrm>
+            <a:off x="0" y="6446520"/>
+            <a:ext cx="12191695" cy="411480"/>
+          </a:xfrm>
+          <a:prstGeom prst="rect">
+            <a:avLst/>
+          </a:prstGeom>
+          <a:solidFill>
+            <a:srgbClr val="000000"/>
+          </a:solidFill>
+          <a:ln w="12700">
+            <a:solidFill>
+              <a:srgbClr val="000000"/>
+            </a:solidFill>
+            <a:prstDash val="solid"/>
+          </a:ln>
+        </p:spPr>
+      </p:sp>
+      <p:sp>
+        <p:nvSpPr>
+          <p:cNvPr id="10" name="Text 8"/>
+          <p:cNvSpPr/>
+          <p:nvPr/>
+        </p:nvSpPr>
+        <p:spPr>
+          <a:xfrm>
+            <a:off x="502920" y="6528816"/>
+            <a:ext cx="11155680" cy="256032"/>
+          </a:xfrm>
+          <a:prstGeom prst="rect">
+            <a:avLst/>
+          </a:prstGeom>
+          <a:noFill/>
+          <a:ln/>
+        </p:spPr>
+        <p:txBody>
+          <a:bodyPr wrap="square" rtlCol="0" anchor="ctr"/>
+          <a:lstStyle/>
+          <a:p>
+            <a:pPr indent="0" marL="0">
+              <a:buNone/>
+            </a:pPr>
+            <a:r>
+              <a:rPr lang="en-US" sz="1100" b="1" dirty="0">
+                <a:solidFill>
+                  <a:srgbClr val="FFDB00"/>
+                </a:solidFill>
+                <a:latin typeface="Arial" pitchFamily="34" charset="0"/>
+                <a:ea typeface="Arial" pitchFamily="34" charset="-122"/>
+                <a:cs typeface="Arial" pitchFamily="34" charset="-120"/>
+              </a:rPr>
+              <a:t>ARROWS ON THE WEB DECK · R FOR RESOURCES · N FOR NOTES</a:t>
+            </a:r>
+            <a:endParaRPr lang="en-US" sz="1100" dirty="0"/>
+          </a:p>
+        </p:txBody>
+      </p:sp>
+    </p:spTree>
+  </p:cSld>
+  <p:clrMapOvr>
+    <a:masterClrMapping/>
+  </p:clrMapOvr>
+</p:sld>
+</file>
+
+<file path=ppt/slides/slide21.xml><?xml version="1.0" encoding="utf-8"?>
+<p:sld xmlns:a="http://schemas.openxmlformats.org/drawingml/2006/main" xmlns:r="http://schemas.openxmlformats.org/officeDocument/2006/relationships" xmlns:p="http://schemas.openxmlformats.org/presentationml/2006/main">
+  <p:cSld name="Slide 21">
+    <p:spTree>
+      <p:nvGrpSpPr>
+        <p:cNvPr id="1" name=""/>
+        <p:cNvGrpSpPr/>
+        <p:nvPr/>
+      </p:nvGrpSpPr>
+      <p:grpSpPr>
+        <a:xfrm>
+          <a:off x="0" y="0"/>
+          <a:ext cx="0" cy="0"/>
+          <a:chOff x="0" y="0"/>
+          <a:chExt cx="0" cy="0"/>
+        </a:xfrm>
+      </p:grpSpPr>
+      <p:sp>
+        <p:nvSpPr>
+          <p:cNvPr id="2" name="Shape 0"/>
+          <p:cNvSpPr/>
+          <p:nvPr/>
+        </p:nvSpPr>
+        <p:spPr>
+          <a:xfrm>
+            <a:off x="0" y="0"/>
+            <a:ext cx="12191695" cy="164592"/>
+          </a:xfrm>
+          <a:prstGeom prst="rect">
+            <a:avLst/>
+          </a:prstGeom>
+          <a:solidFill>
+            <a:srgbClr val="000000"/>
+          </a:solidFill>
+          <a:ln w="12700">
+            <a:solidFill>
+              <a:srgbClr val="000000"/>
+            </a:solidFill>
+            <a:prstDash val="solid"/>
+          </a:ln>
+        </p:spPr>
+      </p:sp>
+      <p:sp>
+        <p:nvSpPr>
+          <p:cNvPr id="3" name="Shape 1"/>
+          <p:cNvSpPr/>
+          <p:nvPr/>
+        </p:nvSpPr>
+        <p:spPr>
+          <a:xfrm>
+            <a:off x="0" y="164592"/>
+            <a:ext cx="12191695" cy="73152"/>
+          </a:xfrm>
+          <a:prstGeom prst="rect">
+            <a:avLst/>
+          </a:prstGeom>
+          <a:solidFill>
+            <a:srgbClr val="FFDB00"/>
+          </a:solidFill>
+          <a:ln w="12700">
+            <a:solidFill>
+              <a:srgbClr val="FFDB00"/>
+            </a:solidFill>
+            <a:prstDash val="solid"/>
+          </a:ln>
+        </p:spPr>
+      </p:sp>
+      <p:sp>
+        <p:nvSpPr>
+          <p:cNvPr id="4" name="Text 2"/>
+          <p:cNvSpPr/>
+          <p:nvPr/>
+        </p:nvSpPr>
+        <p:spPr>
+          <a:xfrm>
+            <a:off x="502920" y="365760"/>
+            <a:ext cx="9601200" cy="256032"/>
+          </a:xfrm>
+          <a:prstGeom prst="rect">
+            <a:avLst/>
+          </a:prstGeom>
+          <a:noFill/>
+          <a:ln/>
+        </p:spPr>
+        <p:txBody>
+          <a:bodyPr wrap="square" rtlCol="0" anchor="ctr"/>
+          <a:lstStyle/>
+          <a:p>
+            <a:pPr indent="0" marL="0">
+              <a:buNone/>
+            </a:pPr>
+            <a:r>
+              <a:rPr lang="en-US" sz="1100" b="1" spc="200" kern="0" dirty="0">
+                <a:solidFill>
+                  <a:srgbClr val="555555"/>
+                </a:solidFill>
+                <a:latin typeface="Arial" pitchFamily="34" charset="0"/>
+                <a:ea typeface="Arial" pitchFamily="34" charset="-122"/>
+                <a:cs typeface="Arial" pitchFamily="34" charset="-120"/>
+              </a:rPr>
+              <a:t>WICHITA STATE · MIS CLUB · WORKSHOP 1</a:t>
+            </a:r>
+            <a:endParaRPr lang="en-US" sz="1100" dirty="0"/>
+          </a:p>
+        </p:txBody>
+      </p:sp>
+      <p:sp>
+        <p:nvSpPr>
+          <p:cNvPr id="5" name="Text 3"/>
+          <p:cNvSpPr/>
+          <p:nvPr/>
+        </p:nvSpPr>
+        <p:spPr>
+          <a:xfrm>
+            <a:off x="10241280" y="365760"/>
+            <a:ext cx="1463040" cy="256032"/>
+          </a:xfrm>
+          <a:prstGeom prst="rect">
+            <a:avLst/>
+          </a:prstGeom>
+          <a:noFill/>
+          <a:ln/>
+        </p:spPr>
+        <p:txBody>
+          <a:bodyPr wrap="square" rtlCol="0" anchor="ctr"/>
+          <a:lstStyle/>
+          <a:p>
+            <a:pPr algn="r" indent="0" marL="0">
+              <a:buNone/>
+            </a:pPr>
+            <a:r>
+              <a:rPr lang="en-US" sz="1100" b="1" dirty="0">
+                <a:solidFill>
+                  <a:srgbClr val="555555"/>
+                </a:solidFill>
+                <a:latin typeface="Arial" pitchFamily="34" charset="0"/>
+                <a:ea typeface="Arial" pitchFamily="34" charset="-122"/>
+                <a:cs typeface="Arial" pitchFamily="34" charset="-120"/>
+              </a:rPr>
+              <a:t>21 / 21</a:t>
+            </a:r>
+            <a:endParaRPr lang="en-US" sz="1100" dirty="0"/>
+          </a:p>
+        </p:txBody>
+      </p:sp>
+      <p:sp>
+        <p:nvSpPr>
+          <p:cNvPr id="6" name="Text 4"/>
+          <p:cNvSpPr/>
+          <p:nvPr/>
+        </p:nvSpPr>
+        <p:spPr>
+          <a:xfrm>
+            <a:off x="502920" y="685800"/>
+            <a:ext cx="11155680" cy="256032"/>
+          </a:xfrm>
+          <a:prstGeom prst="rect">
+            <a:avLst/>
+          </a:prstGeom>
+          <a:noFill/>
+          <a:ln/>
+        </p:spPr>
+        <p:txBody>
+          <a:bodyPr wrap="square" rtlCol="0" anchor="ctr"/>
+          <a:lstStyle/>
+          <a:p>
+            <a:pPr indent="0" marL="0">
+              <a:buNone/>
+            </a:pPr>
+            <a:r>
+              <a:rPr lang="en-US" sz="1200" b="1" dirty="0">
+                <a:solidFill>
+                  <a:srgbClr val="555555"/>
+                </a:solidFill>
+                <a:latin typeface="Arial" pitchFamily="34" charset="0"/>
+                <a:ea typeface="Arial" pitchFamily="34" charset="-122"/>
+                <a:cs typeface="Arial" pitchFamily="34" charset="-120"/>
+              </a:rPr>
+              <a:t>REMEMBER</a:t>
+            </a:r>
+            <a:endParaRPr lang="en-US" sz="1200" dirty="0"/>
+          </a:p>
+        </p:txBody>
+      </p:sp>
+      <p:sp>
+        <p:nvSpPr>
+          <p:cNvPr id="7" name="Text 5"/>
+          <p:cNvSpPr/>
+          <p:nvPr/>
+        </p:nvSpPr>
+        <p:spPr>
+          <a:xfrm>
+            <a:off x="502920" y="960120"/>
+            <a:ext cx="11155680" cy="777240"/>
+          </a:xfrm>
+          <a:prstGeom prst="rect">
+            <a:avLst/>
+          </a:prstGeom>
+          <a:noFill/>
+          <a:ln/>
+        </p:spPr>
+        <p:txBody>
+          <a:bodyPr wrap="square" rtlCol="0" anchor="t"/>
+          <a:lstStyle/>
+          <a:p>
+            <a:pPr indent="0" marL="0">
+              <a:buNone/>
+            </a:pPr>
+            <a:r>
+              <a:rPr lang="en-US" sz="2800" b="1" dirty="0">
+                <a:solidFill>
+                  <a:srgbClr val="1A1A1A"/>
+                </a:solidFill>
+                <a:latin typeface="Arial" pitchFamily="34" charset="0"/>
+                <a:ea typeface="Arial" pitchFamily="34" charset="-122"/>
+                <a:cs typeface="Arial" pitchFamily="34" charset="-120"/>
+              </a:rPr>
+              <a:t>Status first. Diff always. Verify the URL.</a:t>
+            </a:r>
+            <a:endParaRPr lang="en-US" sz="2800" dirty="0"/>
+          </a:p>
+        </p:txBody>
+      </p:sp>
+      <p:sp>
+        <p:nvSpPr>
+          <p:cNvPr id="8" name="Text 6"/>
+          <p:cNvSpPr/>
+          <p:nvPr/>
+        </p:nvSpPr>
+        <p:spPr>
+          <a:xfrm>
+            <a:off x="502920" y="1783080"/>
+            <a:ext cx="11155680" cy="1572768"/>
+          </a:xfrm>
+          <a:prstGeom prst="rect">
+            <a:avLst/>
+          </a:prstGeom>
+          <a:noFill/>
+          <a:ln/>
+        </p:spPr>
+        <p:txBody>
+          <a:bodyPr wrap="square" rtlCol="0" anchor="t"/>
+          <a:lstStyle/>
+          <a:p>
+            <a:pPr marL="342900" indent="-342900">
+              <a:buSzPct val="100000"/>
+              <a:buChar char="•"/>
+            </a:pPr>
+            <a:r>
+              <a:rPr lang="en-US" sz="1500" dirty="0">
+                <a:solidFill>
+                  <a:srgbClr val="1A1A1A"/>
+                </a:solidFill>
+                <a:latin typeface="Arial" pitchFamily="34" charset="0"/>
+                <a:ea typeface="Arial" pitchFamily="34" charset="-122"/>
+                <a:cs typeface="Arial" pitchFamily="34" charset="-120"/>
+              </a:rPr>
+              <a:t>VS Code: Status Bar · Source Control · Publish</a:t>
+            </a:r>
+            <a:endParaRPr lang="en-US" sz="1500" dirty="0"/>
+          </a:p>
+          <a:p>
+            <a:pPr marL="342900" indent="-342900">
+              <a:buSzPct val="100000"/>
+              <a:buChar char="•"/>
+            </a:pPr>
+            <a:r>
+              <a:rPr lang="en-US" sz="1500" dirty="0">
+                <a:solidFill>
+                  <a:srgbClr val="1A1A1A"/>
+                </a:solidFill>
+                <a:latin typeface="Arial" pitchFamily="34" charset="0"/>
+                <a:ea typeface="Arial" pitchFamily="34" charset="-122"/>
+                <a:cs typeface="Arial" pitchFamily="34" charset="-120"/>
+              </a:rPr>
+              <a:t>GitHub: Issue · PR · Files changed · Merge</a:t>
+            </a:r>
+            <a:endParaRPr lang="en-US" sz="1500" dirty="0"/>
+          </a:p>
+          <a:p>
+            <a:pPr marL="342900" indent="-342900">
+              <a:buSzPct val="100000"/>
+              <a:buChar char="•"/>
+            </a:pPr>
+            <a:r>
+              <a:rPr lang="en-US" sz="1500" dirty="0">
+                <a:solidFill>
+                  <a:srgbClr val="1A1A1A"/>
+                </a:solidFill>
+                <a:latin typeface="Arial" pitchFamily="34" charset="0"/>
+                <a:ea typeface="Arial" pitchFamily="34" charset="-122"/>
+                <a:cs typeface="Arial" pitchFamily="34" charset="-120"/>
+              </a:rPr>
+              <a:t>Actions: deploy.yml on main · green run</a:t>
             </a:r>
             <a:endParaRPr lang="en-US" sz="1500" dirty="0"/>
           </a:p>
@@ -7846,7 +8399,7 @@
                 <a:ea typeface="Arial" pitchFamily="34" charset="-122"/>
                 <a:cs typeface="Arial" pitchFamily="34" charset="-120"/>
               </a:rPr>
-              <a:t>03 / 20</a:t>
+              <a:t>03 / 21</a:t>
             </a:r>
             <a:endParaRPr lang="en-US" sz="1100" dirty="0"/>
           </a:p>
@@ -8271,7 +8824,7 @@
                 <a:ea typeface="Arial" pitchFamily="34" charset="-122"/>
                 <a:cs typeface="Arial" pitchFamily="34" charset="-120"/>
               </a:rPr>
-              <a:t>04 / 20</a:t>
+              <a:t>04 / 21</a:t>
             </a:r>
             <a:endParaRPr lang="en-US" sz="1100" dirty="0"/>
           </a:p>
@@ -8678,7 +9231,7 @@
                 <a:ea typeface="Arial" pitchFamily="34" charset="-122"/>
                 <a:cs typeface="Arial" pitchFamily="34" charset="-120"/>
               </a:rPr>
-              <a:t>05 / 20</a:t>
+              <a:t>05 / 21</a:t>
             </a:r>
             <a:endParaRPr lang="en-US" sz="1100" dirty="0"/>
           </a:p>
@@ -9049,7 +9602,7 @@
                 <a:ea typeface="Arial" pitchFamily="34" charset="-122"/>
                 <a:cs typeface="Arial" pitchFamily="34" charset="-120"/>
               </a:rPr>
-              <a:t>06 / 20</a:t>
+              <a:t>06 / 21</a:t>
             </a:r>
             <a:endParaRPr lang="en-US" sz="1100" dirty="0"/>
           </a:p>
@@ -9402,7 +9955,7 @@
                 <a:ea typeface="Arial" pitchFamily="34" charset="-122"/>
                 <a:cs typeface="Arial" pitchFamily="34" charset="-120"/>
               </a:rPr>
-              <a:t>07 / 20</a:t>
+              <a:t>07 / 21</a:t>
             </a:r>
             <a:endParaRPr lang="en-US" sz="1100" dirty="0"/>
           </a:p>
@@ -9794,7 +10347,7 @@
                 <a:ea typeface="Arial" pitchFamily="34" charset="-122"/>
                 <a:cs typeface="Arial" pitchFamily="34" charset="-120"/>
               </a:rPr>
-              <a:t>08 / 20</a:t>
+              <a:t>08 / 21</a:t>
             </a:r>
             <a:endParaRPr lang="en-US" sz="1100" dirty="0"/>
           </a:p>
@@ -10165,7 +10718,7 @@
                 <a:ea typeface="Arial" pitchFamily="34" charset="-122"/>
                 <a:cs typeface="Arial" pitchFamily="34" charset="-120"/>
               </a:rPr>
-              <a:t>09 / 20</a:t>
+              <a:t>09 / 21</a:t>
             </a:r>
             <a:endParaRPr lang="en-US" sz="1100" dirty="0"/>
           </a:p>

</xml_diff>

<commit_message>
Fix workshop journey bugs; add WORKSHOP.md
</commit_message>
<xml_diff>
--- a/downloads/workshop-1-presentation.pptx
+++ b/downloads/workshop-1-presentation.pptx
@@ -610,7 +610,7 @@
           <a:p>
             <a:r>
               <a:rPr lang="en-US" dirty="0"/>
-              <a:t>Demo Status Bar → Create new branch → add-featured-project. Status Bar must show the new name before they edit. Ask: why not commit feature work on main? Keep this slide simple — detail is in the walkthrough.</a:t>
+              <a:t>Students invent one featured-project issue with checkable criteria. Partner check: could a stranger verify done?</a:t>
             </a:r>
             <a:endParaRPr lang="en-US" dirty="0"/>
           </a:p>
@@ -698,7 +698,7 @@
           <a:p>
             <a:r>
               <a:rPr lang="en-US" dirty="0"/>
-              <a:t>After their edit on the feature branch: Source Control → stage → commit → Publish Branch. Then GitHub can open a PR. Terminal optional: git push -u origin add-featured-project.</a:t>
+              <a:t>Demo Status Bar → Create new branch → add-featured-project. Status Bar must show the new name before they commit. Uncommitted Step 8 edits move with the new branch.</a:t>
             </a:r>
             <a:endParaRPr lang="en-US" dirty="0"/>
           </a:p>
@@ -786,7 +786,7 @@
           <a:p>
             <a:r>
               <a:rPr lang="en-US" dirty="0"/>
-              <a:t>Students invent one featured-project issue with checkable criteria. Partner check: could a stranger verify done?</a:t>
+              <a:t>Only now: Source Control → read diff → stage → commit → Publish Branch. Good messages beat vague ones. Terminal optional: git push -u origin add-featured-project.</a:t>
             </a:r>
             <a:endParaRPr lang="en-US" dirty="0"/>
           </a:p>
@@ -2106,7 +2106,7 @@
           <a:p>
             <a:r>
               <a:rPr lang="en-US" dirty="0"/>
-              <a:t>Demo git init through push. Public repo required. If push asks for password: browser sign-in or PAT with repo scope — never account password. Student guide Step 3 for auth recovery.</a:t>
+              <a:t>Demo git init through push. Public repo required. Warn: Actions often shows a red X until Pages is enabled in Step 6 — that is expected. Auth: browser sign-in or PAT with repo scope — never account password.</a:t>
             </a:r>
             <a:endParaRPr lang="en-US" dirty="0"/>
           </a:p>
@@ -2282,7 +2282,7 @@
           <a:p>
             <a:r>
               <a:rPr lang="en-US" dirty="0"/>
-              <a:t>Live-demo Source Control. Do not stage everything blindly. Good messages beat vague ones. After commit, Publish/Sync comes on the next slide with branches.</a:t>
+              <a:t>Personalize profile.js now. Do NOT commit on main. Source Control may show a badge — ignore Commit until after the branch slide.</a:t>
             </a:r>
             <a:endParaRPr lang="en-US" dirty="0"/>
           </a:p>
@@ -3198,7 +3198,7 @@
                 <a:ea typeface="Arial" pitchFamily="34" charset="-122"/>
                 <a:cs typeface="Arial" pitchFamily="34" charset="-120"/>
               </a:rPr>
-              <a:t>DO NOT WORK ON MAIN</a:t>
+              <a:t>BEFORE YOU COMMIT</a:t>
             </a:r>
             <a:endParaRPr lang="en-US" sz="1200" dirty="0"/>
           </a:p>
@@ -3237,7 +3237,7 @@
                 <a:ea typeface="Arial" pitchFamily="34" charset="-122"/>
                 <a:cs typeface="Arial" pitchFamily="34" charset="-120"/>
               </a:rPr>
-              <a:t>Create a branch for the task.</a:t>
+              <a:t>Write an issue.</a:t>
             </a:r>
             <a:endParaRPr lang="en-US" sz="2800" dirty="0"/>
           </a:p>
@@ -3277,7 +3277,7 @@
                 <a:ea typeface="Arial" pitchFamily="34" charset="-122"/>
                 <a:cs typeface="Arial" pitchFamily="34" charset="-120"/>
               </a:rPr>
-              <a:t>Click the branch name bottom-left Status Bar</a:t>
+              <a:t>Issues → New issue</a:t>
             </a:r>
             <a:endParaRPr lang="en-US" sz="1500" dirty="0"/>
           </a:p>
@@ -3295,7 +3295,7 @@
                 <a:ea typeface="Arial" pitchFamily="34" charset="-122"/>
                 <a:cs typeface="Arial" pitchFamily="34" charset="-120"/>
               </a:rPr>
-              <a:t>Create new branch…</a:t>
+              <a:t>Title Add a featured project card</a:t>
             </a:r>
             <a:endParaRPr lang="en-US" sz="1500" dirty="0"/>
           </a:p>
@@ -3313,7 +3313,7 @@
                 <a:ea typeface="Arial" pitchFamily="34" charset="-122"/>
                 <a:cs typeface="Arial" pitchFamily="34" charset="-120"/>
               </a:rPr>
-              <a:t>Name it add-featured-project</a:t>
+              <a:t>Checks honest summary · working link · readable on phone · no secrets</a:t>
             </a:r>
             <a:endParaRPr lang="en-US" sz="1500" dirty="0"/>
           </a:p>
@@ -3331,7 +3331,7 @@
                 <a:ea typeface="Arial" pitchFamily="34" charset="-122"/>
                 <a:cs typeface="Arial" pitchFamily="34" charset="-120"/>
               </a:rPr>
-              <a:t>Click the branch name: bottom-left Status Bar</a:t>
+              <a:t>Issues → New issue Title: Add a featured project card</a:t>
             </a:r>
             <a:endParaRPr lang="en-US" sz="1500" dirty="0"/>
           </a:p>
@@ -3349,7 +3349,7 @@
                 <a:ea typeface="Arial" pitchFamily="34" charset="-122"/>
                 <a:cs typeface="Arial" pitchFamily="34" charset="-120"/>
               </a:rPr>
-              <a:t>Create new branch… Name it: add-featured-project</a:t>
+              <a:t>Checks: honest summary · working link · readable on phone · no secrets</a:t>
             </a:r>
             <a:endParaRPr lang="en-US" sz="1500" dirty="0"/>
           </a:p>
@@ -3605,7 +3605,7 @@
                 <a:ea typeface="Arial" pitchFamily="34" charset="-122"/>
                 <a:cs typeface="Arial" pitchFamily="34" charset="-120"/>
               </a:rPr>
-              <a:t>AFTER YOU EDIT</a:t>
+              <a:t>DO NOT COMMIT ON MAIN</a:t>
             </a:r>
             <a:endParaRPr lang="en-US" sz="1200" dirty="0"/>
           </a:p>
@@ -3644,7 +3644,7 @@
                 <a:ea typeface="Arial" pitchFamily="34" charset="-122"/>
                 <a:cs typeface="Arial" pitchFamily="34" charset="-120"/>
               </a:rPr>
-              <a:t>Commit. Publish the branch.</a:t>
+              <a:t>Create a branch for the task.</a:t>
             </a:r>
             <a:endParaRPr lang="en-US" sz="2800" dirty="0"/>
           </a:p>
@@ -3659,7 +3659,7 @@
         <p:spPr>
           <a:xfrm>
             <a:off x="502920" y="1783080"/>
-            <a:ext cx="11155680" cy="1225296"/>
+            <a:ext cx="11155680" cy="1920240"/>
           </a:xfrm>
           <a:prstGeom prst="rect">
             <a:avLst/>
@@ -3684,7 +3684,7 @@
                 <a:ea typeface="Arial" pitchFamily="34" charset="-122"/>
                 <a:cs typeface="Arial" pitchFamily="34" charset="-120"/>
               </a:rPr>
-              <a:t>Edit profile.js · save · refresh localhost</a:t>
+              <a:t>Click the branch name bottom-left Status Bar</a:t>
             </a:r>
             <a:endParaRPr lang="en-US" sz="1500" dirty="0"/>
           </a:p>
@@ -3702,7 +3702,7 @@
                 <a:ea typeface="Arial" pitchFamily="34" charset="-122"/>
                 <a:cs typeface="Arial" pitchFamily="34" charset="-120"/>
               </a:rPr>
-              <a:t>Source Control · stage (+) · message · Commit</a:t>
+              <a:t>Create new branch…</a:t>
             </a:r>
             <a:endParaRPr lang="en-US" sz="1500" dirty="0"/>
           </a:p>
@@ -3720,7 +3720,43 @@
                 <a:ea typeface="Arial" pitchFamily="34" charset="-122"/>
                 <a:cs typeface="Arial" pitchFamily="34" charset="-120"/>
               </a:rPr>
-              <a:t>Publish Branch or Sync Changes</a:t>
+              <a:t>Name it add-featured-project</a:t>
+            </a:r>
+            <a:endParaRPr lang="en-US" sz="1500" dirty="0"/>
+          </a:p>
+          <a:p>
+            <a:pPr marL="342900" indent="-342900">
+              <a:buSzPct val="100000"/>
+              <a:buChar char="•"/>
+            </a:pPr>
+            <a:r>
+              <a:rPr lang="en-US" sz="1500" dirty="0">
+                <a:solidFill>
+                  <a:srgbClr val="1A1A1A"/>
+                </a:solidFill>
+                <a:latin typeface="Arial" pitchFamily="34" charset="0"/>
+                <a:ea typeface="Arial" pitchFamily="34" charset="-122"/>
+                <a:cs typeface="Arial" pitchFamily="34" charset="-120"/>
+              </a:rPr>
+              <a:t>Click the branch name: bottom-left Status Bar</a:t>
+            </a:r>
+            <a:endParaRPr lang="en-US" sz="1500" dirty="0"/>
+          </a:p>
+          <a:p>
+            <a:pPr marL="342900" indent="-342900">
+              <a:buSzPct val="100000"/>
+              <a:buChar char="•"/>
+            </a:pPr>
+            <a:r>
+              <a:rPr lang="en-US" sz="1500" dirty="0">
+                <a:solidFill>
+                  <a:srgbClr val="1A1A1A"/>
+                </a:solidFill>
+                <a:latin typeface="Arial" pitchFamily="34" charset="0"/>
+                <a:ea typeface="Arial" pitchFamily="34" charset="-122"/>
+                <a:cs typeface="Arial" pitchFamily="34" charset="-120"/>
+              </a:rPr>
+              <a:t>Create new branch… Name it: add-featured-project</a:t>
             </a:r>
             <a:endParaRPr lang="en-US" sz="1500" dirty="0"/>
           </a:p>
@@ -3976,7 +4012,7 @@
                 <a:ea typeface="Arial" pitchFamily="34" charset="-122"/>
                 <a:cs typeface="Arial" pitchFamily="34" charset="-120"/>
               </a:rPr>
-              <a:t>BEFORE YOU CODE</a:t>
+              <a:t>ON YOUR BRANCH</a:t>
             </a:r>
             <a:endParaRPr lang="en-US" sz="1200" dirty="0"/>
           </a:p>
@@ -4015,7 +4051,7 @@
                 <a:ea typeface="Arial" pitchFamily="34" charset="-122"/>
                 <a:cs typeface="Arial" pitchFamily="34" charset="-120"/>
               </a:rPr>
-              <a:t>Write an issue.</a:t>
+              <a:t>Read the diff. Commit. Publish.</a:t>
             </a:r>
             <a:endParaRPr lang="en-US" sz="2800" dirty="0"/>
           </a:p>
@@ -4055,7 +4091,7 @@
                 <a:ea typeface="Arial" pitchFamily="34" charset="-122"/>
                 <a:cs typeface="Arial" pitchFamily="34" charset="-120"/>
               </a:rPr>
-              <a:t>Issues → New issue</a:t>
+              <a:t>Source Control · open the diff · Stage (+)</a:t>
             </a:r>
             <a:endParaRPr lang="en-US" sz="1500" dirty="0"/>
           </a:p>
@@ -4073,7 +4109,7 @@
                 <a:ea typeface="Arial" pitchFamily="34" charset="-122"/>
                 <a:cs typeface="Arial" pitchFamily="34" charset="-120"/>
               </a:rPr>
-              <a:t>Title Add a featured project card</a:t>
+              <a:t>Message → Commit e.g. Add featured project</a:t>
             </a:r>
             <a:endParaRPr lang="en-US" sz="1500" dirty="0"/>
           </a:p>
@@ -4091,7 +4127,7 @@
                 <a:ea typeface="Arial" pitchFamily="34" charset="-122"/>
                 <a:cs typeface="Arial" pitchFamily="34" charset="-120"/>
               </a:rPr>
-              <a:t>Checks honest summary · working link · readable on phone · no secrets</a:t>
+              <a:t>Publish Branch or Sync Changes</a:t>
             </a:r>
             <a:endParaRPr lang="en-US" sz="1500" dirty="0"/>
           </a:p>
@@ -4109,7 +4145,7 @@
                 <a:ea typeface="Arial" pitchFamily="34" charset="-122"/>
                 <a:cs typeface="Arial" pitchFamily="34" charset="-120"/>
               </a:rPr>
-              <a:t>Issues → New issue Title: Add a featured project card</a:t>
+              <a:t>Source Control · open the diff · Stage (+) Message → Commit: e.g. Add featured project</a:t>
             </a:r>
             <a:endParaRPr lang="en-US" sz="1500" dirty="0"/>
           </a:p>
@@ -4127,7 +4163,7 @@
                 <a:ea typeface="Arial" pitchFamily="34" charset="-122"/>
                 <a:cs typeface="Arial" pitchFamily="34" charset="-120"/>
               </a:rPr>
-              <a:t>Checks: honest summary · working link · readable on phone · no secrets</a:t>
+              <a:t>Publish Branch: or Sync Changes</a:t>
             </a:r>
             <a:endParaRPr lang="en-US" sz="1500" dirty="0"/>
           </a:p>
@@ -10757,7 +10793,7 @@
                 <a:ea typeface="Arial" pitchFamily="34" charset="-122"/>
                 <a:cs typeface="Arial" pitchFamily="34" charset="-120"/>
               </a:rPr>
-              <a:t>SOURCE CONTROL</a:t>
+              <a:t>STAY ON MAIN · DO NOT COMMIT</a:t>
             </a:r>
             <a:endParaRPr lang="en-US" sz="1200" dirty="0"/>
           </a:p>
@@ -10796,7 +10832,7 @@
                 <a:ea typeface="Arial" pitchFamily="34" charset="-122"/>
                 <a:cs typeface="Arial" pitchFamily="34" charset="-120"/>
               </a:rPr>
-              <a:t>Read the diff. Then commit.</a:t>
+              <a:t>Edit profile.js . Save. Preview.</a:t>
             </a:r>
             <a:endParaRPr lang="en-US" sz="2800" dirty="0"/>
           </a:p>
@@ -10811,7 +10847,7 @@
         <p:spPr>
           <a:xfrm>
             <a:off x="502920" y="1783080"/>
-            <a:ext cx="11155680" cy="2962656"/>
+            <a:ext cx="11155680" cy="1920240"/>
           </a:xfrm>
           <a:prstGeom prst="rect">
             <a:avLst/>
@@ -10836,7 +10872,7 @@
                 <a:ea typeface="Arial" pitchFamily="34" charset="-122"/>
                 <a:cs typeface="Arial" pitchFamily="34" charset="-120"/>
               </a:rPr>
-              <a:t>Open Source Control Activity Bar · branch icon</a:t>
+              <a:t>Change your details name, links, coursework, projects</a:t>
             </a:r>
             <a:endParaRPr lang="en-US" sz="1500" dirty="0"/>
           </a:p>
@@ -10854,7 +10890,7 @@
                 <a:ea typeface="Arial" pitchFamily="34" charset="-122"/>
                 <a:cs typeface="Arial" pitchFamily="34" charset="-120"/>
               </a:rPr>
-              <a:t>Click the file read green / red</a:t>
+              <a:t>Save · refresh localhost</a:t>
             </a:r>
             <a:endParaRPr lang="en-US" sz="1500" dirty="0"/>
           </a:p>
@@ -10872,7 +10908,7 @@
                 <a:ea typeface="Arial" pitchFamily="34" charset="-122"/>
                 <a:cs typeface="Arial" pitchFamily="34" charset="-120"/>
               </a:rPr>
-              <a:t>Stage with + only what you mean</a:t>
+              <a:t>Do not Commit yet branch first in the next steps</a:t>
             </a:r>
             <a:endParaRPr lang="en-US" sz="1500" dirty="0"/>
           </a:p>
@@ -10890,7 +10926,7 @@
                 <a:ea typeface="Arial" pitchFamily="34" charset="-122"/>
                 <a:cs typeface="Arial" pitchFamily="34" charset="-120"/>
               </a:rPr>
-              <a:t>Message → Commit e.g. Add featured project</a:t>
+              <a:t>Change your details: name, links, coursework, projects</a:t>
             </a:r>
             <a:endParaRPr lang="en-US" sz="1500" dirty="0"/>
           </a:p>
@@ -10908,61 +10944,7 @@
                 <a:ea typeface="Arial" pitchFamily="34" charset="-122"/>
                 <a:cs typeface="Arial" pitchFamily="34" charset="-120"/>
               </a:rPr>
-              <a:t>Open Source Control: Activity Bar · branch icon</a:t>
-            </a:r>
-            <a:endParaRPr lang="en-US" sz="1500" dirty="0"/>
-          </a:p>
-          <a:p>
-            <a:pPr marL="342900" indent="-342900">
-              <a:buSzPct val="100000"/>
-              <a:buChar char="•"/>
-            </a:pPr>
-            <a:r>
-              <a:rPr lang="en-US" sz="1500" dirty="0">
-                <a:solidFill>
-                  <a:srgbClr val="1A1A1A"/>
-                </a:solidFill>
-                <a:latin typeface="Arial" pitchFamily="34" charset="0"/>
-                <a:ea typeface="Arial" pitchFamily="34" charset="-122"/>
-                <a:cs typeface="Arial" pitchFamily="34" charset="-120"/>
-              </a:rPr>
-              <a:t>Click the file: read green / red</a:t>
-            </a:r>
-            <a:endParaRPr lang="en-US" sz="1500" dirty="0"/>
-          </a:p>
-          <a:p>
-            <a:pPr marL="342900" indent="-342900">
-              <a:buSzPct val="100000"/>
-              <a:buChar char="•"/>
-            </a:pPr>
-            <a:r>
-              <a:rPr lang="en-US" sz="1500" dirty="0">
-                <a:solidFill>
-                  <a:srgbClr val="1A1A1A"/>
-                </a:solidFill>
-                <a:latin typeface="Arial" pitchFamily="34" charset="0"/>
-                <a:ea typeface="Arial" pitchFamily="34" charset="-122"/>
-                <a:cs typeface="Arial" pitchFamily="34" charset="-120"/>
-              </a:rPr>
-              <a:t>Stage with +: only what you mean</a:t>
-            </a:r>
-            <a:endParaRPr lang="en-US" sz="1500" dirty="0"/>
-          </a:p>
-          <a:p>
-            <a:pPr marL="342900" indent="-342900">
-              <a:buSzPct val="100000"/>
-              <a:buChar char="•"/>
-            </a:pPr>
-            <a:r>
-              <a:rPr lang="en-US" sz="1500" dirty="0">
-                <a:solidFill>
-                  <a:srgbClr val="1A1A1A"/>
-                </a:solidFill>
-                <a:latin typeface="Arial" pitchFamily="34" charset="0"/>
-                <a:ea typeface="Arial" pitchFamily="34" charset="-122"/>
-                <a:cs typeface="Arial" pitchFamily="34" charset="-120"/>
-              </a:rPr>
-              <a:t>Message → Commit: e.g. Add featured project</a:t>
+              <a:t>Save · refresh localhost Do not Commit yet: branch first in the next steps</a:t>
             </a:r>
             <a:endParaRPr lang="en-US" sz="1500" dirty="0"/>
           </a:p>

</xml_diff>

<commit_message>
Reframe workshop goal: build out resume site
</commit_message>
<xml_diff>
--- a/downloads/workshop-1-presentation.pptx
+++ b/downloads/workshop-1-presentation.pptx
@@ -1134,7 +1134,7 @@
           <a:p>
             <a:r>
               <a:rPr lang="en-US" dirty="0"/>
-              <a:t>Leave this up. Circulate for Status Bar branch name and the diff. Prefer a finished small change.</a:t>
+              <a:t>Leave this up. Goal is a real-looking resume + live URL. PR is required practice. Circulate for profile content and Status Bar branch name.</a:t>
             </a:r>
             <a:endParaRPr lang="en-US" dirty="0"/>
           </a:p>
@@ -1222,7 +1222,7 @@
           <a:p>
             <a:r>
               <a:rPr lang="en-US" dirty="0"/>
-              <a:t>Gallery walk or pair share. Exit ticket: what changed, where’s the diff, what proves it works.</a:t>
+              <a:t>Partner share: does the site look like them? Exit ticket: live URL + one thing they reviewed in the PR.</a:t>
             </a:r>
             <a:endParaRPr lang="en-US" dirty="0"/>
           </a:p>
@@ -1310,7 +1310,7 @@
           <a:p>
             <a:r>
               <a:rPr lang="en-US" dirty="0"/>
-              <a:t>Don’t read a schedule. Point at the outcome. One change they can explain is better than a perfect resume.</a:t>
+              <a:t>Primary goal: their resume content, not a tiny demo PR. Git/PR is how we ship a chunk of that work safely. Prefer a real-looking site over a perfect design.</a:t>
             </a:r>
             <a:endParaRPr lang="en-US" dirty="0"/>
           </a:p>
@@ -2453,7 +2453,7 @@
                 <a:ea typeface="Arial" pitchFamily="34" charset="-122"/>
                 <a:cs typeface="Arial" pitchFamily="34" charset="-120"/>
               </a:rPr>
-              <a:t>Get a portfolio on the internet today.</a:t>
+              <a:t>Build your resume site and put it online.</a:t>
             </a:r>
             <a:endParaRPr lang="en-US" sz="2800" dirty="0"/>
           </a:p>
@@ -2767,7 +2767,7 @@
                 <a:ea typeface="Arial" pitchFamily="34" charset="-122"/>
                 <a:cs typeface="Arial" pitchFamily="34" charset="-120"/>
               </a:rPr>
-              <a:t>Write a tiny issue before you commit.</a:t>
+              <a:t>Pick one piece of that resume work for a pull request.</a:t>
             </a:r>
             <a:endParaRPr lang="en-US" sz="2800" dirty="0"/>
           </a:p>
@@ -4651,7 +4651,7 @@
                 <a:ea typeface="Arial" pitchFamily="34" charset="-122"/>
                 <a:cs typeface="Arial" pitchFamily="34" charset="-120"/>
               </a:rPr>
-              <a:t>Lab time. Finish the loop.</a:t>
+              <a:t>Lab: finish your resume content, then ship it.</a:t>
             </a:r>
             <a:endParaRPr lang="en-US" sz="2800" dirty="0"/>
           </a:p>
@@ -4965,7 +4965,7 @@
                 <a:ea typeface="Arial" pitchFamily="34" charset="-122"/>
                 <a:cs typeface="Arial" pitchFamily="34" charset="-120"/>
               </a:rPr>
-              <a:t>Show a partner: issue, diff, PR, live URL.</a:t>
+              <a:t>Show a partner your live resume — and the PR that got it there.</a:t>
             </a:r>
             <a:endParaRPr lang="en-US" sz="2800" dirty="0"/>
           </a:p>
@@ -5279,7 +5279,7 @@
                 <a:ea typeface="Arial" pitchFamily="34" charset="-122"/>
                 <a:cs typeface="Arial" pitchFamily="34" charset="-120"/>
               </a:rPr>
-              <a:t>You’re done when someone can open your site on their phone.</a:t>
+              <a:t>Today’s job: make this site yours, then publish it.</a:t>
             </a:r>
             <a:endParaRPr lang="en-US" sz="2800" dirty="0"/>
           </a:p>
@@ -7477,7 +7477,7 @@
                 <a:ea typeface="Arial" pitchFamily="34" charset="-122"/>
                 <a:cs typeface="Arial" pitchFamily="34" charset="-120"/>
               </a:rPr>
-              <a:t>Make it yours. Don’t commit yet.</a:t>
+              <a:t>Build out your resume in profile.js .</a:t>
             </a:r>
             <a:endParaRPr lang="en-US" sz="2800" dirty="0"/>
           </a:p>

</xml_diff>

<commit_message>
Add partner +1 PR review step
</commit_message>
<xml_diff>
--- a/downloads/workshop-1-presentation.pptx
+++ b/downloads/workshop-1-presentation.pptx
@@ -22,9 +22,10 @@
     <p:sldId id="270" r:id="rId16"/>
     <p:sldId id="271" r:id="rId17"/>
     <p:sldId id="272" r:id="rId18"/>
+    <p:sldId id="273" r:id="rId19"/>
   </p:sldIdLst>
   <p:notesMasterIdLst>
-    <p:notesMasterId r:id="rId19"/>
+    <p:notesMasterId r:id="rId20"/>
   </p:notesMasterIdLst>
   <p:sldSz cx="12191695" cy="6858000"/>
   <p:notesSz cx="6858000" cy="12191695"/>
@@ -870,7 +871,7 @@
           <a:p>
             <a:r>
               <a:rPr lang="en-US" dirty="0"/>
-              <a:t>Files changed is the review. Merge only when it matches the issue. Partner review if time.</a:t>
+              <a:t>Create the PR with Closes #N. Do not merge yet — next slide is partner +1.</a:t>
             </a:r>
             <a:endParaRPr lang="en-US" dirty="0"/>
           </a:p>
@@ -958,7 +959,7 @@
           <a:p>
             <a:r>
               <a:rPr lang="en-US" dirty="0"/>
-              <a:t>Open deploy.yml in Explorer. Do not write YAML. Feature branch does not publish — only main.</a:t>
+              <a:t>Require a neighbor Approve/Comment before merge. Facilitator can +1 for solos. Odd count → trios.</a:t>
             </a:r>
             <a:endParaRPr lang="en-US" dirty="0"/>
           </a:p>
@@ -1046,7 +1047,7 @@
           <a:p>
             <a:r>
               <a:rPr lang="en-US" dirty="0"/>
-              <a:t>Source = GitHub Actions. Re-run all jobs on the failed run. Then open the real URL.</a:t>
+              <a:t>Open deploy.yml in Explorer. Do not write YAML. Feature branch does not publish — only main.</a:t>
             </a:r>
             <a:endParaRPr lang="en-US" dirty="0"/>
           </a:p>
@@ -1134,7 +1135,7 @@
           <a:p>
             <a:r>
               <a:rPr lang="en-US" dirty="0"/>
-              <a:t>Leave this up. Goal is a real-looking resume + live URL. PR is required practice. Circulate for profile content and Status Bar branch name.</a:t>
+              <a:t>Source = GitHub Actions. Re-run all jobs on the failed run. Then open the real URL.</a:t>
             </a:r>
             <a:endParaRPr lang="en-US" dirty="0"/>
           </a:p>
@@ -1222,7 +1223,7 @@
           <a:p>
             <a:r>
               <a:rPr lang="en-US" dirty="0"/>
-              <a:t>Partner share: does the site look like them? Exit ticket: live URL + one thing they reviewed in the PR.</a:t>
+              <a:t>Leave this up. Goal is a real-looking resume + live URL. PR + partner +1 required. Circulate for profile content and Status Bar branch name.</a:t>
             </a:r>
             <a:endParaRPr lang="en-US" dirty="0"/>
           </a:p>
@@ -1246,6 +1247,94 @@
             <a:fld id="{F7021451-1387-4CA6-816F-3879F97B5CBC}" type="slidenum">
               <a:rPr lang="en-US"/>
               <a:t>17</a:t>
+            </a:fld>
+            <a:endParaRPr lang="en-US"/>
+          </a:p>
+        </p:txBody>
+      </p:sp>
+    </p:spTree>
+    <p:extLst>
+      <p:ext uri="{BB962C8B-B14F-4D97-AF65-F5344CB8AC3E}">
+        <p14:creationId xmlns:p14="http://schemas.microsoft.com/office/powerpoint/2010/main" val="1024086991"/>
+      </p:ext>
+    </p:extLst>
+  </p:cSld>
+  <p:clrMapOvr>
+    <a:masterClrMapping/>
+  </p:clrMapOvr>
+</p:notes>
+</file>
+
+<file path=ppt/notesSlides/notesSlide18.xml><?xml version="1.0" encoding="utf-8"?>
+<p:notes xmlns:a="http://schemas.openxmlformats.org/drawingml/2006/main" xmlns:r="http://schemas.openxmlformats.org/officeDocument/2006/relationships" xmlns:p="http://schemas.openxmlformats.org/presentationml/2006/main">
+  <p:cSld>
+    <p:spTree>
+      <p:nvGrpSpPr>
+        <p:cNvPr id="1" name=""/>
+        <p:cNvGrpSpPr/>
+        <p:nvPr/>
+      </p:nvGrpSpPr>
+      <p:grpSpPr>
+        <a:xfrm>
+          <a:off x="0" y="0"/>
+          <a:ext cx="0" cy="0"/>
+          <a:chOff x="0" y="0"/>
+          <a:chExt cx="0" cy="0"/>
+        </a:xfrm>
+      </p:grpSpPr>
+      <p:sp>
+        <p:nvSpPr>
+          <p:cNvPr id="2" name="Slide Image Placeholder 1"/>
+          <p:cNvSpPr>
+            <a:spLocks noGrp="1" noRot="1" noChangeAspect="1"/>
+          </p:cNvSpPr>
+          <p:nvPr>
+            <p:ph type="sldImg"/>
+          </p:nvPr>
+        </p:nvSpPr>
+        <p:spPr/>
+      </p:sp>
+      <p:sp>
+        <p:nvSpPr>
+          <p:cNvPr id="3" name="Notes Placeholder 2"/>
+          <p:cNvSpPr>
+            <a:spLocks noGrp="1"/>
+          </p:cNvSpPr>
+          <p:nvPr>
+            <p:ph type="body" idx="1"/>
+          </p:nvPr>
+        </p:nvSpPr>
+        <p:spPr/>
+        <p:txBody>
+          <a:bodyPr/>
+          <a:lstStyle/>
+          <a:p>
+            <a:r>
+              <a:rPr lang="en-US" dirty="0"/>
+              <a:t>Exit ticket: live URL + who gave their +1. Site should look like them, not Jordan Lee.</a:t>
+            </a:r>
+            <a:endParaRPr lang="en-US" dirty="0"/>
+          </a:p>
+        </p:txBody>
+      </p:sp>
+      <p:sp>
+        <p:nvSpPr>
+          <p:cNvPr id="4" name="Slide Number Placeholder 3"/>
+          <p:cNvSpPr>
+            <a:spLocks noGrp="1"/>
+          </p:cNvSpPr>
+          <p:nvPr>
+            <p:ph type="sldNum" sz="quarter" idx="10"/>
+          </p:nvPr>
+        </p:nvSpPr>
+        <p:spPr/>
+        <p:txBody>
+          <a:bodyPr/>
+          <a:lstStyle/>
+          <a:p>
+            <a:fld id="{F7021451-1387-4CA6-816F-3879F97B5CBC}" type="slidenum">
+              <a:rPr lang="en-US"/>
+              <a:t>18</a:t>
             </a:fld>
             <a:endParaRPr lang="en-US"/>
           </a:p>
@@ -2414,7 +2503,7 @@
                 <a:ea typeface="Arial" pitchFamily="34" charset="-122"/>
                 <a:cs typeface="Arial" pitchFamily="34" charset="-120"/>
               </a:rPr>
-              <a:t>01 / 17</a:t>
+              <a:t>01 / 18</a:t>
             </a:r>
             <a:endParaRPr lang="en-US" sz="1100" dirty="0"/>
           </a:p>
@@ -2728,7 +2817,7 @@
                 <a:ea typeface="Arial" pitchFamily="34" charset="-122"/>
                 <a:cs typeface="Arial" pitchFamily="34" charset="-120"/>
               </a:rPr>
-              <a:t>10 / 17</a:t>
+              <a:t>10 / 18</a:t>
             </a:r>
             <a:endParaRPr lang="en-US" sz="1100" dirty="0"/>
           </a:p>
@@ -3042,7 +3131,7 @@
                 <a:ea typeface="Arial" pitchFamily="34" charset="-122"/>
                 <a:cs typeface="Arial" pitchFamily="34" charset="-120"/>
               </a:rPr>
-              <a:t>11 / 17</a:t>
+              <a:t>11 / 18</a:t>
             </a:r>
             <a:endParaRPr lang="en-US" sz="1100" dirty="0"/>
           </a:p>
@@ -3356,7 +3445,7 @@
                 <a:ea typeface="Arial" pitchFamily="34" charset="-122"/>
                 <a:cs typeface="Arial" pitchFamily="34" charset="-120"/>
               </a:rPr>
-              <a:t>12 / 17</a:t>
+              <a:t>12 / 18</a:t>
             </a:r>
             <a:endParaRPr lang="en-US" sz="1100" dirty="0"/>
           </a:p>
@@ -3670,7 +3759,7 @@
                 <a:ea typeface="Arial" pitchFamily="34" charset="-122"/>
                 <a:cs typeface="Arial" pitchFamily="34" charset="-120"/>
               </a:rPr>
-              <a:t>13 / 17</a:t>
+              <a:t>13 / 18</a:t>
             </a:r>
             <a:endParaRPr lang="en-US" sz="1100" dirty="0"/>
           </a:p>
@@ -3984,7 +4073,7 @@
                 <a:ea typeface="Arial" pitchFamily="34" charset="-122"/>
                 <a:cs typeface="Arial" pitchFamily="34" charset="-120"/>
               </a:rPr>
-              <a:t>14 / 17</a:t>
+              <a:t>14 / 18</a:t>
             </a:r>
             <a:endParaRPr lang="en-US" sz="1100" dirty="0"/>
           </a:p>
@@ -4023,7 +4112,7 @@
                 <a:ea typeface="Arial" pitchFamily="34" charset="-122"/>
                 <a:cs typeface="Arial" pitchFamily="34" charset="-120"/>
               </a:rPr>
-              <a:t>Your ZIP already includes a GitHub Actions workflow.</a:t>
+              <a:t>Hand your PR to the person beside you for a +1.</a:t>
             </a:r>
             <a:endParaRPr lang="en-US" sz="2800" dirty="0"/>
           </a:p>
@@ -4063,7 +4152,7 @@
                 <a:ea typeface="Arial" pitchFamily="34" charset="-122"/>
                 <a:cs typeface="Arial" pitchFamily="34" charset="-120"/>
               </a:rPr>
-              <a:t>Actions</a:t>
+              <a:t>Partner +1</a:t>
             </a:r>
             <a:endParaRPr lang="en-US" sz="1500" dirty="0"/>
           </a:p>
@@ -4298,7 +4387,7 @@
                 <a:ea typeface="Arial" pitchFamily="34" charset="-122"/>
                 <a:cs typeface="Arial" pitchFamily="34" charset="-120"/>
               </a:rPr>
-              <a:t>15 / 17</a:t>
+              <a:t>15 / 18</a:t>
             </a:r>
             <a:endParaRPr lang="en-US" sz="1100" dirty="0"/>
           </a:p>
@@ -4337,7 +4426,7 @@
                 <a:ea typeface="Arial" pitchFamily="34" charset="-122"/>
                 <a:cs typeface="Arial" pitchFamily="34" charset="-120"/>
               </a:rPr>
-              <a:t>Turn Pages on, then re-run the failed job.</a:t>
+              <a:t>Your ZIP already includes a GitHub Actions workflow.</a:t>
             </a:r>
             <a:endParaRPr lang="en-US" sz="2800" dirty="0"/>
           </a:p>
@@ -4377,7 +4466,7 @@
                 <a:ea typeface="Arial" pitchFamily="34" charset="-122"/>
                 <a:cs typeface="Arial" pitchFamily="34" charset="-120"/>
               </a:rPr>
-              <a:t>Pages</a:t>
+              <a:t>Actions</a:t>
             </a:r>
             <a:endParaRPr lang="en-US" sz="1500" dirty="0"/>
           </a:p>
@@ -4612,7 +4701,7 @@
                 <a:ea typeface="Arial" pitchFamily="34" charset="-122"/>
                 <a:cs typeface="Arial" pitchFamily="34" charset="-120"/>
               </a:rPr>
-              <a:t>16 / 17</a:t>
+              <a:t>16 / 18</a:t>
             </a:r>
             <a:endParaRPr lang="en-US" sz="1100" dirty="0"/>
           </a:p>
@@ -4651,7 +4740,7 @@
                 <a:ea typeface="Arial" pitchFamily="34" charset="-122"/>
                 <a:cs typeface="Arial" pitchFamily="34" charset="-120"/>
               </a:rPr>
-              <a:t>Lab: finish your resume content, then ship it.</a:t>
+              <a:t>Turn Pages on, then re-run the failed job.</a:t>
             </a:r>
             <a:endParaRPr lang="en-US" sz="2800" dirty="0"/>
           </a:p>
@@ -4691,7 +4780,7 @@
                 <a:ea typeface="Arial" pitchFamily="34" charset="-122"/>
                 <a:cs typeface="Arial" pitchFamily="34" charset="-120"/>
               </a:rPr>
-              <a:t>Lab</a:t>
+              <a:t>Pages</a:t>
             </a:r>
             <a:endParaRPr lang="en-US" sz="1500" dirty="0"/>
           </a:p>
@@ -4926,7 +5015,321 @@
                 <a:ea typeface="Arial" pitchFamily="34" charset="-122"/>
                 <a:cs typeface="Arial" pitchFamily="34" charset="-120"/>
               </a:rPr>
-              <a:t>17 / 17</a:t>
+              <a:t>17 / 18</a:t>
+            </a:r>
+            <a:endParaRPr lang="en-US" sz="1100" dirty="0"/>
+          </a:p>
+        </p:txBody>
+      </p:sp>
+      <p:sp>
+        <p:nvSpPr>
+          <p:cNvPr id="6" name="Text 4"/>
+          <p:cNvSpPr/>
+          <p:nvPr/>
+        </p:nvSpPr>
+        <p:spPr>
+          <a:xfrm>
+            <a:off x="502920" y="960120"/>
+            <a:ext cx="11155680" cy="777240"/>
+          </a:xfrm>
+          <a:prstGeom prst="rect">
+            <a:avLst/>
+          </a:prstGeom>
+          <a:noFill/>
+          <a:ln/>
+        </p:spPr>
+        <p:txBody>
+          <a:bodyPr wrap="square" rtlCol="0" anchor="t"/>
+          <a:lstStyle/>
+          <a:p>
+            <a:pPr indent="0" marL="0">
+              <a:buNone/>
+            </a:pPr>
+            <a:r>
+              <a:rPr lang="en-US" sz="2800" b="1" dirty="0">
+                <a:solidFill>
+                  <a:srgbClr val="1A1A1A"/>
+                </a:solidFill>
+                <a:latin typeface="Arial" pitchFamily="34" charset="0"/>
+                <a:ea typeface="Arial" pitchFamily="34" charset="-122"/>
+                <a:cs typeface="Arial" pitchFamily="34" charset="-120"/>
+              </a:rPr>
+              <a:t>Lab: finish your resume content, then ship it.</a:t>
+            </a:r>
+            <a:endParaRPr lang="en-US" sz="2800" dirty="0"/>
+          </a:p>
+        </p:txBody>
+      </p:sp>
+      <p:sp>
+        <p:nvSpPr>
+          <p:cNvPr id="7" name="Text 5"/>
+          <p:cNvSpPr/>
+          <p:nvPr/>
+        </p:nvSpPr>
+        <p:spPr>
+          <a:xfrm>
+            <a:off x="502920" y="1783080"/>
+            <a:ext cx="11155680" cy="877824"/>
+          </a:xfrm>
+          <a:prstGeom prst="rect">
+            <a:avLst/>
+          </a:prstGeom>
+          <a:noFill/>
+          <a:ln/>
+        </p:spPr>
+        <p:txBody>
+          <a:bodyPr wrap="square" rtlCol="0" anchor="t"/>
+          <a:lstStyle/>
+          <a:p>
+            <a:pPr marL="342900" indent="-342900">
+              <a:buSzPct val="100000"/>
+              <a:buChar char="•"/>
+            </a:pPr>
+            <a:r>
+              <a:rPr lang="en-US" sz="1500" dirty="0">
+                <a:solidFill>
+                  <a:srgbClr val="1A1A1A"/>
+                </a:solidFill>
+                <a:latin typeface="Arial" pitchFamily="34" charset="0"/>
+                <a:ea typeface="Arial" pitchFamily="34" charset="-122"/>
+                <a:cs typeface="Arial" pitchFamily="34" charset="-120"/>
+              </a:rPr>
+              <a:t>Lab</a:t>
+            </a:r>
+            <a:endParaRPr lang="en-US" sz="1500" dirty="0"/>
+          </a:p>
+          <a:p>
+            <a:pPr marL="342900" indent="-342900">
+              <a:buSzPct val="100000"/>
+              <a:buChar char="•"/>
+            </a:pPr>
+            <a:r>
+              <a:rPr lang="en-US" sz="1500" dirty="0">
+                <a:solidFill>
+                  <a:srgbClr val="1A1A1A"/>
+                </a:solidFill>
+                <a:latin typeface="Arial" pitchFamily="34" charset="0"/>
+                <a:ea typeface="Arial" pitchFamily="34" charset="-122"/>
+                <a:cs typeface="Arial" pitchFamily="34" charset="-120"/>
+              </a:rPr>
+              <a:t>See the live web deck for full layout and screenshots.</a:t>
+            </a:r>
+            <a:endParaRPr lang="en-US" sz="1500" dirty="0"/>
+          </a:p>
+        </p:txBody>
+      </p:sp>
+      <p:sp>
+        <p:nvSpPr>
+          <p:cNvPr id="8" name="Shape 6"/>
+          <p:cNvSpPr/>
+          <p:nvPr/>
+        </p:nvSpPr>
+        <p:spPr>
+          <a:xfrm>
+            <a:off x="0" y="6446520"/>
+            <a:ext cx="12191695" cy="411480"/>
+          </a:xfrm>
+          <a:prstGeom prst="rect">
+            <a:avLst/>
+          </a:prstGeom>
+          <a:solidFill>
+            <a:srgbClr val="000000"/>
+          </a:solidFill>
+          <a:ln w="12700">
+            <a:solidFill>
+              <a:srgbClr val="000000"/>
+            </a:solidFill>
+            <a:prstDash val="solid"/>
+          </a:ln>
+        </p:spPr>
+      </p:sp>
+      <p:sp>
+        <p:nvSpPr>
+          <p:cNvPr id="9" name="Text 7"/>
+          <p:cNvSpPr/>
+          <p:nvPr/>
+        </p:nvSpPr>
+        <p:spPr>
+          <a:xfrm>
+            <a:off x="502920" y="6528816"/>
+            <a:ext cx="11155680" cy="256032"/>
+          </a:xfrm>
+          <a:prstGeom prst="rect">
+            <a:avLst/>
+          </a:prstGeom>
+          <a:noFill/>
+          <a:ln/>
+        </p:spPr>
+        <p:txBody>
+          <a:bodyPr wrap="square" rtlCol="0" anchor="ctr"/>
+          <a:lstStyle/>
+          <a:p>
+            <a:pPr indent="0" marL="0">
+              <a:buNone/>
+            </a:pPr>
+            <a:r>
+              <a:rPr lang="en-US" sz="1100" b="1" dirty="0">
+                <a:solidFill>
+                  <a:srgbClr val="FFDB00"/>
+                </a:solidFill>
+                <a:latin typeface="Arial" pitchFamily="34" charset="0"/>
+                <a:ea typeface="Arial" pitchFamily="34" charset="-122"/>
+                <a:cs typeface="Arial" pitchFamily="34" charset="-120"/>
+              </a:rPr>
+              <a:t>ARROWS ON THE WEB DECK · R FOR RESOURCES · N FOR NOTES</a:t>
+            </a:r>
+            <a:endParaRPr lang="en-US" sz="1100" dirty="0"/>
+          </a:p>
+        </p:txBody>
+      </p:sp>
+    </p:spTree>
+  </p:cSld>
+  <p:clrMapOvr>
+    <a:masterClrMapping/>
+  </p:clrMapOvr>
+</p:sld>
+</file>
+
+<file path=ppt/slides/slide18.xml><?xml version="1.0" encoding="utf-8"?>
+<p:sld xmlns:a="http://schemas.openxmlformats.org/drawingml/2006/main" xmlns:r="http://schemas.openxmlformats.org/officeDocument/2006/relationships" xmlns:p="http://schemas.openxmlformats.org/presentationml/2006/main">
+  <p:cSld name="Slide 18">
+    <p:spTree>
+      <p:nvGrpSpPr>
+        <p:cNvPr id="1" name=""/>
+        <p:cNvGrpSpPr/>
+        <p:nvPr/>
+      </p:nvGrpSpPr>
+      <p:grpSpPr>
+        <a:xfrm>
+          <a:off x="0" y="0"/>
+          <a:ext cx="0" cy="0"/>
+          <a:chOff x="0" y="0"/>
+          <a:chExt cx="0" cy="0"/>
+        </a:xfrm>
+      </p:grpSpPr>
+      <p:sp>
+        <p:nvSpPr>
+          <p:cNvPr id="2" name="Shape 0"/>
+          <p:cNvSpPr/>
+          <p:nvPr/>
+        </p:nvSpPr>
+        <p:spPr>
+          <a:xfrm>
+            <a:off x="0" y="0"/>
+            <a:ext cx="12191695" cy="164592"/>
+          </a:xfrm>
+          <a:prstGeom prst="rect">
+            <a:avLst/>
+          </a:prstGeom>
+          <a:solidFill>
+            <a:srgbClr val="000000"/>
+          </a:solidFill>
+          <a:ln w="12700">
+            <a:solidFill>
+              <a:srgbClr val="000000"/>
+            </a:solidFill>
+            <a:prstDash val="solid"/>
+          </a:ln>
+        </p:spPr>
+      </p:sp>
+      <p:sp>
+        <p:nvSpPr>
+          <p:cNvPr id="3" name="Shape 1"/>
+          <p:cNvSpPr/>
+          <p:nvPr/>
+        </p:nvSpPr>
+        <p:spPr>
+          <a:xfrm>
+            <a:off x="0" y="164592"/>
+            <a:ext cx="12191695" cy="73152"/>
+          </a:xfrm>
+          <a:prstGeom prst="rect">
+            <a:avLst/>
+          </a:prstGeom>
+          <a:solidFill>
+            <a:srgbClr val="FFDB00"/>
+          </a:solidFill>
+          <a:ln w="12700">
+            <a:solidFill>
+              <a:srgbClr val="FFDB00"/>
+            </a:solidFill>
+            <a:prstDash val="solid"/>
+          </a:ln>
+        </p:spPr>
+      </p:sp>
+      <p:sp>
+        <p:nvSpPr>
+          <p:cNvPr id="4" name="Text 2"/>
+          <p:cNvSpPr/>
+          <p:nvPr/>
+        </p:nvSpPr>
+        <p:spPr>
+          <a:xfrm>
+            <a:off x="502920" y="365760"/>
+            <a:ext cx="9601200" cy="256032"/>
+          </a:xfrm>
+          <a:prstGeom prst="rect">
+            <a:avLst/>
+          </a:prstGeom>
+          <a:noFill/>
+          <a:ln/>
+        </p:spPr>
+        <p:txBody>
+          <a:bodyPr wrap="square" rtlCol="0" anchor="ctr"/>
+          <a:lstStyle/>
+          <a:p>
+            <a:pPr indent="0" marL="0">
+              <a:buNone/>
+            </a:pPr>
+            <a:r>
+              <a:rPr lang="en-US" sz="1100" b="1" spc="200" kern="0" dirty="0">
+                <a:solidFill>
+                  <a:srgbClr val="555555"/>
+                </a:solidFill>
+                <a:latin typeface="Arial" pitchFamily="34" charset="0"/>
+                <a:ea typeface="Arial" pitchFamily="34" charset="-122"/>
+                <a:cs typeface="Arial" pitchFamily="34" charset="-120"/>
+              </a:rPr>
+              <a:t>WICHITA STATE · MIS CLUB · WORKSHOP 1</a:t>
+            </a:r>
+            <a:endParaRPr lang="en-US" sz="1100" dirty="0"/>
+          </a:p>
+        </p:txBody>
+      </p:sp>
+      <p:sp>
+        <p:nvSpPr>
+          <p:cNvPr id="5" name="Text 3"/>
+          <p:cNvSpPr/>
+          <p:nvPr/>
+        </p:nvSpPr>
+        <p:spPr>
+          <a:xfrm>
+            <a:off x="10241280" y="365760"/>
+            <a:ext cx="1463040" cy="256032"/>
+          </a:xfrm>
+          <a:prstGeom prst="rect">
+            <a:avLst/>
+          </a:prstGeom>
+          <a:noFill/>
+          <a:ln/>
+        </p:spPr>
+        <p:txBody>
+          <a:bodyPr wrap="square" rtlCol="0" anchor="ctr"/>
+          <a:lstStyle/>
+          <a:p>
+            <a:pPr algn="r" indent="0" marL="0">
+              <a:buNone/>
+            </a:pPr>
+            <a:r>
+              <a:rPr lang="en-US" sz="1100" b="1" dirty="0">
+                <a:solidFill>
+                  <a:srgbClr val="555555"/>
+                </a:solidFill>
+                <a:latin typeface="Arial" pitchFamily="34" charset="0"/>
+                <a:ea typeface="Arial" pitchFamily="34" charset="-122"/>
+                <a:cs typeface="Arial" pitchFamily="34" charset="-120"/>
+              </a:rPr>
+              <a:t>18 / 18</a:t>
             </a:r>
             <a:endParaRPr lang="en-US" sz="1100" dirty="0"/>
           </a:p>
@@ -5240,7 +5643,7 @@
                 <a:ea typeface="Arial" pitchFamily="34" charset="-122"/>
                 <a:cs typeface="Arial" pitchFamily="34" charset="-120"/>
               </a:rPr>
-              <a:t>02 / 17</a:t>
+              <a:t>02 / 18</a:t>
             </a:r>
             <a:endParaRPr lang="en-US" sz="1100" dirty="0"/>
           </a:p>
@@ -5554,7 +5957,7 @@
                 <a:ea typeface="Arial" pitchFamily="34" charset="-122"/>
                 <a:cs typeface="Arial" pitchFamily="34" charset="-120"/>
               </a:rPr>
-              <a:t>03 / 17</a:t>
+              <a:t>03 / 18</a:t>
             </a:r>
             <a:endParaRPr lang="en-US" sz="1100" dirty="0"/>
           </a:p>
@@ -5868,7 +6271,7 @@
                 <a:ea typeface="Arial" pitchFamily="34" charset="-122"/>
                 <a:cs typeface="Arial" pitchFamily="34" charset="-120"/>
               </a:rPr>
-              <a:t>04 / 17</a:t>
+              <a:t>04 / 18</a:t>
             </a:r>
             <a:endParaRPr lang="en-US" sz="1100" dirty="0"/>
           </a:p>
@@ -6182,7 +6585,7 @@
                 <a:ea typeface="Arial" pitchFamily="34" charset="-122"/>
                 <a:cs typeface="Arial" pitchFamily="34" charset="-120"/>
               </a:rPr>
-              <a:t>05 / 17</a:t>
+              <a:t>05 / 18</a:t>
             </a:r>
             <a:endParaRPr lang="en-US" sz="1100" dirty="0"/>
           </a:p>
@@ -6496,7 +6899,7 @@
                 <a:ea typeface="Arial" pitchFamily="34" charset="-122"/>
                 <a:cs typeface="Arial" pitchFamily="34" charset="-120"/>
               </a:rPr>
-              <a:t>06 / 17</a:t>
+              <a:t>06 / 18</a:t>
             </a:r>
             <a:endParaRPr lang="en-US" sz="1100" dirty="0"/>
           </a:p>
@@ -6810,7 +7213,7 @@
                 <a:ea typeface="Arial" pitchFamily="34" charset="-122"/>
                 <a:cs typeface="Arial" pitchFamily="34" charset="-120"/>
               </a:rPr>
-              <a:t>07 / 17</a:t>
+              <a:t>07 / 18</a:t>
             </a:r>
             <a:endParaRPr lang="en-US" sz="1100" dirty="0"/>
           </a:p>
@@ -7124,7 +7527,7 @@
                 <a:ea typeface="Arial" pitchFamily="34" charset="-122"/>
                 <a:cs typeface="Arial" pitchFamily="34" charset="-120"/>
               </a:rPr>
-              <a:t>08 / 17</a:t>
+              <a:t>08 / 18</a:t>
             </a:r>
             <a:endParaRPr lang="en-US" sz="1100" dirty="0"/>
           </a:p>
@@ -7438,7 +7841,7 @@
                 <a:ea typeface="Arial" pitchFamily="34" charset="-122"/>
                 <a:cs typeface="Arial" pitchFamily="34" charset="-120"/>
               </a:rPr>
-              <a:t>09 / 17</a:t>
+              <a:t>09 / 18</a:t>
             </a:r>
             <a:endParaRPr lang="en-US" sz="1100" dirty="0"/>
           </a:p>

</xml_diff>

<commit_message>
Explicitly teach attaching PR to issue via Closes #N + Development check
</commit_message>
<xml_diff>
--- a/downloads/workshop-1-presentation.pptx
+++ b/downloads/workshop-1-presentation.pptx
@@ -871,7 +871,7 @@
           <a:p>
             <a:r>
               <a:rPr lang="en-US" dirty="0"/>
-              <a:t>Create the PR with Closes #N. Do not merge yet — next slide is partner +1.</a:t>
+              <a:t>Issue = task. PR = fix. Closes #N attaches them. Verify on the issue under Development. Do not merge yet — next slide is partner +1.</a:t>
             </a:r>
             <a:endParaRPr lang="en-US" dirty="0"/>
           </a:p>
@@ -3798,7 +3798,7 @@
                 <a:ea typeface="Arial" pitchFamily="34" charset="-122"/>
                 <a:cs typeface="Arial" pitchFamily="34" charset="-120"/>
               </a:rPr>
-              <a:t>Open the pull request. Put Closes #1 in the description.</a:t>
+              <a:t>Open the PR. Attach it to your issue with Closes #1 .</a:t>
             </a:r>
             <a:endParaRPr lang="en-US" sz="2800" dirty="0"/>
           </a:p>

</xml_diff>

<commit_message>
Add GitHub UI Link an issue as second PR-to-issue attach method
</commit_message>
<xml_diff>
--- a/downloads/workshop-1-presentation.pptx
+++ b/downloads/workshop-1-presentation.pptx
@@ -871,7 +871,7 @@
           <a:p>
             <a:r>
               <a:rPr lang="en-US" dirty="0"/>
-              <a:t>Issue = task. PR = fix. Closes #N attaches them. Verify on the issue under Development. Do not merge yet — next slide is partner +1.</a:t>
+              <a:t>Two attach methods: Closes #N in body (auto-closes) and PR sidebar Development → Link an issue. Verify both sides. Do not merge yet — next slide is partner +1.</a:t>
             </a:r>
             <a:endParaRPr lang="en-US" dirty="0"/>
           </a:p>
@@ -3798,7 +3798,7 @@
                 <a:ea typeface="Arial" pitchFamily="34" charset="-122"/>
                 <a:cs typeface="Arial" pitchFamily="34" charset="-120"/>
               </a:rPr>
-              <a:t>Open the PR. Attach it to your issue with Closes #1 .</a:t>
+              <a:t>Open the PR. Attach it to your issue.</a:t>
             </a:r>
             <a:endParaRPr lang="en-US" sz="2800" dirty="0"/>
           </a:p>

</xml_diff>

<commit_message>
Deck: fix highlight overlap; add Tyler about-me intro slides
</commit_message>
<xml_diff>
--- a/downloads/workshop-1-presentation.pptx
+++ b/downloads/workshop-1-presentation.pptx
@@ -23,9 +23,12 @@
     <p:sldId id="271" r:id="rId17"/>
     <p:sldId id="272" r:id="rId18"/>
     <p:sldId id="273" r:id="rId19"/>
+    <p:sldId id="274" r:id="rId20"/>
+    <p:sldId id="275" r:id="rId21"/>
+    <p:sldId id="276" r:id="rId22"/>
   </p:sldIdLst>
   <p:notesMasterIdLst>
-    <p:notesMasterId r:id="rId20"/>
+    <p:notesMasterId r:id="rId23"/>
   </p:notesMasterIdLst>
   <p:sldSz cx="12191695" cy="6858000"/>
   <p:notesSz cx="6858000" cy="12191695"/>
@@ -607,7 +610,7 @@
           <a:p>
             <a:r>
               <a:rPr lang="en-US" dirty="0"/>
-              <a:t>Partner check: could a stranger verify done? Keep criteria short.</a:t>
+              <a:t>Second terminal if npm run dev is running. Warn: Actions often red-X until Pages is enabled later — expected. Auth = browser or PAT, never GitHub password.</a:t>
             </a:r>
             <a:endParaRPr lang="en-US" dirty="0"/>
           </a:p>
@@ -695,7 +698,7 @@
           <a:p>
             <a:r>
               <a:rPr lang="en-US" dirty="0"/>
-              <a:t>Status Bar bottom-left. Uncommitted edits ride along onto the new branch. Don’t continue until the name shows.</a:t>
+              <a:t>Have everyone type git status once so they see it. Rule for the rest of the day.</a:t>
             </a:r>
             <a:endParaRPr lang="en-US" dirty="0"/>
           </a:p>
@@ -783,7 +786,7 @@
           <a:p>
             <a:r>
               <a:rPr lang="en-US" dirty="0"/>
-              <a:t>Demo Source Control: open diff, stage +, message, Commit, Publish Branch. Roast the message “updates” if it comes up.</a:t>
+              <a:t>Stress: do NOT commit on main. Source Control badge is fine — leave it. Replace example.com placeholders.</a:t>
             </a:r>
             <a:endParaRPr lang="en-US" dirty="0"/>
           </a:p>
@@ -871,7 +874,7 @@
           <a:p>
             <a:r>
               <a:rPr lang="en-US" dirty="0"/>
-              <a:t>Two attach methods: Closes #N in body (auto-closes) and PR sidebar Development → Link an issue. Verify both sides. Do not merge yet — next slide is partner +1.</a:t>
+              <a:t>Partner check: could a stranger verify done? Keep criteria short.</a:t>
             </a:r>
             <a:endParaRPr lang="en-US" dirty="0"/>
           </a:p>
@@ -959,7 +962,7 @@
           <a:p>
             <a:r>
               <a:rPr lang="en-US" dirty="0"/>
-              <a:t>Require a neighbor Approve/Comment before merge. Facilitator can +1 for solos. Odd count → trios.</a:t>
+              <a:t>Status Bar bottom-left. Uncommitted edits ride along onto the new branch. Don’t continue until the name shows.</a:t>
             </a:r>
             <a:endParaRPr lang="en-US" dirty="0"/>
           </a:p>
@@ -1047,7 +1050,7 @@
           <a:p>
             <a:r>
               <a:rPr lang="en-US" dirty="0"/>
-              <a:t>Open deploy.yml in Explorer. Do not write YAML. Feature branch does not publish — only main.</a:t>
+              <a:t>Demo Source Control: open diff, stage +, message, Commit, Publish Branch. Roast the message “updates” if it comes up.</a:t>
             </a:r>
             <a:endParaRPr lang="en-US" dirty="0"/>
           </a:p>
@@ -1135,7 +1138,7 @@
           <a:p>
             <a:r>
               <a:rPr lang="en-US" dirty="0"/>
-              <a:t>Source = GitHub Actions. Re-run all jobs on the failed run. Then open the real URL.</a:t>
+              <a:t>Two attach methods: Closes #N in body (auto-closes) and PR sidebar Development → Link an issue. Verify both sides. Do not merge yet — next slide is partner +1.</a:t>
             </a:r>
             <a:endParaRPr lang="en-US" dirty="0"/>
           </a:p>
@@ -1223,7 +1226,7 @@
           <a:p>
             <a:r>
               <a:rPr lang="en-US" dirty="0"/>
-              <a:t>Leave this up. Goal is a real-looking resume + live URL. PR + partner +1 required. Circulate for profile content and Status Bar branch name.</a:t>
+              <a:t>Require a neighbor Approve/Comment before merge. Facilitator can +1 for solos. Odd count → trios.</a:t>
             </a:r>
             <a:endParaRPr lang="en-US" dirty="0"/>
           </a:p>
@@ -1311,7 +1314,7 @@
           <a:p>
             <a:r>
               <a:rPr lang="en-US" dirty="0"/>
-              <a:t>Exit ticket: live URL + who gave their +1. Site should look like them, not Jordan Lee.</a:t>
+              <a:t>Open deploy.yml in Explorer. Do not write YAML. Feature branch does not publish — only main.</a:t>
             </a:r>
             <a:endParaRPr lang="en-US" dirty="0"/>
           </a:p>
@@ -1335,6 +1338,94 @@
             <a:fld id="{F7021451-1387-4CA6-816F-3879F97B5CBC}" type="slidenum">
               <a:rPr lang="en-US"/>
               <a:t>18</a:t>
+            </a:fld>
+            <a:endParaRPr lang="en-US"/>
+          </a:p>
+        </p:txBody>
+      </p:sp>
+    </p:spTree>
+    <p:extLst>
+      <p:ext uri="{BB962C8B-B14F-4D97-AF65-F5344CB8AC3E}">
+        <p14:creationId xmlns:p14="http://schemas.microsoft.com/office/powerpoint/2010/main" val="1024086991"/>
+      </p:ext>
+    </p:extLst>
+  </p:cSld>
+  <p:clrMapOvr>
+    <a:masterClrMapping/>
+  </p:clrMapOvr>
+</p:notes>
+</file>
+
+<file path=ppt/notesSlides/notesSlide19.xml><?xml version="1.0" encoding="utf-8"?>
+<p:notes xmlns:a="http://schemas.openxmlformats.org/drawingml/2006/main" xmlns:r="http://schemas.openxmlformats.org/officeDocument/2006/relationships" xmlns:p="http://schemas.openxmlformats.org/presentationml/2006/main">
+  <p:cSld>
+    <p:spTree>
+      <p:nvGrpSpPr>
+        <p:cNvPr id="1" name=""/>
+        <p:cNvGrpSpPr/>
+        <p:nvPr/>
+      </p:nvGrpSpPr>
+      <p:grpSpPr>
+        <a:xfrm>
+          <a:off x="0" y="0"/>
+          <a:ext cx="0" cy="0"/>
+          <a:chOff x="0" y="0"/>
+          <a:chExt cx="0" cy="0"/>
+        </a:xfrm>
+      </p:grpSpPr>
+      <p:sp>
+        <p:nvSpPr>
+          <p:cNvPr id="2" name="Slide Image Placeholder 1"/>
+          <p:cNvSpPr>
+            <a:spLocks noGrp="1" noRot="1" noChangeAspect="1"/>
+          </p:cNvSpPr>
+          <p:nvPr>
+            <p:ph type="sldImg"/>
+          </p:nvPr>
+        </p:nvSpPr>
+        <p:spPr/>
+      </p:sp>
+      <p:sp>
+        <p:nvSpPr>
+          <p:cNvPr id="3" name="Notes Placeholder 2"/>
+          <p:cNvSpPr>
+            <a:spLocks noGrp="1"/>
+          </p:cNvSpPr>
+          <p:nvPr>
+            <p:ph type="body" idx="1"/>
+          </p:nvPr>
+        </p:nvSpPr>
+        <p:spPr/>
+        <p:txBody>
+          <a:bodyPr/>
+          <a:lstStyle/>
+          <a:p>
+            <a:r>
+              <a:rPr lang="en-US" dirty="0"/>
+              <a:t>Source = GitHub Actions. Re-run all jobs on the failed run. Then open the real URL.</a:t>
+            </a:r>
+            <a:endParaRPr lang="en-US" dirty="0"/>
+          </a:p>
+        </p:txBody>
+      </p:sp>
+      <p:sp>
+        <p:nvSpPr>
+          <p:cNvPr id="4" name="Slide Number Placeholder 3"/>
+          <p:cNvSpPr>
+            <a:spLocks noGrp="1"/>
+          </p:cNvSpPr>
+          <p:nvPr>
+            <p:ph type="sldNum" sz="quarter" idx="10"/>
+          </p:nvPr>
+        </p:nvSpPr>
+        <p:spPr/>
+        <p:txBody>
+          <a:bodyPr/>
+          <a:lstStyle/>
+          <a:p>
+            <a:fld id="{F7021451-1387-4CA6-816F-3879F97B5CBC}" type="slidenum">
+              <a:rPr lang="en-US"/>
+              <a:t>19</a:t>
             </a:fld>
             <a:endParaRPr lang="en-US"/>
           </a:p>
@@ -1399,7 +1490,7 @@
           <a:p>
             <a:r>
               <a:rPr lang="en-US" dirty="0"/>
-              <a:t>Primary goal: their resume content, not a tiny demo PR. Git/PR is how we ship a chunk of that work safely. Prefer a real-looking site over a perfect design.</a:t>
+              <a:t>Keep this short. Establish credibility, then get to the work. Point at example site later if useful.</a:t>
             </a:r>
             <a:endParaRPr lang="en-US" dirty="0"/>
           </a:p>
@@ -1423,6 +1514,182 @@
             <a:fld id="{F7021451-1387-4CA6-816F-3879F97B5CBC}" type="slidenum">
               <a:rPr lang="en-US"/>
               <a:t>2</a:t>
+            </a:fld>
+            <a:endParaRPr lang="en-US"/>
+          </a:p>
+        </p:txBody>
+      </p:sp>
+    </p:spTree>
+    <p:extLst>
+      <p:ext uri="{BB962C8B-B14F-4D97-AF65-F5344CB8AC3E}">
+        <p14:creationId xmlns:p14="http://schemas.microsoft.com/office/powerpoint/2010/main" val="1024086991"/>
+      </p:ext>
+    </p:extLst>
+  </p:cSld>
+  <p:clrMapOvr>
+    <a:masterClrMapping/>
+  </p:clrMapOvr>
+</p:notes>
+</file>
+
+<file path=ppt/notesSlides/notesSlide20.xml><?xml version="1.0" encoding="utf-8"?>
+<p:notes xmlns:a="http://schemas.openxmlformats.org/drawingml/2006/main" xmlns:r="http://schemas.openxmlformats.org/officeDocument/2006/relationships" xmlns:p="http://schemas.openxmlformats.org/presentationml/2006/main">
+  <p:cSld>
+    <p:spTree>
+      <p:nvGrpSpPr>
+        <p:cNvPr id="1" name=""/>
+        <p:cNvGrpSpPr/>
+        <p:nvPr/>
+      </p:nvGrpSpPr>
+      <p:grpSpPr>
+        <a:xfrm>
+          <a:off x="0" y="0"/>
+          <a:ext cx="0" cy="0"/>
+          <a:chOff x="0" y="0"/>
+          <a:chExt cx="0" cy="0"/>
+        </a:xfrm>
+      </p:grpSpPr>
+      <p:sp>
+        <p:nvSpPr>
+          <p:cNvPr id="2" name="Slide Image Placeholder 1"/>
+          <p:cNvSpPr>
+            <a:spLocks noGrp="1" noRot="1" noChangeAspect="1"/>
+          </p:cNvSpPr>
+          <p:nvPr>
+            <p:ph type="sldImg"/>
+          </p:nvPr>
+        </p:nvSpPr>
+        <p:spPr/>
+      </p:sp>
+      <p:sp>
+        <p:nvSpPr>
+          <p:cNvPr id="3" name="Notes Placeholder 2"/>
+          <p:cNvSpPr>
+            <a:spLocks noGrp="1"/>
+          </p:cNvSpPr>
+          <p:nvPr>
+            <p:ph type="body" idx="1"/>
+          </p:nvPr>
+        </p:nvSpPr>
+        <p:spPr/>
+        <p:txBody>
+          <a:bodyPr/>
+          <a:lstStyle/>
+          <a:p>
+            <a:r>
+              <a:rPr lang="en-US" dirty="0"/>
+              <a:t>Leave this up. Goal is a real-looking resume + live URL. PR + partner +1 required. Circulate for profile content and Status Bar branch name.</a:t>
+            </a:r>
+            <a:endParaRPr lang="en-US" dirty="0"/>
+          </a:p>
+        </p:txBody>
+      </p:sp>
+      <p:sp>
+        <p:nvSpPr>
+          <p:cNvPr id="4" name="Slide Number Placeholder 3"/>
+          <p:cNvSpPr>
+            <a:spLocks noGrp="1"/>
+          </p:cNvSpPr>
+          <p:nvPr>
+            <p:ph type="sldNum" sz="quarter" idx="10"/>
+          </p:nvPr>
+        </p:nvSpPr>
+        <p:spPr/>
+        <p:txBody>
+          <a:bodyPr/>
+          <a:lstStyle/>
+          <a:p>
+            <a:fld id="{F7021451-1387-4CA6-816F-3879F97B5CBC}" type="slidenum">
+              <a:rPr lang="en-US"/>
+              <a:t>20</a:t>
+            </a:fld>
+            <a:endParaRPr lang="en-US"/>
+          </a:p>
+        </p:txBody>
+      </p:sp>
+    </p:spTree>
+    <p:extLst>
+      <p:ext uri="{BB962C8B-B14F-4D97-AF65-F5344CB8AC3E}">
+        <p14:creationId xmlns:p14="http://schemas.microsoft.com/office/powerpoint/2010/main" val="1024086991"/>
+      </p:ext>
+    </p:extLst>
+  </p:cSld>
+  <p:clrMapOvr>
+    <a:masterClrMapping/>
+  </p:clrMapOvr>
+</p:notes>
+</file>
+
+<file path=ppt/notesSlides/notesSlide21.xml><?xml version="1.0" encoding="utf-8"?>
+<p:notes xmlns:a="http://schemas.openxmlformats.org/drawingml/2006/main" xmlns:r="http://schemas.openxmlformats.org/officeDocument/2006/relationships" xmlns:p="http://schemas.openxmlformats.org/presentationml/2006/main">
+  <p:cSld>
+    <p:spTree>
+      <p:nvGrpSpPr>
+        <p:cNvPr id="1" name=""/>
+        <p:cNvGrpSpPr/>
+        <p:nvPr/>
+      </p:nvGrpSpPr>
+      <p:grpSpPr>
+        <a:xfrm>
+          <a:off x="0" y="0"/>
+          <a:ext cx="0" cy="0"/>
+          <a:chOff x="0" y="0"/>
+          <a:chExt cx="0" cy="0"/>
+        </a:xfrm>
+      </p:grpSpPr>
+      <p:sp>
+        <p:nvSpPr>
+          <p:cNvPr id="2" name="Slide Image Placeholder 1"/>
+          <p:cNvSpPr>
+            <a:spLocks noGrp="1" noRot="1" noChangeAspect="1"/>
+          </p:cNvSpPr>
+          <p:nvPr>
+            <p:ph type="sldImg"/>
+          </p:nvPr>
+        </p:nvSpPr>
+        <p:spPr/>
+      </p:sp>
+      <p:sp>
+        <p:nvSpPr>
+          <p:cNvPr id="3" name="Notes Placeholder 2"/>
+          <p:cNvSpPr>
+            <a:spLocks noGrp="1"/>
+          </p:cNvSpPr>
+          <p:nvPr>
+            <p:ph type="body" idx="1"/>
+          </p:nvPr>
+        </p:nvSpPr>
+        <p:spPr/>
+        <p:txBody>
+          <a:bodyPr/>
+          <a:lstStyle/>
+          <a:p>
+            <a:r>
+              <a:rPr lang="en-US" dirty="0"/>
+              <a:t>Exit ticket: live URL + who gave their +1. Site should look like them, not Jordan Lee.</a:t>
+            </a:r>
+            <a:endParaRPr lang="en-US" dirty="0"/>
+          </a:p>
+        </p:txBody>
+      </p:sp>
+      <p:sp>
+        <p:nvSpPr>
+          <p:cNvPr id="4" name="Slide Number Placeholder 3"/>
+          <p:cNvSpPr>
+            <a:spLocks noGrp="1"/>
+          </p:cNvSpPr>
+          <p:nvPr>
+            <p:ph type="sldNum" sz="quarter" idx="10"/>
+          </p:nvPr>
+        </p:nvSpPr>
+        <p:spPr/>
+        <p:txBody>
+          <a:bodyPr/>
+          <a:lstStyle/>
+          <a:p>
+            <a:fld id="{F7021451-1387-4CA6-816F-3879F97B5CBC}" type="slidenum">
+              <a:rPr lang="en-US"/>
+              <a:t>21</a:t>
             </a:fld>
             <a:endParaRPr lang="en-US"/>
           </a:p>
@@ -1487,7 +1754,7 @@
           <a:p>
             <a:r>
               <a:rPr lang="en-US" dirty="0"/>
-              <a:t>Hands up when unzipped. Empty Public repo — no README. Folder must be my-resume-site with package.json visible.</a:t>
+              <a:t>Datavant + WSU adjunct. Connect industry work to why Git/PR/Pages matter in real teams.</a:t>
             </a:r>
             <a:endParaRPr lang="en-US" dirty="0"/>
           </a:p>
@@ -1575,7 +1842,7 @@
           <a:p>
             <a:r>
               <a:rPr lang="en-US" dirty="0"/>
-              <a:t>File → Open Folder on my-resume-site. Trust authors. Terminal → New Terminal. Wait for localhost before moving on.</a:t>
+              <a:t>Bridge to the workshop goal. Then advance to “done looks like.”</a:t>
             </a:r>
             <a:endParaRPr lang="en-US" dirty="0"/>
           </a:p>
@@ -1663,7 +1930,7 @@
           <a:p>
             <a:r>
               <a:rPr lang="en-US" dirty="0"/>
-              <a:t>Demo Explorer live. Photo goes in public/. Empty [] sections stay hidden. Do not open Source Control yet.</a:t>
+              <a:t>Primary goal: their resume content, not a tiny demo PR. Git/PR is how we ship a chunk of that work safely. Prefer a real-looking site over a perfect design.</a:t>
             </a:r>
             <a:endParaRPr lang="en-US" dirty="0"/>
           </a:p>
@@ -1751,7 +2018,7 @@
           <a:p>
             <a:r>
               <a:rPr lang="en-US" dirty="0"/>
-              <a:t>Cold-call: if you save in VS Code, does the live site update? Wait for no. Come back to this whenever someone is confused.</a:t>
+              <a:t>Hands up when unzipped. Empty Public repo — no README. Folder must be my-resume-site with package.json visible.</a:t>
             </a:r>
             <a:endParaRPr lang="en-US" dirty="0"/>
           </a:p>
@@ -1839,7 +2106,7 @@
           <a:p>
             <a:r>
               <a:rPr lang="en-US" dirty="0"/>
-              <a:t>Second terminal if npm run dev is running. Warn: Actions often red-X until Pages is enabled later — expected. Auth = browser or PAT, never GitHub password.</a:t>
+              <a:t>File → Open Folder on my-resume-site. Trust authors. Terminal → New Terminal. Wait for localhost before moving on.</a:t>
             </a:r>
             <a:endParaRPr lang="en-US" dirty="0"/>
           </a:p>
@@ -1927,7 +2194,7 @@
           <a:p>
             <a:r>
               <a:rPr lang="en-US" dirty="0"/>
-              <a:t>Have everyone type git status once so they see it. Rule for the rest of the day.</a:t>
+              <a:t>Demo Explorer live. Photo goes in public/. Empty [] sections stay hidden. Do not open Source Control yet.</a:t>
             </a:r>
             <a:endParaRPr lang="en-US" dirty="0"/>
           </a:p>
@@ -2015,7 +2282,7 @@
           <a:p>
             <a:r>
               <a:rPr lang="en-US" dirty="0"/>
-              <a:t>Stress: do NOT commit on main. Source Control badge is fine — leave it. Replace example.com placeholders.</a:t>
+              <a:t>Cold-call: if you save in VS Code, does the live site update? Wait for no. Come back to this whenever someone is confused.</a:t>
             </a:r>
             <a:endParaRPr lang="en-US" dirty="0"/>
           </a:p>
@@ -2503,7 +2770,7 @@
                 <a:ea typeface="Arial" pitchFamily="34" charset="-122"/>
                 <a:cs typeface="Arial" pitchFamily="34" charset="-120"/>
               </a:rPr>
-              <a:t>01 / 18</a:t>
+              <a:t>01 / 21</a:t>
             </a:r>
             <a:endParaRPr lang="en-US" sz="1100" dirty="0"/>
           </a:p>
@@ -2817,7 +3084,7 @@
                 <a:ea typeface="Arial" pitchFamily="34" charset="-122"/>
                 <a:cs typeface="Arial" pitchFamily="34" charset="-120"/>
               </a:rPr>
-              <a:t>10 / 18</a:t>
+              <a:t>10 / 21</a:t>
             </a:r>
             <a:endParaRPr lang="en-US" sz="1100" dirty="0"/>
           </a:p>
@@ -2856,7 +3123,7 @@
                 <a:ea typeface="Arial" pitchFamily="34" charset="-122"/>
                 <a:cs typeface="Arial" pitchFamily="34" charset="-120"/>
               </a:rPr>
-              <a:t>Pick one piece of that resume work for a pull request.</a:t>
+              <a:t>Push the starter to your empty repo.</a:t>
             </a:r>
             <a:endParaRPr lang="en-US" sz="2800" dirty="0"/>
           </a:p>
@@ -2896,7 +3163,7 @@
                 <a:ea typeface="Arial" pitchFamily="34" charset="-122"/>
                 <a:cs typeface="Arial" pitchFamily="34" charset="-120"/>
               </a:rPr>
-              <a:t>Issue first</a:t>
+              <a:t>First push</a:t>
             </a:r>
             <a:endParaRPr lang="en-US" sz="1500" dirty="0"/>
           </a:p>
@@ -3131,7 +3398,7 @@
                 <a:ea typeface="Arial" pitchFamily="34" charset="-122"/>
                 <a:cs typeface="Arial" pitchFamily="34" charset="-120"/>
               </a:rPr>
-              <a:t>11 / 18</a:t>
+              <a:t>11 / 21</a:t>
             </a:r>
             <a:endParaRPr lang="en-US" sz="1100" dirty="0"/>
           </a:p>
@@ -3170,7 +3437,7 @@
                 <a:ea typeface="Arial" pitchFamily="34" charset="-122"/>
                 <a:cs typeface="Arial" pitchFamily="34" charset="-120"/>
               </a:rPr>
-              <a:t>Bottom-left of VS Code: click main , make a branch.</a:t>
+              <a:t>When something looks wrong, run git status first.</a:t>
             </a:r>
             <a:endParaRPr lang="en-US" sz="2800" dirty="0"/>
           </a:p>
@@ -3210,7 +3477,7 @@
                 <a:ea typeface="Arial" pitchFamily="34" charset="-122"/>
                 <a:cs typeface="Arial" pitchFamily="34" charset="-120"/>
               </a:rPr>
-              <a:t>Branch</a:t>
+              <a:t>When stuck</a:t>
             </a:r>
             <a:endParaRPr lang="en-US" sz="1500" dirty="0"/>
           </a:p>
@@ -3445,7 +3712,7 @@
                 <a:ea typeface="Arial" pitchFamily="34" charset="-122"/>
                 <a:cs typeface="Arial" pitchFamily="34" charset="-120"/>
               </a:rPr>
-              <a:t>12 / 18</a:t>
+              <a:t>12 / 21</a:t>
             </a:r>
             <a:endParaRPr lang="en-US" sz="1100" dirty="0"/>
           </a:p>
@@ -3484,7 +3751,7 @@
                 <a:ea typeface="Arial" pitchFamily="34" charset="-122"/>
                 <a:cs typeface="Arial" pitchFamily="34" charset="-120"/>
               </a:rPr>
-              <a:t>Now commit — on that branch.</a:t>
+              <a:t>Build out your resume in profile.js .</a:t>
             </a:r>
             <a:endParaRPr lang="en-US" sz="2800" dirty="0"/>
           </a:p>
@@ -3524,7 +3791,7 @@
                 <a:ea typeface="Arial" pitchFamily="34" charset="-122"/>
                 <a:cs typeface="Arial" pitchFamily="34" charset="-120"/>
               </a:rPr>
-              <a:t>Commit and publish</a:t>
+              <a:t>Personalize</a:t>
             </a:r>
             <a:endParaRPr lang="en-US" sz="1500" dirty="0"/>
           </a:p>
@@ -3759,7 +4026,7 @@
                 <a:ea typeface="Arial" pitchFamily="34" charset="-122"/>
                 <a:cs typeface="Arial" pitchFamily="34" charset="-120"/>
               </a:rPr>
-              <a:t>13 / 18</a:t>
+              <a:t>13 / 21</a:t>
             </a:r>
             <a:endParaRPr lang="en-US" sz="1100" dirty="0"/>
           </a:p>
@@ -3798,7 +4065,7 @@
                 <a:ea typeface="Arial" pitchFamily="34" charset="-122"/>
                 <a:cs typeface="Arial" pitchFamily="34" charset="-120"/>
               </a:rPr>
-              <a:t>Open the PR. Attach it to your issue.</a:t>
+              <a:t>Pick one piece of that resume work for a pull request.</a:t>
             </a:r>
             <a:endParaRPr lang="en-US" sz="2800" dirty="0"/>
           </a:p>
@@ -3838,7 +4105,7 @@
                 <a:ea typeface="Arial" pitchFamily="34" charset="-122"/>
                 <a:cs typeface="Arial" pitchFamily="34" charset="-120"/>
               </a:rPr>
-              <a:t>Pull request</a:t>
+              <a:t>Issue first</a:t>
             </a:r>
             <a:endParaRPr lang="en-US" sz="1500" dirty="0"/>
           </a:p>
@@ -4073,7 +4340,7 @@
                 <a:ea typeface="Arial" pitchFamily="34" charset="-122"/>
                 <a:cs typeface="Arial" pitchFamily="34" charset="-120"/>
               </a:rPr>
-              <a:t>14 / 18</a:t>
+              <a:t>14 / 21</a:t>
             </a:r>
             <a:endParaRPr lang="en-US" sz="1100" dirty="0"/>
           </a:p>
@@ -4112,7 +4379,7 @@
                 <a:ea typeface="Arial" pitchFamily="34" charset="-122"/>
                 <a:cs typeface="Arial" pitchFamily="34" charset="-120"/>
               </a:rPr>
-              <a:t>Hand your PR to the person beside you for a +1.</a:t>
+              <a:t>Status Bar: click main , then create a branch.</a:t>
             </a:r>
             <a:endParaRPr lang="en-US" sz="2800" dirty="0"/>
           </a:p>
@@ -4152,7 +4419,7 @@
                 <a:ea typeface="Arial" pitchFamily="34" charset="-122"/>
                 <a:cs typeface="Arial" pitchFamily="34" charset="-120"/>
               </a:rPr>
-              <a:t>Partner +1</a:t>
+              <a:t>Branch</a:t>
             </a:r>
             <a:endParaRPr lang="en-US" sz="1500" dirty="0"/>
           </a:p>
@@ -4387,7 +4654,7 @@
                 <a:ea typeface="Arial" pitchFamily="34" charset="-122"/>
                 <a:cs typeface="Arial" pitchFamily="34" charset="-120"/>
               </a:rPr>
-              <a:t>15 / 18</a:t>
+              <a:t>15 / 21</a:t>
             </a:r>
             <a:endParaRPr lang="en-US" sz="1100" dirty="0"/>
           </a:p>
@@ -4426,7 +4693,7 @@
                 <a:ea typeface="Arial" pitchFamily="34" charset="-122"/>
                 <a:cs typeface="Arial" pitchFamily="34" charset="-120"/>
               </a:rPr>
-              <a:t>Your ZIP already includes a GitHub Actions workflow.</a:t>
+              <a:t>Now commit — on that branch.</a:t>
             </a:r>
             <a:endParaRPr lang="en-US" sz="2800" dirty="0"/>
           </a:p>
@@ -4466,7 +4733,7 @@
                 <a:ea typeface="Arial" pitchFamily="34" charset="-122"/>
                 <a:cs typeface="Arial" pitchFamily="34" charset="-120"/>
               </a:rPr>
-              <a:t>Actions</a:t>
+              <a:t>Commit and publish</a:t>
             </a:r>
             <a:endParaRPr lang="en-US" sz="1500" dirty="0"/>
           </a:p>
@@ -4701,7 +4968,7 @@
                 <a:ea typeface="Arial" pitchFamily="34" charset="-122"/>
                 <a:cs typeface="Arial" pitchFamily="34" charset="-120"/>
               </a:rPr>
-              <a:t>16 / 18</a:t>
+              <a:t>16 / 21</a:t>
             </a:r>
             <a:endParaRPr lang="en-US" sz="1100" dirty="0"/>
           </a:p>
@@ -4740,7 +5007,7 @@
                 <a:ea typeface="Arial" pitchFamily="34" charset="-122"/>
                 <a:cs typeface="Arial" pitchFamily="34" charset="-120"/>
               </a:rPr>
-              <a:t>Turn Pages on, then re-run the failed job.</a:t>
+              <a:t>Open the PR. Attach it to your issue.</a:t>
             </a:r>
             <a:endParaRPr lang="en-US" sz="2800" dirty="0"/>
           </a:p>
@@ -4780,7 +5047,7 @@
                 <a:ea typeface="Arial" pitchFamily="34" charset="-122"/>
                 <a:cs typeface="Arial" pitchFamily="34" charset="-120"/>
               </a:rPr>
-              <a:t>Pages</a:t>
+              <a:t>Pull request</a:t>
             </a:r>
             <a:endParaRPr lang="en-US" sz="1500" dirty="0"/>
           </a:p>
@@ -5015,7 +5282,7 @@
                 <a:ea typeface="Arial" pitchFamily="34" charset="-122"/>
                 <a:cs typeface="Arial" pitchFamily="34" charset="-120"/>
               </a:rPr>
-              <a:t>17 / 18</a:t>
+              <a:t>17 / 21</a:t>
             </a:r>
             <a:endParaRPr lang="en-US" sz="1100" dirty="0"/>
           </a:p>
@@ -5054,7 +5321,7 @@
                 <a:ea typeface="Arial" pitchFamily="34" charset="-122"/>
                 <a:cs typeface="Arial" pitchFamily="34" charset="-120"/>
               </a:rPr>
-              <a:t>Lab: finish your resume content, then ship it.</a:t>
+              <a:t>Hand your PR to the person beside you for a +1.</a:t>
             </a:r>
             <a:endParaRPr lang="en-US" sz="2800" dirty="0"/>
           </a:p>
@@ -5094,7 +5361,7 @@
                 <a:ea typeface="Arial" pitchFamily="34" charset="-122"/>
                 <a:cs typeface="Arial" pitchFamily="34" charset="-120"/>
               </a:rPr>
-              <a:t>Lab</a:t>
+              <a:t>Partner +1</a:t>
             </a:r>
             <a:endParaRPr lang="en-US" sz="1500" dirty="0"/>
           </a:p>
@@ -5329,7 +5596,7 @@
                 <a:ea typeface="Arial" pitchFamily="34" charset="-122"/>
                 <a:cs typeface="Arial" pitchFamily="34" charset="-120"/>
               </a:rPr>
-              <a:t>18 / 18</a:t>
+              <a:t>18 / 21</a:t>
             </a:r>
             <a:endParaRPr lang="en-US" sz="1100" dirty="0"/>
           </a:p>
@@ -5368,7 +5635,7 @@
                 <a:ea typeface="Arial" pitchFamily="34" charset="-122"/>
                 <a:cs typeface="Arial" pitchFamily="34" charset="-120"/>
               </a:rPr>
-              <a:t>Show a partner your live resume — and the PR that got it there.</a:t>
+              <a:t>Your ZIP already includes a GitHub Actions workflow.</a:t>
             </a:r>
             <a:endParaRPr lang="en-US" sz="2800" dirty="0"/>
           </a:p>
@@ -5408,7 +5675,321 @@
                 <a:ea typeface="Arial" pitchFamily="34" charset="-122"/>
                 <a:cs typeface="Arial" pitchFamily="34" charset="-120"/>
               </a:rPr>
-              <a:t>Show your work</a:t>
+              <a:t>Actions</a:t>
+            </a:r>
+            <a:endParaRPr lang="en-US" sz="1500" dirty="0"/>
+          </a:p>
+          <a:p>
+            <a:pPr marL="342900" indent="-342900">
+              <a:buSzPct val="100000"/>
+              <a:buChar char="•"/>
+            </a:pPr>
+            <a:r>
+              <a:rPr lang="en-US" sz="1500" dirty="0">
+                <a:solidFill>
+                  <a:srgbClr val="1A1A1A"/>
+                </a:solidFill>
+                <a:latin typeface="Arial" pitchFamily="34" charset="0"/>
+                <a:ea typeface="Arial" pitchFamily="34" charset="-122"/>
+                <a:cs typeface="Arial" pitchFamily="34" charset="-120"/>
+              </a:rPr>
+              <a:t>See the live web deck for full layout and screenshots.</a:t>
+            </a:r>
+            <a:endParaRPr lang="en-US" sz="1500" dirty="0"/>
+          </a:p>
+        </p:txBody>
+      </p:sp>
+      <p:sp>
+        <p:nvSpPr>
+          <p:cNvPr id="8" name="Shape 6"/>
+          <p:cNvSpPr/>
+          <p:nvPr/>
+        </p:nvSpPr>
+        <p:spPr>
+          <a:xfrm>
+            <a:off x="0" y="6446520"/>
+            <a:ext cx="12191695" cy="411480"/>
+          </a:xfrm>
+          <a:prstGeom prst="rect">
+            <a:avLst/>
+          </a:prstGeom>
+          <a:solidFill>
+            <a:srgbClr val="000000"/>
+          </a:solidFill>
+          <a:ln w="12700">
+            <a:solidFill>
+              <a:srgbClr val="000000"/>
+            </a:solidFill>
+            <a:prstDash val="solid"/>
+          </a:ln>
+        </p:spPr>
+      </p:sp>
+      <p:sp>
+        <p:nvSpPr>
+          <p:cNvPr id="9" name="Text 7"/>
+          <p:cNvSpPr/>
+          <p:nvPr/>
+        </p:nvSpPr>
+        <p:spPr>
+          <a:xfrm>
+            <a:off x="502920" y="6528816"/>
+            <a:ext cx="11155680" cy="256032"/>
+          </a:xfrm>
+          <a:prstGeom prst="rect">
+            <a:avLst/>
+          </a:prstGeom>
+          <a:noFill/>
+          <a:ln/>
+        </p:spPr>
+        <p:txBody>
+          <a:bodyPr wrap="square" rtlCol="0" anchor="ctr"/>
+          <a:lstStyle/>
+          <a:p>
+            <a:pPr indent="0" marL="0">
+              <a:buNone/>
+            </a:pPr>
+            <a:r>
+              <a:rPr lang="en-US" sz="1100" b="1" dirty="0">
+                <a:solidFill>
+                  <a:srgbClr val="FFDB00"/>
+                </a:solidFill>
+                <a:latin typeface="Arial" pitchFamily="34" charset="0"/>
+                <a:ea typeface="Arial" pitchFamily="34" charset="-122"/>
+                <a:cs typeface="Arial" pitchFamily="34" charset="-120"/>
+              </a:rPr>
+              <a:t>ARROWS ON THE WEB DECK · R FOR RESOURCES · N FOR NOTES</a:t>
+            </a:r>
+            <a:endParaRPr lang="en-US" sz="1100" dirty="0"/>
+          </a:p>
+        </p:txBody>
+      </p:sp>
+    </p:spTree>
+  </p:cSld>
+  <p:clrMapOvr>
+    <a:masterClrMapping/>
+  </p:clrMapOvr>
+</p:sld>
+</file>
+
+<file path=ppt/slides/slide19.xml><?xml version="1.0" encoding="utf-8"?>
+<p:sld xmlns:a="http://schemas.openxmlformats.org/drawingml/2006/main" xmlns:r="http://schemas.openxmlformats.org/officeDocument/2006/relationships" xmlns:p="http://schemas.openxmlformats.org/presentationml/2006/main">
+  <p:cSld name="Slide 19">
+    <p:spTree>
+      <p:nvGrpSpPr>
+        <p:cNvPr id="1" name=""/>
+        <p:cNvGrpSpPr/>
+        <p:nvPr/>
+      </p:nvGrpSpPr>
+      <p:grpSpPr>
+        <a:xfrm>
+          <a:off x="0" y="0"/>
+          <a:ext cx="0" cy="0"/>
+          <a:chOff x="0" y="0"/>
+          <a:chExt cx="0" cy="0"/>
+        </a:xfrm>
+      </p:grpSpPr>
+      <p:sp>
+        <p:nvSpPr>
+          <p:cNvPr id="2" name="Shape 0"/>
+          <p:cNvSpPr/>
+          <p:nvPr/>
+        </p:nvSpPr>
+        <p:spPr>
+          <a:xfrm>
+            <a:off x="0" y="0"/>
+            <a:ext cx="12191695" cy="164592"/>
+          </a:xfrm>
+          <a:prstGeom prst="rect">
+            <a:avLst/>
+          </a:prstGeom>
+          <a:solidFill>
+            <a:srgbClr val="000000"/>
+          </a:solidFill>
+          <a:ln w="12700">
+            <a:solidFill>
+              <a:srgbClr val="000000"/>
+            </a:solidFill>
+            <a:prstDash val="solid"/>
+          </a:ln>
+        </p:spPr>
+      </p:sp>
+      <p:sp>
+        <p:nvSpPr>
+          <p:cNvPr id="3" name="Shape 1"/>
+          <p:cNvSpPr/>
+          <p:nvPr/>
+        </p:nvSpPr>
+        <p:spPr>
+          <a:xfrm>
+            <a:off x="0" y="164592"/>
+            <a:ext cx="12191695" cy="73152"/>
+          </a:xfrm>
+          <a:prstGeom prst="rect">
+            <a:avLst/>
+          </a:prstGeom>
+          <a:solidFill>
+            <a:srgbClr val="FFDB00"/>
+          </a:solidFill>
+          <a:ln w="12700">
+            <a:solidFill>
+              <a:srgbClr val="FFDB00"/>
+            </a:solidFill>
+            <a:prstDash val="solid"/>
+          </a:ln>
+        </p:spPr>
+      </p:sp>
+      <p:sp>
+        <p:nvSpPr>
+          <p:cNvPr id="4" name="Text 2"/>
+          <p:cNvSpPr/>
+          <p:nvPr/>
+        </p:nvSpPr>
+        <p:spPr>
+          <a:xfrm>
+            <a:off x="502920" y="365760"/>
+            <a:ext cx="9601200" cy="256032"/>
+          </a:xfrm>
+          <a:prstGeom prst="rect">
+            <a:avLst/>
+          </a:prstGeom>
+          <a:noFill/>
+          <a:ln/>
+        </p:spPr>
+        <p:txBody>
+          <a:bodyPr wrap="square" rtlCol="0" anchor="ctr"/>
+          <a:lstStyle/>
+          <a:p>
+            <a:pPr indent="0" marL="0">
+              <a:buNone/>
+            </a:pPr>
+            <a:r>
+              <a:rPr lang="en-US" sz="1100" b="1" spc="200" kern="0" dirty="0">
+                <a:solidFill>
+                  <a:srgbClr val="555555"/>
+                </a:solidFill>
+                <a:latin typeface="Arial" pitchFamily="34" charset="0"/>
+                <a:ea typeface="Arial" pitchFamily="34" charset="-122"/>
+                <a:cs typeface="Arial" pitchFamily="34" charset="-120"/>
+              </a:rPr>
+              <a:t>WICHITA STATE · MIS CLUB · WORKSHOP 1</a:t>
+            </a:r>
+            <a:endParaRPr lang="en-US" sz="1100" dirty="0"/>
+          </a:p>
+        </p:txBody>
+      </p:sp>
+      <p:sp>
+        <p:nvSpPr>
+          <p:cNvPr id="5" name="Text 3"/>
+          <p:cNvSpPr/>
+          <p:nvPr/>
+        </p:nvSpPr>
+        <p:spPr>
+          <a:xfrm>
+            <a:off x="10241280" y="365760"/>
+            <a:ext cx="1463040" cy="256032"/>
+          </a:xfrm>
+          <a:prstGeom prst="rect">
+            <a:avLst/>
+          </a:prstGeom>
+          <a:noFill/>
+          <a:ln/>
+        </p:spPr>
+        <p:txBody>
+          <a:bodyPr wrap="square" rtlCol="0" anchor="ctr"/>
+          <a:lstStyle/>
+          <a:p>
+            <a:pPr algn="r" indent="0" marL="0">
+              <a:buNone/>
+            </a:pPr>
+            <a:r>
+              <a:rPr lang="en-US" sz="1100" b="1" dirty="0">
+                <a:solidFill>
+                  <a:srgbClr val="555555"/>
+                </a:solidFill>
+                <a:latin typeface="Arial" pitchFamily="34" charset="0"/>
+                <a:ea typeface="Arial" pitchFamily="34" charset="-122"/>
+                <a:cs typeface="Arial" pitchFamily="34" charset="-120"/>
+              </a:rPr>
+              <a:t>19 / 21</a:t>
+            </a:r>
+            <a:endParaRPr lang="en-US" sz="1100" dirty="0"/>
+          </a:p>
+        </p:txBody>
+      </p:sp>
+      <p:sp>
+        <p:nvSpPr>
+          <p:cNvPr id="6" name="Text 4"/>
+          <p:cNvSpPr/>
+          <p:nvPr/>
+        </p:nvSpPr>
+        <p:spPr>
+          <a:xfrm>
+            <a:off x="502920" y="960120"/>
+            <a:ext cx="11155680" cy="777240"/>
+          </a:xfrm>
+          <a:prstGeom prst="rect">
+            <a:avLst/>
+          </a:prstGeom>
+          <a:noFill/>
+          <a:ln/>
+        </p:spPr>
+        <p:txBody>
+          <a:bodyPr wrap="square" rtlCol="0" anchor="t"/>
+          <a:lstStyle/>
+          <a:p>
+            <a:pPr indent="0" marL="0">
+              <a:buNone/>
+            </a:pPr>
+            <a:r>
+              <a:rPr lang="en-US" sz="2800" b="1" dirty="0">
+                <a:solidFill>
+                  <a:srgbClr val="1A1A1A"/>
+                </a:solidFill>
+                <a:latin typeface="Arial" pitchFamily="34" charset="0"/>
+                <a:ea typeface="Arial" pitchFamily="34" charset="-122"/>
+                <a:cs typeface="Arial" pitchFamily="34" charset="-120"/>
+              </a:rPr>
+              <a:t>Turn Pages on, then re-run the failed job.</a:t>
+            </a:r>
+            <a:endParaRPr lang="en-US" sz="2800" dirty="0"/>
+          </a:p>
+        </p:txBody>
+      </p:sp>
+      <p:sp>
+        <p:nvSpPr>
+          <p:cNvPr id="7" name="Text 5"/>
+          <p:cNvSpPr/>
+          <p:nvPr/>
+        </p:nvSpPr>
+        <p:spPr>
+          <a:xfrm>
+            <a:off x="502920" y="1783080"/>
+            <a:ext cx="11155680" cy="877824"/>
+          </a:xfrm>
+          <a:prstGeom prst="rect">
+            <a:avLst/>
+          </a:prstGeom>
+          <a:noFill/>
+          <a:ln/>
+        </p:spPr>
+        <p:txBody>
+          <a:bodyPr wrap="square" rtlCol="0" anchor="t"/>
+          <a:lstStyle/>
+          <a:p>
+            <a:pPr marL="342900" indent="-342900">
+              <a:buSzPct val="100000"/>
+              <a:buChar char="•"/>
+            </a:pPr>
+            <a:r>
+              <a:rPr lang="en-US" sz="1500" dirty="0">
+                <a:solidFill>
+                  <a:srgbClr val="1A1A1A"/>
+                </a:solidFill>
+                <a:latin typeface="Arial" pitchFamily="34" charset="0"/>
+                <a:ea typeface="Arial" pitchFamily="34" charset="-122"/>
+                <a:cs typeface="Arial" pitchFamily="34" charset="-120"/>
+              </a:rPr>
+              <a:t>Pages</a:t>
             </a:r>
             <a:endParaRPr lang="en-US" sz="1500" dirty="0"/>
           </a:p>
@@ -5643,7 +6224,7 @@
                 <a:ea typeface="Arial" pitchFamily="34" charset="-122"/>
                 <a:cs typeface="Arial" pitchFamily="34" charset="-120"/>
               </a:rPr>
-              <a:t>02 / 18</a:t>
+              <a:t>02 / 21</a:t>
             </a:r>
             <a:endParaRPr lang="en-US" sz="1100" dirty="0"/>
           </a:p>
@@ -5682,7 +6263,7 @@
                 <a:ea typeface="Arial" pitchFamily="34" charset="-122"/>
                 <a:cs typeface="Arial" pitchFamily="34" charset="-120"/>
               </a:rPr>
-              <a:t>Today’s job: make this site yours, then publish it.</a:t>
+              <a:t>I’m Tyler Beach.</a:t>
             </a:r>
             <a:endParaRPr lang="en-US" sz="2800" dirty="0"/>
           </a:p>
@@ -5722,7 +6303,635 @@
                 <a:ea typeface="Arial" pitchFamily="34" charset="-122"/>
                 <a:cs typeface="Arial" pitchFamily="34" charset="-120"/>
               </a:rPr>
-              <a:t>What “done” looks like</a:t>
+              <a:t>About me</a:t>
+            </a:r>
+            <a:endParaRPr lang="en-US" sz="1500" dirty="0"/>
+          </a:p>
+          <a:p>
+            <a:pPr marL="342900" indent="-342900">
+              <a:buSzPct val="100000"/>
+              <a:buChar char="•"/>
+            </a:pPr>
+            <a:r>
+              <a:rPr lang="en-US" sz="1500" dirty="0">
+                <a:solidFill>
+                  <a:srgbClr val="1A1A1A"/>
+                </a:solidFill>
+                <a:latin typeface="Arial" pitchFamily="34" charset="0"/>
+                <a:ea typeface="Arial" pitchFamily="34" charset="-122"/>
+                <a:cs typeface="Arial" pitchFamily="34" charset="-120"/>
+              </a:rPr>
+              <a:t>See the live web deck for full layout and screenshots.</a:t>
+            </a:r>
+            <a:endParaRPr lang="en-US" sz="1500" dirty="0"/>
+          </a:p>
+        </p:txBody>
+      </p:sp>
+      <p:sp>
+        <p:nvSpPr>
+          <p:cNvPr id="8" name="Shape 6"/>
+          <p:cNvSpPr/>
+          <p:nvPr/>
+        </p:nvSpPr>
+        <p:spPr>
+          <a:xfrm>
+            <a:off x="0" y="6446520"/>
+            <a:ext cx="12191695" cy="411480"/>
+          </a:xfrm>
+          <a:prstGeom prst="rect">
+            <a:avLst/>
+          </a:prstGeom>
+          <a:solidFill>
+            <a:srgbClr val="000000"/>
+          </a:solidFill>
+          <a:ln w="12700">
+            <a:solidFill>
+              <a:srgbClr val="000000"/>
+            </a:solidFill>
+            <a:prstDash val="solid"/>
+          </a:ln>
+        </p:spPr>
+      </p:sp>
+      <p:sp>
+        <p:nvSpPr>
+          <p:cNvPr id="9" name="Text 7"/>
+          <p:cNvSpPr/>
+          <p:nvPr/>
+        </p:nvSpPr>
+        <p:spPr>
+          <a:xfrm>
+            <a:off x="502920" y="6528816"/>
+            <a:ext cx="11155680" cy="256032"/>
+          </a:xfrm>
+          <a:prstGeom prst="rect">
+            <a:avLst/>
+          </a:prstGeom>
+          <a:noFill/>
+          <a:ln/>
+        </p:spPr>
+        <p:txBody>
+          <a:bodyPr wrap="square" rtlCol="0" anchor="ctr"/>
+          <a:lstStyle/>
+          <a:p>
+            <a:pPr indent="0" marL="0">
+              <a:buNone/>
+            </a:pPr>
+            <a:r>
+              <a:rPr lang="en-US" sz="1100" b="1" dirty="0">
+                <a:solidFill>
+                  <a:srgbClr val="FFDB00"/>
+                </a:solidFill>
+                <a:latin typeface="Arial" pitchFamily="34" charset="0"/>
+                <a:ea typeface="Arial" pitchFamily="34" charset="-122"/>
+                <a:cs typeface="Arial" pitchFamily="34" charset="-120"/>
+              </a:rPr>
+              <a:t>ARROWS ON THE WEB DECK · R FOR RESOURCES · N FOR NOTES</a:t>
+            </a:r>
+            <a:endParaRPr lang="en-US" sz="1100" dirty="0"/>
+          </a:p>
+        </p:txBody>
+      </p:sp>
+    </p:spTree>
+  </p:cSld>
+  <p:clrMapOvr>
+    <a:masterClrMapping/>
+  </p:clrMapOvr>
+</p:sld>
+</file>
+
+<file path=ppt/slides/slide20.xml><?xml version="1.0" encoding="utf-8"?>
+<p:sld xmlns:a="http://schemas.openxmlformats.org/drawingml/2006/main" xmlns:r="http://schemas.openxmlformats.org/officeDocument/2006/relationships" xmlns:p="http://schemas.openxmlformats.org/presentationml/2006/main">
+  <p:cSld name="Slide 20">
+    <p:spTree>
+      <p:nvGrpSpPr>
+        <p:cNvPr id="1" name=""/>
+        <p:cNvGrpSpPr/>
+        <p:nvPr/>
+      </p:nvGrpSpPr>
+      <p:grpSpPr>
+        <a:xfrm>
+          <a:off x="0" y="0"/>
+          <a:ext cx="0" cy="0"/>
+          <a:chOff x="0" y="0"/>
+          <a:chExt cx="0" cy="0"/>
+        </a:xfrm>
+      </p:grpSpPr>
+      <p:sp>
+        <p:nvSpPr>
+          <p:cNvPr id="2" name="Shape 0"/>
+          <p:cNvSpPr/>
+          <p:nvPr/>
+        </p:nvSpPr>
+        <p:spPr>
+          <a:xfrm>
+            <a:off x="0" y="0"/>
+            <a:ext cx="12191695" cy="164592"/>
+          </a:xfrm>
+          <a:prstGeom prst="rect">
+            <a:avLst/>
+          </a:prstGeom>
+          <a:solidFill>
+            <a:srgbClr val="000000"/>
+          </a:solidFill>
+          <a:ln w="12700">
+            <a:solidFill>
+              <a:srgbClr val="000000"/>
+            </a:solidFill>
+            <a:prstDash val="solid"/>
+          </a:ln>
+        </p:spPr>
+      </p:sp>
+      <p:sp>
+        <p:nvSpPr>
+          <p:cNvPr id="3" name="Shape 1"/>
+          <p:cNvSpPr/>
+          <p:nvPr/>
+        </p:nvSpPr>
+        <p:spPr>
+          <a:xfrm>
+            <a:off x="0" y="164592"/>
+            <a:ext cx="12191695" cy="73152"/>
+          </a:xfrm>
+          <a:prstGeom prst="rect">
+            <a:avLst/>
+          </a:prstGeom>
+          <a:solidFill>
+            <a:srgbClr val="FFDB00"/>
+          </a:solidFill>
+          <a:ln w="12700">
+            <a:solidFill>
+              <a:srgbClr val="FFDB00"/>
+            </a:solidFill>
+            <a:prstDash val="solid"/>
+          </a:ln>
+        </p:spPr>
+      </p:sp>
+      <p:sp>
+        <p:nvSpPr>
+          <p:cNvPr id="4" name="Text 2"/>
+          <p:cNvSpPr/>
+          <p:nvPr/>
+        </p:nvSpPr>
+        <p:spPr>
+          <a:xfrm>
+            <a:off x="502920" y="365760"/>
+            <a:ext cx="9601200" cy="256032"/>
+          </a:xfrm>
+          <a:prstGeom prst="rect">
+            <a:avLst/>
+          </a:prstGeom>
+          <a:noFill/>
+          <a:ln/>
+        </p:spPr>
+        <p:txBody>
+          <a:bodyPr wrap="square" rtlCol="0" anchor="ctr"/>
+          <a:lstStyle/>
+          <a:p>
+            <a:pPr indent="0" marL="0">
+              <a:buNone/>
+            </a:pPr>
+            <a:r>
+              <a:rPr lang="en-US" sz="1100" b="1" spc="200" kern="0" dirty="0">
+                <a:solidFill>
+                  <a:srgbClr val="555555"/>
+                </a:solidFill>
+                <a:latin typeface="Arial" pitchFamily="34" charset="0"/>
+                <a:ea typeface="Arial" pitchFamily="34" charset="-122"/>
+                <a:cs typeface="Arial" pitchFamily="34" charset="-120"/>
+              </a:rPr>
+              <a:t>WICHITA STATE · MIS CLUB · WORKSHOP 1</a:t>
+            </a:r>
+            <a:endParaRPr lang="en-US" sz="1100" dirty="0"/>
+          </a:p>
+        </p:txBody>
+      </p:sp>
+      <p:sp>
+        <p:nvSpPr>
+          <p:cNvPr id="5" name="Text 3"/>
+          <p:cNvSpPr/>
+          <p:nvPr/>
+        </p:nvSpPr>
+        <p:spPr>
+          <a:xfrm>
+            <a:off x="10241280" y="365760"/>
+            <a:ext cx="1463040" cy="256032"/>
+          </a:xfrm>
+          <a:prstGeom prst="rect">
+            <a:avLst/>
+          </a:prstGeom>
+          <a:noFill/>
+          <a:ln/>
+        </p:spPr>
+        <p:txBody>
+          <a:bodyPr wrap="square" rtlCol="0" anchor="ctr"/>
+          <a:lstStyle/>
+          <a:p>
+            <a:pPr algn="r" indent="0" marL="0">
+              <a:buNone/>
+            </a:pPr>
+            <a:r>
+              <a:rPr lang="en-US" sz="1100" b="1" dirty="0">
+                <a:solidFill>
+                  <a:srgbClr val="555555"/>
+                </a:solidFill>
+                <a:latin typeface="Arial" pitchFamily="34" charset="0"/>
+                <a:ea typeface="Arial" pitchFamily="34" charset="-122"/>
+                <a:cs typeface="Arial" pitchFamily="34" charset="-120"/>
+              </a:rPr>
+              <a:t>20 / 21</a:t>
+            </a:r>
+            <a:endParaRPr lang="en-US" sz="1100" dirty="0"/>
+          </a:p>
+        </p:txBody>
+      </p:sp>
+      <p:sp>
+        <p:nvSpPr>
+          <p:cNvPr id="6" name="Text 4"/>
+          <p:cNvSpPr/>
+          <p:nvPr/>
+        </p:nvSpPr>
+        <p:spPr>
+          <a:xfrm>
+            <a:off x="502920" y="960120"/>
+            <a:ext cx="11155680" cy="777240"/>
+          </a:xfrm>
+          <a:prstGeom prst="rect">
+            <a:avLst/>
+          </a:prstGeom>
+          <a:noFill/>
+          <a:ln/>
+        </p:spPr>
+        <p:txBody>
+          <a:bodyPr wrap="square" rtlCol="0" anchor="t"/>
+          <a:lstStyle/>
+          <a:p>
+            <a:pPr indent="0" marL="0">
+              <a:buNone/>
+            </a:pPr>
+            <a:r>
+              <a:rPr lang="en-US" sz="2800" b="1" dirty="0">
+                <a:solidFill>
+                  <a:srgbClr val="1A1A1A"/>
+                </a:solidFill>
+                <a:latin typeface="Arial" pitchFamily="34" charset="0"/>
+                <a:ea typeface="Arial" pitchFamily="34" charset="-122"/>
+                <a:cs typeface="Arial" pitchFamily="34" charset="-120"/>
+              </a:rPr>
+              <a:t>Lab: finish your resume content, then ship it.</a:t>
+            </a:r>
+            <a:endParaRPr lang="en-US" sz="2800" dirty="0"/>
+          </a:p>
+        </p:txBody>
+      </p:sp>
+      <p:sp>
+        <p:nvSpPr>
+          <p:cNvPr id="7" name="Text 5"/>
+          <p:cNvSpPr/>
+          <p:nvPr/>
+        </p:nvSpPr>
+        <p:spPr>
+          <a:xfrm>
+            <a:off x="502920" y="1783080"/>
+            <a:ext cx="11155680" cy="877824"/>
+          </a:xfrm>
+          <a:prstGeom prst="rect">
+            <a:avLst/>
+          </a:prstGeom>
+          <a:noFill/>
+          <a:ln/>
+        </p:spPr>
+        <p:txBody>
+          <a:bodyPr wrap="square" rtlCol="0" anchor="t"/>
+          <a:lstStyle/>
+          <a:p>
+            <a:pPr marL="342900" indent="-342900">
+              <a:buSzPct val="100000"/>
+              <a:buChar char="•"/>
+            </a:pPr>
+            <a:r>
+              <a:rPr lang="en-US" sz="1500" dirty="0">
+                <a:solidFill>
+                  <a:srgbClr val="1A1A1A"/>
+                </a:solidFill>
+                <a:latin typeface="Arial" pitchFamily="34" charset="0"/>
+                <a:ea typeface="Arial" pitchFamily="34" charset="-122"/>
+                <a:cs typeface="Arial" pitchFamily="34" charset="-120"/>
+              </a:rPr>
+              <a:t>Lab</a:t>
+            </a:r>
+            <a:endParaRPr lang="en-US" sz="1500" dirty="0"/>
+          </a:p>
+          <a:p>
+            <a:pPr marL="342900" indent="-342900">
+              <a:buSzPct val="100000"/>
+              <a:buChar char="•"/>
+            </a:pPr>
+            <a:r>
+              <a:rPr lang="en-US" sz="1500" dirty="0">
+                <a:solidFill>
+                  <a:srgbClr val="1A1A1A"/>
+                </a:solidFill>
+                <a:latin typeface="Arial" pitchFamily="34" charset="0"/>
+                <a:ea typeface="Arial" pitchFamily="34" charset="-122"/>
+                <a:cs typeface="Arial" pitchFamily="34" charset="-120"/>
+              </a:rPr>
+              <a:t>See the live web deck for full layout and screenshots.</a:t>
+            </a:r>
+            <a:endParaRPr lang="en-US" sz="1500" dirty="0"/>
+          </a:p>
+        </p:txBody>
+      </p:sp>
+      <p:sp>
+        <p:nvSpPr>
+          <p:cNvPr id="8" name="Shape 6"/>
+          <p:cNvSpPr/>
+          <p:nvPr/>
+        </p:nvSpPr>
+        <p:spPr>
+          <a:xfrm>
+            <a:off x="0" y="6446520"/>
+            <a:ext cx="12191695" cy="411480"/>
+          </a:xfrm>
+          <a:prstGeom prst="rect">
+            <a:avLst/>
+          </a:prstGeom>
+          <a:solidFill>
+            <a:srgbClr val="000000"/>
+          </a:solidFill>
+          <a:ln w="12700">
+            <a:solidFill>
+              <a:srgbClr val="000000"/>
+            </a:solidFill>
+            <a:prstDash val="solid"/>
+          </a:ln>
+        </p:spPr>
+      </p:sp>
+      <p:sp>
+        <p:nvSpPr>
+          <p:cNvPr id="9" name="Text 7"/>
+          <p:cNvSpPr/>
+          <p:nvPr/>
+        </p:nvSpPr>
+        <p:spPr>
+          <a:xfrm>
+            <a:off x="502920" y="6528816"/>
+            <a:ext cx="11155680" cy="256032"/>
+          </a:xfrm>
+          <a:prstGeom prst="rect">
+            <a:avLst/>
+          </a:prstGeom>
+          <a:noFill/>
+          <a:ln/>
+        </p:spPr>
+        <p:txBody>
+          <a:bodyPr wrap="square" rtlCol="0" anchor="ctr"/>
+          <a:lstStyle/>
+          <a:p>
+            <a:pPr indent="0" marL="0">
+              <a:buNone/>
+            </a:pPr>
+            <a:r>
+              <a:rPr lang="en-US" sz="1100" b="1" dirty="0">
+                <a:solidFill>
+                  <a:srgbClr val="FFDB00"/>
+                </a:solidFill>
+                <a:latin typeface="Arial" pitchFamily="34" charset="0"/>
+                <a:ea typeface="Arial" pitchFamily="34" charset="-122"/>
+                <a:cs typeface="Arial" pitchFamily="34" charset="-120"/>
+              </a:rPr>
+              <a:t>ARROWS ON THE WEB DECK · R FOR RESOURCES · N FOR NOTES</a:t>
+            </a:r>
+            <a:endParaRPr lang="en-US" sz="1100" dirty="0"/>
+          </a:p>
+        </p:txBody>
+      </p:sp>
+    </p:spTree>
+  </p:cSld>
+  <p:clrMapOvr>
+    <a:masterClrMapping/>
+  </p:clrMapOvr>
+</p:sld>
+</file>
+
+<file path=ppt/slides/slide21.xml><?xml version="1.0" encoding="utf-8"?>
+<p:sld xmlns:a="http://schemas.openxmlformats.org/drawingml/2006/main" xmlns:r="http://schemas.openxmlformats.org/officeDocument/2006/relationships" xmlns:p="http://schemas.openxmlformats.org/presentationml/2006/main">
+  <p:cSld name="Slide 21">
+    <p:spTree>
+      <p:nvGrpSpPr>
+        <p:cNvPr id="1" name=""/>
+        <p:cNvGrpSpPr/>
+        <p:nvPr/>
+      </p:nvGrpSpPr>
+      <p:grpSpPr>
+        <a:xfrm>
+          <a:off x="0" y="0"/>
+          <a:ext cx="0" cy="0"/>
+          <a:chOff x="0" y="0"/>
+          <a:chExt cx="0" cy="0"/>
+        </a:xfrm>
+      </p:grpSpPr>
+      <p:sp>
+        <p:nvSpPr>
+          <p:cNvPr id="2" name="Shape 0"/>
+          <p:cNvSpPr/>
+          <p:nvPr/>
+        </p:nvSpPr>
+        <p:spPr>
+          <a:xfrm>
+            <a:off x="0" y="0"/>
+            <a:ext cx="12191695" cy="164592"/>
+          </a:xfrm>
+          <a:prstGeom prst="rect">
+            <a:avLst/>
+          </a:prstGeom>
+          <a:solidFill>
+            <a:srgbClr val="000000"/>
+          </a:solidFill>
+          <a:ln w="12700">
+            <a:solidFill>
+              <a:srgbClr val="000000"/>
+            </a:solidFill>
+            <a:prstDash val="solid"/>
+          </a:ln>
+        </p:spPr>
+      </p:sp>
+      <p:sp>
+        <p:nvSpPr>
+          <p:cNvPr id="3" name="Shape 1"/>
+          <p:cNvSpPr/>
+          <p:nvPr/>
+        </p:nvSpPr>
+        <p:spPr>
+          <a:xfrm>
+            <a:off x="0" y="164592"/>
+            <a:ext cx="12191695" cy="73152"/>
+          </a:xfrm>
+          <a:prstGeom prst="rect">
+            <a:avLst/>
+          </a:prstGeom>
+          <a:solidFill>
+            <a:srgbClr val="FFDB00"/>
+          </a:solidFill>
+          <a:ln w="12700">
+            <a:solidFill>
+              <a:srgbClr val="FFDB00"/>
+            </a:solidFill>
+            <a:prstDash val="solid"/>
+          </a:ln>
+        </p:spPr>
+      </p:sp>
+      <p:sp>
+        <p:nvSpPr>
+          <p:cNvPr id="4" name="Text 2"/>
+          <p:cNvSpPr/>
+          <p:nvPr/>
+        </p:nvSpPr>
+        <p:spPr>
+          <a:xfrm>
+            <a:off x="502920" y="365760"/>
+            <a:ext cx="9601200" cy="256032"/>
+          </a:xfrm>
+          <a:prstGeom prst="rect">
+            <a:avLst/>
+          </a:prstGeom>
+          <a:noFill/>
+          <a:ln/>
+        </p:spPr>
+        <p:txBody>
+          <a:bodyPr wrap="square" rtlCol="0" anchor="ctr"/>
+          <a:lstStyle/>
+          <a:p>
+            <a:pPr indent="0" marL="0">
+              <a:buNone/>
+            </a:pPr>
+            <a:r>
+              <a:rPr lang="en-US" sz="1100" b="1" spc="200" kern="0" dirty="0">
+                <a:solidFill>
+                  <a:srgbClr val="555555"/>
+                </a:solidFill>
+                <a:latin typeface="Arial" pitchFamily="34" charset="0"/>
+                <a:ea typeface="Arial" pitchFamily="34" charset="-122"/>
+                <a:cs typeface="Arial" pitchFamily="34" charset="-120"/>
+              </a:rPr>
+              <a:t>WICHITA STATE · MIS CLUB · WORKSHOP 1</a:t>
+            </a:r>
+            <a:endParaRPr lang="en-US" sz="1100" dirty="0"/>
+          </a:p>
+        </p:txBody>
+      </p:sp>
+      <p:sp>
+        <p:nvSpPr>
+          <p:cNvPr id="5" name="Text 3"/>
+          <p:cNvSpPr/>
+          <p:nvPr/>
+        </p:nvSpPr>
+        <p:spPr>
+          <a:xfrm>
+            <a:off x="10241280" y="365760"/>
+            <a:ext cx="1463040" cy="256032"/>
+          </a:xfrm>
+          <a:prstGeom prst="rect">
+            <a:avLst/>
+          </a:prstGeom>
+          <a:noFill/>
+          <a:ln/>
+        </p:spPr>
+        <p:txBody>
+          <a:bodyPr wrap="square" rtlCol="0" anchor="ctr"/>
+          <a:lstStyle/>
+          <a:p>
+            <a:pPr algn="r" indent="0" marL="0">
+              <a:buNone/>
+            </a:pPr>
+            <a:r>
+              <a:rPr lang="en-US" sz="1100" b="1" dirty="0">
+                <a:solidFill>
+                  <a:srgbClr val="555555"/>
+                </a:solidFill>
+                <a:latin typeface="Arial" pitchFamily="34" charset="0"/>
+                <a:ea typeface="Arial" pitchFamily="34" charset="-122"/>
+                <a:cs typeface="Arial" pitchFamily="34" charset="-120"/>
+              </a:rPr>
+              <a:t>21 / 21</a:t>
+            </a:r>
+            <a:endParaRPr lang="en-US" sz="1100" dirty="0"/>
+          </a:p>
+        </p:txBody>
+      </p:sp>
+      <p:sp>
+        <p:nvSpPr>
+          <p:cNvPr id="6" name="Text 4"/>
+          <p:cNvSpPr/>
+          <p:nvPr/>
+        </p:nvSpPr>
+        <p:spPr>
+          <a:xfrm>
+            <a:off x="502920" y="960120"/>
+            <a:ext cx="11155680" cy="777240"/>
+          </a:xfrm>
+          <a:prstGeom prst="rect">
+            <a:avLst/>
+          </a:prstGeom>
+          <a:noFill/>
+          <a:ln/>
+        </p:spPr>
+        <p:txBody>
+          <a:bodyPr wrap="square" rtlCol="0" anchor="t"/>
+          <a:lstStyle/>
+          <a:p>
+            <a:pPr indent="0" marL="0">
+              <a:buNone/>
+            </a:pPr>
+            <a:r>
+              <a:rPr lang="en-US" sz="2800" b="1" dirty="0">
+                <a:solidFill>
+                  <a:srgbClr val="1A1A1A"/>
+                </a:solidFill>
+                <a:latin typeface="Arial" pitchFamily="34" charset="0"/>
+                <a:ea typeface="Arial" pitchFamily="34" charset="-122"/>
+                <a:cs typeface="Arial" pitchFamily="34" charset="-120"/>
+              </a:rPr>
+              <a:t>Show a partner your live resume — and the PR that got it there.</a:t>
+            </a:r>
+            <a:endParaRPr lang="en-US" sz="2800" dirty="0"/>
+          </a:p>
+        </p:txBody>
+      </p:sp>
+      <p:sp>
+        <p:nvSpPr>
+          <p:cNvPr id="7" name="Text 5"/>
+          <p:cNvSpPr/>
+          <p:nvPr/>
+        </p:nvSpPr>
+        <p:spPr>
+          <a:xfrm>
+            <a:off x="502920" y="1783080"/>
+            <a:ext cx="11155680" cy="877824"/>
+          </a:xfrm>
+          <a:prstGeom prst="rect">
+            <a:avLst/>
+          </a:prstGeom>
+          <a:noFill/>
+          <a:ln/>
+        </p:spPr>
+        <p:txBody>
+          <a:bodyPr wrap="square" rtlCol="0" anchor="t"/>
+          <a:lstStyle/>
+          <a:p>
+            <a:pPr marL="342900" indent="-342900">
+              <a:buSzPct val="100000"/>
+              <a:buChar char="•"/>
+            </a:pPr>
+            <a:r>
+              <a:rPr lang="en-US" sz="1500" dirty="0">
+                <a:solidFill>
+                  <a:srgbClr val="1A1A1A"/>
+                </a:solidFill>
+                <a:latin typeface="Arial" pitchFamily="34" charset="0"/>
+                <a:ea typeface="Arial" pitchFamily="34" charset="-122"/>
+                <a:cs typeface="Arial" pitchFamily="34" charset="-120"/>
+              </a:rPr>
+              <a:t>Show your work</a:t>
             </a:r>
             <a:endParaRPr lang="en-US" sz="1500" dirty="0"/>
           </a:p>
@@ -5957,7 +7166,7 @@
                 <a:ea typeface="Arial" pitchFamily="34" charset="-122"/>
                 <a:cs typeface="Arial" pitchFamily="34" charset="-120"/>
               </a:rPr>
-              <a:t>03 / 18</a:t>
+              <a:t>03 / 21</a:t>
             </a:r>
             <a:endParaRPr lang="en-US" sz="1100" dirty="0"/>
           </a:p>
@@ -5996,7 +7205,7 @@
                 <a:ea typeface="Arial" pitchFamily="34" charset="-122"/>
                 <a:cs typeface="Arial" pitchFamily="34" charset="-120"/>
               </a:rPr>
-              <a:t>First: download and unzip.</a:t>
+              <a:t>Industry work, plus teaching at WSU.</a:t>
             </a:r>
             <a:endParaRPr lang="en-US" sz="2800" dirty="0"/>
           </a:p>
@@ -6011,7 +7220,7 @@
         <p:spPr>
           <a:xfrm>
             <a:off x="502920" y="1783080"/>
-            <a:ext cx="11155680" cy="877824"/>
+            <a:ext cx="11155680" cy="1225296"/>
           </a:xfrm>
           <a:prstGeom prst="rect">
             <a:avLst/>
@@ -6036,7 +7245,7 @@
                 <a:ea typeface="Arial" pitchFamily="34" charset="-122"/>
                 <a:cs typeface="Arial" pitchFamily="34" charset="-120"/>
               </a:rPr>
-              <a:t>Get the starter</a:t>
+              <a:t>Datavant — Senior Application Security Architect</a:t>
             </a:r>
             <a:endParaRPr lang="en-US" sz="1500" dirty="0"/>
           </a:p>
@@ -6054,7 +7263,25 @@
                 <a:ea typeface="Arial" pitchFamily="34" charset="-122"/>
                 <a:cs typeface="Arial" pitchFamily="34" charset="-120"/>
               </a:rPr>
-              <a:t>See the live web deck for full layout and screenshots.</a:t>
+              <a:t>Wichita State — Adjunct Professor, MIS 711 (graduate cybersecurity)</a:t>
+            </a:r>
+            <a:endParaRPr lang="en-US" sz="1500" dirty="0"/>
+          </a:p>
+          <a:p>
+            <a:pPr marL="342900" indent="-342900">
+              <a:buSzPct val="100000"/>
+              <a:buChar char="•"/>
+            </a:pPr>
+            <a:r>
+              <a:rPr lang="en-US" sz="1500" dirty="0">
+                <a:solidFill>
+                  <a:srgbClr val="1A1A1A"/>
+                </a:solidFill>
+                <a:latin typeface="Arial" pitchFamily="34" charset="0"/>
+                <a:ea typeface="Arial" pitchFamily="34" charset="-122"/>
+                <a:cs typeface="Arial" pitchFamily="34" charset="-120"/>
+              </a:rPr>
+              <a:t>Earlier: AppSec and IT risk at Cargill; software development before that</a:t>
             </a:r>
             <a:endParaRPr lang="en-US" sz="1500" dirty="0"/>
           </a:p>
@@ -6271,7 +7498,7 @@
                 <a:ea typeface="Arial" pitchFamily="34" charset="-122"/>
                 <a:cs typeface="Arial" pitchFamily="34" charset="-120"/>
               </a:rPr>
-              <a:t>04 / 18</a:t>
+              <a:t>04 / 21</a:t>
             </a:r>
             <a:endParaRPr lang="en-US" sz="1100" dirty="0"/>
           </a:p>
@@ -6310,7 +7537,7 @@
                 <a:ea typeface="Arial" pitchFamily="34" charset="-122"/>
                 <a:cs typeface="Arial" pitchFamily="34" charset="-120"/>
               </a:rPr>
-              <a:t>Open the folder in VS Code and run it.</a:t>
+              <a:t>I’m here to get you a live resume URL.</a:t>
             </a:r>
             <a:endParaRPr lang="en-US" sz="2800" dirty="0"/>
           </a:p>
@@ -6350,7 +7577,7 @@
                 <a:ea typeface="Arial" pitchFamily="34" charset="-122"/>
                 <a:cs typeface="Arial" pitchFamily="34" charset="-120"/>
               </a:rPr>
-              <a:t>Run it locally</a:t>
+              <a:t>Why I’m here</a:t>
             </a:r>
             <a:endParaRPr lang="en-US" sz="1500" dirty="0"/>
           </a:p>
@@ -6585,7 +7812,7 @@
                 <a:ea typeface="Arial" pitchFamily="34" charset="-122"/>
                 <a:cs typeface="Arial" pitchFamily="34" charset="-120"/>
               </a:rPr>
-              <a:t>05 / 18</a:t>
+              <a:t>05 / 21</a:t>
             </a:r>
             <a:endParaRPr lang="en-US" sz="1100" dirty="0"/>
           </a:p>
@@ -6624,7 +7851,7 @@
                 <a:ea typeface="Arial" pitchFamily="34" charset="-122"/>
                 <a:cs typeface="Arial" pitchFamily="34" charset="-120"/>
               </a:rPr>
-              <a:t>Almost everything you edit is one file.</a:t>
+              <a:t>Today’s job: make this site yours, then publish it.</a:t>
             </a:r>
             <a:endParaRPr lang="en-US" sz="2800" dirty="0"/>
           </a:p>
@@ -6664,7 +7891,7 @@
                 <a:ea typeface="Arial" pitchFamily="34" charset="-122"/>
                 <a:cs typeface="Arial" pitchFamily="34" charset="-120"/>
               </a:rPr>
-              <a:t>The content file</a:t>
+              <a:t>What “done” looks like</a:t>
             </a:r>
             <a:endParaRPr lang="en-US" sz="1500" dirty="0"/>
           </a:p>
@@ -6899,7 +8126,7 @@
                 <a:ea typeface="Arial" pitchFamily="34" charset="-122"/>
                 <a:cs typeface="Arial" pitchFamily="34" charset="-120"/>
               </a:rPr>
-              <a:t>06 / 18</a:t>
+              <a:t>06 / 21</a:t>
             </a:r>
             <a:endParaRPr lang="en-US" sz="1100" dirty="0"/>
           </a:p>
@@ -6938,7 +8165,7 @@
                 <a:ea typeface="Arial" pitchFamily="34" charset="-122"/>
                 <a:cs typeface="Arial" pitchFamily="34" charset="-120"/>
               </a:rPr>
-              <a:t>Saving a file does not put it on the internet.</a:t>
+              <a:t>First: download and unzip.</a:t>
             </a:r>
             <a:endParaRPr lang="en-US" sz="2800" dirty="0"/>
           </a:p>
@@ -6978,7 +8205,7 @@
                 <a:ea typeface="Arial" pitchFamily="34" charset="-122"/>
                 <a:cs typeface="Arial" pitchFamily="34" charset="-120"/>
               </a:rPr>
-              <a:t>Save isn’t publish</a:t>
+              <a:t>Get the starter</a:t>
             </a:r>
             <a:endParaRPr lang="en-US" sz="1500" dirty="0"/>
           </a:p>
@@ -7213,7 +8440,7 @@
                 <a:ea typeface="Arial" pitchFamily="34" charset="-122"/>
                 <a:cs typeface="Arial" pitchFamily="34" charset="-120"/>
               </a:rPr>
-              <a:t>07 / 18</a:t>
+              <a:t>07 / 21</a:t>
             </a:r>
             <a:endParaRPr lang="en-US" sz="1100" dirty="0"/>
           </a:p>
@@ -7252,7 +8479,7 @@
                 <a:ea typeface="Arial" pitchFamily="34" charset="-122"/>
                 <a:cs typeface="Arial" pitchFamily="34" charset="-120"/>
               </a:rPr>
-              <a:t>Push the starter to your empty repo.</a:t>
+              <a:t>Open the folder in VS Code and run it.</a:t>
             </a:r>
             <a:endParaRPr lang="en-US" sz="2800" dirty="0"/>
           </a:p>
@@ -7292,7 +8519,7 @@
                 <a:ea typeface="Arial" pitchFamily="34" charset="-122"/>
                 <a:cs typeface="Arial" pitchFamily="34" charset="-120"/>
               </a:rPr>
-              <a:t>First push</a:t>
+              <a:t>Run it locally</a:t>
             </a:r>
             <a:endParaRPr lang="en-US" sz="1500" dirty="0"/>
           </a:p>
@@ -7527,7 +8754,7 @@
                 <a:ea typeface="Arial" pitchFamily="34" charset="-122"/>
                 <a:cs typeface="Arial" pitchFamily="34" charset="-120"/>
               </a:rPr>
-              <a:t>08 / 18</a:t>
+              <a:t>08 / 21</a:t>
             </a:r>
             <a:endParaRPr lang="en-US" sz="1100" dirty="0"/>
           </a:p>
@@ -7566,7 +8793,7 @@
                 <a:ea typeface="Arial" pitchFamily="34" charset="-122"/>
                 <a:cs typeface="Arial" pitchFamily="34" charset="-120"/>
               </a:rPr>
-              <a:t>When something looks wrong, run git status first.</a:t>
+              <a:t>Almost everything you edit is one file.</a:t>
             </a:r>
             <a:endParaRPr lang="en-US" sz="2800" dirty="0"/>
           </a:p>
@@ -7606,7 +8833,7 @@
                 <a:ea typeface="Arial" pitchFamily="34" charset="-122"/>
                 <a:cs typeface="Arial" pitchFamily="34" charset="-120"/>
               </a:rPr>
-              <a:t>When stuck</a:t>
+              <a:t>The content file</a:t>
             </a:r>
             <a:endParaRPr lang="en-US" sz="1500" dirty="0"/>
           </a:p>
@@ -7841,7 +9068,7 @@
                 <a:ea typeface="Arial" pitchFamily="34" charset="-122"/>
                 <a:cs typeface="Arial" pitchFamily="34" charset="-120"/>
               </a:rPr>
-              <a:t>09 / 18</a:t>
+              <a:t>09 / 21</a:t>
             </a:r>
             <a:endParaRPr lang="en-US" sz="1100" dirty="0"/>
           </a:p>
@@ -7880,7 +9107,7 @@
                 <a:ea typeface="Arial" pitchFamily="34" charset="-122"/>
                 <a:cs typeface="Arial" pitchFamily="34" charset="-120"/>
               </a:rPr>
-              <a:t>Build out your resume in profile.js .</a:t>
+              <a:t>Saving a file does not put it on the internet.</a:t>
             </a:r>
             <a:endParaRPr lang="en-US" sz="2800" dirty="0"/>
           </a:p>
@@ -7920,7 +9147,7 @@
                 <a:ea typeface="Arial" pitchFamily="34" charset="-122"/>
                 <a:cs typeface="Arial" pitchFamily="34" charset="-120"/>
               </a:rPr>
-              <a:t>Personalize</a:t>
+              <a:t>Save isn’t publish</a:t>
             </a:r>
             <a:endParaRPr lang="en-US" sz="1500" dirty="0"/>
           </a:p>

</xml_diff>

<commit_message>
Deck: drop Adjunct Professor from about-me slide
</commit_message>
<xml_diff>
--- a/downloads/workshop-1-presentation.pptx
+++ b/downloads/workshop-1-presentation.pptx
@@ -1754,7 +1754,7 @@
           <a:p>
             <a:r>
               <a:rPr lang="en-US" dirty="0"/>
-              <a:t>Datavant + WSU adjunct. Connect industry work to why Git/PR/Pages matter in real teams.</a:t>
+              <a:t>Datavant + prior roles. Connect industry work to why Git/PR/Pages matter in real teams.</a:t>
             </a:r>
             <a:endParaRPr lang="en-US" dirty="0"/>
           </a:p>
@@ -7205,7 +7205,7 @@
                 <a:ea typeface="Arial" pitchFamily="34" charset="-122"/>
                 <a:cs typeface="Arial" pitchFamily="34" charset="-120"/>
               </a:rPr>
-              <a:t>Industry work, plus teaching at WSU.</a:t>
+              <a:t>Day job and the path that got me here.</a:t>
             </a:r>
             <a:endParaRPr lang="en-US" sz="2800" dirty="0"/>
           </a:p>
@@ -7220,7 +7220,7 @@
         <p:spPr>
           <a:xfrm>
             <a:off x="502920" y="1783080"/>
-            <a:ext cx="11155680" cy="1225296"/>
+            <a:ext cx="11155680" cy="877824"/>
           </a:xfrm>
           <a:prstGeom prst="rect">
             <a:avLst/>
@@ -7246,24 +7246,6 @@
                 <a:cs typeface="Arial" pitchFamily="34" charset="-120"/>
               </a:rPr>
               <a:t>Datavant — Senior Application Security Architect</a:t>
-            </a:r>
-            <a:endParaRPr lang="en-US" sz="1500" dirty="0"/>
-          </a:p>
-          <a:p>
-            <a:pPr marL="342900" indent="-342900">
-              <a:buSzPct val="100000"/>
-              <a:buChar char="•"/>
-            </a:pPr>
-            <a:r>
-              <a:rPr lang="en-US" sz="1500" dirty="0">
-                <a:solidFill>
-                  <a:srgbClr val="1A1A1A"/>
-                </a:solidFill>
-                <a:latin typeface="Arial" pitchFamily="34" charset="0"/>
-                <a:ea typeface="Arial" pitchFamily="34" charset="-122"/>
-                <a:cs typeface="Arial" pitchFamily="34" charset="-120"/>
-              </a:rPr>
-              <a:t>Wichita State — Adjunct Professor, MIS 711 (graduate cybersecurity)</a:t>
             </a:r>
             <a:endParaRPr lang="en-US" sz="1500" dirty="0"/>
           </a:p>

</xml_diff>

<commit_message>
Deck: personal About Me with photo and education
</commit_message>
<xml_diff>
--- a/downloads/workshop-1-presentation.pptx
+++ b/downloads/workshop-1-presentation.pptx
@@ -1490,7 +1490,7 @@
           <a:p>
             <a:r>
               <a:rPr lang="en-US" dirty="0"/>
-              <a:t>Keep this short. Establish credibility, then get to the work. Point at example site later if useful.</a:t>
+              <a:t>Smile, wave, keep it human. One beat on Wichita / family / dogs, then move on. Credibility comes next.</a:t>
             </a:r>
             <a:endParaRPr lang="en-US" dirty="0"/>
           </a:p>
@@ -1754,7 +1754,7 @@
           <a:p>
             <a:r>
               <a:rPr lang="en-US" dirty="0"/>
-              <a:t>Datavant + prior roles. Connect industry work to why Git/PR/Pages matter in real teams.</a:t>
+              <a:t>WSU undergrad, Friends MS Cybersecurity, then Datavant. No teaching title. Connect industry work to why Git/PR/Pages matter on real teams.</a:t>
             </a:r>
             <a:endParaRPr lang="en-US" dirty="0"/>
           </a:p>
@@ -3452,7 +3452,7 @@
         <p:spPr>
           <a:xfrm>
             <a:off x="502920" y="1783080"/>
-            <a:ext cx="11155680" cy="877824"/>
+            <a:ext cx="11155680" cy="530352"/>
           </a:xfrm>
           <a:prstGeom prst="rect">
             <a:avLst/>
@@ -3477,25 +3477,7 @@
                 <a:ea typeface="Arial" pitchFamily="34" charset="-122"/>
                 <a:cs typeface="Arial" pitchFamily="34" charset="-120"/>
               </a:rPr>
-              <a:t>When stuck</a:t>
-            </a:r>
-            <a:endParaRPr lang="en-US" sz="1500" dirty="0"/>
-          </a:p>
-          <a:p>
-            <a:pPr marL="342900" indent="-342900">
-              <a:buSzPct val="100000"/>
-              <a:buChar char="•"/>
-            </a:pPr>
-            <a:r>
-              <a:rPr lang="en-US" sz="1500" dirty="0">
-                <a:solidFill>
-                  <a:srgbClr val="1A1A1A"/>
-                </a:solidFill>
-                <a:latin typeface="Arial" pitchFamily="34" charset="0"/>
-                <a:ea typeface="Arial" pitchFamily="34" charset="-122"/>
-                <a:cs typeface="Arial" pitchFamily="34" charset="-120"/>
-              </a:rPr>
-              <a:t>See the live web deck for full layout and screenshots.</a:t>
+              <a:t>Then git diff if you need to see what you edited. Guessing burns time.</a:t>
             </a:r>
             <a:endParaRPr lang="en-US" sz="1500" dirty="0"/>
           </a:p>
@@ -3766,7 +3748,7 @@
         <p:spPr>
           <a:xfrm>
             <a:off x="502920" y="1783080"/>
-            <a:ext cx="11155680" cy="877824"/>
+            <a:ext cx="11155680" cy="530352"/>
           </a:xfrm>
           <a:prstGeom prst="rect">
             <a:avLst/>
@@ -3791,25 +3773,7 @@
                 <a:ea typeface="Arial" pitchFamily="34" charset="-122"/>
                 <a:cs typeface="Arial" pitchFamily="34" charset="-120"/>
               </a:rPr>
-              <a:t>Personalize</a:t>
-            </a:r>
-            <a:endParaRPr lang="en-US" sz="1500" dirty="0"/>
-          </a:p>
-          <a:p>
-            <a:pPr marL="342900" indent="-342900">
-              <a:buSzPct val="100000"/>
-              <a:buChar char="•"/>
-            </a:pPr>
-            <a:r>
-              <a:rPr lang="en-US" sz="1500" dirty="0">
-                <a:solidFill>
-                  <a:srgbClr val="1A1A1A"/>
-                </a:solidFill>
-                <a:latin typeface="Arial" pitchFamily="34" charset="0"/>
-                <a:ea typeface="Arial" pitchFamily="34" charset="-122"/>
-                <a:cs typeface="Arial" pitchFamily="34" charset="-120"/>
-              </a:rPr>
-              <a:t>See the live web deck for full layout and screenshots.</a:t>
+              <a:t>Replace the sample person with you. Fill what you have — coursework, activities, projects, experience if any. Replace every example.com link. Save and check localhost. Don’t Commit yet; next we ship a chunk of this work through a pull request.</a:t>
             </a:r>
             <a:endParaRPr lang="en-US" sz="1500" dirty="0"/>
           </a:p>
@@ -4080,7 +4044,7 @@
         <p:spPr>
           <a:xfrm>
             <a:off x="502920" y="1783080"/>
-            <a:ext cx="11155680" cy="877824"/>
+            <a:ext cx="11155680" cy="530352"/>
           </a:xfrm>
           <a:prstGeom prst="rect">
             <a:avLst/>
@@ -4105,25 +4069,7 @@
                 <a:ea typeface="Arial" pitchFamily="34" charset="-122"/>
                 <a:cs typeface="Arial" pitchFamily="34" charset="-120"/>
               </a:rPr>
-              <a:t>Issue first</a:t>
-            </a:r>
-            <a:endParaRPr lang="en-US" sz="1500" dirty="0"/>
-          </a:p>
-          <a:p>
-            <a:pPr marL="342900" indent="-342900">
-              <a:buSzPct val="100000"/>
-              <a:buChar char="•"/>
-            </a:pPr>
-            <a:r>
-              <a:rPr lang="en-US" sz="1500" dirty="0">
-                <a:solidFill>
-                  <a:srgbClr val="1A1A1A"/>
-                </a:solidFill>
-                <a:latin typeface="Arial" pitchFamily="34" charset="0"/>
-                <a:ea typeface="Arial" pitchFamily="34" charset="-122"/>
-                <a:cs typeface="Arial" pitchFamily="34" charset="-120"/>
-              </a:rPr>
-              <a:t>See the live web deck for full layout and screenshots.</a:t>
+              <a:t>Example: featured project card. GitHub → Issues → New. Write how you’ll know it’s done — honest summary, working link, readable on a phone, no secrets. The rest of your personalization can ride in the same commit.</a:t>
             </a:r>
             <a:endParaRPr lang="en-US" sz="1500" dirty="0"/>
           </a:p>
@@ -4394,7 +4340,7 @@
         <p:spPr>
           <a:xfrm>
             <a:off x="502920" y="1783080"/>
-            <a:ext cx="11155680" cy="877824"/>
+            <a:ext cx="11155680" cy="530352"/>
           </a:xfrm>
           <a:prstGeom prst="rect">
             <a:avLst/>
@@ -4419,25 +4365,7 @@
                 <a:ea typeface="Arial" pitchFamily="34" charset="-122"/>
                 <a:cs typeface="Arial" pitchFamily="34" charset="-120"/>
               </a:rPr>
-              <a:t>Branch</a:t>
-            </a:r>
-            <a:endParaRPr lang="en-US" sz="1500" dirty="0"/>
-          </a:p>
-          <a:p>
-            <a:pPr marL="342900" indent="-342900">
-              <a:buSzPct val="100000"/>
-              <a:buChar char="•"/>
-            </a:pPr>
-            <a:r>
-              <a:rPr lang="en-US" sz="1500" dirty="0">
-                <a:solidFill>
-                  <a:srgbClr val="1A1A1A"/>
-                </a:solidFill>
-                <a:latin typeface="Arial" pitchFamily="34" charset="0"/>
-                <a:ea typeface="Arial" pitchFamily="34" charset="-122"/>
-                <a:cs typeface="Arial" pitchFamily="34" charset="-120"/>
-              </a:rPr>
-              <a:t>See the live web deck for full layout and screenshots.</a:t>
+              <a:t>Name it add-featured-project . The Status Bar should show that name before you commit anything.</a:t>
             </a:r>
             <a:endParaRPr lang="en-US" sz="1500" dirty="0"/>
           </a:p>
@@ -4708,7 +4636,7 @@
         <p:spPr>
           <a:xfrm>
             <a:off x="502920" y="1783080"/>
-            <a:ext cx="11155680" cy="877824"/>
+            <a:ext cx="11155680" cy="530352"/>
           </a:xfrm>
           <a:prstGeom prst="rect">
             <a:avLst/>
@@ -4733,25 +4661,7 @@
                 <a:ea typeface="Arial" pitchFamily="34" charset="-122"/>
                 <a:cs typeface="Arial" pitchFamily="34" charset="-120"/>
               </a:rPr>
-              <a:t>Commit and publish</a:t>
-            </a:r>
-            <a:endParaRPr lang="en-US" sz="1500" dirty="0"/>
-          </a:p>
-          <a:p>
-            <a:pPr marL="342900" indent="-342900">
-              <a:buSzPct val="100000"/>
-              <a:buChar char="•"/>
-            </a:pPr>
-            <a:r>
-              <a:rPr lang="en-US" sz="1500" dirty="0">
-                <a:solidFill>
-                  <a:srgbClr val="1A1A1A"/>
-                </a:solidFill>
-                <a:latin typeface="Arial" pitchFamily="34" charset="0"/>
-                <a:ea typeface="Arial" pitchFamily="34" charset="-122"/>
-                <a:cs typeface="Arial" pitchFamily="34" charset="-120"/>
-              </a:rPr>
-              <a:t>See the live web deck for full layout and screenshots.</a:t>
+              <a:t>Source Control → read the diff → Stage (+) → write a real message → Commit → Publish Branch .</a:t>
             </a:r>
             <a:endParaRPr lang="en-US" sz="1500" dirty="0"/>
           </a:p>
@@ -5022,7 +4932,7 @@
         <p:spPr>
           <a:xfrm>
             <a:off x="502920" y="1783080"/>
-            <a:ext cx="11155680" cy="877824"/>
+            <a:ext cx="11155680" cy="530352"/>
           </a:xfrm>
           <a:prstGeom prst="rect">
             <a:avLst/>
@@ -5047,25 +4957,7 @@
                 <a:ea typeface="Arial" pitchFamily="34" charset="-122"/>
                 <a:cs typeface="Arial" pitchFamily="34" charset="-120"/>
               </a:rPr>
-              <a:t>Pull request</a:t>
-            </a:r>
-            <a:endParaRPr lang="en-US" sz="1500" dirty="0"/>
-          </a:p>
-          <a:p>
-            <a:pPr marL="342900" indent="-342900">
-              <a:buSzPct val="100000"/>
-              <a:buChar char="•"/>
-            </a:pPr>
-            <a:r>
-              <a:rPr lang="en-US" sz="1500" dirty="0">
-                <a:solidFill>
-                  <a:srgbClr val="1A1A1A"/>
-                </a:solidFill>
-                <a:latin typeface="Arial" pitchFamily="34" charset="0"/>
-                <a:ea typeface="Arial" pitchFamily="34" charset="-122"/>
-                <a:cs typeface="Arial" pitchFamily="34" charset="-120"/>
-              </a:rPr>
-              <a:t>See the live web deck for full layout and screenshots.</a:t>
+              <a:t>Issue = task. PR = fix. Two ways: (1) put Closes #1 on its own line in the PR body — closes the issue on merge. (2) PR sidebar → Development → Link an issue → pick yours. Confirm the link on the issue page, then Files changed . Don’t merge yet.</a:t>
             </a:r>
             <a:endParaRPr lang="en-US" sz="1500" dirty="0"/>
           </a:p>
@@ -5336,7 +5228,7 @@
         <p:spPr>
           <a:xfrm>
             <a:off x="502920" y="1783080"/>
-            <a:ext cx="11155680" cy="877824"/>
+            <a:ext cx="11155680" cy="530352"/>
           </a:xfrm>
           <a:prstGeom prst="rect">
             <a:avLst/>
@@ -5361,25 +5253,7 @@
                 <a:ea typeface="Arial" pitchFamily="34" charset="-122"/>
                 <a:cs typeface="Arial" pitchFamily="34" charset="-120"/>
               </a:rPr>
-              <a:t>Partner +1</a:t>
-            </a:r>
-            <a:endParaRPr lang="en-US" sz="1500" dirty="0"/>
-          </a:p>
-          <a:p>
-            <a:pPr marL="342900" indent="-342900">
-              <a:buSzPct val="100000"/>
-              <a:buChar char="•"/>
-            </a:pPr>
-            <a:r>
-              <a:rPr lang="en-US" sz="1500" dirty="0">
-                <a:solidFill>
-                  <a:srgbClr val="1A1A1A"/>
-                </a:solidFill>
-                <a:latin typeface="Arial" pitchFamily="34" charset="0"/>
-                <a:ea typeface="Arial" pitchFamily="34" charset="-122"/>
-                <a:cs typeface="Arial" pitchFamily="34" charset="-120"/>
-              </a:rPr>
-              <a:t>See the live web deck for full layout and screenshots.</a:t>
+              <a:t>They open Files changed , skim the diff, then Review changes → Approve (or Comment with +1 ). You do the same on theirs. Merge only after you have a partner review.</a:t>
             </a:r>
             <a:endParaRPr lang="en-US" sz="1500" dirty="0"/>
           </a:p>
@@ -5650,7 +5524,7 @@
         <p:spPr>
           <a:xfrm>
             <a:off x="502920" y="1783080"/>
-            <a:ext cx="11155680" cy="877824"/>
+            <a:ext cx="11155680" cy="530352"/>
           </a:xfrm>
           <a:prstGeom prst="rect">
             <a:avLst/>
@@ -5675,25 +5549,7 @@
                 <a:ea typeface="Arial" pitchFamily="34" charset="-122"/>
                 <a:cs typeface="Arial" pitchFamily="34" charset="-120"/>
               </a:rPr>
-              <a:t>Actions</a:t>
-            </a:r>
-            <a:endParaRPr lang="en-US" sz="1500" dirty="0"/>
-          </a:p>
-          <a:p>
-            <a:pPr marL="342900" indent="-342900">
-              <a:buSzPct val="100000"/>
-              <a:buChar char="•"/>
-            </a:pPr>
-            <a:r>
-              <a:rPr lang="en-US" sz="1500" dirty="0">
-                <a:solidFill>
-                  <a:srgbClr val="1A1A1A"/>
-                </a:solidFill>
-                <a:latin typeface="Arial" pitchFamily="34" charset="0"/>
-                <a:ea typeface="Arial" pitchFamily="34" charset="-122"/>
-                <a:cs typeface="Arial" pitchFamily="34" charset="-120"/>
-              </a:rPr>
-              <a:t>See the live web deck for full layout and screenshots.</a:t>
+              <a:t>On a push to main it installs, builds, and deploys. You’re not writing YAML today — you’re watching it run. Feature branches don’t publish.</a:t>
             </a:r>
             <a:endParaRPr lang="en-US" sz="1500" dirty="0"/>
           </a:p>
@@ -5964,7 +5820,7 @@
         <p:spPr>
           <a:xfrm>
             <a:off x="502920" y="1783080"/>
-            <a:ext cx="11155680" cy="877824"/>
+            <a:ext cx="11155680" cy="530352"/>
           </a:xfrm>
           <a:prstGeom prst="rect">
             <a:avLst/>
@@ -5989,25 +5845,7 @@
                 <a:ea typeface="Arial" pitchFamily="34" charset="-122"/>
                 <a:cs typeface="Arial" pitchFamily="34" charset="-120"/>
               </a:rPr>
-              <a:t>Pages</a:t>
-            </a:r>
-            <a:endParaRPr lang="en-US" sz="1500" dirty="0"/>
-          </a:p>
-          <a:p>
-            <a:pPr marL="342900" indent="-342900">
-              <a:buSzPct val="100000"/>
-              <a:buChar char="•"/>
-            </a:pPr>
-            <a:r>
-              <a:rPr lang="en-US" sz="1500" dirty="0">
-                <a:solidFill>
-                  <a:srgbClr val="1A1A1A"/>
-                </a:solidFill>
-                <a:latin typeface="Arial" pitchFamily="34" charset="0"/>
-                <a:ea typeface="Arial" pitchFamily="34" charset="-122"/>
-                <a:cs typeface="Arial" pitchFamily="34" charset="-120"/>
-              </a:rPr>
-              <a:t>See the live web deck for full layout and screenshots.</a:t>
+              <a:t>Settings → Pages → Source: GitHub Actions . Actions tab → open the run → Re-run all jobs if it failed earlier. When it’s green, open the URL and poke it on your phone.</a:t>
             </a:r>
             <a:endParaRPr lang="en-US" sz="1500" dirty="0"/>
           </a:p>
@@ -6238,23 +6076,86 @@
         </p:nvSpPr>
         <p:spPr>
           <a:xfrm>
-            <a:off x="502920" y="960120"/>
-            <a:ext cx="11155680" cy="777240"/>
-          </a:xfrm>
-          <a:prstGeom prst="rect">
-            <a:avLst/>
-          </a:prstGeom>
-          <a:noFill/>
-          <a:ln/>
-        </p:spPr>
-        <p:txBody>
-          <a:bodyPr wrap="square" rtlCol="0" anchor="t"/>
+            <a:off x="502920" y="685800"/>
+            <a:ext cx="11155680" cy="256032"/>
+          </a:xfrm>
+          <a:prstGeom prst="rect">
+            <a:avLst/>
+          </a:prstGeom>
+          <a:noFill/>
+          <a:ln/>
+        </p:spPr>
+        <p:txBody>
+          <a:bodyPr wrap="square" rtlCol="0" anchor="ctr"/>
           <a:lstStyle/>
           <a:p>
             <a:pPr indent="0" marL="0">
               <a:buNone/>
             </a:pPr>
             <a:r>
+              <a:rPr lang="en-US" sz="1200" b="1" dirty="0">
+                <a:solidFill>
+                  <a:srgbClr val="555555"/>
+                </a:solidFill>
+                <a:latin typeface="Arial" pitchFamily="34" charset="0"/>
+                <a:ea typeface="Arial" pitchFamily="34" charset="-122"/>
+                <a:cs typeface="Arial" pitchFamily="34" charset="-120"/>
+              </a:rPr>
+              <a:t>YOUR FACILITATOR</a:t>
+            </a:r>
+            <a:endParaRPr lang="en-US" sz="1200" dirty="0"/>
+          </a:p>
+        </p:txBody>
+      </p:sp>
+      <p:pic>
+        <p:nvPicPr>
+          <p:cNvPr id="7" name="Image 0" descr="/Users/coding/workshop/public/slides/tyler-beach.jpg">    </p:cNvPr>
+          <p:cNvPicPr>
+            <a:picLocks noChangeAspect="1"/>
+          </p:cNvPicPr>
+          <p:nvPr/>
+        </p:nvPicPr>
+        <p:blipFill>
+          <a:blip r:embed="rId1"/>
+          <a:stretch>
+            <a:fillRect/>
+          </a:stretch>
+        </p:blipFill>
+        <p:spPr>
+          <a:xfrm>
+            <a:off x="502920" y="1051560"/>
+            <a:ext cx="2926080" cy="2926080"/>
+          </a:xfrm>
+          <a:prstGeom prst="rect">
+            <a:avLst/>
+          </a:prstGeom>
+        </p:spPr>
+      </p:pic>
+      <p:sp>
+        <p:nvSpPr>
+          <p:cNvPr id="8" name="Text 5"/>
+          <p:cNvSpPr/>
+          <p:nvPr/>
+        </p:nvSpPr>
+        <p:spPr>
+          <a:xfrm>
+            <a:off x="3749040" y="960120"/>
+            <a:ext cx="7863840" cy="777240"/>
+          </a:xfrm>
+          <a:prstGeom prst="rect">
+            <a:avLst/>
+          </a:prstGeom>
+          <a:noFill/>
+          <a:ln/>
+        </p:spPr>
+        <p:txBody>
+          <a:bodyPr wrap="square" rtlCol="0" anchor="t"/>
+          <a:lstStyle/>
+          <a:p>
+            <a:pPr indent="0" marL="0">
+              <a:buNone/>
+            </a:pPr>
+            <a:r>
               <a:rPr lang="en-US" sz="2800" b="1" dirty="0">
                 <a:solidFill>
                   <a:srgbClr val="1A1A1A"/>
@@ -6271,14 +6172,14 @@
       </p:sp>
       <p:sp>
         <p:nvSpPr>
-          <p:cNvPr id="7" name="Text 5"/>
-          <p:cNvSpPr/>
-          <p:nvPr/>
-        </p:nvSpPr>
-        <p:spPr>
-          <a:xfrm>
-            <a:off x="502920" y="1783080"/>
-            <a:ext cx="11155680" cy="877824"/>
+          <p:cNvPr id="9" name="Text 6"/>
+          <p:cNvSpPr/>
+          <p:nvPr/>
+        </p:nvSpPr>
+        <p:spPr>
+          <a:xfrm>
+            <a:off x="3749040" y="1783080"/>
+            <a:ext cx="7863840" cy="1572768"/>
           </a:xfrm>
           <a:prstGeom prst="rect">
             <a:avLst/>
@@ -6303,7 +6204,7 @@
                 <a:ea typeface="Arial" pitchFamily="34" charset="-122"/>
                 <a:cs typeface="Arial" pitchFamily="34" charset="-120"/>
               </a:rPr>
-              <a:t>About me</a:t>
+              <a:t>Shockers alum. Based in Wichita with my wife and two dogs. Security is the day job — not the whole story.</a:t>
             </a:r>
             <a:endParaRPr lang="en-US" sz="1500" dirty="0"/>
           </a:p>
@@ -6321,15 +6222,51 @@
                 <a:ea typeface="Arial" pitchFamily="34" charset="-122"/>
                 <a:cs typeface="Arial" pitchFamily="34" charset="-120"/>
               </a:rPr>
-              <a:t>See the live web deck for full layout and screenshots.</a:t>
+              <a:t>Wichita, KS</a:t>
             </a:r>
             <a:endParaRPr lang="en-US" sz="1500" dirty="0"/>
           </a:p>
-        </p:txBody>
-      </p:sp>
-      <p:sp>
-        <p:nvSpPr>
-          <p:cNvPr id="8" name="Shape 6"/>
+          <a:p>
+            <a:pPr marL="342900" indent="-342900">
+              <a:buSzPct val="100000"/>
+              <a:buChar char="•"/>
+            </a:pPr>
+            <a:r>
+              <a:rPr lang="en-US" sz="1500" dirty="0">
+                <a:solidFill>
+                  <a:srgbClr val="1A1A1A"/>
+                </a:solidFill>
+                <a:latin typeface="Arial" pitchFamily="34" charset="0"/>
+                <a:ea typeface="Arial" pitchFamily="34" charset="-122"/>
+                <a:cs typeface="Arial" pitchFamily="34" charset="-120"/>
+              </a:rPr>
+              <a:t>~11 years in industry</a:t>
+            </a:r>
+            <a:endParaRPr lang="en-US" sz="1500" dirty="0"/>
+          </a:p>
+          <a:p>
+            <a:pPr marL="342900" indent="-342900">
+              <a:buSzPct val="100000"/>
+              <a:buChar char="•"/>
+            </a:pPr>
+            <a:r>
+              <a:rPr lang="en-US" sz="1500" dirty="0">
+                <a:solidFill>
+                  <a:srgbClr val="1A1A1A"/>
+                </a:solidFill>
+                <a:latin typeface="Arial" pitchFamily="34" charset="0"/>
+                <a:ea typeface="Arial" pitchFamily="34" charset="-122"/>
+                <a:cs typeface="Arial" pitchFamily="34" charset="-120"/>
+              </a:rPr>
+              <a:t>Two dogs at home</a:t>
+            </a:r>
+            <a:endParaRPr lang="en-US" sz="1500" dirty="0"/>
+          </a:p>
+        </p:txBody>
+      </p:sp>
+      <p:sp>
+        <p:nvSpPr>
+          <p:cNvPr id="10" name="Shape 7"/>
           <p:cNvSpPr/>
           <p:nvPr/>
         </p:nvSpPr>
@@ -6354,7 +6291,7 @@
       </p:sp>
       <p:sp>
         <p:nvSpPr>
-          <p:cNvPr id="9" name="Text 7"/>
+          <p:cNvPr id="11" name="Text 8"/>
           <p:cNvSpPr/>
           <p:nvPr/>
         </p:nvSpPr>
@@ -6592,7 +6529,7 @@
         <p:spPr>
           <a:xfrm>
             <a:off x="502920" y="1783080"/>
-            <a:ext cx="11155680" cy="877824"/>
+            <a:ext cx="11155680" cy="530352"/>
           </a:xfrm>
           <a:prstGeom prst="rect">
             <a:avLst/>
@@ -6617,25 +6554,7 @@
                 <a:ea typeface="Arial" pitchFamily="34" charset="-122"/>
                 <a:cs typeface="Arial" pitchFamily="34" charset="-120"/>
               </a:rPr>
-              <a:t>Lab</a:t>
-            </a:r>
-            <a:endParaRPr lang="en-US" sz="1500" dirty="0"/>
-          </a:p>
-          <a:p>
-            <a:pPr marL="342900" indent="-342900">
-              <a:buSzPct val="100000"/>
-              <a:buChar char="•"/>
-            </a:pPr>
-            <a:r>
-              <a:rPr lang="en-US" sz="1500" dirty="0">
-                <a:solidFill>
-                  <a:srgbClr val="1A1A1A"/>
-                </a:solidFill>
-                <a:latin typeface="Arial" pitchFamily="34" charset="0"/>
-                <a:ea typeface="Arial" pitchFamily="34" charset="-122"/>
-                <a:cs typeface="Arial" pitchFamily="34" charset="-120"/>
-              </a:rPr>
-              <a:t>See the live web deck for full layout and screenshots.</a:t>
+              <a:t>Keep filling profile.js . Use the issue → branch → PR → partner +1 path for the featured project. Then Pages → live URL. Stuck? Show the error and your Status Bar branch name.</a:t>
             </a:r>
             <a:endParaRPr lang="en-US" sz="1500" dirty="0"/>
           </a:p>
@@ -6906,7 +6825,7 @@
         <p:spPr>
           <a:xfrm>
             <a:off x="502920" y="1783080"/>
-            <a:ext cx="11155680" cy="877824"/>
+            <a:ext cx="11155680" cy="530352"/>
           </a:xfrm>
           <a:prstGeom prst="rect">
             <a:avLst/>
@@ -6931,25 +6850,7 @@
                 <a:ea typeface="Arial" pitchFamily="34" charset="-122"/>
                 <a:cs typeface="Arial" pitchFamily="34" charset="-120"/>
               </a:rPr>
-              <a:t>Show your work</a:t>
-            </a:r>
-            <a:endParaRPr lang="en-US" sz="1500" dirty="0"/>
-          </a:p>
-          <a:p>
-            <a:pPr marL="342900" indent="-342900">
-              <a:buSzPct val="100000"/>
-              <a:buChar char="•"/>
-            </a:pPr>
-            <a:r>
-              <a:rPr lang="en-US" sz="1500" dirty="0">
-                <a:solidFill>
-                  <a:srgbClr val="1A1A1A"/>
-                </a:solidFill>
-                <a:latin typeface="Arial" pitchFamily="34" charset="0"/>
-                <a:ea typeface="Arial" pitchFamily="34" charset="-122"/>
-                <a:cs typeface="Arial" pitchFamily="34" charset="-120"/>
-              </a:rPr>
-              <a:t>See the live web deck for full layout and screenshots.</a:t>
+              <a:t>If the site still looks like Jordan Lee, you’re not done yet.</a:t>
             </a:r>
             <a:endParaRPr lang="en-US" sz="1500" dirty="0"/>
           </a:p>
@@ -7180,6 +7081,45 @@
         </p:nvSpPr>
         <p:spPr>
           <a:xfrm>
+            <a:off x="502920" y="685800"/>
+            <a:ext cx="11155680" cy="256032"/>
+          </a:xfrm>
+          <a:prstGeom prst="rect">
+            <a:avLst/>
+          </a:prstGeom>
+          <a:noFill/>
+          <a:ln/>
+        </p:spPr>
+        <p:txBody>
+          <a:bodyPr wrap="square" rtlCol="0" anchor="ctr"/>
+          <a:lstStyle/>
+          <a:p>
+            <a:pPr indent="0" marL="0">
+              <a:buNone/>
+            </a:pPr>
+            <a:r>
+              <a:rPr lang="en-US" sz="1200" b="1" dirty="0">
+                <a:solidFill>
+                  <a:srgbClr val="555555"/>
+                </a:solidFill>
+                <a:latin typeface="Arial" pitchFamily="34" charset="0"/>
+                <a:ea typeface="Arial" pitchFamily="34" charset="-122"/>
+                <a:cs typeface="Arial" pitchFamily="34" charset="-120"/>
+              </a:rPr>
+              <a:t>SCHOOL + WORK</a:t>
+            </a:r>
+            <a:endParaRPr lang="en-US" sz="1200" dirty="0"/>
+          </a:p>
+        </p:txBody>
+      </p:sp>
+      <p:sp>
+        <p:nvSpPr>
+          <p:cNvPr id="7" name="Text 5"/>
+          <p:cNvSpPr/>
+          <p:nvPr/>
+        </p:nvSpPr>
+        <p:spPr>
+          <a:xfrm>
             <a:off x="502920" y="960120"/>
             <a:ext cx="11155680" cy="777240"/>
           </a:xfrm>
@@ -7205,7 +7145,7 @@
                 <a:ea typeface="Arial" pitchFamily="34" charset="-122"/>
                 <a:cs typeface="Arial" pitchFamily="34" charset="-120"/>
               </a:rPr>
-              <a:t>Day job and the path that got me here.</a:t>
+              <a:t>Local roots. Industry practice.</a:t>
             </a:r>
             <a:endParaRPr lang="en-US" sz="2800" dirty="0"/>
           </a:p>
@@ -7213,14 +7153,14 @@
       </p:sp>
       <p:sp>
         <p:nvSpPr>
-          <p:cNvPr id="7" name="Text 5"/>
+          <p:cNvPr id="8" name="Text 6"/>
           <p:cNvSpPr/>
           <p:nvPr/>
         </p:nvSpPr>
         <p:spPr>
           <a:xfrm>
             <a:off x="502920" y="1783080"/>
-            <a:ext cx="11155680" cy="877824"/>
+            <a:ext cx="11155680" cy="1920240"/>
           </a:xfrm>
           <a:prstGeom prst="rect">
             <a:avLst/>
@@ -7245,7 +7185,7 @@
                 <a:ea typeface="Arial" pitchFamily="34" charset="-122"/>
                 <a:cs typeface="Arial" pitchFamily="34" charset="-120"/>
               </a:rPr>
-              <a:t>Datavant — Senior Application Security Architect</a:t>
+              <a:t>I care about developer enablement — the same skills we’re practicing today.</a:t>
             </a:r>
             <a:endParaRPr lang="en-US" sz="1500" dirty="0"/>
           </a:p>
@@ -7263,6 +7203,60 @@
                 <a:ea typeface="Arial" pitchFamily="34" charset="-122"/>
                 <a:cs typeface="Arial" pitchFamily="34" charset="-120"/>
               </a:rPr>
+              <a:t>Wichita State — graduated here</a:t>
+            </a:r>
+            <a:endParaRPr lang="en-US" sz="1500" dirty="0"/>
+          </a:p>
+          <a:p>
+            <a:pPr marL="342900" indent="-342900">
+              <a:buSzPct val="100000"/>
+              <a:buChar char="•"/>
+            </a:pPr>
+            <a:r>
+              <a:rPr lang="en-US" sz="1500" dirty="0">
+                <a:solidFill>
+                  <a:srgbClr val="1A1A1A"/>
+                </a:solidFill>
+                <a:latin typeface="Arial" pitchFamily="34" charset="0"/>
+                <a:ea typeface="Arial" pitchFamily="34" charset="-122"/>
+                <a:cs typeface="Arial" pitchFamily="34" charset="-120"/>
+              </a:rPr>
+              <a:t>Friends University — Master’s in Cybersecurity</a:t>
+            </a:r>
+            <a:endParaRPr lang="en-US" sz="1500" dirty="0"/>
+          </a:p>
+          <a:p>
+            <a:pPr marL="342900" indent="-342900">
+              <a:buSzPct val="100000"/>
+              <a:buChar char="•"/>
+            </a:pPr>
+            <a:r>
+              <a:rPr lang="en-US" sz="1500" dirty="0">
+                <a:solidFill>
+                  <a:srgbClr val="1A1A1A"/>
+                </a:solidFill>
+                <a:latin typeface="Arial" pitchFamily="34" charset="0"/>
+                <a:ea typeface="Arial" pitchFamily="34" charset="-122"/>
+                <a:cs typeface="Arial" pitchFamily="34" charset="-120"/>
+              </a:rPr>
+              <a:t>Datavant — Senior Application Security Architect (Product Security)</a:t>
+            </a:r>
+            <a:endParaRPr lang="en-US" sz="1500" dirty="0"/>
+          </a:p>
+          <a:p>
+            <a:pPr marL="342900" indent="-342900">
+              <a:buSzPct val="100000"/>
+              <a:buChar char="•"/>
+            </a:pPr>
+            <a:r>
+              <a:rPr lang="en-US" sz="1500" dirty="0">
+                <a:solidFill>
+                  <a:srgbClr val="1A1A1A"/>
+                </a:solidFill>
+                <a:latin typeface="Arial" pitchFamily="34" charset="0"/>
+                <a:ea typeface="Arial" pitchFamily="34" charset="-122"/>
+                <a:cs typeface="Arial" pitchFamily="34" charset="-120"/>
+              </a:rPr>
               <a:t>Earlier: AppSec and IT risk at Cargill; software development before that</a:t>
             </a:r>
             <a:endParaRPr lang="en-US" sz="1500" dirty="0"/>
@@ -7271,7 +7265,7 @@
       </p:sp>
       <p:sp>
         <p:nvSpPr>
-          <p:cNvPr id="8" name="Shape 6"/>
+          <p:cNvPr id="9" name="Shape 7"/>
           <p:cNvSpPr/>
           <p:nvPr/>
         </p:nvSpPr>
@@ -7296,7 +7290,7 @@
       </p:sp>
       <p:sp>
         <p:nvSpPr>
-          <p:cNvPr id="9" name="Text 7"/>
+          <p:cNvPr id="10" name="Text 8"/>
           <p:cNvSpPr/>
           <p:nvPr/>
         </p:nvSpPr>
@@ -7534,7 +7528,7 @@
         <p:spPr>
           <a:xfrm>
             <a:off x="502920" y="1783080"/>
-            <a:ext cx="11155680" cy="877824"/>
+            <a:ext cx="11155680" cy="530352"/>
           </a:xfrm>
           <a:prstGeom prst="rect">
             <a:avLst/>
@@ -7559,25 +7553,7 @@
                 <a:ea typeface="Arial" pitchFamily="34" charset="-122"/>
                 <a:cs typeface="Arial" pitchFamily="34" charset="-120"/>
               </a:rPr>
-              <a:t>Why I’m here</a:t>
-            </a:r>
-            <a:endParaRPr lang="en-US" sz="1500" dirty="0"/>
-          </a:p>
-          <a:p>
-            <a:pPr marL="342900" indent="-342900">
-              <a:buSzPct val="100000"/>
-              <a:buChar char="•"/>
-            </a:pPr>
-            <a:r>
-              <a:rPr lang="en-US" sz="1500" dirty="0">
-                <a:solidFill>
-                  <a:srgbClr val="1A1A1A"/>
-                </a:solidFill>
-                <a:latin typeface="Arial" pitchFamily="34" charset="0"/>
-                <a:ea typeface="Arial" pitchFamily="34" charset="-122"/>
-                <a:cs typeface="Arial" pitchFamily="34" charset="-120"/>
-              </a:rPr>
-              <a:t>See the live web deck for full layout and screenshots.</a:t>
+              <a:t>Not a toy demo — your content, a real pull request with a partner review, and GitHub Pages publishing the way teams actually ship. Ask questions early. Stuck is normal; guessing burns time.</a:t>
             </a:r>
             <a:endParaRPr lang="en-US" sz="1500" dirty="0"/>
           </a:p>
@@ -7848,7 +7824,7 @@
         <p:spPr>
           <a:xfrm>
             <a:off x="502920" y="1783080"/>
-            <a:ext cx="11155680" cy="877824"/>
+            <a:ext cx="11155680" cy="530352"/>
           </a:xfrm>
           <a:prstGeom prst="rect">
             <a:avLst/>
@@ -7873,25 +7849,7 @@
                 <a:ea typeface="Arial" pitchFamily="34" charset="-122"/>
                 <a:cs typeface="Arial" pitchFamily="34" charset="-120"/>
               </a:rPr>
-              <a:t>What “done” looks like</a:t>
-            </a:r>
-            <a:endParaRPr lang="en-US" sz="1500" dirty="0"/>
-          </a:p>
-          <a:p>
-            <a:pPr marL="342900" indent="-342900">
-              <a:buSzPct val="100000"/>
-              <a:buChar char="•"/>
-            </a:pPr>
-            <a:r>
-              <a:rPr lang="en-US" sz="1500" dirty="0">
-                <a:solidFill>
-                  <a:srgbClr val="1A1A1A"/>
-                </a:solidFill>
-                <a:latin typeface="Arial" pitchFamily="34" charset="0"/>
-                <a:ea typeface="Arial" pitchFamily="34" charset="-122"/>
-                <a:cs typeface="Arial" pitchFamily="34" charset="-120"/>
-              </a:rPr>
-              <a:t>See the live web deck for full layout and screenshots.</a:t>
+              <a:t>Name, education, coursework, projects, photo if you want — then a real GitHub Pages URL. We’ll use a branch and pull request so you practice how teams review work before it goes live.</a:t>
             </a:r>
             <a:endParaRPr lang="en-US" sz="1500" dirty="0"/>
           </a:p>
@@ -8162,7 +8120,7 @@
         <p:spPr>
           <a:xfrm>
             <a:off x="502920" y="1783080"/>
-            <a:ext cx="11155680" cy="877824"/>
+            <a:ext cx="11155680" cy="530352"/>
           </a:xfrm>
           <a:prstGeom prst="rect">
             <a:avLst/>
@@ -8187,25 +8145,7 @@
                 <a:ea typeface="Arial" pitchFamily="34" charset="-122"/>
                 <a:cs typeface="Arial" pitchFamily="34" charset="-120"/>
               </a:rPr>
-              <a:t>Get the starter</a:t>
-            </a:r>
-            <a:endParaRPr lang="en-US" sz="1500" dirty="0"/>
-          </a:p>
-          <a:p>
-            <a:pPr marL="342900" indent="-342900">
-              <a:buSzPct val="100000"/>
-              <a:buChar char="•"/>
-            </a:pPr>
-            <a:r>
-              <a:rPr lang="en-US" sz="1500" dirty="0">
-                <a:solidFill>
-                  <a:srgbClr val="1A1A1A"/>
-                </a:solidFill>
-                <a:latin typeface="Arial" pitchFamily="34" charset="0"/>
-                <a:ea typeface="Arial" pitchFamily="34" charset="-122"/>
-                <a:cs typeface="Arial" pitchFamily="34" charset="-120"/>
-              </a:rPr>
-              <a:t>See the live web deck for full layout and screenshots.</a:t>
+              <a:t>You want a folder named my-resume-site . Also create an empty Public GitHub repo — leave README / .gitignore / license unchecked.</a:t>
             </a:r>
             <a:endParaRPr lang="en-US" sz="1500" dirty="0"/>
           </a:p>
@@ -8476,7 +8416,7 @@
         <p:spPr>
           <a:xfrm>
             <a:off x="502920" y="1783080"/>
-            <a:ext cx="11155680" cy="877824"/>
+            <a:ext cx="11155680" cy="530352"/>
           </a:xfrm>
           <a:prstGeom prst="rect">
             <a:avLst/>
@@ -8501,25 +8441,7 @@
                 <a:ea typeface="Arial" pitchFamily="34" charset="-122"/>
                 <a:cs typeface="Arial" pitchFamily="34" charset="-120"/>
               </a:rPr>
-              <a:t>Run it locally</a:t>
-            </a:r>
-            <a:endParaRPr lang="en-US" sz="1500" dirty="0"/>
-          </a:p>
-          <a:p>
-            <a:pPr marL="342900" indent="-342900">
-              <a:buSzPct val="100000"/>
-              <a:buChar char="•"/>
-            </a:pPr>
-            <a:r>
-              <a:rPr lang="en-US" sz="1500" dirty="0">
-                <a:solidFill>
-                  <a:srgbClr val="1A1A1A"/>
-                </a:solidFill>
-                <a:latin typeface="Arial" pitchFamily="34" charset="0"/>
-                <a:ea typeface="Arial" pitchFamily="34" charset="-122"/>
-                <a:cs typeface="Arial" pitchFamily="34" charset="-120"/>
-              </a:rPr>
-              <a:t>See the live web deck for full layout and screenshots.</a:t>
+              <a:t>Click the localhost link in the terminal. You should see a sample resume. Leave that terminal running.</a:t>
             </a:r>
             <a:endParaRPr lang="en-US" sz="1500" dirty="0"/>
           </a:p>
@@ -8790,7 +8712,7 @@
         <p:spPr>
           <a:xfrm>
             <a:off x="502920" y="1783080"/>
-            <a:ext cx="11155680" cy="877824"/>
+            <a:ext cx="11155680" cy="530352"/>
           </a:xfrm>
           <a:prstGeom prst="rect">
             <a:avLst/>
@@ -8815,25 +8737,7 @@
                 <a:ea typeface="Arial" pitchFamily="34" charset="-122"/>
                 <a:cs typeface="Arial" pitchFamily="34" charset="-120"/>
               </a:rPr>
-              <a:t>The content file</a:t>
-            </a:r>
-            <a:endParaRPr lang="en-US" sz="1500" dirty="0"/>
-          </a:p>
-          <a:p>
-            <a:pPr marL="342900" indent="-342900">
-              <a:buSzPct val="100000"/>
-              <a:buChar char="•"/>
-            </a:pPr>
-            <a:r>
-              <a:rPr lang="en-US" sz="1500" dirty="0">
-                <a:solidFill>
-                  <a:srgbClr val="1A1A1A"/>
-                </a:solidFill>
-                <a:latin typeface="Arial" pitchFamily="34" charset="0"/>
-                <a:ea typeface="Arial" pitchFamily="34" charset="-122"/>
-                <a:cs typeface="Arial" pitchFamily="34" charset="-120"/>
-              </a:rPr>
-              <a:t>See the live web deck for full layout and screenshots.</a:t>
+              <a:t>Name, about, coursework, projects, links. Optional photo: drop photo.jpg in public/ . Leave lists you don’t need as [] .</a:t>
             </a:r>
             <a:endParaRPr lang="en-US" sz="1500" dirty="0"/>
           </a:p>
@@ -9104,7 +9008,7 @@
         <p:spPr>
           <a:xfrm>
             <a:off x="502920" y="1783080"/>
-            <a:ext cx="11155680" cy="877824"/>
+            <a:ext cx="11155680" cy="530352"/>
           </a:xfrm>
           <a:prstGeom prst="rect">
             <a:avLst/>
@@ -9129,25 +9033,7 @@
                 <a:ea typeface="Arial" pitchFamily="34" charset="-122"/>
                 <a:cs typeface="Arial" pitchFamily="34" charset="-120"/>
               </a:rPr>
-              <a:t>Save isn’t publish</a:t>
-            </a:r>
-            <a:endParaRPr lang="en-US" sz="1500" dirty="0"/>
-          </a:p>
-          <a:p>
-            <a:pPr marL="342900" indent="-342900">
-              <a:buSzPct val="100000"/>
-              <a:buChar char="•"/>
-            </a:pPr>
-            <a:r>
-              <a:rPr lang="en-US" sz="1500" dirty="0">
-                <a:solidFill>
-                  <a:srgbClr val="1A1A1A"/>
-                </a:solidFill>
-                <a:latin typeface="Arial" pitchFamily="34" charset="0"/>
-                <a:ea typeface="Arial" pitchFamily="34" charset="-122"/>
-                <a:cs typeface="Arial" pitchFamily="34" charset="-120"/>
-              </a:rPr>
-              <a:t>See the live web deck for full layout and screenshots.</a:t>
+              <a:t>We’ll hit each of those on purpose. Don’t skip ahead.</a:t>
             </a:r>
             <a:endParaRPr lang="en-US" sz="1500" dirty="0"/>
           </a:p>

</xml_diff>

<commit_message>
Deck: Barton School of Business alum wording
</commit_message>
<xml_diff>
--- a/downloads/workshop-1-presentation.pptx
+++ b/downloads/workshop-1-presentation.pptx
@@ -6204,7 +6204,7 @@
                 <a:ea typeface="Arial" pitchFamily="34" charset="-122"/>
                 <a:cs typeface="Arial" pitchFamily="34" charset="-120"/>
               </a:rPr>
-              <a:t>Shockers alum. Based in Wichita with my wife and two dogs. Security is the day job — not the whole story.</a:t>
+              <a:t>Wichita State Barton School of Business alum. Based in Wichita with my wife and two dogs. Security is the day job — not the whole story.</a:t>
             </a:r>
             <a:endParaRPr lang="en-US" sz="1500" dirty="0"/>
           </a:p>
@@ -7203,7 +7203,7 @@
                 <a:ea typeface="Arial" pitchFamily="34" charset="-122"/>
                 <a:cs typeface="Arial" pitchFamily="34" charset="-120"/>
               </a:rPr>
-              <a:t>Wichita State — graduated here</a:t>
+              <a:t>Wichita State — Barton School of Business alum</a:t>
             </a:r>
             <a:endParaRPr lang="en-US" sz="1500" dirty="0"/>
           </a:p>

</xml_diff>